<commit_message>
Add synchronized verification diagrams
</commit_message>
<xml_diff>
--- a/presentation/Huntrix_Final_Presentation.pptx
+++ b/presentation/Huntrix_Final_Presentation.pptx
@@ -2,27 +2,27 @@
 <file path=ppt/presentation.xml><?xml version="1.0" encoding="utf-8"?>
 <p:presentation xmlns:p="http://schemas.openxmlformats.org/presentationml/2006/main">
   <p:sldMasterIdLst>
-    <p:sldMasterId xmlns:r="http://schemas.openxmlformats.org/officeDocument/2006/relationships" id="2147483648" r:id="Ra2074f835e6e49d3"/>
+    <p:sldMasterId xmlns:r="http://schemas.openxmlformats.org/officeDocument/2006/relationships" id="2147483648" r:id="Rd2a48ed8a2c6463a"/>
   </p:sldMasterIdLst>
   <p:notesMasterIdLst>
-    <p:notesMasterId xmlns:r="http://schemas.openxmlformats.org/officeDocument/2006/relationships" r:id="Re9dee522748445ca"/>
+    <p:notesMasterId xmlns:r="http://schemas.openxmlformats.org/officeDocument/2006/relationships" r:id="R2fc945781a2c4092"/>
   </p:notesMasterIdLst>
   <p:sldIdLst>
-    <p:sldId xmlns:r="http://schemas.openxmlformats.org/officeDocument/2006/relationships" id="256" r:id="R48fdf22a5e53407c"/>
-    <p:sldId xmlns:r="http://schemas.openxmlformats.org/officeDocument/2006/relationships" id="257" r:id="R2298c36092834288"/>
-    <p:sldId xmlns:r="http://schemas.openxmlformats.org/officeDocument/2006/relationships" id="258" r:id="R35e45843a6724e9e"/>
-    <p:sldId xmlns:r="http://schemas.openxmlformats.org/officeDocument/2006/relationships" id="259" r:id="R066230ac937e4520"/>
-    <p:sldId xmlns:r="http://schemas.openxmlformats.org/officeDocument/2006/relationships" id="260" r:id="R9face599c8704143"/>
-    <p:sldId xmlns:r="http://schemas.openxmlformats.org/officeDocument/2006/relationships" id="261" r:id="R41067e09c75b4e9d"/>
-    <p:sldId xmlns:r="http://schemas.openxmlformats.org/officeDocument/2006/relationships" id="262" r:id="Rad721ac56b934c19"/>
-    <p:sldId xmlns:r="http://schemas.openxmlformats.org/officeDocument/2006/relationships" id="263" r:id="R6d025e94c4dd4ef8"/>
-    <p:sldId xmlns:r="http://schemas.openxmlformats.org/officeDocument/2006/relationships" id="264" r:id="R95c6d96a27094305"/>
-    <p:sldId xmlns:r="http://schemas.openxmlformats.org/officeDocument/2006/relationships" id="265" r:id="R351374c76ca944f0"/>
-    <p:sldId xmlns:r="http://schemas.openxmlformats.org/officeDocument/2006/relationships" id="266" r:id="R8f1c48d80d7146f0"/>
-    <p:sldId xmlns:r="http://schemas.openxmlformats.org/officeDocument/2006/relationships" id="267" r:id="R9bbdf36b608b4a82"/>
-    <p:sldId xmlns:r="http://schemas.openxmlformats.org/officeDocument/2006/relationships" id="268" r:id="Re31b7c7f64c74b32"/>
-    <p:sldId xmlns:r="http://schemas.openxmlformats.org/officeDocument/2006/relationships" id="269" r:id="Rcac2cf87b3524dd6"/>
-    <p:sldId xmlns:r="http://schemas.openxmlformats.org/officeDocument/2006/relationships" id="270" r:id="Rfb0317e0a97744db"/>
+    <p:sldId xmlns:r="http://schemas.openxmlformats.org/officeDocument/2006/relationships" id="256" r:id="Ra58b8b1998f543b3"/>
+    <p:sldId xmlns:r="http://schemas.openxmlformats.org/officeDocument/2006/relationships" id="257" r:id="R4f4a40980abe4715"/>
+    <p:sldId xmlns:r="http://schemas.openxmlformats.org/officeDocument/2006/relationships" id="258" r:id="Rffdb4b44933348ad"/>
+    <p:sldId xmlns:r="http://schemas.openxmlformats.org/officeDocument/2006/relationships" id="259" r:id="Rd3bc25cebc5b46aa"/>
+    <p:sldId xmlns:r="http://schemas.openxmlformats.org/officeDocument/2006/relationships" id="260" r:id="R6c30e85f4e3f491c"/>
+    <p:sldId xmlns:r="http://schemas.openxmlformats.org/officeDocument/2006/relationships" id="261" r:id="R6549cda9def54ac8"/>
+    <p:sldId xmlns:r="http://schemas.openxmlformats.org/officeDocument/2006/relationships" id="262" r:id="R5e8c8ebf92a748c7"/>
+    <p:sldId xmlns:r="http://schemas.openxmlformats.org/officeDocument/2006/relationships" id="263" r:id="R6fb01cb66d794111"/>
+    <p:sldId xmlns:r="http://schemas.openxmlformats.org/officeDocument/2006/relationships" id="264" r:id="Ree494e75d1504f32"/>
+    <p:sldId xmlns:r="http://schemas.openxmlformats.org/officeDocument/2006/relationships" id="265" r:id="Re5f67254b2cb448e"/>
+    <p:sldId xmlns:r="http://schemas.openxmlformats.org/officeDocument/2006/relationships" id="266" r:id="R400d569af7a04c78"/>
+    <p:sldId xmlns:r="http://schemas.openxmlformats.org/officeDocument/2006/relationships" id="267" r:id="R183856c41c1e4aff"/>
+    <p:sldId xmlns:r="http://schemas.openxmlformats.org/officeDocument/2006/relationships" id="268" r:id="Re05c45240bcb4f05"/>
+    <p:sldId xmlns:r="http://schemas.openxmlformats.org/officeDocument/2006/relationships" id="269" r:id="R972365ca22144ffc"/>
+    <p:sldId xmlns:r="http://schemas.openxmlformats.org/officeDocument/2006/relationships" id="270" r:id="Rb8125201ab7e4f83"/>
   </p:sldIdLst>
   <p:sldSz cx="12192000" cy="6858000"/>
   <p:notesSz cx="6858000" cy="9144000"/>
@@ -1846,7 +1846,7 @@
           </a:p>
           <a:p xmlns:a="http://schemas.openxmlformats.org/drawingml/2006/main">
             <a:r>
-              <a:t>[3] BenHalluEval context-faithfulness tasks. [7] Frozen v91 clause segmentation, anchor alignment, and claim decision policy.</a:t>
+              <a:t>This is the expanded presentation view of Figure 2a in the report. [3] BenHalluEval context-faithfulness tasks. [7] Frozen v91 clause segmentation, anchor alignment, and claim decision policy.</a:t>
             </a:r>
           </a:p>
         </p:txBody>
@@ -2056,7 +2056,7 @@
           </a:p>
           <a:p xmlns:a="http://schemas.openxmlformats.org/drawingml/2006/main">
             <a:r>
-              <a:t>[7] Frozen v91 evidence schema, provenance ledger, conflict audit, and row-level trace format.</a:t>
+              <a:t>This is the expanded presentation view of Figure 2b in the report. [7] Frozen v91 evidence schema, provenance ledger, conflict audit, and row-level trace format.</a:t>
             </a:r>
           </a:p>
         </p:txBody>
@@ -2124,7 +2124,7 @@
   </p:cSld>
   <p:clrMap bg1="lt1" tx1="dk1" bg2="lt2" tx2="dk2" accent1="accent1" accent2="accent2" accent3="accent3" accent4="accent4" accent5="accent5" accent6="accent6" hlink="hlink" folHlink="folHlink"/>
   <p:sldLayoutIdLst>
-    <p:sldLayoutId xmlns:r="http://schemas.openxmlformats.org/officeDocument/2006/relationships" id="2147483649" r:id="R9b51d89fc7784281"/>
+    <p:sldLayoutId xmlns:r="http://schemas.openxmlformats.org/officeDocument/2006/relationships" id="2147483649" r:id="R2a5defec6cf04828"/>
   </p:sldLayoutIdLst>
   <p:txStyles>
     <p:titleStyle>
@@ -2886,7 +2886,7 @@
           <p:cNvPr id="14" name="">
             <a:extLst xmlns:a="http://schemas.openxmlformats.org/drawingml/2006/main">
               <a:ext uri="{FF2B5EF4-FFF2-40B4-BE49-F238E27FC236}">
-                <a16:creationId xmlns:a16="http://schemas.microsoft.com/office/drawing/2014/main" id="{8C40AA49-77BD-4C09-A56D-0D1DB5CEF4D0}"/>
+                <a16:creationId xmlns:a16="http://schemas.microsoft.com/office/drawing/2014/main" id="{B12FAAA4-A02E-4321-9D51-90952CAA3C16}"/>
               </a:ext>
             </a:extLst>
           </p:cNvPr>
@@ -2919,7 +2919,7 @@
           <p:cNvPr id="2" name="">
             <a:extLst xmlns:a="http://schemas.openxmlformats.org/drawingml/2006/main">
               <a:ext uri="{FF2B5EF4-FFF2-40B4-BE49-F238E27FC236}">
-                <a16:creationId xmlns:a16="http://schemas.microsoft.com/office/drawing/2014/main" id="{70EB99D8-4F09-40D7-B09C-10C91384532C}"/>
+                <a16:creationId xmlns:a16="http://schemas.microsoft.com/office/drawing/2014/main" id="{DEC90AC5-DDBA-4E54-B215-014291277444}"/>
               </a:ext>
             </a:extLst>
           </p:cNvPr>
@@ -2969,7 +2969,7 @@
           <p:cNvPr id="3" name="">
             <a:extLst xmlns:a="http://schemas.openxmlformats.org/drawingml/2006/main">
               <a:ext uri="{FF2B5EF4-FFF2-40B4-BE49-F238E27FC236}">
-                <a16:creationId xmlns:a16="http://schemas.microsoft.com/office/drawing/2014/main" id="{30E9DDE2-17E1-408A-887A-412E6A6B3DF9}"/>
+                <a16:creationId xmlns:a16="http://schemas.microsoft.com/office/drawing/2014/main" id="{BD016CCC-F61C-4AA1-B1A9-82CC60B34466}"/>
               </a:ext>
             </a:extLst>
           </p:cNvPr>
@@ -3036,7 +3036,7 @@
           <p:cNvPr id="4" name="">
             <a:extLst xmlns:a="http://schemas.openxmlformats.org/drawingml/2006/main">
               <a:ext uri="{FF2B5EF4-FFF2-40B4-BE49-F238E27FC236}">
-                <a16:creationId xmlns:a16="http://schemas.microsoft.com/office/drawing/2014/main" id="{6BE3BE6E-7DAA-458A-809B-A7333AA7D6B1}"/>
+                <a16:creationId xmlns:a16="http://schemas.microsoft.com/office/drawing/2014/main" id="{65D4D3A0-C517-4396-AD5F-74E7B22AE9AA}"/>
               </a:ext>
             </a:extLst>
           </p:cNvPr>
@@ -3086,7 +3086,7 @@
           <p:cNvPr id="5" name="">
             <a:extLst xmlns:a="http://schemas.openxmlformats.org/drawingml/2006/main">
               <a:ext uri="{FF2B5EF4-FFF2-40B4-BE49-F238E27FC236}">
-                <a16:creationId xmlns:a16="http://schemas.microsoft.com/office/drawing/2014/main" id="{41F7ACD0-EA70-4572-A6BC-B7269C529EE2}"/>
+                <a16:creationId xmlns:a16="http://schemas.microsoft.com/office/drawing/2014/main" id="{C8696CB4-6B88-4E4A-8ACD-D0A9F5A2514A}"/>
               </a:ext>
             </a:extLst>
           </p:cNvPr>
@@ -3117,7 +3117,7 @@
           <p:cNvPr id="6" name="">
             <a:extLst xmlns:a="http://schemas.openxmlformats.org/drawingml/2006/main">
               <a:ext uri="{FF2B5EF4-FFF2-40B4-BE49-F238E27FC236}">
-                <a16:creationId xmlns:a16="http://schemas.microsoft.com/office/drawing/2014/main" id="{E972804D-2DA2-4B6D-868B-63517B158F3C}"/>
+                <a16:creationId xmlns:a16="http://schemas.microsoft.com/office/drawing/2014/main" id="{91E866E3-EAF2-4705-972B-276838D2A8A5}"/>
               </a:ext>
             </a:extLst>
           </p:cNvPr>
@@ -3158,7 +3158,7 @@
           <p:cNvPr id="7" name="">
             <a:extLst xmlns:a="http://schemas.openxmlformats.org/drawingml/2006/main">
               <a:ext uri="{FF2B5EF4-FFF2-40B4-BE49-F238E27FC236}">
-                <a16:creationId xmlns:a16="http://schemas.microsoft.com/office/drawing/2014/main" id="{BF58DDF3-6467-4E66-BE91-4460BBD3742E}"/>
+                <a16:creationId xmlns:a16="http://schemas.microsoft.com/office/drawing/2014/main" id="{3A8A1C89-C245-4F4C-BAC7-B77D81354A5B}"/>
               </a:ext>
             </a:extLst>
           </p:cNvPr>
@@ -3208,7 +3208,7 @@
           <p:cNvPr id="8" name="">
             <a:extLst xmlns:a="http://schemas.openxmlformats.org/drawingml/2006/main">
               <a:ext uri="{FF2B5EF4-FFF2-40B4-BE49-F238E27FC236}">
-                <a16:creationId xmlns:a16="http://schemas.microsoft.com/office/drawing/2014/main" id="{22C0C530-0169-4A7D-8CF2-57BB5B936770}"/>
+                <a16:creationId xmlns:a16="http://schemas.microsoft.com/office/drawing/2014/main" id="{DCC29B0B-4D74-41B2-9B65-C96DC3C5877E}"/>
               </a:ext>
             </a:extLst>
           </p:cNvPr>
@@ -3258,7 +3258,7 @@
           <p:cNvPr id="9" name="">
             <a:extLst xmlns:a="http://schemas.openxmlformats.org/drawingml/2006/main">
               <a:ext uri="{FF2B5EF4-FFF2-40B4-BE49-F238E27FC236}">
-                <a16:creationId xmlns:a16="http://schemas.microsoft.com/office/drawing/2014/main" id="{F5459A7A-2A50-4F3F-9C3D-646AC5268515}"/>
+                <a16:creationId xmlns:a16="http://schemas.microsoft.com/office/drawing/2014/main" id="{F974FA57-C35C-47FF-8A74-DF700E7DE6C3}"/>
               </a:ext>
             </a:extLst>
           </p:cNvPr>
@@ -3308,7 +3308,7 @@
           <p:cNvPr id="10" name="">
             <a:extLst xmlns:a="http://schemas.openxmlformats.org/drawingml/2006/main">
               <a:ext uri="{FF2B5EF4-FFF2-40B4-BE49-F238E27FC236}">
-                <a16:creationId xmlns:a16="http://schemas.microsoft.com/office/drawing/2014/main" id="{0CB6B8E7-C3AC-4C02-928F-68282823926D}"/>
+                <a16:creationId xmlns:a16="http://schemas.microsoft.com/office/drawing/2014/main" id="{661F7B0A-A084-40CC-A965-2E9A315C4457}"/>
               </a:ext>
             </a:extLst>
           </p:cNvPr>
@@ -3358,7 +3358,7 @@
           <p:cNvPr id="11" name="">
             <a:extLst xmlns:a="http://schemas.openxmlformats.org/drawingml/2006/main">
               <a:ext uri="{FF2B5EF4-FFF2-40B4-BE49-F238E27FC236}">
-                <a16:creationId xmlns:a16="http://schemas.microsoft.com/office/drawing/2014/main" id="{942D8F79-E257-403F-9DCE-733075C13E45}"/>
+                <a16:creationId xmlns:a16="http://schemas.microsoft.com/office/drawing/2014/main" id="{D0E83386-EC1D-46C3-8B77-41D0E4D4759D}"/>
               </a:ext>
             </a:extLst>
           </p:cNvPr>
@@ -3408,7 +3408,7 @@
           <p:cNvPr id="12" name="">
             <a:extLst xmlns:a="http://schemas.openxmlformats.org/drawingml/2006/main">
               <a:ext uri="{FF2B5EF4-FFF2-40B4-BE49-F238E27FC236}">
-                <a16:creationId xmlns:a16="http://schemas.microsoft.com/office/drawing/2014/main" id="{C75C0311-4A34-47D7-92E0-BDFFCB8C3EFE}"/>
+                <a16:creationId xmlns:a16="http://schemas.microsoft.com/office/drawing/2014/main" id="{A38E483B-7E5C-446E-AD7C-D20F521E340A}"/>
               </a:ext>
             </a:extLst>
           </p:cNvPr>
@@ -3458,7 +3458,7 @@
           <p:cNvPr id="13" name="">
             <a:extLst xmlns:a="http://schemas.openxmlformats.org/drawingml/2006/main">
               <a:ext uri="{FF2B5EF4-FFF2-40B4-BE49-F238E27FC236}">
-                <a16:creationId xmlns:a16="http://schemas.microsoft.com/office/drawing/2014/main" id="{B1A477DB-CBA1-4896-87E1-5A69DCE9DE0F}"/>
+                <a16:creationId xmlns:a16="http://schemas.microsoft.com/office/drawing/2014/main" id="{90538314-7C8F-4219-A965-3111BB36A6C4}"/>
               </a:ext>
             </a:extLst>
           </p:cNvPr>
@@ -3506,7 +3506,7 @@
     </p:spTree>
     <p:extLst>
       <p:ext uri="{BB962C8B-B14F-4D97-AF65-F5344CB8AC3E}">
-        <p14:creationId xmlns:p14="http://schemas.microsoft.com/office/powerpoint/2010/main" val="1050747199"/>
+        <p14:creationId xmlns:p14="http://schemas.microsoft.com/office/powerpoint/2010/main" val="1115966672"/>
       </p:ext>
     </p:extLst>
   </p:cSld>
@@ -3537,7 +3537,7 @@
           <p:cNvPr id="20" name="kicker-10">
             <a:extLst xmlns:a="http://schemas.openxmlformats.org/drawingml/2006/main">
               <a:ext uri="{FF2B5EF4-FFF2-40B4-BE49-F238E27FC236}">
-                <a16:creationId xmlns:a16="http://schemas.microsoft.com/office/drawing/2014/main" id="{2266C73C-66AE-4275-A834-A3C460772811}"/>
+                <a16:creationId xmlns:a16="http://schemas.microsoft.com/office/drawing/2014/main" id="{2CA3F696-72FD-4BAC-8FAD-F637F5947AFD}"/>
               </a:ext>
             </a:extLst>
           </p:cNvPr>
@@ -3587,7 +3587,7 @@
           <p:cNvPr id="2" name="title-10">
             <a:extLst xmlns:a="http://schemas.openxmlformats.org/drawingml/2006/main">
               <a:ext uri="{FF2B5EF4-FFF2-40B4-BE49-F238E27FC236}">
-                <a16:creationId xmlns:a16="http://schemas.microsoft.com/office/drawing/2014/main" id="{EFAFC5E8-E1F3-4BB7-8A09-33D99C92CC75}"/>
+                <a16:creationId xmlns:a16="http://schemas.microsoft.com/office/drawing/2014/main" id="{DEAB9FF2-4F4A-4C8D-8D36-0DE2F837A86F}"/>
               </a:ext>
             </a:extLst>
           </p:cNvPr>
@@ -3637,7 +3637,7 @@
           <p:cNvPr id="3" name="">
             <a:extLst xmlns:a="http://schemas.openxmlformats.org/drawingml/2006/main">
               <a:ext uri="{FF2B5EF4-FFF2-40B4-BE49-F238E27FC236}">
-                <a16:creationId xmlns:a16="http://schemas.microsoft.com/office/drawing/2014/main" id="{21AF8242-5A24-4A71-9176-D56FB42FDC19}"/>
+                <a16:creationId xmlns:a16="http://schemas.microsoft.com/office/drawing/2014/main" id="{3ECEEDC4-19C1-4DD4-A20C-FD6128565382}"/>
               </a:ext>
             </a:extLst>
           </p:cNvPr>
@@ -3668,7 +3668,7 @@
           <p:cNvPr id="4" name="">
             <a:extLst xmlns:a="http://schemas.openxmlformats.org/drawingml/2006/main">
               <a:ext uri="{FF2B5EF4-FFF2-40B4-BE49-F238E27FC236}">
-                <a16:creationId xmlns:a16="http://schemas.microsoft.com/office/drawing/2014/main" id="{EABE6FD2-6752-47C6-97D0-6B2B8101D427}"/>
+                <a16:creationId xmlns:a16="http://schemas.microsoft.com/office/drawing/2014/main" id="{B86DC8D7-8B74-4C4A-B19E-06970DE2D148}"/>
               </a:ext>
             </a:extLst>
           </p:cNvPr>
@@ -3680,7 +3680,7 @@
         <p:spPr>
           <a:xfrm xmlns:a="http://schemas.openxmlformats.org/drawingml/2006/main">
             <a:off x="685800" y="1381125"/>
-            <a:ext cx="9715500" cy="419100"/>
+            <a:ext cx="8858250" cy="381000"/>
           </a:xfrm>
           <a:prstGeom xmlns:a="http://schemas.openxmlformats.org/drawingml/2006/main" prst="rect">
             <a:avLst/>
@@ -3708,7 +3708,7 @@
                   <a:srgbClr val="526174"/>
                 </a:solidFill>
               </a:rPr>
-              <a:t>The important points were architectural pivots, regressions, and reversions—not a monotonic climb.</a:t>
+              <a:t>Pivots, regressions, and reversions mattered more than a monotonic climb.</a:t>
             </a:r>
           </a:p>
         </p:txBody>
@@ -3725,7 +3725,7 @@
         </p:xfrm>
         <a:graphic xmlns:a="http://schemas.openxmlformats.org/drawingml/2006/main">
           <a:graphicData uri="http://schemas.openxmlformats.org/drawingml/2006/chart">
-            <c:chart xmlns:r="http://schemas.openxmlformats.org/officeDocument/2006/relationships" xmlns:c="http://schemas.openxmlformats.org/drawingml/2006/chart" r:id="R4c2db883d9414cda"/>
+            <c:chart xmlns:r="http://schemas.openxmlformats.org/officeDocument/2006/relationships" xmlns:c="http://schemas.openxmlformats.org/drawingml/2006/chart" r:id="R9987da4d35dc4173"/>
           </a:graphicData>
         </a:graphic>
       </p:graphicFrame>
@@ -3734,7 +3734,7 @@
           <p:cNvPr id="6" name="">
             <a:extLst xmlns:a="http://schemas.openxmlformats.org/drawingml/2006/main">
               <a:ext uri="{FF2B5EF4-FFF2-40B4-BE49-F238E27FC236}">
-                <a16:creationId xmlns:a16="http://schemas.microsoft.com/office/drawing/2014/main" id="{B480E4B5-4E45-4644-B95F-CACD73AB9073}"/>
+                <a16:creationId xmlns:a16="http://schemas.microsoft.com/office/drawing/2014/main" id="{046BD20E-4042-435F-AA3A-3376DCB3B104}"/>
               </a:ext>
             </a:extLst>
           </p:cNvPr>
@@ -3769,7 +3769,7 @@
           <p:cNvPr id="7" name="">
             <a:extLst xmlns:a="http://schemas.openxmlformats.org/drawingml/2006/main">
               <a:ext uri="{FF2B5EF4-FFF2-40B4-BE49-F238E27FC236}">
-                <a16:creationId xmlns:a16="http://schemas.microsoft.com/office/drawing/2014/main" id="{BAE9C764-7789-48C3-976B-D8BA3C290E16}"/>
+                <a16:creationId xmlns:a16="http://schemas.microsoft.com/office/drawing/2014/main" id="{464B5EA6-FC81-4A3F-B6F1-910AB37902F7}"/>
               </a:ext>
             </a:extLst>
           </p:cNvPr>
@@ -3819,7 +3819,7 @@
           <p:cNvPr id="8" name="">
             <a:extLst xmlns:a="http://schemas.openxmlformats.org/drawingml/2006/main">
               <a:ext uri="{FF2B5EF4-FFF2-40B4-BE49-F238E27FC236}">
-                <a16:creationId xmlns:a16="http://schemas.microsoft.com/office/drawing/2014/main" id="{2DC4E9D8-42D7-43F1-BCED-2EEA810BAB9B}"/>
+                <a16:creationId xmlns:a16="http://schemas.microsoft.com/office/drawing/2014/main" id="{073A1651-547A-4606-A969-2ADD3FABDCB9}"/>
               </a:ext>
             </a:extLst>
           </p:cNvPr>
@@ -3869,7 +3869,7 @@
           <p:cNvPr id="9" name="">
             <a:extLst xmlns:a="http://schemas.openxmlformats.org/drawingml/2006/main">
               <a:ext uri="{FF2B5EF4-FFF2-40B4-BE49-F238E27FC236}">
-                <a16:creationId xmlns:a16="http://schemas.microsoft.com/office/drawing/2014/main" id="{1028609C-7FC1-475D-B0B6-BE2286EB8868}"/>
+                <a16:creationId xmlns:a16="http://schemas.microsoft.com/office/drawing/2014/main" id="{019648AB-2810-4B34-9685-F40738AE050A}"/>
               </a:ext>
             </a:extLst>
           </p:cNvPr>
@@ -3919,7 +3919,7 @@
           <p:cNvPr id="10" name="">
             <a:extLst xmlns:a="http://schemas.openxmlformats.org/drawingml/2006/main">
               <a:ext uri="{FF2B5EF4-FFF2-40B4-BE49-F238E27FC236}">
-                <a16:creationId xmlns:a16="http://schemas.microsoft.com/office/drawing/2014/main" id="{89ACD5D9-3B84-48A0-B7F6-E6FC2EBC57B0}"/>
+                <a16:creationId xmlns:a16="http://schemas.microsoft.com/office/drawing/2014/main" id="{561896D2-28AA-4175-A655-D1F28E81DE7D}"/>
               </a:ext>
             </a:extLst>
           </p:cNvPr>
@@ -3954,7 +3954,7 @@
           <p:cNvPr id="11" name="">
             <a:extLst xmlns:a="http://schemas.openxmlformats.org/drawingml/2006/main">
               <a:ext uri="{FF2B5EF4-FFF2-40B4-BE49-F238E27FC236}">
-                <a16:creationId xmlns:a16="http://schemas.microsoft.com/office/drawing/2014/main" id="{768C13E5-3B5F-43D0-9DA7-927FE279EC37}"/>
+                <a16:creationId xmlns:a16="http://schemas.microsoft.com/office/drawing/2014/main" id="{2C2FC7B6-1840-4DC0-8532-149FA4ECB2BD}"/>
               </a:ext>
             </a:extLst>
           </p:cNvPr>
@@ -4004,7 +4004,7 @@
           <p:cNvPr id="12" name="">
             <a:extLst xmlns:a="http://schemas.openxmlformats.org/drawingml/2006/main">
               <a:ext uri="{FF2B5EF4-FFF2-40B4-BE49-F238E27FC236}">
-                <a16:creationId xmlns:a16="http://schemas.microsoft.com/office/drawing/2014/main" id="{83CBA987-C71B-493E-AB61-156DDB59B7E0}"/>
+                <a16:creationId xmlns:a16="http://schemas.microsoft.com/office/drawing/2014/main" id="{966CB9F8-9EF7-44E6-B882-0972C646BED3}"/>
               </a:ext>
             </a:extLst>
           </p:cNvPr>
@@ -4054,7 +4054,7 @@
           <p:cNvPr id="13" name="">
             <a:extLst xmlns:a="http://schemas.openxmlformats.org/drawingml/2006/main">
               <a:ext uri="{FF2B5EF4-FFF2-40B4-BE49-F238E27FC236}">
-                <a16:creationId xmlns:a16="http://schemas.microsoft.com/office/drawing/2014/main" id="{31865EB5-65DD-4B39-867A-58C60B32706A}"/>
+                <a16:creationId xmlns:a16="http://schemas.microsoft.com/office/drawing/2014/main" id="{B3653432-B39A-4840-AA4C-D8C435B79444}"/>
               </a:ext>
             </a:extLst>
           </p:cNvPr>
@@ -4104,7 +4104,7 @@
           <p:cNvPr id="14" name="">
             <a:extLst xmlns:a="http://schemas.openxmlformats.org/drawingml/2006/main">
               <a:ext uri="{FF2B5EF4-FFF2-40B4-BE49-F238E27FC236}">
-                <a16:creationId xmlns:a16="http://schemas.microsoft.com/office/drawing/2014/main" id="{CD0975C6-F862-4169-B694-A745738FE944}"/>
+                <a16:creationId xmlns:a16="http://schemas.microsoft.com/office/drawing/2014/main" id="{6DDFA4E3-A441-40AC-A17D-F7AE628CA502}"/>
               </a:ext>
             </a:extLst>
           </p:cNvPr>
@@ -4154,7 +4154,7 @@
           <p:cNvPr id="15" name="">
             <a:extLst xmlns:a="http://schemas.openxmlformats.org/drawingml/2006/main">
               <a:ext uri="{FF2B5EF4-FFF2-40B4-BE49-F238E27FC236}">
-                <a16:creationId xmlns:a16="http://schemas.microsoft.com/office/drawing/2014/main" id="{81B3D0B8-8793-4755-BA00-EE233E11218C}"/>
+                <a16:creationId xmlns:a16="http://schemas.microsoft.com/office/drawing/2014/main" id="{0C10E8CE-9794-4E12-A9D6-F1E2F98E7D0B}"/>
               </a:ext>
             </a:extLst>
           </p:cNvPr>
@@ -4204,7 +4204,7 @@
           <p:cNvPr id="16" name="">
             <a:extLst xmlns:a="http://schemas.openxmlformats.org/drawingml/2006/main">
               <a:ext uri="{FF2B5EF4-FFF2-40B4-BE49-F238E27FC236}">
-                <a16:creationId xmlns:a16="http://schemas.microsoft.com/office/drawing/2014/main" id="{7231A80C-BBCD-4005-A812-AF47E067C770}"/>
+                <a16:creationId xmlns:a16="http://schemas.microsoft.com/office/drawing/2014/main" id="{861FF3B3-49B8-4C7B-A309-B6F697451AEC}"/>
               </a:ext>
             </a:extLst>
           </p:cNvPr>
@@ -4254,7 +4254,7 @@
           <p:cNvPr id="17" name="">
             <a:extLst xmlns:a="http://schemas.openxmlformats.org/drawingml/2006/main">
               <a:ext uri="{FF2B5EF4-FFF2-40B4-BE49-F238E27FC236}">
-                <a16:creationId xmlns:a16="http://schemas.microsoft.com/office/drawing/2014/main" id="{D50B81CD-D598-4603-A9E4-9E5753262F8B}"/>
+                <a16:creationId xmlns:a16="http://schemas.microsoft.com/office/drawing/2014/main" id="{15B43BA7-C2FB-4687-9147-2CF8F0C62A3C}"/>
               </a:ext>
             </a:extLst>
           </p:cNvPr>
@@ -4285,7 +4285,7 @@
           <p:cNvPr id="18" name="source-10">
             <a:extLst xmlns:a="http://schemas.openxmlformats.org/drawingml/2006/main">
               <a:ext uri="{FF2B5EF4-FFF2-40B4-BE49-F238E27FC236}">
-                <a16:creationId xmlns:a16="http://schemas.microsoft.com/office/drawing/2014/main" id="{981BBBC3-DF61-41D3-BAEF-A10E31F25434}"/>
+                <a16:creationId xmlns:a16="http://schemas.microsoft.com/office/drawing/2014/main" id="{9B5BF208-DAEC-4961-9D96-77F9D19B1868}"/>
               </a:ext>
             </a:extLst>
           </p:cNvPr>
@@ -4335,7 +4335,7 @@
           <p:cNvPr id="19" name="page-10">
             <a:extLst xmlns:a="http://schemas.openxmlformats.org/drawingml/2006/main">
               <a:ext uri="{FF2B5EF4-FFF2-40B4-BE49-F238E27FC236}">
-                <a16:creationId xmlns:a16="http://schemas.microsoft.com/office/drawing/2014/main" id="{883E75EB-4B30-406A-A431-00CF0866C6B9}"/>
+                <a16:creationId xmlns:a16="http://schemas.microsoft.com/office/drawing/2014/main" id="{FD62EF52-4423-4601-BE94-003728F65874}"/>
               </a:ext>
             </a:extLst>
           </p:cNvPr>
@@ -4383,7 +4383,7 @@
     </p:spTree>
     <p:extLst>
       <p:ext uri="{BB962C8B-B14F-4D97-AF65-F5344CB8AC3E}">
-        <p14:creationId xmlns:p14="http://schemas.microsoft.com/office/powerpoint/2010/main" val="1268578479"/>
+        <p14:creationId xmlns:p14="http://schemas.microsoft.com/office/powerpoint/2010/main" val="1213699094"/>
       </p:ext>
     </p:extLst>
   </p:cSld>
@@ -4414,7 +4414,7 @@
           <p:cNvPr id="29" name="kicker-11">
             <a:extLst xmlns:a="http://schemas.openxmlformats.org/drawingml/2006/main">
               <a:ext uri="{FF2B5EF4-FFF2-40B4-BE49-F238E27FC236}">
-                <a16:creationId xmlns:a16="http://schemas.microsoft.com/office/drawing/2014/main" id="{625AE8CB-0C94-4609-8390-4C97A41C01AC}"/>
+                <a16:creationId xmlns:a16="http://schemas.microsoft.com/office/drawing/2014/main" id="{F3DBFDA9-BA7F-4D04-898E-3826BBB705E5}"/>
               </a:ext>
             </a:extLst>
           </p:cNvPr>
@@ -4464,7 +4464,7 @@
           <p:cNvPr id="2" name="title-11">
             <a:extLst xmlns:a="http://schemas.openxmlformats.org/drawingml/2006/main">
               <a:ext uri="{FF2B5EF4-FFF2-40B4-BE49-F238E27FC236}">
-                <a16:creationId xmlns:a16="http://schemas.microsoft.com/office/drawing/2014/main" id="{594B65A9-6760-4C3B-931D-5F496FAA8EDE}"/>
+                <a16:creationId xmlns:a16="http://schemas.microsoft.com/office/drawing/2014/main" id="{F470E77B-A5D5-484D-A575-9AACD1181DB8}"/>
               </a:ext>
             </a:extLst>
           </p:cNvPr>
@@ -4514,7 +4514,7 @@
           <p:cNvPr id="3" name="">
             <a:extLst xmlns:a="http://schemas.openxmlformats.org/drawingml/2006/main">
               <a:ext uri="{FF2B5EF4-FFF2-40B4-BE49-F238E27FC236}">
-                <a16:creationId xmlns:a16="http://schemas.microsoft.com/office/drawing/2014/main" id="{AD0C3652-9D01-40EA-BECA-B2BECD8D36F7}"/>
+                <a16:creationId xmlns:a16="http://schemas.microsoft.com/office/drawing/2014/main" id="{97FFCB1D-63A8-4CD5-8B59-453EA5CE3A84}"/>
               </a:ext>
             </a:extLst>
           </p:cNvPr>
@@ -4545,7 +4545,7 @@
           <p:cNvPr id="4" name="">
             <a:extLst xmlns:a="http://schemas.openxmlformats.org/drawingml/2006/main">
               <a:ext uri="{FF2B5EF4-FFF2-40B4-BE49-F238E27FC236}">
-                <a16:creationId xmlns:a16="http://schemas.microsoft.com/office/drawing/2014/main" id="{8FFE28C2-5AD6-432C-9A77-4A47E48F60D6}"/>
+                <a16:creationId xmlns:a16="http://schemas.microsoft.com/office/drawing/2014/main" id="{35F503D0-3137-41EF-B3CC-3BBE7ACB20D0}"/>
               </a:ext>
             </a:extLst>
           </p:cNvPr>
@@ -4595,7 +4595,7 @@
           <p:cNvPr id="5" name="">
             <a:extLst xmlns:a="http://schemas.openxmlformats.org/drawingml/2006/main">
               <a:ext uri="{FF2B5EF4-FFF2-40B4-BE49-F238E27FC236}">
-                <a16:creationId xmlns:a16="http://schemas.microsoft.com/office/drawing/2014/main" id="{95103302-A6A5-47D3-83D7-651C64E9DE6A}"/>
+                <a16:creationId xmlns:a16="http://schemas.microsoft.com/office/drawing/2014/main" id="{77E824C1-0A20-4229-9A1F-6B9464A87CE4}"/>
               </a:ext>
             </a:extLst>
           </p:cNvPr>
@@ -4645,7 +4645,7 @@
           <p:cNvPr id="6" name="">
             <a:extLst xmlns:a="http://schemas.openxmlformats.org/drawingml/2006/main">
               <a:ext uri="{FF2B5EF4-FFF2-40B4-BE49-F238E27FC236}">
-                <a16:creationId xmlns:a16="http://schemas.microsoft.com/office/drawing/2014/main" id="{57CF3F3E-D372-47FB-BC71-6926E9EAB000}"/>
+                <a16:creationId xmlns:a16="http://schemas.microsoft.com/office/drawing/2014/main" id="{B46F8802-D2A8-4A62-8909-A5DFC38F8160}"/>
               </a:ext>
             </a:extLst>
           </p:cNvPr>
@@ -4695,7 +4695,7 @@
           <p:cNvPr id="7" name="">
             <a:extLst xmlns:a="http://schemas.openxmlformats.org/drawingml/2006/main">
               <a:ext uri="{FF2B5EF4-FFF2-40B4-BE49-F238E27FC236}">
-                <a16:creationId xmlns:a16="http://schemas.microsoft.com/office/drawing/2014/main" id="{C9DB1B5B-C2B6-4DF6-95F8-54A08ACA949E}"/>
+                <a16:creationId xmlns:a16="http://schemas.microsoft.com/office/drawing/2014/main" id="{DA0E359B-EE1C-4181-8ACD-EEE5C9CD35CA}"/>
               </a:ext>
             </a:extLst>
           </p:cNvPr>
@@ -4745,7 +4745,7 @@
           <p:cNvPr id="8" name="">
             <a:extLst xmlns:a="http://schemas.openxmlformats.org/drawingml/2006/main">
               <a:ext uri="{FF2B5EF4-FFF2-40B4-BE49-F238E27FC236}">
-                <a16:creationId xmlns:a16="http://schemas.microsoft.com/office/drawing/2014/main" id="{9CD186C0-E526-4169-8499-16A0D34ED8BC}"/>
+                <a16:creationId xmlns:a16="http://schemas.microsoft.com/office/drawing/2014/main" id="{23473C24-2D3B-42B7-9AE5-6117D6B692FE}"/>
               </a:ext>
             </a:extLst>
           </p:cNvPr>
@@ -4776,7 +4776,7 @@
           <p:cNvPr id="9" name="">
             <a:extLst xmlns:a="http://schemas.openxmlformats.org/drawingml/2006/main">
               <a:ext uri="{FF2B5EF4-FFF2-40B4-BE49-F238E27FC236}">
-                <a16:creationId xmlns:a16="http://schemas.microsoft.com/office/drawing/2014/main" id="{B9AC08FD-2628-442A-88EE-BE33E83F5D60}"/>
+                <a16:creationId xmlns:a16="http://schemas.microsoft.com/office/drawing/2014/main" id="{E9812DC9-7936-4F8C-ABC5-29D35116D285}"/>
               </a:ext>
             </a:extLst>
           </p:cNvPr>
@@ -4826,7 +4826,7 @@
           <p:cNvPr id="10" name="">
             <a:extLst xmlns:a="http://schemas.openxmlformats.org/drawingml/2006/main">
               <a:ext uri="{FF2B5EF4-FFF2-40B4-BE49-F238E27FC236}">
-                <a16:creationId xmlns:a16="http://schemas.microsoft.com/office/drawing/2014/main" id="{C3FDFC95-5F7B-4606-8DE8-326F99805378}"/>
+                <a16:creationId xmlns:a16="http://schemas.microsoft.com/office/drawing/2014/main" id="{E73E9CDD-11AD-4AD7-8C81-0CC7B6BF3ACB}"/>
               </a:ext>
             </a:extLst>
           </p:cNvPr>
@@ -4876,7 +4876,7 @@
           <p:cNvPr id="11" name="">
             <a:extLst xmlns:a="http://schemas.openxmlformats.org/drawingml/2006/main">
               <a:ext uri="{FF2B5EF4-FFF2-40B4-BE49-F238E27FC236}">
-                <a16:creationId xmlns:a16="http://schemas.microsoft.com/office/drawing/2014/main" id="{C4C360FF-E04E-491E-B0C2-81312F6D1E4F}"/>
+                <a16:creationId xmlns:a16="http://schemas.microsoft.com/office/drawing/2014/main" id="{9FEFC2B3-20FB-4D3D-A707-8D05DA3835A7}"/>
               </a:ext>
             </a:extLst>
           </p:cNvPr>
@@ -4926,7 +4926,7 @@
           <p:cNvPr id="12" name="">
             <a:extLst xmlns:a="http://schemas.openxmlformats.org/drawingml/2006/main">
               <a:ext uri="{FF2B5EF4-FFF2-40B4-BE49-F238E27FC236}">
-                <a16:creationId xmlns:a16="http://schemas.microsoft.com/office/drawing/2014/main" id="{D01F79FD-61F1-4A31-95F8-7F2CC8778206}"/>
+                <a16:creationId xmlns:a16="http://schemas.microsoft.com/office/drawing/2014/main" id="{D54DFCDC-B420-4B3D-955E-7361D5E9D7D1}"/>
               </a:ext>
             </a:extLst>
           </p:cNvPr>
@@ -4957,7 +4957,7 @@
           <p:cNvPr id="13" name="">
             <a:extLst xmlns:a="http://schemas.openxmlformats.org/drawingml/2006/main">
               <a:ext uri="{FF2B5EF4-FFF2-40B4-BE49-F238E27FC236}">
-                <a16:creationId xmlns:a16="http://schemas.microsoft.com/office/drawing/2014/main" id="{BB038077-AE17-4549-8449-43624651231D}"/>
+                <a16:creationId xmlns:a16="http://schemas.microsoft.com/office/drawing/2014/main" id="{AE6E5141-BAC6-4D0D-A707-F9A59AB24B34}"/>
               </a:ext>
             </a:extLst>
           </p:cNvPr>
@@ -5007,7 +5007,7 @@
           <p:cNvPr id="14" name="">
             <a:extLst xmlns:a="http://schemas.openxmlformats.org/drawingml/2006/main">
               <a:ext uri="{FF2B5EF4-FFF2-40B4-BE49-F238E27FC236}">
-                <a16:creationId xmlns:a16="http://schemas.microsoft.com/office/drawing/2014/main" id="{91A13FE0-DF7D-4AE5-99F8-DCE53725FA0F}"/>
+                <a16:creationId xmlns:a16="http://schemas.microsoft.com/office/drawing/2014/main" id="{F413A6E9-A286-4226-A017-21F74968F7A2}"/>
               </a:ext>
             </a:extLst>
           </p:cNvPr>
@@ -5057,7 +5057,7 @@
           <p:cNvPr id="15" name="">
             <a:extLst xmlns:a="http://schemas.openxmlformats.org/drawingml/2006/main">
               <a:ext uri="{FF2B5EF4-FFF2-40B4-BE49-F238E27FC236}">
-                <a16:creationId xmlns:a16="http://schemas.microsoft.com/office/drawing/2014/main" id="{DDDC46DC-5BE5-4A52-A0AE-3E16D789EFF1}"/>
+                <a16:creationId xmlns:a16="http://schemas.microsoft.com/office/drawing/2014/main" id="{EEC688B5-A246-4357-A4CA-A06597FEC0D6}"/>
               </a:ext>
             </a:extLst>
           </p:cNvPr>
@@ -5107,7 +5107,7 @@
           <p:cNvPr id="16" name="">
             <a:extLst xmlns:a="http://schemas.openxmlformats.org/drawingml/2006/main">
               <a:ext uri="{FF2B5EF4-FFF2-40B4-BE49-F238E27FC236}">
-                <a16:creationId xmlns:a16="http://schemas.microsoft.com/office/drawing/2014/main" id="{A268A6E8-4E27-4A18-B412-E0F7A01349B3}"/>
+                <a16:creationId xmlns:a16="http://schemas.microsoft.com/office/drawing/2014/main" id="{94AF8249-7180-4559-8050-84F9B3E3BAAB}"/>
               </a:ext>
             </a:extLst>
           </p:cNvPr>
@@ -5138,7 +5138,7 @@
           <p:cNvPr id="17" name="">
             <a:extLst xmlns:a="http://schemas.openxmlformats.org/drawingml/2006/main">
               <a:ext uri="{FF2B5EF4-FFF2-40B4-BE49-F238E27FC236}">
-                <a16:creationId xmlns:a16="http://schemas.microsoft.com/office/drawing/2014/main" id="{B94478DD-E93E-4572-9359-7E27F1D51497}"/>
+                <a16:creationId xmlns:a16="http://schemas.microsoft.com/office/drawing/2014/main" id="{290E46DA-E04F-4675-B504-44C10289BC05}"/>
               </a:ext>
             </a:extLst>
           </p:cNvPr>
@@ -5188,7 +5188,7 @@
           <p:cNvPr id="18" name="">
             <a:extLst xmlns:a="http://schemas.openxmlformats.org/drawingml/2006/main">
               <a:ext uri="{FF2B5EF4-FFF2-40B4-BE49-F238E27FC236}">
-                <a16:creationId xmlns:a16="http://schemas.microsoft.com/office/drawing/2014/main" id="{5F8453F5-CA98-446A-AC75-63B3D91D1F7B}"/>
+                <a16:creationId xmlns:a16="http://schemas.microsoft.com/office/drawing/2014/main" id="{1479F48A-89E0-44F0-88EA-BD77B7513DD6}"/>
               </a:ext>
             </a:extLst>
           </p:cNvPr>
@@ -5238,7 +5238,7 @@
           <p:cNvPr id="19" name="">
             <a:extLst xmlns:a="http://schemas.openxmlformats.org/drawingml/2006/main">
               <a:ext uri="{FF2B5EF4-FFF2-40B4-BE49-F238E27FC236}">
-                <a16:creationId xmlns:a16="http://schemas.microsoft.com/office/drawing/2014/main" id="{405614A3-3842-4A46-B240-4A677279101D}"/>
+                <a16:creationId xmlns:a16="http://schemas.microsoft.com/office/drawing/2014/main" id="{400EA1C2-539F-400C-AD8F-4A8EDA80F814}"/>
               </a:ext>
             </a:extLst>
           </p:cNvPr>
@@ -5288,7 +5288,7 @@
           <p:cNvPr id="20" name="">
             <a:extLst xmlns:a="http://schemas.openxmlformats.org/drawingml/2006/main">
               <a:ext uri="{FF2B5EF4-FFF2-40B4-BE49-F238E27FC236}">
-                <a16:creationId xmlns:a16="http://schemas.microsoft.com/office/drawing/2014/main" id="{D30D0CCC-DA79-4DD9-93A6-A46E84A5D5CC}"/>
+                <a16:creationId xmlns:a16="http://schemas.microsoft.com/office/drawing/2014/main" id="{65FD9291-C64C-4A98-9723-52DAC70FF1B6}"/>
               </a:ext>
             </a:extLst>
           </p:cNvPr>
@@ -5319,7 +5319,7 @@
           <p:cNvPr id="21" name="">
             <a:extLst xmlns:a="http://schemas.openxmlformats.org/drawingml/2006/main">
               <a:ext uri="{FF2B5EF4-FFF2-40B4-BE49-F238E27FC236}">
-                <a16:creationId xmlns:a16="http://schemas.microsoft.com/office/drawing/2014/main" id="{530E50BF-E199-4BE6-809C-E8CA59971879}"/>
+                <a16:creationId xmlns:a16="http://schemas.microsoft.com/office/drawing/2014/main" id="{CC682344-7258-4D8C-90E5-0A6ADE46521A}"/>
               </a:ext>
             </a:extLst>
           </p:cNvPr>
@@ -5369,7 +5369,7 @@
           <p:cNvPr id="22" name="">
             <a:extLst xmlns:a="http://schemas.openxmlformats.org/drawingml/2006/main">
               <a:ext uri="{FF2B5EF4-FFF2-40B4-BE49-F238E27FC236}">
-                <a16:creationId xmlns:a16="http://schemas.microsoft.com/office/drawing/2014/main" id="{8A5AD899-E95A-4A99-9248-DBDD7FA38740}"/>
+                <a16:creationId xmlns:a16="http://schemas.microsoft.com/office/drawing/2014/main" id="{19FCE310-D45E-426D-8108-0C7690CA2F97}"/>
               </a:ext>
             </a:extLst>
           </p:cNvPr>
@@ -5419,7 +5419,7 @@
           <p:cNvPr id="23" name="">
             <a:extLst xmlns:a="http://schemas.openxmlformats.org/drawingml/2006/main">
               <a:ext uri="{FF2B5EF4-FFF2-40B4-BE49-F238E27FC236}">
-                <a16:creationId xmlns:a16="http://schemas.microsoft.com/office/drawing/2014/main" id="{FA04B6E4-C897-4256-92AA-4E485C0547D5}"/>
+                <a16:creationId xmlns:a16="http://schemas.microsoft.com/office/drawing/2014/main" id="{2F7ECC2E-92FF-45D4-9DC5-069604F32255}"/>
               </a:ext>
             </a:extLst>
           </p:cNvPr>
@@ -5469,7 +5469,7 @@
           <p:cNvPr id="24" name="">
             <a:extLst xmlns:a="http://schemas.openxmlformats.org/drawingml/2006/main">
               <a:ext uri="{FF2B5EF4-FFF2-40B4-BE49-F238E27FC236}">
-                <a16:creationId xmlns:a16="http://schemas.microsoft.com/office/drawing/2014/main" id="{C0CE661D-1A5E-4F22-A281-FACBE7ECEB8B}"/>
+                <a16:creationId xmlns:a16="http://schemas.microsoft.com/office/drawing/2014/main" id="{DC828BC4-8155-4821-8B0A-80DD2FABA1EC}"/>
               </a:ext>
             </a:extLst>
           </p:cNvPr>
@@ -5500,7 +5500,7 @@
           <p:cNvPr id="25" name="">
             <a:extLst xmlns:a="http://schemas.openxmlformats.org/drawingml/2006/main">
               <a:ext uri="{FF2B5EF4-FFF2-40B4-BE49-F238E27FC236}">
-                <a16:creationId xmlns:a16="http://schemas.microsoft.com/office/drawing/2014/main" id="{B51FAC8C-954C-401F-91A1-E2B70172E4A5}"/>
+                <a16:creationId xmlns:a16="http://schemas.microsoft.com/office/drawing/2014/main" id="{6EC760CA-B5F7-4DC8-9A5A-FCB5AAC473F7}"/>
               </a:ext>
             </a:extLst>
           </p:cNvPr>
@@ -5550,7 +5550,7 @@
           <p:cNvPr id="26" name="">
             <a:extLst xmlns:a="http://schemas.openxmlformats.org/drawingml/2006/main">
               <a:ext uri="{FF2B5EF4-FFF2-40B4-BE49-F238E27FC236}">
-                <a16:creationId xmlns:a16="http://schemas.microsoft.com/office/drawing/2014/main" id="{B8921EB6-F693-4CD5-B111-C21C8048AAE0}"/>
+                <a16:creationId xmlns:a16="http://schemas.microsoft.com/office/drawing/2014/main" id="{7238477F-2F66-4E4B-958D-C39DAF464ADB}"/>
               </a:ext>
             </a:extLst>
           </p:cNvPr>
@@ -5581,7 +5581,7 @@
           <p:cNvPr id="27" name="source-11">
             <a:extLst xmlns:a="http://schemas.openxmlformats.org/drawingml/2006/main">
               <a:ext uri="{FF2B5EF4-FFF2-40B4-BE49-F238E27FC236}">
-                <a16:creationId xmlns:a16="http://schemas.microsoft.com/office/drawing/2014/main" id="{07BC1876-CB43-4267-B07C-07A08A532B9F}"/>
+                <a16:creationId xmlns:a16="http://schemas.microsoft.com/office/drawing/2014/main" id="{39066BF5-584F-4948-9803-17F52E2E10BC}"/>
               </a:ext>
             </a:extLst>
           </p:cNvPr>
@@ -5631,7 +5631,7 @@
           <p:cNvPr id="28" name="page-11">
             <a:extLst xmlns:a="http://schemas.openxmlformats.org/drawingml/2006/main">
               <a:ext uri="{FF2B5EF4-FFF2-40B4-BE49-F238E27FC236}">
-                <a16:creationId xmlns:a16="http://schemas.microsoft.com/office/drawing/2014/main" id="{59AEB281-26AB-4D1C-8E6C-96EE9FA96B4A}"/>
+                <a16:creationId xmlns:a16="http://schemas.microsoft.com/office/drawing/2014/main" id="{8609A73E-D053-40E8-A88F-F9BC8DF2A171}"/>
               </a:ext>
             </a:extLst>
           </p:cNvPr>
@@ -5679,7 +5679,7 @@
     </p:spTree>
     <p:extLst>
       <p:ext uri="{BB962C8B-B14F-4D97-AF65-F5344CB8AC3E}">
-        <p14:creationId xmlns:p14="http://schemas.microsoft.com/office/powerpoint/2010/main" val="547779737"/>
+        <p14:creationId xmlns:p14="http://schemas.microsoft.com/office/powerpoint/2010/main" val="572719868"/>
       </p:ext>
     </p:extLst>
   </p:cSld>
@@ -5710,7 +5710,7 @@
           <p:cNvPr id="26" name="kicker-12">
             <a:extLst xmlns:a="http://schemas.openxmlformats.org/drawingml/2006/main">
               <a:ext uri="{FF2B5EF4-FFF2-40B4-BE49-F238E27FC236}">
-                <a16:creationId xmlns:a16="http://schemas.microsoft.com/office/drawing/2014/main" id="{21124CDE-42E3-443F-84F1-A87B87685162}"/>
+                <a16:creationId xmlns:a16="http://schemas.microsoft.com/office/drawing/2014/main" id="{F4CED5DC-4B22-4C6A-B766-616C6992A8F8}"/>
               </a:ext>
             </a:extLst>
           </p:cNvPr>
@@ -5760,7 +5760,7 @@
           <p:cNvPr id="2" name="title-12">
             <a:extLst xmlns:a="http://schemas.openxmlformats.org/drawingml/2006/main">
               <a:ext uri="{FF2B5EF4-FFF2-40B4-BE49-F238E27FC236}">
-                <a16:creationId xmlns:a16="http://schemas.microsoft.com/office/drawing/2014/main" id="{9F7DC580-1AEC-4C20-9956-EDA6C02C46D0}"/>
+                <a16:creationId xmlns:a16="http://schemas.microsoft.com/office/drawing/2014/main" id="{4BD22BE0-D388-4520-A8C1-2C8C4C5BE8E1}"/>
               </a:ext>
             </a:extLst>
           </p:cNvPr>
@@ -5810,7 +5810,7 @@
           <p:cNvPr id="3" name="">
             <a:extLst xmlns:a="http://schemas.openxmlformats.org/drawingml/2006/main">
               <a:ext uri="{FF2B5EF4-FFF2-40B4-BE49-F238E27FC236}">
-                <a16:creationId xmlns:a16="http://schemas.microsoft.com/office/drawing/2014/main" id="{19FF1DFC-BFB1-48F3-9771-5BC9813543A2}"/>
+                <a16:creationId xmlns:a16="http://schemas.microsoft.com/office/drawing/2014/main" id="{D22F6FE7-EB63-45E0-B91D-153063084008}"/>
               </a:ext>
             </a:extLst>
           </p:cNvPr>
@@ -5841,7 +5841,7 @@
           <p:cNvPr id="4" name="">
             <a:extLst xmlns:a="http://schemas.openxmlformats.org/drawingml/2006/main">
               <a:ext uri="{FF2B5EF4-FFF2-40B4-BE49-F238E27FC236}">
-                <a16:creationId xmlns:a16="http://schemas.microsoft.com/office/drawing/2014/main" id="{8E11D8A1-A35F-48BD-8EAB-B0E8AA7512C2}"/>
+                <a16:creationId xmlns:a16="http://schemas.microsoft.com/office/drawing/2014/main" id="{464A1689-EE76-41C6-A480-F0E579FAD5A9}"/>
               </a:ext>
             </a:extLst>
           </p:cNvPr>
@@ -5891,7 +5891,7 @@
           <p:cNvPr id="5" name="">
             <a:extLst xmlns:a="http://schemas.openxmlformats.org/drawingml/2006/main">
               <a:ext uri="{FF2B5EF4-FFF2-40B4-BE49-F238E27FC236}">
-                <a16:creationId xmlns:a16="http://schemas.microsoft.com/office/drawing/2014/main" id="{A76A13DE-C348-4306-A67D-8209990DDB72}"/>
+                <a16:creationId xmlns:a16="http://schemas.microsoft.com/office/drawing/2014/main" id="{01D45AC8-5193-4ADC-AD1D-56FDBEA1F66C}"/>
               </a:ext>
             </a:extLst>
           </p:cNvPr>
@@ -5941,7 +5941,7 @@
           <p:cNvPr id="6" name="">
             <a:extLst xmlns:a="http://schemas.openxmlformats.org/drawingml/2006/main">
               <a:ext uri="{FF2B5EF4-FFF2-40B4-BE49-F238E27FC236}">
-                <a16:creationId xmlns:a16="http://schemas.microsoft.com/office/drawing/2014/main" id="{F7D8E3EF-B0E6-4EAD-8137-621766326B15}"/>
+                <a16:creationId xmlns:a16="http://schemas.microsoft.com/office/drawing/2014/main" id="{CF4DB6E1-1239-43B1-869E-A3C37C845A8C}"/>
               </a:ext>
             </a:extLst>
           </p:cNvPr>
@@ -5991,7 +5991,7 @@
           <p:cNvPr id="7" name="">
             <a:extLst xmlns:a="http://schemas.openxmlformats.org/drawingml/2006/main">
               <a:ext uri="{FF2B5EF4-FFF2-40B4-BE49-F238E27FC236}">
-                <a16:creationId xmlns:a16="http://schemas.microsoft.com/office/drawing/2014/main" id="{A96A4259-23C5-421A-B438-206AB3AAE0B4}"/>
+                <a16:creationId xmlns:a16="http://schemas.microsoft.com/office/drawing/2014/main" id="{28B09C0E-3A4E-4840-B23D-E9F21663DFCA}"/>
               </a:ext>
             </a:extLst>
           </p:cNvPr>
@@ -6041,7 +6041,7 @@
           <p:cNvPr id="8" name="">
             <a:extLst xmlns:a="http://schemas.openxmlformats.org/drawingml/2006/main">
               <a:ext uri="{FF2B5EF4-FFF2-40B4-BE49-F238E27FC236}">
-                <a16:creationId xmlns:a16="http://schemas.microsoft.com/office/drawing/2014/main" id="{42E32E9D-23BF-49B3-A331-596E80B2293F}"/>
+                <a16:creationId xmlns:a16="http://schemas.microsoft.com/office/drawing/2014/main" id="{CD46205B-79C5-469C-89CA-A534FE90451E}"/>
               </a:ext>
             </a:extLst>
           </p:cNvPr>
@@ -6091,7 +6091,7 @@
           <p:cNvPr id="9" name="">
             <a:extLst xmlns:a="http://schemas.openxmlformats.org/drawingml/2006/main">
               <a:ext uri="{FF2B5EF4-FFF2-40B4-BE49-F238E27FC236}">
-                <a16:creationId xmlns:a16="http://schemas.microsoft.com/office/drawing/2014/main" id="{C0680FB1-FFC9-4A81-9975-5AE1C994F61A}"/>
+                <a16:creationId xmlns:a16="http://schemas.microsoft.com/office/drawing/2014/main" id="{B75712BD-4DDB-4462-939B-39C70FBC37EA}"/>
               </a:ext>
             </a:extLst>
           </p:cNvPr>
@@ -6141,7 +6141,7 @@
           <p:cNvPr id="10" name="">
             <a:extLst xmlns:a="http://schemas.openxmlformats.org/drawingml/2006/main">
               <a:ext uri="{FF2B5EF4-FFF2-40B4-BE49-F238E27FC236}">
-                <a16:creationId xmlns:a16="http://schemas.microsoft.com/office/drawing/2014/main" id="{16B98617-6DE7-42B4-AB6B-A5BEE8AB84E2}"/>
+                <a16:creationId xmlns:a16="http://schemas.microsoft.com/office/drawing/2014/main" id="{133D087E-2352-4223-AE39-056E1E4E4A10}"/>
               </a:ext>
             </a:extLst>
           </p:cNvPr>
@@ -6191,7 +6191,7 @@
           <p:cNvPr id="11" name="">
             <a:extLst xmlns:a="http://schemas.openxmlformats.org/drawingml/2006/main">
               <a:ext uri="{FF2B5EF4-FFF2-40B4-BE49-F238E27FC236}">
-                <a16:creationId xmlns:a16="http://schemas.microsoft.com/office/drawing/2014/main" id="{776D1D8D-F9D4-4B8F-A3F8-ABD11D990D47}"/>
+                <a16:creationId xmlns:a16="http://schemas.microsoft.com/office/drawing/2014/main" id="{4E512426-D044-419D-A83B-E121F19A12B1}"/>
               </a:ext>
             </a:extLst>
           </p:cNvPr>
@@ -6241,7 +6241,7 @@
           <p:cNvPr id="12" name="">
             <a:extLst xmlns:a="http://schemas.openxmlformats.org/drawingml/2006/main">
               <a:ext uri="{FF2B5EF4-FFF2-40B4-BE49-F238E27FC236}">
-                <a16:creationId xmlns:a16="http://schemas.microsoft.com/office/drawing/2014/main" id="{36F44AD7-7121-45F0-AA7E-6D3612C22C2D}"/>
+                <a16:creationId xmlns:a16="http://schemas.microsoft.com/office/drawing/2014/main" id="{BCC6EEFD-195B-42C5-8DF4-F13F3007FB17}"/>
               </a:ext>
             </a:extLst>
           </p:cNvPr>
@@ -6291,7 +6291,7 @@
           <p:cNvPr id="13" name="">
             <a:extLst xmlns:a="http://schemas.openxmlformats.org/drawingml/2006/main">
               <a:ext uri="{FF2B5EF4-FFF2-40B4-BE49-F238E27FC236}">
-                <a16:creationId xmlns:a16="http://schemas.microsoft.com/office/drawing/2014/main" id="{C49AEAA0-C27B-4B5A-89C3-39911C7DA513}"/>
+                <a16:creationId xmlns:a16="http://schemas.microsoft.com/office/drawing/2014/main" id="{FA9FD03C-A20A-42AF-A326-F32664AAA65C}"/>
               </a:ext>
             </a:extLst>
           </p:cNvPr>
@@ -6322,7 +6322,7 @@
           <p:cNvPr id="14" name="">
             <a:extLst xmlns:a="http://schemas.openxmlformats.org/drawingml/2006/main">
               <a:ext uri="{FF2B5EF4-FFF2-40B4-BE49-F238E27FC236}">
-                <a16:creationId xmlns:a16="http://schemas.microsoft.com/office/drawing/2014/main" id="{87E7BEB6-B3FD-434D-A962-72ABA36D8505}"/>
+                <a16:creationId xmlns:a16="http://schemas.microsoft.com/office/drawing/2014/main" id="{CE754483-FD9B-4466-A378-85AD382B8839}"/>
               </a:ext>
             </a:extLst>
           </p:cNvPr>
@@ -6357,7 +6357,7 @@
           <p:cNvPr id="15" name="">
             <a:extLst xmlns:a="http://schemas.openxmlformats.org/drawingml/2006/main">
               <a:ext uri="{FF2B5EF4-FFF2-40B4-BE49-F238E27FC236}">
-                <a16:creationId xmlns:a16="http://schemas.microsoft.com/office/drawing/2014/main" id="{2B21598F-0596-4C30-804B-B915BD547051}"/>
+                <a16:creationId xmlns:a16="http://schemas.microsoft.com/office/drawing/2014/main" id="{70FC5675-DB41-4688-A657-C72512400053}"/>
               </a:ext>
             </a:extLst>
           </p:cNvPr>
@@ -6407,7 +6407,7 @@
           <p:cNvPr id="16" name="">
             <a:extLst xmlns:a="http://schemas.openxmlformats.org/drawingml/2006/main">
               <a:ext uri="{FF2B5EF4-FFF2-40B4-BE49-F238E27FC236}">
-                <a16:creationId xmlns:a16="http://schemas.microsoft.com/office/drawing/2014/main" id="{7B902A5B-E913-4200-ADD2-FE65343269F7}"/>
+                <a16:creationId xmlns:a16="http://schemas.microsoft.com/office/drawing/2014/main" id="{F08C9A20-2120-446F-B164-BDAA782A3FC5}"/>
               </a:ext>
             </a:extLst>
           </p:cNvPr>
@@ -6457,7 +6457,7 @@
           <p:cNvPr id="17" name="">
             <a:extLst xmlns:a="http://schemas.openxmlformats.org/drawingml/2006/main">
               <a:ext uri="{FF2B5EF4-FFF2-40B4-BE49-F238E27FC236}">
-                <a16:creationId xmlns:a16="http://schemas.microsoft.com/office/drawing/2014/main" id="{E1D33924-7B47-42E9-AD29-750269AA19A1}"/>
+                <a16:creationId xmlns:a16="http://schemas.microsoft.com/office/drawing/2014/main" id="{899CDE58-6DAF-49E7-AC83-9615542740F0}"/>
               </a:ext>
             </a:extLst>
           </p:cNvPr>
@@ -6507,7 +6507,7 @@
           <p:cNvPr id="18" name="">
             <a:extLst xmlns:a="http://schemas.openxmlformats.org/drawingml/2006/main">
               <a:ext uri="{FF2B5EF4-FFF2-40B4-BE49-F238E27FC236}">
-                <a16:creationId xmlns:a16="http://schemas.microsoft.com/office/drawing/2014/main" id="{36E16BE8-43A7-464C-8ADE-582E420B2FE9}"/>
+                <a16:creationId xmlns:a16="http://schemas.microsoft.com/office/drawing/2014/main" id="{A57BB2FC-AAA4-428E-B6E8-19756D1C52AE}"/>
               </a:ext>
             </a:extLst>
           </p:cNvPr>
@@ -6557,7 +6557,7 @@
           <p:cNvPr id="19" name="">
             <a:extLst xmlns:a="http://schemas.openxmlformats.org/drawingml/2006/main">
               <a:ext uri="{FF2B5EF4-FFF2-40B4-BE49-F238E27FC236}">
-                <a16:creationId xmlns:a16="http://schemas.microsoft.com/office/drawing/2014/main" id="{5295B11D-0C97-47AE-B41E-1B5810496A80}"/>
+                <a16:creationId xmlns:a16="http://schemas.microsoft.com/office/drawing/2014/main" id="{4E94D751-AD98-4B85-BA2D-DFDDB2E402CB}"/>
               </a:ext>
             </a:extLst>
           </p:cNvPr>
@@ -6607,7 +6607,7 @@
           <p:cNvPr id="20" name="">
             <a:extLst xmlns:a="http://schemas.openxmlformats.org/drawingml/2006/main">
               <a:ext uri="{FF2B5EF4-FFF2-40B4-BE49-F238E27FC236}">
-                <a16:creationId xmlns:a16="http://schemas.microsoft.com/office/drawing/2014/main" id="{A15D2101-8EE8-4624-B982-1A083E4EEE11}"/>
+                <a16:creationId xmlns:a16="http://schemas.microsoft.com/office/drawing/2014/main" id="{0BA9284A-165F-4851-B8B2-D96032CEBA36}"/>
               </a:ext>
             </a:extLst>
           </p:cNvPr>
@@ -6657,7 +6657,7 @@
           <p:cNvPr id="21" name="">
             <a:extLst xmlns:a="http://schemas.openxmlformats.org/drawingml/2006/main">
               <a:ext uri="{FF2B5EF4-FFF2-40B4-BE49-F238E27FC236}">
-                <a16:creationId xmlns:a16="http://schemas.microsoft.com/office/drawing/2014/main" id="{9883E36E-309F-4EC1-84ED-8639C5D6AFAE}"/>
+                <a16:creationId xmlns:a16="http://schemas.microsoft.com/office/drawing/2014/main" id="{519B8BB8-2E0A-4FD0-AF5D-75924AA4814C}"/>
               </a:ext>
             </a:extLst>
           </p:cNvPr>
@@ -6707,7 +6707,7 @@
           <p:cNvPr id="22" name="">
             <a:extLst xmlns:a="http://schemas.openxmlformats.org/drawingml/2006/main">
               <a:ext uri="{FF2B5EF4-FFF2-40B4-BE49-F238E27FC236}">
-                <a16:creationId xmlns:a16="http://schemas.microsoft.com/office/drawing/2014/main" id="{3A7AE3DD-2A88-45DF-A6A9-9B8AE1956887}"/>
+                <a16:creationId xmlns:a16="http://schemas.microsoft.com/office/drawing/2014/main" id="{4CA3DED2-77FA-4ACA-B08D-FC1B853F62F7}"/>
               </a:ext>
             </a:extLst>
           </p:cNvPr>
@@ -6757,7 +6757,7 @@
           <p:cNvPr id="23" name="">
             <a:extLst xmlns:a="http://schemas.openxmlformats.org/drawingml/2006/main">
               <a:ext uri="{FF2B5EF4-FFF2-40B4-BE49-F238E27FC236}">
-                <a16:creationId xmlns:a16="http://schemas.microsoft.com/office/drawing/2014/main" id="{C580FB3E-B77C-41EC-9F01-15883C1363AE}"/>
+                <a16:creationId xmlns:a16="http://schemas.microsoft.com/office/drawing/2014/main" id="{7AFE4188-3D3D-44BB-99A6-1397C57CCCDD}"/>
               </a:ext>
             </a:extLst>
           </p:cNvPr>
@@ -6788,7 +6788,7 @@
           <p:cNvPr id="24" name="source-12">
             <a:extLst xmlns:a="http://schemas.openxmlformats.org/drawingml/2006/main">
               <a:ext uri="{FF2B5EF4-FFF2-40B4-BE49-F238E27FC236}">
-                <a16:creationId xmlns:a16="http://schemas.microsoft.com/office/drawing/2014/main" id="{F4B1FD70-F49D-4DEA-B3FD-DAEB9AAD10F6}"/>
+                <a16:creationId xmlns:a16="http://schemas.microsoft.com/office/drawing/2014/main" id="{B8F62910-58CF-40A6-A4B7-FA65D0278A00}"/>
               </a:ext>
             </a:extLst>
           </p:cNvPr>
@@ -6838,7 +6838,7 @@
           <p:cNvPr id="25" name="page-12">
             <a:extLst xmlns:a="http://schemas.openxmlformats.org/drawingml/2006/main">
               <a:ext uri="{FF2B5EF4-FFF2-40B4-BE49-F238E27FC236}">
-                <a16:creationId xmlns:a16="http://schemas.microsoft.com/office/drawing/2014/main" id="{C3694267-DDCD-4F13-A65E-5CD99DC3C541}"/>
+                <a16:creationId xmlns:a16="http://schemas.microsoft.com/office/drawing/2014/main" id="{7EC30200-19A2-4891-BD17-137CBA043126}"/>
               </a:ext>
             </a:extLst>
           </p:cNvPr>
@@ -6886,7 +6886,7 @@
     </p:spTree>
     <p:extLst>
       <p:ext uri="{BB962C8B-B14F-4D97-AF65-F5344CB8AC3E}">
-        <p14:creationId xmlns:p14="http://schemas.microsoft.com/office/powerpoint/2010/main" val="354991230"/>
+        <p14:creationId xmlns:p14="http://schemas.microsoft.com/office/powerpoint/2010/main" val="1017265844"/>
       </p:ext>
     </p:extLst>
   </p:cSld>
@@ -6917,7 +6917,7 @@
           <p:cNvPr id="36" name="kicker-13">
             <a:extLst xmlns:a="http://schemas.openxmlformats.org/drawingml/2006/main">
               <a:ext uri="{FF2B5EF4-FFF2-40B4-BE49-F238E27FC236}">
-                <a16:creationId xmlns:a16="http://schemas.microsoft.com/office/drawing/2014/main" id="{08EA9D9F-EC07-4ED1-9C3C-B99F41F08C64}"/>
+                <a16:creationId xmlns:a16="http://schemas.microsoft.com/office/drawing/2014/main" id="{0C466CC3-4EF5-4797-95C8-39C14D76010D}"/>
               </a:ext>
             </a:extLst>
           </p:cNvPr>
@@ -6967,7 +6967,7 @@
           <p:cNvPr id="2" name="title-13">
             <a:extLst xmlns:a="http://schemas.openxmlformats.org/drawingml/2006/main">
               <a:ext uri="{FF2B5EF4-FFF2-40B4-BE49-F238E27FC236}">
-                <a16:creationId xmlns:a16="http://schemas.microsoft.com/office/drawing/2014/main" id="{5018F185-51D9-478E-99F1-B7A1656FB11C}"/>
+                <a16:creationId xmlns:a16="http://schemas.microsoft.com/office/drawing/2014/main" id="{887924BA-A17F-46D0-AFAC-0D932B4D4C16}"/>
               </a:ext>
             </a:extLst>
           </p:cNvPr>
@@ -7017,7 +7017,7 @@
           <p:cNvPr id="3" name="">
             <a:extLst xmlns:a="http://schemas.openxmlformats.org/drawingml/2006/main">
               <a:ext uri="{FF2B5EF4-FFF2-40B4-BE49-F238E27FC236}">
-                <a16:creationId xmlns:a16="http://schemas.microsoft.com/office/drawing/2014/main" id="{5E40B5B9-01B4-4F7B-B62E-F8B1B1C50DE9}"/>
+                <a16:creationId xmlns:a16="http://schemas.microsoft.com/office/drawing/2014/main" id="{748D8DEB-B59A-4F79-8F88-8042702C0EAF}"/>
               </a:ext>
             </a:extLst>
           </p:cNvPr>
@@ -7048,7 +7048,7 @@
           <p:cNvPr id="4" name="">
             <a:extLst xmlns:a="http://schemas.openxmlformats.org/drawingml/2006/main">
               <a:ext uri="{FF2B5EF4-FFF2-40B4-BE49-F238E27FC236}">
-                <a16:creationId xmlns:a16="http://schemas.microsoft.com/office/drawing/2014/main" id="{CFBC0D92-26ED-4BB3-8912-C31590318752}"/>
+                <a16:creationId xmlns:a16="http://schemas.microsoft.com/office/drawing/2014/main" id="{90A9084A-7CD1-4E6B-B143-4360A8C1604F}"/>
               </a:ext>
             </a:extLst>
           </p:cNvPr>
@@ -7098,7 +7098,7 @@
           <p:cNvPr id="5" name="">
             <a:extLst xmlns:a="http://schemas.openxmlformats.org/drawingml/2006/main">
               <a:ext uri="{FF2B5EF4-FFF2-40B4-BE49-F238E27FC236}">
-                <a16:creationId xmlns:a16="http://schemas.microsoft.com/office/drawing/2014/main" id="{2F397C4F-2226-4BEB-990C-AF900685E929}"/>
+                <a16:creationId xmlns:a16="http://schemas.microsoft.com/office/drawing/2014/main" id="{2D98BD9A-0FB0-431A-9D96-3DF0FF0D8FD2}"/>
               </a:ext>
             </a:extLst>
           </p:cNvPr>
@@ -7148,7 +7148,7 @@
           <p:cNvPr id="6" name="">
             <a:extLst xmlns:a="http://schemas.openxmlformats.org/drawingml/2006/main">
               <a:ext uri="{FF2B5EF4-FFF2-40B4-BE49-F238E27FC236}">
-                <a16:creationId xmlns:a16="http://schemas.microsoft.com/office/drawing/2014/main" id="{3D75A14C-365C-4EF5-9CC8-933281E20F74}"/>
+                <a16:creationId xmlns:a16="http://schemas.microsoft.com/office/drawing/2014/main" id="{E7E2AA45-4B95-4CBE-9C41-72490B633C48}"/>
               </a:ext>
             </a:extLst>
           </p:cNvPr>
@@ -7198,7 +7198,7 @@
           <p:cNvPr id="7" name="">
             <a:extLst xmlns:a="http://schemas.openxmlformats.org/drawingml/2006/main">
               <a:ext uri="{FF2B5EF4-FFF2-40B4-BE49-F238E27FC236}">
-                <a16:creationId xmlns:a16="http://schemas.microsoft.com/office/drawing/2014/main" id="{A198033B-F402-4D5A-832F-849F276455AA}"/>
+                <a16:creationId xmlns:a16="http://schemas.microsoft.com/office/drawing/2014/main" id="{727A0EB1-9204-4BF6-837C-7E08C076199E}"/>
               </a:ext>
             </a:extLst>
           </p:cNvPr>
@@ -7248,7 +7248,7 @@
           <p:cNvPr id="8" name="">
             <a:extLst xmlns:a="http://schemas.openxmlformats.org/drawingml/2006/main">
               <a:ext uri="{FF2B5EF4-FFF2-40B4-BE49-F238E27FC236}">
-                <a16:creationId xmlns:a16="http://schemas.microsoft.com/office/drawing/2014/main" id="{6E1AD017-5386-494E-BDFC-CAE0ABC1D16B}"/>
+                <a16:creationId xmlns:a16="http://schemas.microsoft.com/office/drawing/2014/main" id="{F801C81A-2B13-4FFA-B4DE-4419AD689DA0}"/>
               </a:ext>
             </a:extLst>
           </p:cNvPr>
@@ -7298,7 +7298,7 @@
           <p:cNvPr id="9" name="">
             <a:extLst xmlns:a="http://schemas.openxmlformats.org/drawingml/2006/main">
               <a:ext uri="{FF2B5EF4-FFF2-40B4-BE49-F238E27FC236}">
-                <a16:creationId xmlns:a16="http://schemas.microsoft.com/office/drawing/2014/main" id="{4D298023-F6BE-46C7-BEFA-D69CCD62743D}"/>
+                <a16:creationId xmlns:a16="http://schemas.microsoft.com/office/drawing/2014/main" id="{DE32986C-7DC8-4305-890C-EA98BC2A9BF0}"/>
               </a:ext>
             </a:extLst>
           </p:cNvPr>
@@ -7348,7 +7348,7 @@
           <p:cNvPr id="10" name="">
             <a:extLst xmlns:a="http://schemas.openxmlformats.org/drawingml/2006/main">
               <a:ext uri="{FF2B5EF4-FFF2-40B4-BE49-F238E27FC236}">
-                <a16:creationId xmlns:a16="http://schemas.microsoft.com/office/drawing/2014/main" id="{55D1B936-B455-4001-973F-C0E7C23C58C5}"/>
+                <a16:creationId xmlns:a16="http://schemas.microsoft.com/office/drawing/2014/main" id="{1E8D35E1-04A5-4C69-AEA3-E6FDA17159DE}"/>
               </a:ext>
             </a:extLst>
           </p:cNvPr>
@@ -7398,7 +7398,7 @@
           <p:cNvPr id="11" name="">
             <a:extLst xmlns:a="http://schemas.openxmlformats.org/drawingml/2006/main">
               <a:ext uri="{FF2B5EF4-FFF2-40B4-BE49-F238E27FC236}">
-                <a16:creationId xmlns:a16="http://schemas.microsoft.com/office/drawing/2014/main" id="{6B9F3450-B968-48EC-9B6B-4B7DFAF29ACF}"/>
+                <a16:creationId xmlns:a16="http://schemas.microsoft.com/office/drawing/2014/main" id="{C1FAA002-A40F-48B7-9EC0-0327C5154123}"/>
               </a:ext>
             </a:extLst>
           </p:cNvPr>
@@ -7448,7 +7448,7 @@
           <p:cNvPr id="12" name="">
             <a:extLst xmlns:a="http://schemas.openxmlformats.org/drawingml/2006/main">
               <a:ext uri="{FF2B5EF4-FFF2-40B4-BE49-F238E27FC236}">
-                <a16:creationId xmlns:a16="http://schemas.microsoft.com/office/drawing/2014/main" id="{7AFD2CB4-F2F5-4398-A2D8-9B81D9785296}"/>
+                <a16:creationId xmlns:a16="http://schemas.microsoft.com/office/drawing/2014/main" id="{10090DC0-D12E-4F94-8FA9-4A4CD92052B9}"/>
               </a:ext>
             </a:extLst>
           </p:cNvPr>
@@ -7498,7 +7498,7 @@
           <p:cNvPr id="13" name="">
             <a:extLst xmlns:a="http://schemas.openxmlformats.org/drawingml/2006/main">
               <a:ext uri="{FF2B5EF4-FFF2-40B4-BE49-F238E27FC236}">
-                <a16:creationId xmlns:a16="http://schemas.microsoft.com/office/drawing/2014/main" id="{98428F48-0294-4BA2-8DBD-09AA5047E48E}"/>
+                <a16:creationId xmlns:a16="http://schemas.microsoft.com/office/drawing/2014/main" id="{F07FA879-CA65-47A1-BB34-64F930A7AA59}"/>
               </a:ext>
             </a:extLst>
           </p:cNvPr>
@@ -7548,7 +7548,7 @@
           <p:cNvPr id="14" name="">
             <a:extLst xmlns:a="http://schemas.openxmlformats.org/drawingml/2006/main">
               <a:ext uri="{FF2B5EF4-FFF2-40B4-BE49-F238E27FC236}">
-                <a16:creationId xmlns:a16="http://schemas.microsoft.com/office/drawing/2014/main" id="{91FA80DF-536D-4349-BC1B-E3FC90B75D7D}"/>
+                <a16:creationId xmlns:a16="http://schemas.microsoft.com/office/drawing/2014/main" id="{9D736179-98E2-48D8-B00B-396CB0C7FB3E}"/>
               </a:ext>
             </a:extLst>
           </p:cNvPr>
@@ -7598,7 +7598,7 @@
           <p:cNvPr id="15" name="">
             <a:extLst xmlns:a="http://schemas.openxmlformats.org/drawingml/2006/main">
               <a:ext uri="{FF2B5EF4-FFF2-40B4-BE49-F238E27FC236}">
-                <a16:creationId xmlns:a16="http://schemas.microsoft.com/office/drawing/2014/main" id="{8E1117E8-3B0B-4839-BFC9-983FE7E5A829}"/>
+                <a16:creationId xmlns:a16="http://schemas.microsoft.com/office/drawing/2014/main" id="{10B8A889-846B-423C-BF1E-5E853023B0E2}"/>
               </a:ext>
             </a:extLst>
           </p:cNvPr>
@@ -7648,7 +7648,7 @@
           <p:cNvPr id="16" name="">
             <a:extLst xmlns:a="http://schemas.openxmlformats.org/drawingml/2006/main">
               <a:ext uri="{FF2B5EF4-FFF2-40B4-BE49-F238E27FC236}">
-                <a16:creationId xmlns:a16="http://schemas.microsoft.com/office/drawing/2014/main" id="{D8629289-A485-4D97-B6EE-19207F99550C}"/>
+                <a16:creationId xmlns:a16="http://schemas.microsoft.com/office/drawing/2014/main" id="{2B024ECE-0C41-4E5A-BBCD-6C5E3B887C9B}"/>
               </a:ext>
             </a:extLst>
           </p:cNvPr>
@@ -7679,7 +7679,7 @@
           <p:cNvPr id="17" name="">
             <a:extLst xmlns:a="http://schemas.openxmlformats.org/drawingml/2006/main">
               <a:ext uri="{FF2B5EF4-FFF2-40B4-BE49-F238E27FC236}">
-                <a16:creationId xmlns:a16="http://schemas.microsoft.com/office/drawing/2014/main" id="{6EFDAE9A-E5D4-4354-805F-E861FA7B7223}"/>
+                <a16:creationId xmlns:a16="http://schemas.microsoft.com/office/drawing/2014/main" id="{3A1F61E5-FC10-4FCC-8811-1016F97E74B0}"/>
               </a:ext>
             </a:extLst>
           </p:cNvPr>
@@ -7729,7 +7729,7 @@
           <p:cNvPr id="18" name="">
             <a:extLst xmlns:a="http://schemas.openxmlformats.org/drawingml/2006/main">
               <a:ext uri="{FF2B5EF4-FFF2-40B4-BE49-F238E27FC236}">
-                <a16:creationId xmlns:a16="http://schemas.microsoft.com/office/drawing/2014/main" id="{B2152F5D-FE26-4A78-93A1-A2C7D60289E9}"/>
+                <a16:creationId xmlns:a16="http://schemas.microsoft.com/office/drawing/2014/main" id="{97740A33-1BD9-4599-82FF-2E3AFC9AFD7C}"/>
               </a:ext>
             </a:extLst>
           </p:cNvPr>
@@ -7779,7 +7779,7 @@
           <p:cNvPr id="19" name="">
             <a:extLst xmlns:a="http://schemas.openxmlformats.org/drawingml/2006/main">
               <a:ext uri="{FF2B5EF4-FFF2-40B4-BE49-F238E27FC236}">
-                <a16:creationId xmlns:a16="http://schemas.microsoft.com/office/drawing/2014/main" id="{8CE0A63C-0E06-486A-AB8D-B692AF11BFE5}"/>
+                <a16:creationId xmlns:a16="http://schemas.microsoft.com/office/drawing/2014/main" id="{23D99702-D470-48CF-B482-2D63138D2594}"/>
               </a:ext>
             </a:extLst>
           </p:cNvPr>
@@ -7829,7 +7829,7 @@
           <p:cNvPr id="20" name="">
             <a:extLst xmlns:a="http://schemas.openxmlformats.org/drawingml/2006/main">
               <a:ext uri="{FF2B5EF4-FFF2-40B4-BE49-F238E27FC236}">
-                <a16:creationId xmlns:a16="http://schemas.microsoft.com/office/drawing/2014/main" id="{7984AB67-C415-4E24-BD35-78112A32D027}"/>
+                <a16:creationId xmlns:a16="http://schemas.microsoft.com/office/drawing/2014/main" id="{C506263C-6F55-407D-BD19-45D6F495E5D3}"/>
               </a:ext>
             </a:extLst>
           </p:cNvPr>
@@ -7860,7 +7860,7 @@
           <p:cNvPr id="21" name="">
             <a:extLst xmlns:a="http://schemas.openxmlformats.org/drawingml/2006/main">
               <a:ext uri="{FF2B5EF4-FFF2-40B4-BE49-F238E27FC236}">
-                <a16:creationId xmlns:a16="http://schemas.microsoft.com/office/drawing/2014/main" id="{CCF30C90-B9CF-4884-9766-3663C9D992BE}"/>
+                <a16:creationId xmlns:a16="http://schemas.microsoft.com/office/drawing/2014/main" id="{E8876211-06A3-4E95-9C3D-BD517953AA88}"/>
               </a:ext>
             </a:extLst>
           </p:cNvPr>
@@ -7910,7 +7910,7 @@
           <p:cNvPr id="22" name="">
             <a:extLst xmlns:a="http://schemas.openxmlformats.org/drawingml/2006/main">
               <a:ext uri="{FF2B5EF4-FFF2-40B4-BE49-F238E27FC236}">
-                <a16:creationId xmlns:a16="http://schemas.microsoft.com/office/drawing/2014/main" id="{81DEB01B-E6FF-414F-8487-411C8D4B7135}"/>
+                <a16:creationId xmlns:a16="http://schemas.microsoft.com/office/drawing/2014/main" id="{4C785A94-8BD8-4B48-B91D-F637AAC73A80}"/>
               </a:ext>
             </a:extLst>
           </p:cNvPr>
@@ -7960,7 +7960,7 @@
           <p:cNvPr id="23" name="">
             <a:extLst xmlns:a="http://schemas.openxmlformats.org/drawingml/2006/main">
               <a:ext uri="{FF2B5EF4-FFF2-40B4-BE49-F238E27FC236}">
-                <a16:creationId xmlns:a16="http://schemas.microsoft.com/office/drawing/2014/main" id="{47F86FB5-EAD1-4BB6-869C-BE34FBF1972E}"/>
+                <a16:creationId xmlns:a16="http://schemas.microsoft.com/office/drawing/2014/main" id="{2B08E3F7-798F-4D63-934C-4DCF18631BF1}"/>
               </a:ext>
             </a:extLst>
           </p:cNvPr>
@@ -8010,7 +8010,7 @@
           <p:cNvPr id="24" name="">
             <a:extLst xmlns:a="http://schemas.openxmlformats.org/drawingml/2006/main">
               <a:ext uri="{FF2B5EF4-FFF2-40B4-BE49-F238E27FC236}">
-                <a16:creationId xmlns:a16="http://schemas.microsoft.com/office/drawing/2014/main" id="{496A3353-8AB7-4B88-9135-2E7B3E35D662}"/>
+                <a16:creationId xmlns:a16="http://schemas.microsoft.com/office/drawing/2014/main" id="{274F37A5-CE07-4030-AE48-462B2EDA6FEC}"/>
               </a:ext>
             </a:extLst>
           </p:cNvPr>
@@ -8041,7 +8041,7 @@
           <p:cNvPr id="25" name="">
             <a:extLst xmlns:a="http://schemas.openxmlformats.org/drawingml/2006/main">
               <a:ext uri="{FF2B5EF4-FFF2-40B4-BE49-F238E27FC236}">
-                <a16:creationId xmlns:a16="http://schemas.microsoft.com/office/drawing/2014/main" id="{B006009F-078C-4E88-BCC3-C1514C940648}"/>
+                <a16:creationId xmlns:a16="http://schemas.microsoft.com/office/drawing/2014/main" id="{CA7AA93C-B60A-4EF5-9180-F4A51EDA23D6}"/>
               </a:ext>
             </a:extLst>
           </p:cNvPr>
@@ -8091,7 +8091,7 @@
           <p:cNvPr id="26" name="">
             <a:extLst xmlns:a="http://schemas.openxmlformats.org/drawingml/2006/main">
               <a:ext uri="{FF2B5EF4-FFF2-40B4-BE49-F238E27FC236}">
-                <a16:creationId xmlns:a16="http://schemas.microsoft.com/office/drawing/2014/main" id="{1EF7B33F-A39F-4E0C-92FD-125D8A57CED1}"/>
+                <a16:creationId xmlns:a16="http://schemas.microsoft.com/office/drawing/2014/main" id="{83B89B7D-314D-4F19-934C-5230FDD36CEE}"/>
               </a:ext>
             </a:extLst>
           </p:cNvPr>
@@ -8141,7 +8141,7 @@
           <p:cNvPr id="27" name="">
             <a:extLst xmlns:a="http://schemas.openxmlformats.org/drawingml/2006/main">
               <a:ext uri="{FF2B5EF4-FFF2-40B4-BE49-F238E27FC236}">
-                <a16:creationId xmlns:a16="http://schemas.microsoft.com/office/drawing/2014/main" id="{24BC2A87-C8B9-4975-9CD4-836DEF2D99AE}"/>
+                <a16:creationId xmlns:a16="http://schemas.microsoft.com/office/drawing/2014/main" id="{3BC26C90-C3C5-4322-8034-213B2F6F1FA0}"/>
               </a:ext>
             </a:extLst>
           </p:cNvPr>
@@ -8191,7 +8191,7 @@
           <p:cNvPr id="28" name="">
             <a:extLst xmlns:a="http://schemas.openxmlformats.org/drawingml/2006/main">
               <a:ext uri="{FF2B5EF4-FFF2-40B4-BE49-F238E27FC236}">
-                <a16:creationId xmlns:a16="http://schemas.microsoft.com/office/drawing/2014/main" id="{19CB0DC9-9C82-4718-922E-1B3EFF4F1B43}"/>
+                <a16:creationId xmlns:a16="http://schemas.microsoft.com/office/drawing/2014/main" id="{7EDF4748-962A-4A86-AF1D-6D1B26FB066F}"/>
               </a:ext>
             </a:extLst>
           </p:cNvPr>
@@ -8222,7 +8222,7 @@
           <p:cNvPr id="29" name="">
             <a:extLst xmlns:a="http://schemas.openxmlformats.org/drawingml/2006/main">
               <a:ext uri="{FF2B5EF4-FFF2-40B4-BE49-F238E27FC236}">
-                <a16:creationId xmlns:a16="http://schemas.microsoft.com/office/drawing/2014/main" id="{1177DB08-2315-425E-8DE6-BEC9DA898FE7}"/>
+                <a16:creationId xmlns:a16="http://schemas.microsoft.com/office/drawing/2014/main" id="{D5412DAA-23BC-4E0A-A094-368FE215360A}"/>
               </a:ext>
             </a:extLst>
           </p:cNvPr>
@@ -8257,7 +8257,7 @@
           <p:cNvPr id="30" name="">
             <a:extLst xmlns:a="http://schemas.openxmlformats.org/drawingml/2006/main">
               <a:ext uri="{FF2B5EF4-FFF2-40B4-BE49-F238E27FC236}">
-                <a16:creationId xmlns:a16="http://schemas.microsoft.com/office/drawing/2014/main" id="{0A265FEC-707E-4569-AE68-8EC680629154}"/>
+                <a16:creationId xmlns:a16="http://schemas.microsoft.com/office/drawing/2014/main" id="{4E84315F-27F1-4B01-8D39-828271D8EAA7}"/>
               </a:ext>
             </a:extLst>
           </p:cNvPr>
@@ -8292,7 +8292,7 @@
           <p:cNvPr id="31" name="">
             <a:extLst xmlns:a="http://schemas.openxmlformats.org/drawingml/2006/main">
               <a:ext uri="{FF2B5EF4-FFF2-40B4-BE49-F238E27FC236}">
-                <a16:creationId xmlns:a16="http://schemas.microsoft.com/office/drawing/2014/main" id="{B753128A-E0A6-4D5D-AE3F-CE7533C33E65}"/>
+                <a16:creationId xmlns:a16="http://schemas.microsoft.com/office/drawing/2014/main" id="{B94F726D-F0A2-4C1B-905A-84E6E4BDED18}"/>
               </a:ext>
             </a:extLst>
           </p:cNvPr>
@@ -8342,7 +8342,7 @@
           <p:cNvPr id="32" name="">
             <a:extLst xmlns:a="http://schemas.openxmlformats.org/drawingml/2006/main">
               <a:ext uri="{FF2B5EF4-FFF2-40B4-BE49-F238E27FC236}">
-                <a16:creationId xmlns:a16="http://schemas.microsoft.com/office/drawing/2014/main" id="{356B1403-E9A7-4FA9-BFCE-14296DC971D6}"/>
+                <a16:creationId xmlns:a16="http://schemas.microsoft.com/office/drawing/2014/main" id="{CDF2B8BA-98AB-47EC-893D-94226D5D9301}"/>
               </a:ext>
             </a:extLst>
           </p:cNvPr>
@@ -8392,7 +8392,7 @@
           <p:cNvPr id="33" name="">
             <a:extLst xmlns:a="http://schemas.openxmlformats.org/drawingml/2006/main">
               <a:ext uri="{FF2B5EF4-FFF2-40B4-BE49-F238E27FC236}">
-                <a16:creationId xmlns:a16="http://schemas.microsoft.com/office/drawing/2014/main" id="{F0A5D704-9272-46AF-8EB7-C27A53F3BAB0}"/>
+                <a16:creationId xmlns:a16="http://schemas.microsoft.com/office/drawing/2014/main" id="{6E4FA2EB-35C1-4CA9-8F5E-D65AB7E882CA}"/>
               </a:ext>
             </a:extLst>
           </p:cNvPr>
@@ -8423,7 +8423,7 @@
           <p:cNvPr id="34" name="source-13">
             <a:extLst xmlns:a="http://schemas.openxmlformats.org/drawingml/2006/main">
               <a:ext uri="{FF2B5EF4-FFF2-40B4-BE49-F238E27FC236}">
-                <a16:creationId xmlns:a16="http://schemas.microsoft.com/office/drawing/2014/main" id="{725E7AB9-4889-4872-8C53-79C55DCEF491}"/>
+                <a16:creationId xmlns:a16="http://schemas.microsoft.com/office/drawing/2014/main" id="{6D0444CC-4F2A-4BF0-9FDF-D0C73F62D3CD}"/>
               </a:ext>
             </a:extLst>
           </p:cNvPr>
@@ -8473,7 +8473,7 @@
           <p:cNvPr id="35" name="page-13">
             <a:extLst xmlns:a="http://schemas.openxmlformats.org/drawingml/2006/main">
               <a:ext uri="{FF2B5EF4-FFF2-40B4-BE49-F238E27FC236}">
-                <a16:creationId xmlns:a16="http://schemas.microsoft.com/office/drawing/2014/main" id="{A98E0FB1-2128-434C-A9ED-EDD83261C846}"/>
+                <a16:creationId xmlns:a16="http://schemas.microsoft.com/office/drawing/2014/main" id="{ACA95DE3-E39C-4AE2-91C6-F15BB5E3294E}"/>
               </a:ext>
             </a:extLst>
           </p:cNvPr>
@@ -8521,7 +8521,7 @@
     </p:spTree>
     <p:extLst>
       <p:ext uri="{BB962C8B-B14F-4D97-AF65-F5344CB8AC3E}">
-        <p14:creationId xmlns:p14="http://schemas.microsoft.com/office/powerpoint/2010/main" val="1740923909"/>
+        <p14:creationId xmlns:p14="http://schemas.microsoft.com/office/powerpoint/2010/main" val="742856922"/>
       </p:ext>
     </p:extLst>
   </p:cSld>
@@ -8552,7 +8552,7 @@
           <p:cNvPr id="31" name="kicker-14">
             <a:extLst xmlns:a="http://schemas.openxmlformats.org/drawingml/2006/main">
               <a:ext uri="{FF2B5EF4-FFF2-40B4-BE49-F238E27FC236}">
-                <a16:creationId xmlns:a16="http://schemas.microsoft.com/office/drawing/2014/main" id="{90D67FD6-7C22-4496-820C-9D101441F6C9}"/>
+                <a16:creationId xmlns:a16="http://schemas.microsoft.com/office/drawing/2014/main" id="{778E196D-2725-4F92-858B-AF0A4D4004F3}"/>
               </a:ext>
             </a:extLst>
           </p:cNvPr>
@@ -8602,7 +8602,7 @@
           <p:cNvPr id="2" name="title-14">
             <a:extLst xmlns:a="http://schemas.openxmlformats.org/drawingml/2006/main">
               <a:ext uri="{FF2B5EF4-FFF2-40B4-BE49-F238E27FC236}">
-                <a16:creationId xmlns:a16="http://schemas.microsoft.com/office/drawing/2014/main" id="{3F7CABC6-783A-4D4D-8E86-9EDEF2FEA466}"/>
+                <a16:creationId xmlns:a16="http://schemas.microsoft.com/office/drawing/2014/main" id="{36D90E81-5867-4FC9-AACC-DC19CACFE779}"/>
               </a:ext>
             </a:extLst>
           </p:cNvPr>
@@ -8642,7 +8642,7 @@
                   <a:srgbClr val="0F172A"/>
                 </a:solidFill>
               </a:rPr>
-              <a:t>Phase 2 coverage fell from 93.72% to 4.14%</a:t>
+              <a:t>Phase 2 source shift collapsed deterministic coverage</a:t>
             </a:r>
           </a:p>
         </p:txBody>
@@ -8652,7 +8652,7 @@
           <p:cNvPr id="3" name="">
             <a:extLst xmlns:a="http://schemas.openxmlformats.org/drawingml/2006/main">
               <a:ext uri="{FF2B5EF4-FFF2-40B4-BE49-F238E27FC236}">
-                <a16:creationId xmlns:a16="http://schemas.microsoft.com/office/drawing/2014/main" id="{432ABE0A-ABC8-4F99-B344-5275C60E3EAC}"/>
+                <a16:creationId xmlns:a16="http://schemas.microsoft.com/office/drawing/2014/main" id="{AB556682-DB6F-4C52-ACBD-A0336EA8CADC}"/>
               </a:ext>
             </a:extLst>
           </p:cNvPr>
@@ -8683,7 +8683,7 @@
           <p:cNvPr id="4" name="">
             <a:extLst xmlns:a="http://schemas.openxmlformats.org/drawingml/2006/main">
               <a:ext uri="{FF2B5EF4-FFF2-40B4-BE49-F238E27FC236}">
-                <a16:creationId xmlns:a16="http://schemas.microsoft.com/office/drawing/2014/main" id="{E597357D-9B7F-405B-BA66-CB3CFB4D2FB1}"/>
+                <a16:creationId xmlns:a16="http://schemas.microsoft.com/office/drawing/2014/main" id="{BE2A6903-5116-46AD-899C-284AF1F24CBD}"/>
               </a:ext>
             </a:extLst>
           </p:cNvPr>
@@ -8733,7 +8733,7 @@
           <p:cNvPr id="5" name="">
             <a:extLst xmlns:a="http://schemas.openxmlformats.org/drawingml/2006/main">
               <a:ext uri="{FF2B5EF4-FFF2-40B4-BE49-F238E27FC236}">
-                <a16:creationId xmlns:a16="http://schemas.microsoft.com/office/drawing/2014/main" id="{96E4D679-9253-445F-9A20-9CF23953E536}"/>
+                <a16:creationId xmlns:a16="http://schemas.microsoft.com/office/drawing/2014/main" id="{9518A7EE-BD2F-4D45-94A3-8109359D3644}"/>
               </a:ext>
             </a:extLst>
           </p:cNvPr>
@@ -8783,7 +8783,7 @@
           <p:cNvPr id="6" name="">
             <a:extLst xmlns:a="http://schemas.openxmlformats.org/drawingml/2006/main">
               <a:ext uri="{FF2B5EF4-FFF2-40B4-BE49-F238E27FC236}">
-                <a16:creationId xmlns:a16="http://schemas.microsoft.com/office/drawing/2014/main" id="{B5079DA5-24B1-43F8-9ED8-77E5439DADD9}"/>
+                <a16:creationId xmlns:a16="http://schemas.microsoft.com/office/drawing/2014/main" id="{33CB4680-C0BB-4030-8AB7-C64B9AF732C1}"/>
               </a:ext>
             </a:extLst>
           </p:cNvPr>
@@ -8833,7 +8833,7 @@
           <p:cNvPr id="7" name="">
             <a:extLst xmlns:a="http://schemas.openxmlformats.org/drawingml/2006/main">
               <a:ext uri="{FF2B5EF4-FFF2-40B4-BE49-F238E27FC236}">
-                <a16:creationId xmlns:a16="http://schemas.microsoft.com/office/drawing/2014/main" id="{ED6D5DCD-3578-4FB8-AAF5-4AD843FC0300}"/>
+                <a16:creationId xmlns:a16="http://schemas.microsoft.com/office/drawing/2014/main" id="{EB6B9885-07B8-4293-A7DA-9BFD4F82A9E6}"/>
               </a:ext>
             </a:extLst>
           </p:cNvPr>
@@ -8864,7 +8864,7 @@
           <p:cNvPr id="8" name="">
             <a:extLst xmlns:a="http://schemas.openxmlformats.org/drawingml/2006/main">
               <a:ext uri="{FF2B5EF4-FFF2-40B4-BE49-F238E27FC236}">
-                <a16:creationId xmlns:a16="http://schemas.microsoft.com/office/drawing/2014/main" id="{B9612770-CDB8-42F1-811D-FF6AA77A9CD0}"/>
+                <a16:creationId xmlns:a16="http://schemas.microsoft.com/office/drawing/2014/main" id="{C60DF267-96DE-429F-8F17-9440E1976E2A}"/>
               </a:ext>
             </a:extLst>
           </p:cNvPr>
@@ -8914,7 +8914,7 @@
           <p:cNvPr id="9" name="">
             <a:extLst xmlns:a="http://schemas.openxmlformats.org/drawingml/2006/main">
               <a:ext uri="{FF2B5EF4-FFF2-40B4-BE49-F238E27FC236}">
-                <a16:creationId xmlns:a16="http://schemas.microsoft.com/office/drawing/2014/main" id="{EBE5E054-2586-4668-B38B-8C1363EA30F5}"/>
+                <a16:creationId xmlns:a16="http://schemas.microsoft.com/office/drawing/2014/main" id="{42E105E1-B083-40FB-A908-C9CF151A5FB6}"/>
               </a:ext>
             </a:extLst>
           </p:cNvPr>
@@ -8964,7 +8964,7 @@
           <p:cNvPr id="10" name="">
             <a:extLst xmlns:a="http://schemas.openxmlformats.org/drawingml/2006/main">
               <a:ext uri="{FF2B5EF4-FFF2-40B4-BE49-F238E27FC236}">
-                <a16:creationId xmlns:a16="http://schemas.microsoft.com/office/drawing/2014/main" id="{04E856E9-F47F-4F8D-B860-4D0A4AF45C1B}"/>
+                <a16:creationId xmlns:a16="http://schemas.microsoft.com/office/drawing/2014/main" id="{0103BA9F-BE3F-4875-B4A5-24DCB8A22BCD}"/>
               </a:ext>
             </a:extLst>
           </p:cNvPr>
@@ -8995,7 +8995,7 @@
           <p:cNvPr id="11" name="">
             <a:extLst xmlns:a="http://schemas.openxmlformats.org/drawingml/2006/main">
               <a:ext uri="{FF2B5EF4-FFF2-40B4-BE49-F238E27FC236}">
-                <a16:creationId xmlns:a16="http://schemas.microsoft.com/office/drawing/2014/main" id="{3A43B170-DB6D-4238-AB2D-F103E8555C36}"/>
+                <a16:creationId xmlns:a16="http://schemas.microsoft.com/office/drawing/2014/main" id="{6F9EA1E7-31B0-4C34-B60A-BD2BC5E4D092}"/>
               </a:ext>
             </a:extLst>
           </p:cNvPr>
@@ -9045,7 +9045,7 @@
           <p:cNvPr id="12" name="">
             <a:extLst xmlns:a="http://schemas.openxmlformats.org/drawingml/2006/main">
               <a:ext uri="{FF2B5EF4-FFF2-40B4-BE49-F238E27FC236}">
-                <a16:creationId xmlns:a16="http://schemas.microsoft.com/office/drawing/2014/main" id="{F23404EE-AD2B-4ACF-811F-89F5C2E206F9}"/>
+                <a16:creationId xmlns:a16="http://schemas.microsoft.com/office/drawing/2014/main" id="{E0A853A8-6013-4F40-B318-5EE9F3236D96}"/>
               </a:ext>
             </a:extLst>
           </p:cNvPr>
@@ -9095,7 +9095,7 @@
           <p:cNvPr id="13" name="">
             <a:extLst xmlns:a="http://schemas.openxmlformats.org/drawingml/2006/main">
               <a:ext uri="{FF2B5EF4-FFF2-40B4-BE49-F238E27FC236}">
-                <a16:creationId xmlns:a16="http://schemas.microsoft.com/office/drawing/2014/main" id="{005A0F57-D679-4AD9-92EF-F4256278169C}"/>
+                <a16:creationId xmlns:a16="http://schemas.microsoft.com/office/drawing/2014/main" id="{BE604AC9-539C-4A3D-965A-3679558E0D57}"/>
               </a:ext>
             </a:extLst>
           </p:cNvPr>
@@ -9126,7 +9126,7 @@
           <p:cNvPr id="14" name="">
             <a:extLst xmlns:a="http://schemas.openxmlformats.org/drawingml/2006/main">
               <a:ext uri="{FF2B5EF4-FFF2-40B4-BE49-F238E27FC236}">
-                <a16:creationId xmlns:a16="http://schemas.microsoft.com/office/drawing/2014/main" id="{8D4F667B-438C-4F6D-AF65-29326ED76263}"/>
+                <a16:creationId xmlns:a16="http://schemas.microsoft.com/office/drawing/2014/main" id="{B616F080-F6A1-4EAB-865C-E979113DAE07}"/>
               </a:ext>
             </a:extLst>
           </p:cNvPr>
@@ -9176,7 +9176,7 @@
           <p:cNvPr id="15" name="">
             <a:extLst xmlns:a="http://schemas.openxmlformats.org/drawingml/2006/main">
               <a:ext uri="{FF2B5EF4-FFF2-40B4-BE49-F238E27FC236}">
-                <a16:creationId xmlns:a16="http://schemas.microsoft.com/office/drawing/2014/main" id="{C0209546-552E-4845-8565-EDA4103256F7}"/>
+                <a16:creationId xmlns:a16="http://schemas.microsoft.com/office/drawing/2014/main" id="{47395962-9662-47C8-B8B7-3F283C4C8851}"/>
               </a:ext>
             </a:extLst>
           </p:cNvPr>
@@ -9226,7 +9226,7 @@
           <p:cNvPr id="16" name="">
             <a:extLst xmlns:a="http://schemas.openxmlformats.org/drawingml/2006/main">
               <a:ext uri="{FF2B5EF4-FFF2-40B4-BE49-F238E27FC236}">
-                <a16:creationId xmlns:a16="http://schemas.microsoft.com/office/drawing/2014/main" id="{AAF5F9AD-8B8F-4B53-B8E6-FB097C3AA433}"/>
+                <a16:creationId xmlns:a16="http://schemas.microsoft.com/office/drawing/2014/main" id="{FA982134-CBFC-4EC0-93E4-11289BCFC1CA}"/>
               </a:ext>
             </a:extLst>
           </p:cNvPr>
@@ -9257,7 +9257,7 @@
           <p:cNvPr id="17" name="">
             <a:extLst xmlns:a="http://schemas.openxmlformats.org/drawingml/2006/main">
               <a:ext uri="{FF2B5EF4-FFF2-40B4-BE49-F238E27FC236}">
-                <a16:creationId xmlns:a16="http://schemas.microsoft.com/office/drawing/2014/main" id="{0E4359D6-330E-4A32-AEA8-B5A2CAB1C605}"/>
+                <a16:creationId xmlns:a16="http://schemas.microsoft.com/office/drawing/2014/main" id="{0B2535B6-7B89-4D18-99BF-8D2C534ED0B8}"/>
               </a:ext>
             </a:extLst>
           </p:cNvPr>
@@ -9290,7 +9290,7 @@
           <p:cNvPr id="18" name="">
             <a:extLst xmlns:a="http://schemas.openxmlformats.org/drawingml/2006/main">
               <a:ext uri="{FF2B5EF4-FFF2-40B4-BE49-F238E27FC236}">
-                <a16:creationId xmlns:a16="http://schemas.microsoft.com/office/drawing/2014/main" id="{AD8A8FEC-6CCA-49D6-956B-FB9BCFDB7411}"/>
+                <a16:creationId xmlns:a16="http://schemas.microsoft.com/office/drawing/2014/main" id="{0F5617B3-FF5D-489F-A98F-5FE049A100FA}"/>
               </a:ext>
             </a:extLst>
           </p:cNvPr>
@@ -9323,7 +9323,7 @@
           <p:cNvPr id="19" name="">
             <a:extLst xmlns:a="http://schemas.openxmlformats.org/drawingml/2006/main">
               <a:ext uri="{FF2B5EF4-FFF2-40B4-BE49-F238E27FC236}">
-                <a16:creationId xmlns:a16="http://schemas.microsoft.com/office/drawing/2014/main" id="{AFD15C9F-E211-437F-A0C0-1E921F09EF0E}"/>
+                <a16:creationId xmlns:a16="http://schemas.microsoft.com/office/drawing/2014/main" id="{06213A73-FB80-4A96-B9FF-DE90960B58A3}"/>
               </a:ext>
             </a:extLst>
           </p:cNvPr>
@@ -9364,7 +9364,7 @@
           <p:cNvPr id="20" name="">
             <a:extLst xmlns:a="http://schemas.openxmlformats.org/drawingml/2006/main">
               <a:ext uri="{FF2B5EF4-FFF2-40B4-BE49-F238E27FC236}">
-                <a16:creationId xmlns:a16="http://schemas.microsoft.com/office/drawing/2014/main" id="{E6E4DE71-FF7C-4739-B015-DA736528DD65}"/>
+                <a16:creationId xmlns:a16="http://schemas.microsoft.com/office/drawing/2014/main" id="{47317BA4-7930-4AF5-8A52-90FE1C0D6CE8}"/>
               </a:ext>
             </a:extLst>
           </p:cNvPr>
@@ -9414,7 +9414,7 @@
           <p:cNvPr id="21" name="">
             <a:extLst xmlns:a="http://schemas.openxmlformats.org/drawingml/2006/main">
               <a:ext uri="{FF2B5EF4-FFF2-40B4-BE49-F238E27FC236}">
-                <a16:creationId xmlns:a16="http://schemas.microsoft.com/office/drawing/2014/main" id="{718D6CCF-2A9A-4513-9513-1B1E1E7202CB}"/>
+                <a16:creationId xmlns:a16="http://schemas.microsoft.com/office/drawing/2014/main" id="{807AB4F3-92DF-4358-B926-941593041E10}"/>
               </a:ext>
             </a:extLst>
           </p:cNvPr>
@@ -9498,7 +9498,7 @@
           <p:cNvPr id="22" name="">
             <a:extLst xmlns:a="http://schemas.openxmlformats.org/drawingml/2006/main">
               <a:ext uri="{FF2B5EF4-FFF2-40B4-BE49-F238E27FC236}">
-                <a16:creationId xmlns:a16="http://schemas.microsoft.com/office/drawing/2014/main" id="{B8997795-4E3C-4A0C-9C26-478DF0D2BCF6}"/>
+                <a16:creationId xmlns:a16="http://schemas.microsoft.com/office/drawing/2014/main" id="{98A41139-E6A1-4B40-9E6D-10F774A9947A}"/>
               </a:ext>
             </a:extLst>
           </p:cNvPr>
@@ -9539,7 +9539,7 @@
           <p:cNvPr id="23" name="">
             <a:extLst xmlns:a="http://schemas.openxmlformats.org/drawingml/2006/main">
               <a:ext uri="{FF2B5EF4-FFF2-40B4-BE49-F238E27FC236}">
-                <a16:creationId xmlns:a16="http://schemas.microsoft.com/office/drawing/2014/main" id="{BE2A5FD6-E187-4422-8D4E-F51C344F3347}"/>
+                <a16:creationId xmlns:a16="http://schemas.microsoft.com/office/drawing/2014/main" id="{9824B898-0D03-4185-9475-A3503B29BE4B}"/>
               </a:ext>
             </a:extLst>
           </p:cNvPr>
@@ -9589,7 +9589,7 @@
           <p:cNvPr id="24" name="">
             <a:extLst xmlns:a="http://schemas.openxmlformats.org/drawingml/2006/main">
               <a:ext uri="{FF2B5EF4-FFF2-40B4-BE49-F238E27FC236}">
-                <a16:creationId xmlns:a16="http://schemas.microsoft.com/office/drawing/2014/main" id="{E8282D56-791D-4176-8B23-062C8FB8E2B6}"/>
+                <a16:creationId xmlns:a16="http://schemas.microsoft.com/office/drawing/2014/main" id="{7221EA17-6231-4DB3-834C-236C38E68A8A}"/>
               </a:ext>
             </a:extLst>
           </p:cNvPr>
@@ -9673,7 +9673,7 @@
           <p:cNvPr id="25" name="">
             <a:extLst xmlns:a="http://schemas.openxmlformats.org/drawingml/2006/main">
               <a:ext uri="{FF2B5EF4-FFF2-40B4-BE49-F238E27FC236}">
-                <a16:creationId xmlns:a16="http://schemas.microsoft.com/office/drawing/2014/main" id="{2C4AFD94-B50B-43F2-B81C-FE9CD5CA5692}"/>
+                <a16:creationId xmlns:a16="http://schemas.microsoft.com/office/drawing/2014/main" id="{68952354-BF2A-4868-9D17-8A9DD060E671}"/>
               </a:ext>
             </a:extLst>
           </p:cNvPr>
@@ -9708,7 +9708,7 @@
           <p:cNvPr id="26" name="">
             <a:extLst xmlns:a="http://schemas.openxmlformats.org/drawingml/2006/main">
               <a:ext uri="{FF2B5EF4-FFF2-40B4-BE49-F238E27FC236}">
-                <a16:creationId xmlns:a16="http://schemas.microsoft.com/office/drawing/2014/main" id="{37823AFC-E6FF-4F38-9421-F867252AD7BE}"/>
+                <a16:creationId xmlns:a16="http://schemas.microsoft.com/office/drawing/2014/main" id="{6C0405BB-CB3F-4C96-8187-1392984E63D4}"/>
               </a:ext>
             </a:extLst>
           </p:cNvPr>
@@ -9758,7 +9758,7 @@
           <p:cNvPr id="27" name="">
             <a:extLst xmlns:a="http://schemas.openxmlformats.org/drawingml/2006/main">
               <a:ext uri="{FF2B5EF4-FFF2-40B4-BE49-F238E27FC236}">
-                <a16:creationId xmlns:a16="http://schemas.microsoft.com/office/drawing/2014/main" id="{DC09F3D9-CD25-4B3F-82D6-063D2462680B}"/>
+                <a16:creationId xmlns:a16="http://schemas.microsoft.com/office/drawing/2014/main" id="{D83826BB-977B-4FC1-9A4C-0F746D41FF6D}"/>
               </a:ext>
             </a:extLst>
           </p:cNvPr>
@@ -9808,7 +9808,7 @@
           <p:cNvPr id="28" name="">
             <a:extLst xmlns:a="http://schemas.openxmlformats.org/drawingml/2006/main">
               <a:ext uri="{FF2B5EF4-FFF2-40B4-BE49-F238E27FC236}">
-                <a16:creationId xmlns:a16="http://schemas.microsoft.com/office/drawing/2014/main" id="{406A6216-4B65-4017-A55A-76AF363FD0FB}"/>
+                <a16:creationId xmlns:a16="http://schemas.microsoft.com/office/drawing/2014/main" id="{AE0E8DA4-204A-412A-A005-0BF03F3F29D7}"/>
               </a:ext>
             </a:extLst>
           </p:cNvPr>
@@ -9839,7 +9839,7 @@
           <p:cNvPr id="29" name="source-14">
             <a:extLst xmlns:a="http://schemas.openxmlformats.org/drawingml/2006/main">
               <a:ext uri="{FF2B5EF4-FFF2-40B4-BE49-F238E27FC236}">
-                <a16:creationId xmlns:a16="http://schemas.microsoft.com/office/drawing/2014/main" id="{84FD9FD3-DB92-4712-800C-138C4A191EC6}"/>
+                <a16:creationId xmlns:a16="http://schemas.microsoft.com/office/drawing/2014/main" id="{4FA3102D-F1D3-41D0-B45F-9EDF6DC06D61}"/>
               </a:ext>
             </a:extLst>
           </p:cNvPr>
@@ -9889,7 +9889,7 @@
           <p:cNvPr id="30" name="page-14">
             <a:extLst xmlns:a="http://schemas.openxmlformats.org/drawingml/2006/main">
               <a:ext uri="{FF2B5EF4-FFF2-40B4-BE49-F238E27FC236}">
-                <a16:creationId xmlns:a16="http://schemas.microsoft.com/office/drawing/2014/main" id="{72F04BA8-7A6A-4771-9748-FB94CFC71CCF}"/>
+                <a16:creationId xmlns:a16="http://schemas.microsoft.com/office/drawing/2014/main" id="{76D6A106-1A20-40B0-8EC3-9F41BE3D5C2E}"/>
               </a:ext>
             </a:extLst>
           </p:cNvPr>
@@ -9937,7 +9937,7 @@
     </p:spTree>
     <p:extLst>
       <p:ext uri="{BB962C8B-B14F-4D97-AF65-F5344CB8AC3E}">
-        <p14:creationId xmlns:p14="http://schemas.microsoft.com/office/powerpoint/2010/main" val="778424743"/>
+        <p14:creationId xmlns:p14="http://schemas.microsoft.com/office/powerpoint/2010/main" val="1618010076"/>
       </p:ext>
     </p:extLst>
   </p:cSld>
@@ -9968,7 +9968,7 @@
           <p:cNvPr id="17" name="">
             <a:extLst xmlns:a="http://schemas.openxmlformats.org/drawingml/2006/main">
               <a:ext uri="{FF2B5EF4-FFF2-40B4-BE49-F238E27FC236}">
-                <a16:creationId xmlns:a16="http://schemas.microsoft.com/office/drawing/2014/main" id="{3D2B50AA-DFFC-4F87-8BA8-3350B07A4ACD}"/>
+                <a16:creationId xmlns:a16="http://schemas.microsoft.com/office/drawing/2014/main" id="{6616C739-D264-4A19-B9FE-AABE1A83236C}"/>
               </a:ext>
             </a:extLst>
           </p:cNvPr>
@@ -10018,7 +10018,7 @@
           <p:cNvPr id="2" name="">
             <a:extLst xmlns:a="http://schemas.openxmlformats.org/drawingml/2006/main">
               <a:ext uri="{FF2B5EF4-FFF2-40B4-BE49-F238E27FC236}">
-                <a16:creationId xmlns:a16="http://schemas.microsoft.com/office/drawing/2014/main" id="{51C7C5F4-7E5B-4620-94EB-DE657B9A376A}"/>
+                <a16:creationId xmlns:a16="http://schemas.microsoft.com/office/drawing/2014/main" id="{B8B3FF84-160E-4361-B02F-D9C63E865594}"/>
               </a:ext>
             </a:extLst>
           </p:cNvPr>
@@ -10085,7 +10085,7 @@
           <p:cNvPr id="3" name="">
             <a:extLst xmlns:a="http://schemas.openxmlformats.org/drawingml/2006/main">
               <a:ext uri="{FF2B5EF4-FFF2-40B4-BE49-F238E27FC236}">
-                <a16:creationId xmlns:a16="http://schemas.microsoft.com/office/drawing/2014/main" id="{43EBAC11-86C0-45BC-958D-B5DAD62456DF}"/>
+                <a16:creationId xmlns:a16="http://schemas.microsoft.com/office/drawing/2014/main" id="{75BBE7C6-3143-4E17-A780-48C7BB2FC726}"/>
               </a:ext>
             </a:extLst>
           </p:cNvPr>
@@ -10126,7 +10126,7 @@
           <p:cNvPr id="4" name="">
             <a:extLst xmlns:a="http://schemas.openxmlformats.org/drawingml/2006/main">
               <a:ext uri="{FF2B5EF4-FFF2-40B4-BE49-F238E27FC236}">
-                <a16:creationId xmlns:a16="http://schemas.microsoft.com/office/drawing/2014/main" id="{CEE4A96C-DBBE-4B8F-902B-59972D8097CC}"/>
+                <a16:creationId xmlns:a16="http://schemas.microsoft.com/office/drawing/2014/main" id="{DE44C291-17C9-4B82-8B65-CF3931D5CB4F}"/>
               </a:ext>
             </a:extLst>
           </p:cNvPr>
@@ -10176,7 +10176,7 @@
           <p:cNvPr id="5" name="">
             <a:extLst xmlns:a="http://schemas.openxmlformats.org/drawingml/2006/main">
               <a:ext uri="{FF2B5EF4-FFF2-40B4-BE49-F238E27FC236}">
-                <a16:creationId xmlns:a16="http://schemas.microsoft.com/office/drawing/2014/main" id="{1C74FDB9-754D-4D83-B38D-038B8DBBCDD8}"/>
+                <a16:creationId xmlns:a16="http://schemas.microsoft.com/office/drawing/2014/main" id="{86F83137-965E-44BC-8E52-6D374FBECF34}"/>
               </a:ext>
             </a:extLst>
           </p:cNvPr>
@@ -10260,7 +10260,7 @@
           <p:cNvPr id="6" name="">
             <a:extLst xmlns:a="http://schemas.openxmlformats.org/drawingml/2006/main">
               <a:ext uri="{FF2B5EF4-FFF2-40B4-BE49-F238E27FC236}">
-                <a16:creationId xmlns:a16="http://schemas.microsoft.com/office/drawing/2014/main" id="{E5723BA6-41F3-49CE-AC27-3992D8B30D10}"/>
+                <a16:creationId xmlns:a16="http://schemas.microsoft.com/office/drawing/2014/main" id="{2321D992-D4C0-4072-BCF7-7E04EBD6ABC3}"/>
               </a:ext>
             </a:extLst>
           </p:cNvPr>
@@ -10301,7 +10301,7 @@
           <p:cNvPr id="7" name="">
             <a:extLst xmlns:a="http://schemas.openxmlformats.org/drawingml/2006/main">
               <a:ext uri="{FF2B5EF4-FFF2-40B4-BE49-F238E27FC236}">
-                <a16:creationId xmlns:a16="http://schemas.microsoft.com/office/drawing/2014/main" id="{50C4BFE5-CDA4-4229-99BF-93F715CA3A57}"/>
+                <a16:creationId xmlns:a16="http://schemas.microsoft.com/office/drawing/2014/main" id="{18A2228D-6EFD-452E-9D0F-09B28D96F66B}"/>
               </a:ext>
             </a:extLst>
           </p:cNvPr>
@@ -10351,7 +10351,7 @@
           <p:cNvPr id="8" name="">
             <a:extLst xmlns:a="http://schemas.openxmlformats.org/drawingml/2006/main">
               <a:ext uri="{FF2B5EF4-FFF2-40B4-BE49-F238E27FC236}">
-                <a16:creationId xmlns:a16="http://schemas.microsoft.com/office/drawing/2014/main" id="{C0C036EE-AB2D-4902-BC6D-62CE99F8A340}"/>
+                <a16:creationId xmlns:a16="http://schemas.microsoft.com/office/drawing/2014/main" id="{FD280358-D10B-45F0-AC4E-6BA423BEDC44}"/>
               </a:ext>
             </a:extLst>
           </p:cNvPr>
@@ -10435,7 +10435,7 @@
           <p:cNvPr id="9" name="">
             <a:extLst xmlns:a="http://schemas.openxmlformats.org/drawingml/2006/main">
               <a:ext uri="{FF2B5EF4-FFF2-40B4-BE49-F238E27FC236}">
-                <a16:creationId xmlns:a16="http://schemas.microsoft.com/office/drawing/2014/main" id="{CFA44C56-0B3A-4043-A612-04BB67073B76}"/>
+                <a16:creationId xmlns:a16="http://schemas.microsoft.com/office/drawing/2014/main" id="{B77445E4-1673-44E7-AF1B-CD620468C0DB}"/>
               </a:ext>
             </a:extLst>
           </p:cNvPr>
@@ -10476,7 +10476,7 @@
           <p:cNvPr id="10" name="">
             <a:extLst xmlns:a="http://schemas.openxmlformats.org/drawingml/2006/main">
               <a:ext uri="{FF2B5EF4-FFF2-40B4-BE49-F238E27FC236}">
-                <a16:creationId xmlns:a16="http://schemas.microsoft.com/office/drawing/2014/main" id="{0B862DEC-19FB-420D-99D2-D67BE2978B42}"/>
+                <a16:creationId xmlns:a16="http://schemas.microsoft.com/office/drawing/2014/main" id="{4EFB1193-451E-42D3-8F57-2CB8BC379135}"/>
               </a:ext>
             </a:extLst>
           </p:cNvPr>
@@ -10526,7 +10526,7 @@
           <p:cNvPr id="11" name="">
             <a:extLst xmlns:a="http://schemas.openxmlformats.org/drawingml/2006/main">
               <a:ext uri="{FF2B5EF4-FFF2-40B4-BE49-F238E27FC236}">
-                <a16:creationId xmlns:a16="http://schemas.microsoft.com/office/drawing/2014/main" id="{605406C1-8011-4F17-93A8-B74555025ACA}"/>
+                <a16:creationId xmlns:a16="http://schemas.microsoft.com/office/drawing/2014/main" id="{E13FC635-A8D5-468B-A020-31711A46F769}"/>
               </a:ext>
             </a:extLst>
           </p:cNvPr>
@@ -10610,7 +10610,7 @@
           <p:cNvPr id="12" name="">
             <a:extLst xmlns:a="http://schemas.openxmlformats.org/drawingml/2006/main">
               <a:ext uri="{FF2B5EF4-FFF2-40B4-BE49-F238E27FC236}">
-                <a16:creationId xmlns:a16="http://schemas.microsoft.com/office/drawing/2014/main" id="{2E9D950B-3BBC-4A1D-9865-32242E8A2373}"/>
+                <a16:creationId xmlns:a16="http://schemas.microsoft.com/office/drawing/2014/main" id="{0FD96A9F-29D5-4DBE-BF72-66648174D902}"/>
               </a:ext>
             </a:extLst>
           </p:cNvPr>
@@ -10660,7 +10660,7 @@
           <p:cNvPr id="13" name="">
             <a:extLst xmlns:a="http://schemas.openxmlformats.org/drawingml/2006/main">
               <a:ext uri="{FF2B5EF4-FFF2-40B4-BE49-F238E27FC236}">
-                <a16:creationId xmlns:a16="http://schemas.microsoft.com/office/drawing/2014/main" id="{7E2E0417-E987-4F8B-B5EA-D15E9ACA17F4}"/>
+                <a16:creationId xmlns:a16="http://schemas.microsoft.com/office/drawing/2014/main" id="{2B8BAC1D-1097-4F60-A5D4-B655ADD582E0}"/>
               </a:ext>
             </a:extLst>
           </p:cNvPr>
@@ -10710,7 +10710,7 @@
           <p:cNvPr id="14" name="">
             <a:extLst xmlns:a="http://schemas.openxmlformats.org/drawingml/2006/main">
               <a:ext uri="{FF2B5EF4-FFF2-40B4-BE49-F238E27FC236}">
-                <a16:creationId xmlns:a16="http://schemas.microsoft.com/office/drawing/2014/main" id="{8406EE11-AB56-47B3-B74E-EB39B9ACC2F3}"/>
+                <a16:creationId xmlns:a16="http://schemas.microsoft.com/office/drawing/2014/main" id="{F26472C0-E999-40D2-B18D-0EC85CC45D92}"/>
               </a:ext>
             </a:extLst>
           </p:cNvPr>
@@ -10741,7 +10741,7 @@
           <p:cNvPr id="15" name="">
             <a:extLst xmlns:a="http://schemas.openxmlformats.org/drawingml/2006/main">
               <a:ext uri="{FF2B5EF4-FFF2-40B4-BE49-F238E27FC236}">
-                <a16:creationId xmlns:a16="http://schemas.microsoft.com/office/drawing/2014/main" id="{640024BD-FD05-47A7-B818-F7394D7207E4}"/>
+                <a16:creationId xmlns:a16="http://schemas.microsoft.com/office/drawing/2014/main" id="{C214942F-05C0-4849-B65C-92859DD8C60C}"/>
               </a:ext>
             </a:extLst>
           </p:cNvPr>
@@ -10791,7 +10791,7 @@
           <p:cNvPr id="16" name="">
             <a:extLst xmlns:a="http://schemas.openxmlformats.org/drawingml/2006/main">
               <a:ext uri="{FF2B5EF4-FFF2-40B4-BE49-F238E27FC236}">
-                <a16:creationId xmlns:a16="http://schemas.microsoft.com/office/drawing/2014/main" id="{4317606A-48A7-4F30-B9F7-931B672D4E0D}"/>
+                <a16:creationId xmlns:a16="http://schemas.microsoft.com/office/drawing/2014/main" id="{2B1743CC-F08F-4114-8116-762006E60081}"/>
               </a:ext>
             </a:extLst>
           </p:cNvPr>
@@ -10839,7 +10839,7 @@
     </p:spTree>
     <p:extLst>
       <p:ext uri="{BB962C8B-B14F-4D97-AF65-F5344CB8AC3E}">
-        <p14:creationId xmlns:p14="http://schemas.microsoft.com/office/powerpoint/2010/main" val="136153475"/>
+        <p14:creationId xmlns:p14="http://schemas.microsoft.com/office/powerpoint/2010/main" val="721392785"/>
       </p:ext>
     </p:extLst>
   </p:cSld>
@@ -10870,7 +10870,7 @@
           <p:cNvPr id="30" name="kicker-2">
             <a:extLst xmlns:a="http://schemas.openxmlformats.org/drawingml/2006/main">
               <a:ext uri="{FF2B5EF4-FFF2-40B4-BE49-F238E27FC236}">
-                <a16:creationId xmlns:a16="http://schemas.microsoft.com/office/drawing/2014/main" id="{386DF953-A53E-4301-A436-82AD6D3369CA}"/>
+                <a16:creationId xmlns:a16="http://schemas.microsoft.com/office/drawing/2014/main" id="{CBCC5706-7307-4D31-AC8E-A2DBF72FA3C0}"/>
               </a:ext>
             </a:extLst>
           </p:cNvPr>
@@ -10920,7 +10920,7 @@
           <p:cNvPr id="2" name="title-2">
             <a:extLst xmlns:a="http://schemas.openxmlformats.org/drawingml/2006/main">
               <a:ext uri="{FF2B5EF4-FFF2-40B4-BE49-F238E27FC236}">
-                <a16:creationId xmlns:a16="http://schemas.microsoft.com/office/drawing/2014/main" id="{604E9483-2A49-48FC-9C61-4A11521AB285}"/>
+                <a16:creationId xmlns:a16="http://schemas.microsoft.com/office/drawing/2014/main" id="{40F38B53-F8D4-4969-8C43-48482A5EA540}"/>
               </a:ext>
             </a:extLst>
           </p:cNvPr>
@@ -10970,7 +10970,7 @@
           <p:cNvPr id="3" name="">
             <a:extLst xmlns:a="http://schemas.openxmlformats.org/drawingml/2006/main">
               <a:ext uri="{FF2B5EF4-FFF2-40B4-BE49-F238E27FC236}">
-                <a16:creationId xmlns:a16="http://schemas.microsoft.com/office/drawing/2014/main" id="{DA40D6AB-E12A-4CCF-908A-524087A75268}"/>
+                <a16:creationId xmlns:a16="http://schemas.microsoft.com/office/drawing/2014/main" id="{608FB724-CFA0-45BD-BFBF-85118BD67E61}"/>
               </a:ext>
             </a:extLst>
           </p:cNvPr>
@@ -11001,7 +11001,7 @@
           <p:cNvPr id="4" name="">
             <a:extLst xmlns:a="http://schemas.openxmlformats.org/drawingml/2006/main">
               <a:ext uri="{FF2B5EF4-FFF2-40B4-BE49-F238E27FC236}">
-                <a16:creationId xmlns:a16="http://schemas.microsoft.com/office/drawing/2014/main" id="{D271C44A-576F-4F5F-BC09-0E89C80B39AE}"/>
+                <a16:creationId xmlns:a16="http://schemas.microsoft.com/office/drawing/2014/main" id="{1C847C3C-4238-4E6B-B2C9-24AAF7EB60FF}"/>
               </a:ext>
             </a:extLst>
           </p:cNvPr>
@@ -11051,7 +11051,7 @@
           <p:cNvPr id="5" name="">
             <a:extLst xmlns:a="http://schemas.openxmlformats.org/drawingml/2006/main">
               <a:ext uri="{FF2B5EF4-FFF2-40B4-BE49-F238E27FC236}">
-                <a16:creationId xmlns:a16="http://schemas.microsoft.com/office/drawing/2014/main" id="{B6A35D4A-4BAF-4FC0-8CD8-F6195773D644}"/>
+                <a16:creationId xmlns:a16="http://schemas.microsoft.com/office/drawing/2014/main" id="{B64BA4ED-529A-4424-8F29-67C7D5269010}"/>
               </a:ext>
             </a:extLst>
           </p:cNvPr>
@@ -11082,7 +11082,7 @@
           <p:cNvPr id="6" name="">
             <a:extLst xmlns:a="http://schemas.openxmlformats.org/drawingml/2006/main">
               <a:ext uri="{FF2B5EF4-FFF2-40B4-BE49-F238E27FC236}">
-                <a16:creationId xmlns:a16="http://schemas.microsoft.com/office/drawing/2014/main" id="{9E85BCC6-CDDD-492D-ABC9-FBF6CDC55049}"/>
+                <a16:creationId xmlns:a16="http://schemas.microsoft.com/office/drawing/2014/main" id="{5FEC47F6-8E71-409A-8864-7DFD0A06E7D3}"/>
               </a:ext>
             </a:extLst>
           </p:cNvPr>
@@ -11115,7 +11115,7 @@
           <p:cNvPr id="7" name="">
             <a:extLst xmlns:a="http://schemas.openxmlformats.org/drawingml/2006/main">
               <a:ext uri="{FF2B5EF4-FFF2-40B4-BE49-F238E27FC236}">
-                <a16:creationId xmlns:a16="http://schemas.microsoft.com/office/drawing/2014/main" id="{D4C9206A-EF91-4F56-90D6-ECBF89987F55}"/>
+                <a16:creationId xmlns:a16="http://schemas.microsoft.com/office/drawing/2014/main" id="{B8681C01-671D-46E7-BB16-2A9BCAED8388}"/>
               </a:ext>
             </a:extLst>
           </p:cNvPr>
@@ -11165,7 +11165,7 @@
           <p:cNvPr id="8" name="">
             <a:extLst xmlns:a="http://schemas.openxmlformats.org/drawingml/2006/main">
               <a:ext uri="{FF2B5EF4-FFF2-40B4-BE49-F238E27FC236}">
-                <a16:creationId xmlns:a16="http://schemas.microsoft.com/office/drawing/2014/main" id="{EED382D2-73DB-47A5-ABAC-2206AEEBD9A6}"/>
+                <a16:creationId xmlns:a16="http://schemas.microsoft.com/office/drawing/2014/main" id="{1FFCB2E8-4CD3-4AF9-91D3-D95900BF73D1}"/>
               </a:ext>
             </a:extLst>
           </p:cNvPr>
@@ -11215,7 +11215,7 @@
           <p:cNvPr id="9" name="">
             <a:extLst xmlns:a="http://schemas.openxmlformats.org/drawingml/2006/main">
               <a:ext uri="{FF2B5EF4-FFF2-40B4-BE49-F238E27FC236}">
-                <a16:creationId xmlns:a16="http://schemas.microsoft.com/office/drawing/2014/main" id="{09DA4E00-CE92-45F3-84BC-21541DAE5D15}"/>
+                <a16:creationId xmlns:a16="http://schemas.microsoft.com/office/drawing/2014/main" id="{1C7B7C25-FB48-407D-B242-BCFF66B41206}"/>
               </a:ext>
             </a:extLst>
           </p:cNvPr>
@@ -11248,7 +11248,7 @@
           <p:cNvPr id="10" name="">
             <a:extLst xmlns:a="http://schemas.openxmlformats.org/drawingml/2006/main">
               <a:ext uri="{FF2B5EF4-FFF2-40B4-BE49-F238E27FC236}">
-                <a16:creationId xmlns:a16="http://schemas.microsoft.com/office/drawing/2014/main" id="{4C9008A4-D7CC-4A55-B7C8-9BA9E280BE80}"/>
+                <a16:creationId xmlns:a16="http://schemas.microsoft.com/office/drawing/2014/main" id="{614A0CBD-CEE7-4ECF-A7CD-86AFA2254876}"/>
               </a:ext>
             </a:extLst>
           </p:cNvPr>
@@ -11298,7 +11298,7 @@
           <p:cNvPr id="11" name="">
             <a:extLst xmlns:a="http://schemas.openxmlformats.org/drawingml/2006/main">
               <a:ext uri="{FF2B5EF4-FFF2-40B4-BE49-F238E27FC236}">
-                <a16:creationId xmlns:a16="http://schemas.microsoft.com/office/drawing/2014/main" id="{1D7A6880-855B-418A-8EFC-93B49880DF60}"/>
+                <a16:creationId xmlns:a16="http://schemas.microsoft.com/office/drawing/2014/main" id="{ADDC5568-77D3-4CA8-8903-641D742BDAFC}"/>
               </a:ext>
             </a:extLst>
           </p:cNvPr>
@@ -11348,7 +11348,7 @@
           <p:cNvPr id="12" name="">
             <a:extLst xmlns:a="http://schemas.openxmlformats.org/drawingml/2006/main">
               <a:ext uri="{FF2B5EF4-FFF2-40B4-BE49-F238E27FC236}">
-                <a16:creationId xmlns:a16="http://schemas.microsoft.com/office/drawing/2014/main" id="{856F76E4-CAE4-491B-BBD9-C181C90AE18E}"/>
+                <a16:creationId xmlns:a16="http://schemas.microsoft.com/office/drawing/2014/main" id="{243F4B3B-DA52-4ABC-B885-62F94642AB67}"/>
               </a:ext>
             </a:extLst>
           </p:cNvPr>
@@ -11381,7 +11381,7 @@
           <p:cNvPr id="13" name="">
             <a:extLst xmlns:a="http://schemas.openxmlformats.org/drawingml/2006/main">
               <a:ext uri="{FF2B5EF4-FFF2-40B4-BE49-F238E27FC236}">
-                <a16:creationId xmlns:a16="http://schemas.microsoft.com/office/drawing/2014/main" id="{0761E939-8329-493E-A005-3B54802DED4C}"/>
+                <a16:creationId xmlns:a16="http://schemas.microsoft.com/office/drawing/2014/main" id="{BCE7CFB9-C7AB-4767-86F0-2A383A6DE6AA}"/>
               </a:ext>
             </a:extLst>
           </p:cNvPr>
@@ -11431,7 +11431,7 @@
           <p:cNvPr id="14" name="">
             <a:extLst xmlns:a="http://schemas.openxmlformats.org/drawingml/2006/main">
               <a:ext uri="{FF2B5EF4-FFF2-40B4-BE49-F238E27FC236}">
-                <a16:creationId xmlns:a16="http://schemas.microsoft.com/office/drawing/2014/main" id="{152F1C8A-8C57-48A9-BF1E-870092B328B8}"/>
+                <a16:creationId xmlns:a16="http://schemas.microsoft.com/office/drawing/2014/main" id="{FE9E0800-FC63-42A9-8C3E-1B71A836A535}"/>
               </a:ext>
             </a:extLst>
           </p:cNvPr>
@@ -11481,7 +11481,7 @@
           <p:cNvPr id="15" name="">
             <a:extLst xmlns:a="http://schemas.openxmlformats.org/drawingml/2006/main">
               <a:ext uri="{FF2B5EF4-FFF2-40B4-BE49-F238E27FC236}">
-                <a16:creationId xmlns:a16="http://schemas.microsoft.com/office/drawing/2014/main" id="{1AF4E21B-407B-423D-84CD-C458D6EF35A5}"/>
+                <a16:creationId xmlns:a16="http://schemas.microsoft.com/office/drawing/2014/main" id="{3BD4FF62-2868-4DFC-8783-152B35B5FF16}"/>
               </a:ext>
             </a:extLst>
           </p:cNvPr>
@@ -11514,7 +11514,7 @@
           <p:cNvPr id="16" name="">
             <a:extLst xmlns:a="http://schemas.openxmlformats.org/drawingml/2006/main">
               <a:ext uri="{FF2B5EF4-FFF2-40B4-BE49-F238E27FC236}">
-                <a16:creationId xmlns:a16="http://schemas.microsoft.com/office/drawing/2014/main" id="{472B2A09-60A0-4D76-9F4C-A0BB55368389}"/>
+                <a16:creationId xmlns:a16="http://schemas.microsoft.com/office/drawing/2014/main" id="{69053D0F-2C69-4262-9250-C835C106EACE}"/>
               </a:ext>
             </a:extLst>
           </p:cNvPr>
@@ -11564,7 +11564,7 @@
           <p:cNvPr id="17" name="">
             <a:extLst xmlns:a="http://schemas.openxmlformats.org/drawingml/2006/main">
               <a:ext uri="{FF2B5EF4-FFF2-40B4-BE49-F238E27FC236}">
-                <a16:creationId xmlns:a16="http://schemas.microsoft.com/office/drawing/2014/main" id="{D657DBFD-D5E3-449A-B1C9-6FAD5A9658B0}"/>
+                <a16:creationId xmlns:a16="http://schemas.microsoft.com/office/drawing/2014/main" id="{84C0D09A-B132-4BD0-981E-7515EB660DA4}"/>
               </a:ext>
             </a:extLst>
           </p:cNvPr>
@@ -11614,7 +11614,7 @@
           <p:cNvPr id="18" name="">
             <a:extLst xmlns:a="http://schemas.openxmlformats.org/drawingml/2006/main">
               <a:ext uri="{FF2B5EF4-FFF2-40B4-BE49-F238E27FC236}">
-                <a16:creationId xmlns:a16="http://schemas.microsoft.com/office/drawing/2014/main" id="{62859696-40FA-4F29-9FFC-86F88C77655F}"/>
+                <a16:creationId xmlns:a16="http://schemas.microsoft.com/office/drawing/2014/main" id="{C8C76EE4-EDA7-4F0B-AEDC-0DE8991A6E64}"/>
               </a:ext>
             </a:extLst>
           </p:cNvPr>
@@ -11647,7 +11647,7 @@
           <p:cNvPr id="19" name="">
             <a:extLst xmlns:a="http://schemas.openxmlformats.org/drawingml/2006/main">
               <a:ext uri="{FF2B5EF4-FFF2-40B4-BE49-F238E27FC236}">
-                <a16:creationId xmlns:a16="http://schemas.microsoft.com/office/drawing/2014/main" id="{95BF3BD5-5A04-4170-A596-F8BFEC311D92}"/>
+                <a16:creationId xmlns:a16="http://schemas.microsoft.com/office/drawing/2014/main" id="{867C7D5F-D85D-4BD3-B819-6852F6B41A3E}"/>
               </a:ext>
             </a:extLst>
           </p:cNvPr>
@@ -11697,7 +11697,7 @@
           <p:cNvPr id="20" name="">
             <a:extLst xmlns:a="http://schemas.openxmlformats.org/drawingml/2006/main">
               <a:ext uri="{FF2B5EF4-FFF2-40B4-BE49-F238E27FC236}">
-                <a16:creationId xmlns:a16="http://schemas.microsoft.com/office/drawing/2014/main" id="{56F5141C-C7A9-40AD-97BB-40E730C9BE32}"/>
+                <a16:creationId xmlns:a16="http://schemas.microsoft.com/office/drawing/2014/main" id="{8C6FE24A-5BAE-4679-A30C-FF180FD6EBAF}"/>
               </a:ext>
             </a:extLst>
           </p:cNvPr>
@@ -11747,7 +11747,7 @@
           <p:cNvPr id="21" name="">
             <a:extLst xmlns:a="http://schemas.openxmlformats.org/drawingml/2006/main">
               <a:ext uri="{FF2B5EF4-FFF2-40B4-BE49-F238E27FC236}">
-                <a16:creationId xmlns:a16="http://schemas.microsoft.com/office/drawing/2014/main" id="{5D6CE8F2-C92D-4CD3-B44B-9E4E8BDEA2F5}"/>
+                <a16:creationId xmlns:a16="http://schemas.microsoft.com/office/drawing/2014/main" id="{97032F44-4B3B-44D2-B869-35E2BE6C52E3}"/>
               </a:ext>
             </a:extLst>
           </p:cNvPr>
@@ -11780,7 +11780,7 @@
           <p:cNvPr id="22" name="">
             <a:extLst xmlns:a="http://schemas.openxmlformats.org/drawingml/2006/main">
               <a:ext uri="{FF2B5EF4-FFF2-40B4-BE49-F238E27FC236}">
-                <a16:creationId xmlns:a16="http://schemas.microsoft.com/office/drawing/2014/main" id="{D52B9E50-6734-40D8-8216-B5AA1CD006FC}"/>
+                <a16:creationId xmlns:a16="http://schemas.microsoft.com/office/drawing/2014/main" id="{A671DEDB-B292-40CA-B18C-62512EA4B6E1}"/>
               </a:ext>
             </a:extLst>
           </p:cNvPr>
@@ -11830,7 +11830,7 @@
           <p:cNvPr id="23" name="">
             <a:extLst xmlns:a="http://schemas.openxmlformats.org/drawingml/2006/main">
               <a:ext uri="{FF2B5EF4-FFF2-40B4-BE49-F238E27FC236}">
-                <a16:creationId xmlns:a16="http://schemas.microsoft.com/office/drawing/2014/main" id="{4CE9406E-24BD-411F-BBEA-B2AD4001F237}"/>
+                <a16:creationId xmlns:a16="http://schemas.microsoft.com/office/drawing/2014/main" id="{3C9F6947-5D59-4B9E-9A1E-B945934BC1F6}"/>
               </a:ext>
             </a:extLst>
           </p:cNvPr>
@@ -11880,7 +11880,7 @@
           <p:cNvPr id="24" name="">
             <a:extLst xmlns:a="http://schemas.openxmlformats.org/drawingml/2006/main">
               <a:ext uri="{FF2B5EF4-FFF2-40B4-BE49-F238E27FC236}">
-                <a16:creationId xmlns:a16="http://schemas.microsoft.com/office/drawing/2014/main" id="{5C0476B7-C9F4-4266-AE1B-2AEAA2A659FC}"/>
+                <a16:creationId xmlns:a16="http://schemas.microsoft.com/office/drawing/2014/main" id="{EB6CE7AC-BF51-4010-AC77-A1F8D83E7D60}"/>
               </a:ext>
             </a:extLst>
           </p:cNvPr>
@@ -11921,7 +11921,7 @@
           <p:cNvPr id="25" name="">
             <a:extLst xmlns:a="http://schemas.openxmlformats.org/drawingml/2006/main">
               <a:ext uri="{FF2B5EF4-FFF2-40B4-BE49-F238E27FC236}">
-                <a16:creationId xmlns:a16="http://schemas.microsoft.com/office/drawing/2014/main" id="{084EE425-C9FF-4EAC-AF0F-8B8FEDC78237}"/>
+                <a16:creationId xmlns:a16="http://schemas.microsoft.com/office/drawing/2014/main" id="{CFB9CFC2-4E93-4C06-8A98-FBD313D5C52D}"/>
               </a:ext>
             </a:extLst>
           </p:cNvPr>
@@ -11971,7 +11971,7 @@
           <p:cNvPr id="26" name="">
             <a:extLst xmlns:a="http://schemas.openxmlformats.org/drawingml/2006/main">
               <a:ext uri="{FF2B5EF4-FFF2-40B4-BE49-F238E27FC236}">
-                <a16:creationId xmlns:a16="http://schemas.microsoft.com/office/drawing/2014/main" id="{04E4CC6F-4B55-402E-B1F6-DDE53251F429}"/>
+                <a16:creationId xmlns:a16="http://schemas.microsoft.com/office/drawing/2014/main" id="{9DF3D9CE-E66B-44F0-8150-CE930655CB27}"/>
               </a:ext>
             </a:extLst>
           </p:cNvPr>
@@ -12021,7 +12021,7 @@
           <p:cNvPr id="27" name="">
             <a:extLst xmlns:a="http://schemas.openxmlformats.org/drawingml/2006/main">
               <a:ext uri="{FF2B5EF4-FFF2-40B4-BE49-F238E27FC236}">
-                <a16:creationId xmlns:a16="http://schemas.microsoft.com/office/drawing/2014/main" id="{CE9BB1B4-0038-4668-A365-10AA54FE3D35}"/>
+                <a16:creationId xmlns:a16="http://schemas.microsoft.com/office/drawing/2014/main" id="{546542FB-D776-4403-9FA7-BED4E537CA50}"/>
               </a:ext>
             </a:extLst>
           </p:cNvPr>
@@ -12052,7 +12052,7 @@
           <p:cNvPr id="28" name="source-2">
             <a:extLst xmlns:a="http://schemas.openxmlformats.org/drawingml/2006/main">
               <a:ext uri="{FF2B5EF4-FFF2-40B4-BE49-F238E27FC236}">
-                <a16:creationId xmlns:a16="http://schemas.microsoft.com/office/drawing/2014/main" id="{1D3608C8-B6A8-498B-9E6A-B160178CE5FD}"/>
+                <a16:creationId xmlns:a16="http://schemas.microsoft.com/office/drawing/2014/main" id="{7602F65B-37EA-4909-B394-CA31E75BBD08}"/>
               </a:ext>
             </a:extLst>
           </p:cNvPr>
@@ -12102,7 +12102,7 @@
           <p:cNvPr id="29" name="page-2">
             <a:extLst xmlns:a="http://schemas.openxmlformats.org/drawingml/2006/main">
               <a:ext uri="{FF2B5EF4-FFF2-40B4-BE49-F238E27FC236}">
-                <a16:creationId xmlns:a16="http://schemas.microsoft.com/office/drawing/2014/main" id="{B0EB3BD7-7223-475C-A8FC-936B684807A7}"/>
+                <a16:creationId xmlns:a16="http://schemas.microsoft.com/office/drawing/2014/main" id="{E7975AE5-5ABE-4A55-8462-4A812A7A47E8}"/>
               </a:ext>
             </a:extLst>
           </p:cNvPr>
@@ -12150,7 +12150,7 @@
     </p:spTree>
     <p:extLst>
       <p:ext uri="{BB962C8B-B14F-4D97-AF65-F5344CB8AC3E}">
-        <p14:creationId xmlns:p14="http://schemas.microsoft.com/office/powerpoint/2010/main" val="1478103298"/>
+        <p14:creationId xmlns:p14="http://schemas.microsoft.com/office/powerpoint/2010/main" val="293704456"/>
       </p:ext>
     </p:extLst>
   </p:cSld>
@@ -12181,7 +12181,7 @@
           <p:cNvPr id="29" name="kicker-3">
             <a:extLst xmlns:a="http://schemas.openxmlformats.org/drawingml/2006/main">
               <a:ext uri="{FF2B5EF4-FFF2-40B4-BE49-F238E27FC236}">
-                <a16:creationId xmlns:a16="http://schemas.microsoft.com/office/drawing/2014/main" id="{1EDD93B9-D336-43FF-9D39-5F3A70042F07}"/>
+                <a16:creationId xmlns:a16="http://schemas.microsoft.com/office/drawing/2014/main" id="{149CB62E-7129-4078-87D4-16F707F7975D}"/>
               </a:ext>
             </a:extLst>
           </p:cNvPr>
@@ -12231,7 +12231,7 @@
           <p:cNvPr id="2" name="title-3">
             <a:extLst xmlns:a="http://schemas.openxmlformats.org/drawingml/2006/main">
               <a:ext uri="{FF2B5EF4-FFF2-40B4-BE49-F238E27FC236}">
-                <a16:creationId xmlns:a16="http://schemas.microsoft.com/office/drawing/2014/main" id="{F15915F0-4E4B-4CFD-84C8-5179FB100BB9}"/>
+                <a16:creationId xmlns:a16="http://schemas.microsoft.com/office/drawing/2014/main" id="{423747C6-1A48-49CE-9461-A250CD6D0CFD}"/>
               </a:ext>
             </a:extLst>
           </p:cNvPr>
@@ -12281,7 +12281,7 @@
           <p:cNvPr id="3" name="">
             <a:extLst xmlns:a="http://schemas.openxmlformats.org/drawingml/2006/main">
               <a:ext uri="{FF2B5EF4-FFF2-40B4-BE49-F238E27FC236}">
-                <a16:creationId xmlns:a16="http://schemas.microsoft.com/office/drawing/2014/main" id="{C21D17DE-EF03-47AB-BBFA-3F7DACE19618}"/>
+                <a16:creationId xmlns:a16="http://schemas.microsoft.com/office/drawing/2014/main" id="{CE53ADB0-34C3-4197-879D-420B27C8DEDD}"/>
               </a:ext>
             </a:extLst>
           </p:cNvPr>
@@ -12312,7 +12312,7 @@
           <p:cNvPr id="4" name="">
             <a:extLst xmlns:a="http://schemas.openxmlformats.org/drawingml/2006/main">
               <a:ext uri="{FF2B5EF4-FFF2-40B4-BE49-F238E27FC236}">
-                <a16:creationId xmlns:a16="http://schemas.microsoft.com/office/drawing/2014/main" id="{ED1EB538-C74F-443F-AC7C-A656ABF74A39}"/>
+                <a16:creationId xmlns:a16="http://schemas.microsoft.com/office/drawing/2014/main" id="{6659C292-9634-4C3B-A87A-1288FD63E2BA}"/>
               </a:ext>
             </a:extLst>
           </p:cNvPr>
@@ -12362,7 +12362,7 @@
           <p:cNvPr id="5" name="">
             <a:extLst xmlns:a="http://schemas.openxmlformats.org/drawingml/2006/main">
               <a:ext uri="{FF2B5EF4-FFF2-40B4-BE49-F238E27FC236}">
-                <a16:creationId xmlns:a16="http://schemas.microsoft.com/office/drawing/2014/main" id="{CE56F57B-ADCD-4E84-BA7A-040813D81DEF}"/>
+                <a16:creationId xmlns:a16="http://schemas.microsoft.com/office/drawing/2014/main" id="{222A0CE9-52FC-49BA-A2F8-15CC99B83EA6}"/>
               </a:ext>
             </a:extLst>
           </p:cNvPr>
@@ -12395,7 +12395,7 @@
           <p:cNvPr id="6" name="">
             <a:extLst xmlns:a="http://schemas.openxmlformats.org/drawingml/2006/main">
               <a:ext uri="{FF2B5EF4-FFF2-40B4-BE49-F238E27FC236}">
-                <a16:creationId xmlns:a16="http://schemas.microsoft.com/office/drawing/2014/main" id="{8A5778D6-7B38-4A97-BBF8-925C24A0FB34}"/>
+                <a16:creationId xmlns:a16="http://schemas.microsoft.com/office/drawing/2014/main" id="{89359F7D-30A9-46D9-B1CE-D7821178DA43}"/>
               </a:ext>
             </a:extLst>
           </p:cNvPr>
@@ -12428,7 +12428,7 @@
           <p:cNvPr id="7" name="">
             <a:extLst xmlns:a="http://schemas.openxmlformats.org/drawingml/2006/main">
               <a:ext uri="{FF2B5EF4-FFF2-40B4-BE49-F238E27FC236}">
-                <a16:creationId xmlns:a16="http://schemas.microsoft.com/office/drawing/2014/main" id="{AEB9CF4F-5452-4E42-B94C-707D65AEDF30}"/>
+                <a16:creationId xmlns:a16="http://schemas.microsoft.com/office/drawing/2014/main" id="{31529528-BB06-456E-AF17-FC7D033DCCF1}"/>
               </a:ext>
             </a:extLst>
           </p:cNvPr>
@@ -12461,7 +12461,7 @@
           <p:cNvPr id="8" name="">
             <a:extLst xmlns:a="http://schemas.openxmlformats.org/drawingml/2006/main">
               <a:ext uri="{FF2B5EF4-FFF2-40B4-BE49-F238E27FC236}">
-                <a16:creationId xmlns:a16="http://schemas.microsoft.com/office/drawing/2014/main" id="{359BD188-0754-4F90-ACDA-ED2E873C70A0}"/>
+                <a16:creationId xmlns:a16="http://schemas.microsoft.com/office/drawing/2014/main" id="{E87D87CC-B41D-42B0-9DAF-C14F1703D6E7}"/>
               </a:ext>
             </a:extLst>
           </p:cNvPr>
@@ -12494,7 +12494,7 @@
           <p:cNvPr id="9" name="pipeline-0">
             <a:extLst xmlns:a="http://schemas.openxmlformats.org/drawingml/2006/main">
               <a:ext uri="{FF2B5EF4-FFF2-40B4-BE49-F238E27FC236}">
-                <a16:creationId xmlns:a16="http://schemas.microsoft.com/office/drawing/2014/main" id="{C755496F-EC8C-4637-9C05-FD52D8B62F0B}"/>
+                <a16:creationId xmlns:a16="http://schemas.microsoft.com/office/drawing/2014/main" id="{90E6850B-5EA6-4CC3-973F-2010319A4F9E}"/>
               </a:ext>
             </a:extLst>
           </p:cNvPr>
@@ -12535,7 +12535,7 @@
           <p:cNvPr id="10" name="">
             <a:extLst xmlns:a="http://schemas.openxmlformats.org/drawingml/2006/main">
               <a:ext uri="{FF2B5EF4-FFF2-40B4-BE49-F238E27FC236}">
-                <a16:creationId xmlns:a16="http://schemas.microsoft.com/office/drawing/2014/main" id="{53D8CB73-A5A6-4739-8014-890F66879153}"/>
+                <a16:creationId xmlns:a16="http://schemas.microsoft.com/office/drawing/2014/main" id="{0F8E8EAB-18D8-4230-9C51-4A658FB2DD96}"/>
               </a:ext>
             </a:extLst>
           </p:cNvPr>
@@ -12585,7 +12585,7 @@
           <p:cNvPr id="11" name="">
             <a:extLst xmlns:a="http://schemas.openxmlformats.org/drawingml/2006/main">
               <a:ext uri="{FF2B5EF4-FFF2-40B4-BE49-F238E27FC236}">
-                <a16:creationId xmlns:a16="http://schemas.microsoft.com/office/drawing/2014/main" id="{07BEDDB1-6D20-44B8-91EA-457700F6F049}"/>
+                <a16:creationId xmlns:a16="http://schemas.microsoft.com/office/drawing/2014/main" id="{25AE086E-A405-4D92-98D3-35A8CEFB7D7E}"/>
               </a:ext>
             </a:extLst>
           </p:cNvPr>
@@ -12652,7 +12652,7 @@
           <p:cNvPr id="12" name="pipeline-1">
             <a:extLst xmlns:a="http://schemas.openxmlformats.org/drawingml/2006/main">
               <a:ext uri="{FF2B5EF4-FFF2-40B4-BE49-F238E27FC236}">
-                <a16:creationId xmlns:a16="http://schemas.microsoft.com/office/drawing/2014/main" id="{EB86841F-CE7D-4FC4-8965-5D111BA1D107}"/>
+                <a16:creationId xmlns:a16="http://schemas.microsoft.com/office/drawing/2014/main" id="{8F7B2866-C7E6-45EB-8976-F117E622DCAC}"/>
               </a:ext>
             </a:extLst>
           </p:cNvPr>
@@ -12693,7 +12693,7 @@
           <p:cNvPr id="13" name="">
             <a:extLst xmlns:a="http://schemas.openxmlformats.org/drawingml/2006/main">
               <a:ext uri="{FF2B5EF4-FFF2-40B4-BE49-F238E27FC236}">
-                <a16:creationId xmlns:a16="http://schemas.microsoft.com/office/drawing/2014/main" id="{848BFAFF-3CAA-4E4B-ADE2-8D8AF548C496}"/>
+                <a16:creationId xmlns:a16="http://schemas.microsoft.com/office/drawing/2014/main" id="{51972382-FFE3-4BC9-AADE-7F3A7FE89F3F}"/>
               </a:ext>
             </a:extLst>
           </p:cNvPr>
@@ -12743,7 +12743,7 @@
           <p:cNvPr id="14" name="">
             <a:extLst xmlns:a="http://schemas.openxmlformats.org/drawingml/2006/main">
               <a:ext uri="{FF2B5EF4-FFF2-40B4-BE49-F238E27FC236}">
-                <a16:creationId xmlns:a16="http://schemas.microsoft.com/office/drawing/2014/main" id="{691AA2E5-4E5B-47EA-A9D6-C4A51F3D136C}"/>
+                <a16:creationId xmlns:a16="http://schemas.microsoft.com/office/drawing/2014/main" id="{65406B78-BB43-4955-9EC6-C9707787FDE2}"/>
               </a:ext>
             </a:extLst>
           </p:cNvPr>
@@ -12810,7 +12810,7 @@
           <p:cNvPr id="15" name="pipeline-2">
             <a:extLst xmlns:a="http://schemas.openxmlformats.org/drawingml/2006/main">
               <a:ext uri="{FF2B5EF4-FFF2-40B4-BE49-F238E27FC236}">
-                <a16:creationId xmlns:a16="http://schemas.microsoft.com/office/drawing/2014/main" id="{CD4E5498-95BF-4A0A-B015-AEBEBE25504C}"/>
+                <a16:creationId xmlns:a16="http://schemas.microsoft.com/office/drawing/2014/main" id="{B97413BA-1B5B-41DE-9131-657A88D27359}"/>
               </a:ext>
             </a:extLst>
           </p:cNvPr>
@@ -12851,7 +12851,7 @@
           <p:cNvPr id="16" name="">
             <a:extLst xmlns:a="http://schemas.openxmlformats.org/drawingml/2006/main">
               <a:ext uri="{FF2B5EF4-FFF2-40B4-BE49-F238E27FC236}">
-                <a16:creationId xmlns:a16="http://schemas.microsoft.com/office/drawing/2014/main" id="{3A631005-123B-4AB5-A315-29D05CE282E5}"/>
+                <a16:creationId xmlns:a16="http://schemas.microsoft.com/office/drawing/2014/main" id="{93698CA0-F355-4915-B739-ACA61190A707}"/>
               </a:ext>
             </a:extLst>
           </p:cNvPr>
@@ -12901,7 +12901,7 @@
           <p:cNvPr id="17" name="">
             <a:extLst xmlns:a="http://schemas.openxmlformats.org/drawingml/2006/main">
               <a:ext uri="{FF2B5EF4-FFF2-40B4-BE49-F238E27FC236}">
-                <a16:creationId xmlns:a16="http://schemas.microsoft.com/office/drawing/2014/main" id="{130CCF3E-42CB-48F9-B821-93083803D321}"/>
+                <a16:creationId xmlns:a16="http://schemas.microsoft.com/office/drawing/2014/main" id="{9E587DE4-F8DA-4A14-A04B-18EFB127F2F9}"/>
               </a:ext>
             </a:extLst>
           </p:cNvPr>
@@ -12968,7 +12968,7 @@
           <p:cNvPr id="18" name="pipeline-3">
             <a:extLst xmlns:a="http://schemas.openxmlformats.org/drawingml/2006/main">
               <a:ext uri="{FF2B5EF4-FFF2-40B4-BE49-F238E27FC236}">
-                <a16:creationId xmlns:a16="http://schemas.microsoft.com/office/drawing/2014/main" id="{1763E046-E424-477C-B224-D54C30E8D596}"/>
+                <a16:creationId xmlns:a16="http://schemas.microsoft.com/office/drawing/2014/main" id="{1DE5A328-F74D-4949-AFB4-3DCD10E73F6B}"/>
               </a:ext>
             </a:extLst>
           </p:cNvPr>
@@ -13009,7 +13009,7 @@
           <p:cNvPr id="19" name="">
             <a:extLst xmlns:a="http://schemas.openxmlformats.org/drawingml/2006/main">
               <a:ext uri="{FF2B5EF4-FFF2-40B4-BE49-F238E27FC236}">
-                <a16:creationId xmlns:a16="http://schemas.microsoft.com/office/drawing/2014/main" id="{8D9F6A5A-AC62-4DF4-AE01-D92799E9627B}"/>
+                <a16:creationId xmlns:a16="http://schemas.microsoft.com/office/drawing/2014/main" id="{B9BA53BA-760C-40F2-87F2-C94B4CF2BD4E}"/>
               </a:ext>
             </a:extLst>
           </p:cNvPr>
@@ -13059,7 +13059,7 @@
           <p:cNvPr id="20" name="">
             <a:extLst xmlns:a="http://schemas.openxmlformats.org/drawingml/2006/main">
               <a:ext uri="{FF2B5EF4-FFF2-40B4-BE49-F238E27FC236}">
-                <a16:creationId xmlns:a16="http://schemas.microsoft.com/office/drawing/2014/main" id="{E2C68B8E-7F8F-4C8E-B8D5-C5DC2C773471}"/>
+                <a16:creationId xmlns:a16="http://schemas.microsoft.com/office/drawing/2014/main" id="{B81B0678-8E71-4C9B-9F8E-561ADE5ABB24}"/>
               </a:ext>
             </a:extLst>
           </p:cNvPr>
@@ -13126,7 +13126,7 @@
           <p:cNvPr id="21" name="pipeline-4">
             <a:extLst xmlns:a="http://schemas.openxmlformats.org/drawingml/2006/main">
               <a:ext uri="{FF2B5EF4-FFF2-40B4-BE49-F238E27FC236}">
-                <a16:creationId xmlns:a16="http://schemas.microsoft.com/office/drawing/2014/main" id="{106F8333-CAD4-4A8E-A56C-DA44D90AE5A5}"/>
+                <a16:creationId xmlns:a16="http://schemas.microsoft.com/office/drawing/2014/main" id="{6927552C-6F19-404A-8463-AB18009E2EB1}"/>
               </a:ext>
             </a:extLst>
           </p:cNvPr>
@@ -13167,7 +13167,7 @@
           <p:cNvPr id="22" name="">
             <a:extLst xmlns:a="http://schemas.openxmlformats.org/drawingml/2006/main">
               <a:ext uri="{FF2B5EF4-FFF2-40B4-BE49-F238E27FC236}">
-                <a16:creationId xmlns:a16="http://schemas.microsoft.com/office/drawing/2014/main" id="{87303980-DB20-4BC0-8153-5FCDB28A839F}"/>
+                <a16:creationId xmlns:a16="http://schemas.microsoft.com/office/drawing/2014/main" id="{3DFF7400-55FE-4291-AA97-949AF7F3F830}"/>
               </a:ext>
             </a:extLst>
           </p:cNvPr>
@@ -13217,7 +13217,7 @@
           <p:cNvPr id="23" name="">
             <a:extLst xmlns:a="http://schemas.openxmlformats.org/drawingml/2006/main">
               <a:ext uri="{FF2B5EF4-FFF2-40B4-BE49-F238E27FC236}">
-                <a16:creationId xmlns:a16="http://schemas.microsoft.com/office/drawing/2014/main" id="{2434B39E-3014-47C6-82DC-84CA7482F2A1}"/>
+                <a16:creationId xmlns:a16="http://schemas.microsoft.com/office/drawing/2014/main" id="{01DBCC52-5B2F-48F2-82EB-634240A5D920}"/>
               </a:ext>
             </a:extLst>
           </p:cNvPr>
@@ -13284,7 +13284,7 @@
           <p:cNvPr id="24" name="">
             <a:extLst xmlns:a="http://schemas.openxmlformats.org/drawingml/2006/main">
               <a:ext uri="{FF2B5EF4-FFF2-40B4-BE49-F238E27FC236}">
-                <a16:creationId xmlns:a16="http://schemas.microsoft.com/office/drawing/2014/main" id="{AE0A5C6F-A1C5-4E41-9E19-4B9F738E158F}"/>
+                <a16:creationId xmlns:a16="http://schemas.microsoft.com/office/drawing/2014/main" id="{68629915-052F-4C6F-9E8B-5B1130DFC36B}"/>
               </a:ext>
             </a:extLst>
           </p:cNvPr>
@@ -13334,7 +13334,7 @@
           <p:cNvPr id="25" name="">
             <a:extLst xmlns:a="http://schemas.openxmlformats.org/drawingml/2006/main">
               <a:ext uri="{FF2B5EF4-FFF2-40B4-BE49-F238E27FC236}">
-                <a16:creationId xmlns:a16="http://schemas.microsoft.com/office/drawing/2014/main" id="{23A64C4D-1326-4B91-88C4-D13500F2C44C}"/>
+                <a16:creationId xmlns:a16="http://schemas.microsoft.com/office/drawing/2014/main" id="{CEB4BBAD-DE4D-4D58-AE20-BD2F146745AB}"/>
               </a:ext>
             </a:extLst>
           </p:cNvPr>
@@ -13384,7 +13384,7 @@
           <p:cNvPr id="26" name="">
             <a:extLst xmlns:a="http://schemas.openxmlformats.org/drawingml/2006/main">
               <a:ext uri="{FF2B5EF4-FFF2-40B4-BE49-F238E27FC236}">
-                <a16:creationId xmlns:a16="http://schemas.microsoft.com/office/drawing/2014/main" id="{EB4D11CD-7952-457A-B193-AEF991F0EB41}"/>
+                <a16:creationId xmlns:a16="http://schemas.microsoft.com/office/drawing/2014/main" id="{F7C5AF71-66ED-4523-A2E0-BDB29EBCBA5D}"/>
               </a:ext>
             </a:extLst>
           </p:cNvPr>
@@ -13415,7 +13415,7 @@
           <p:cNvPr id="27" name="source-3">
             <a:extLst xmlns:a="http://schemas.openxmlformats.org/drawingml/2006/main">
               <a:ext uri="{FF2B5EF4-FFF2-40B4-BE49-F238E27FC236}">
-                <a16:creationId xmlns:a16="http://schemas.microsoft.com/office/drawing/2014/main" id="{5465011E-8753-4CA1-8A52-C189DE9B142C}"/>
+                <a16:creationId xmlns:a16="http://schemas.microsoft.com/office/drawing/2014/main" id="{CAB7B782-A1A7-4940-BAEE-91B79E8F489D}"/>
               </a:ext>
             </a:extLst>
           </p:cNvPr>
@@ -13465,7 +13465,7 @@
           <p:cNvPr id="28" name="page-3">
             <a:extLst xmlns:a="http://schemas.openxmlformats.org/drawingml/2006/main">
               <a:ext uri="{FF2B5EF4-FFF2-40B4-BE49-F238E27FC236}">
-                <a16:creationId xmlns:a16="http://schemas.microsoft.com/office/drawing/2014/main" id="{AF3E1CDA-4CA2-4CF8-A84C-2859C190E8E7}"/>
+                <a16:creationId xmlns:a16="http://schemas.microsoft.com/office/drawing/2014/main" id="{184BFB37-E004-4769-91BD-4FF5C7635E38}"/>
               </a:ext>
             </a:extLst>
           </p:cNvPr>
@@ -13513,7 +13513,7 @@
     </p:spTree>
     <p:extLst>
       <p:ext uri="{BB962C8B-B14F-4D97-AF65-F5344CB8AC3E}">
-        <p14:creationId xmlns:p14="http://schemas.microsoft.com/office/powerpoint/2010/main" val="851341806"/>
+        <p14:creationId xmlns:p14="http://schemas.microsoft.com/office/powerpoint/2010/main" val="1534549032"/>
       </p:ext>
     </p:extLst>
   </p:cSld>
@@ -13544,7 +13544,7 @@
           <p:cNvPr id="49" name="kicker-4">
             <a:extLst xmlns:a="http://schemas.openxmlformats.org/drawingml/2006/main">
               <a:ext uri="{FF2B5EF4-FFF2-40B4-BE49-F238E27FC236}">
-                <a16:creationId xmlns:a16="http://schemas.microsoft.com/office/drawing/2014/main" id="{7A92DA30-FDBB-4708-A4BC-8F28C060FBEE}"/>
+                <a16:creationId xmlns:a16="http://schemas.microsoft.com/office/drawing/2014/main" id="{EEA26ABC-4DDE-4D32-9B8A-8138A9AFD781}"/>
               </a:ext>
             </a:extLst>
           </p:cNvPr>
@@ -13594,7 +13594,7 @@
           <p:cNvPr id="2" name="title-4">
             <a:extLst xmlns:a="http://schemas.openxmlformats.org/drawingml/2006/main">
               <a:ext uri="{FF2B5EF4-FFF2-40B4-BE49-F238E27FC236}">
-                <a16:creationId xmlns:a16="http://schemas.microsoft.com/office/drawing/2014/main" id="{074E97EA-2800-453A-A9BE-3C38ADF0616F}"/>
+                <a16:creationId xmlns:a16="http://schemas.microsoft.com/office/drawing/2014/main" id="{840044BE-EF8C-472B-B624-34B3C5C900C9}"/>
               </a:ext>
             </a:extLst>
           </p:cNvPr>
@@ -13644,7 +13644,7 @@
           <p:cNvPr id="3" name="">
             <a:extLst xmlns:a="http://schemas.openxmlformats.org/drawingml/2006/main">
               <a:ext uri="{FF2B5EF4-FFF2-40B4-BE49-F238E27FC236}">
-                <a16:creationId xmlns:a16="http://schemas.microsoft.com/office/drawing/2014/main" id="{2D3B87DC-D4A6-487D-A118-157A08A1BE5D}"/>
+                <a16:creationId xmlns:a16="http://schemas.microsoft.com/office/drawing/2014/main" id="{0104DCA3-371D-431F-95BE-8A1CCF2087C4}"/>
               </a:ext>
             </a:extLst>
           </p:cNvPr>
@@ -13675,7 +13675,7 @@
           <p:cNvPr id="4" name="">
             <a:extLst xmlns:a="http://schemas.openxmlformats.org/drawingml/2006/main">
               <a:ext uri="{FF2B5EF4-FFF2-40B4-BE49-F238E27FC236}">
-                <a16:creationId xmlns:a16="http://schemas.microsoft.com/office/drawing/2014/main" id="{F2547AFC-8C96-4718-A2D9-7AA81ED7E9BA}"/>
+                <a16:creationId xmlns:a16="http://schemas.microsoft.com/office/drawing/2014/main" id="{ADB9D797-5F59-43F2-8D2D-0509E2B18F70}"/>
               </a:ext>
             </a:extLst>
           </p:cNvPr>
@@ -13725,7 +13725,7 @@
           <p:cNvPr id="5" name="">
             <a:extLst xmlns:a="http://schemas.openxmlformats.org/drawingml/2006/main">
               <a:ext uri="{FF2B5EF4-FFF2-40B4-BE49-F238E27FC236}">
-                <a16:creationId xmlns:a16="http://schemas.microsoft.com/office/drawing/2014/main" id="{80A2BF3A-6846-4709-9C7D-3EFC25C3D251}"/>
+                <a16:creationId xmlns:a16="http://schemas.microsoft.com/office/drawing/2014/main" id="{A372A325-8460-4E4C-99E8-0ABF6B850988}"/>
               </a:ext>
             </a:extLst>
           </p:cNvPr>
@@ -13758,7 +13758,7 @@
           <p:cNvPr id="6" name="">
             <a:extLst xmlns:a="http://schemas.openxmlformats.org/drawingml/2006/main">
               <a:ext uri="{FF2B5EF4-FFF2-40B4-BE49-F238E27FC236}">
-                <a16:creationId xmlns:a16="http://schemas.microsoft.com/office/drawing/2014/main" id="{1D33BB3F-CF36-4A64-9539-5B63FB862CCF}"/>
+                <a16:creationId xmlns:a16="http://schemas.microsoft.com/office/drawing/2014/main" id="{CC9AB3D8-7B9C-41DB-B5E2-0806249E4766}"/>
               </a:ext>
             </a:extLst>
           </p:cNvPr>
@@ -13791,7 +13791,7 @@
           <p:cNvPr id="7" name="">
             <a:extLst xmlns:a="http://schemas.openxmlformats.org/drawingml/2006/main">
               <a:ext uri="{FF2B5EF4-FFF2-40B4-BE49-F238E27FC236}">
-                <a16:creationId xmlns:a16="http://schemas.microsoft.com/office/drawing/2014/main" id="{64CA2443-B169-4AF7-B783-3404F0FBB29B}"/>
+                <a16:creationId xmlns:a16="http://schemas.microsoft.com/office/drawing/2014/main" id="{D514B679-995A-4E6F-A992-5E7301F725EB}"/>
               </a:ext>
             </a:extLst>
           </p:cNvPr>
@@ -13824,7 +13824,7 @@
           <p:cNvPr id="8" name="">
             <a:extLst xmlns:a="http://schemas.openxmlformats.org/drawingml/2006/main">
               <a:ext uri="{FF2B5EF4-FFF2-40B4-BE49-F238E27FC236}">
-                <a16:creationId xmlns:a16="http://schemas.microsoft.com/office/drawing/2014/main" id="{F58AC71C-9B78-4ABB-A232-22CB6ACC73FB}"/>
+                <a16:creationId xmlns:a16="http://schemas.microsoft.com/office/drawing/2014/main" id="{CE500FA2-1212-4FAB-B7B6-03E60842ED41}"/>
               </a:ext>
             </a:extLst>
           </p:cNvPr>
@@ -13857,7 +13857,7 @@
           <p:cNvPr id="9" name="">
             <a:extLst xmlns:a="http://schemas.openxmlformats.org/drawingml/2006/main">
               <a:ext uri="{FF2B5EF4-FFF2-40B4-BE49-F238E27FC236}">
-                <a16:creationId xmlns:a16="http://schemas.microsoft.com/office/drawing/2014/main" id="{BBAD1DAA-2FF6-47F7-B303-6C0344382029}"/>
+                <a16:creationId xmlns:a16="http://schemas.microsoft.com/office/drawing/2014/main" id="{19FEC51A-E234-404E-B036-5307AC37A108}"/>
               </a:ext>
             </a:extLst>
           </p:cNvPr>
@@ -13890,7 +13890,7 @@
           <p:cNvPr id="10" name="">
             <a:extLst xmlns:a="http://schemas.openxmlformats.org/drawingml/2006/main">
               <a:ext uri="{FF2B5EF4-FFF2-40B4-BE49-F238E27FC236}">
-                <a16:creationId xmlns:a16="http://schemas.microsoft.com/office/drawing/2014/main" id="{78873D9A-079D-4D9F-ACC8-114A2D37131E}"/>
+                <a16:creationId xmlns:a16="http://schemas.microsoft.com/office/drawing/2014/main" id="{D720A769-8C07-43B1-85C4-B0EFAE2EB318}"/>
               </a:ext>
             </a:extLst>
           </p:cNvPr>
@@ -13923,7 +13923,7 @@
           <p:cNvPr id="11" name="">
             <a:extLst xmlns:a="http://schemas.openxmlformats.org/drawingml/2006/main">
               <a:ext uri="{FF2B5EF4-FFF2-40B4-BE49-F238E27FC236}">
-                <a16:creationId xmlns:a16="http://schemas.microsoft.com/office/drawing/2014/main" id="{1AAB3976-A3D0-4DA7-98B4-BBCC3CFAA4D5}"/>
+                <a16:creationId xmlns:a16="http://schemas.microsoft.com/office/drawing/2014/main" id="{3BC1CBE0-5CCE-4325-A89E-F76977E06148}"/>
               </a:ext>
             </a:extLst>
           </p:cNvPr>
@@ -13956,7 +13956,7 @@
           <p:cNvPr id="12" name="">
             <a:extLst xmlns:a="http://schemas.openxmlformats.org/drawingml/2006/main">
               <a:ext uri="{FF2B5EF4-FFF2-40B4-BE49-F238E27FC236}">
-                <a16:creationId xmlns:a16="http://schemas.microsoft.com/office/drawing/2014/main" id="{0B5C22D2-18D5-45ED-B538-D81D1B143D8D}"/>
+                <a16:creationId xmlns:a16="http://schemas.microsoft.com/office/drawing/2014/main" id="{5A7E1B95-1BF8-477A-ACF8-F5F7E592F6AF}"/>
               </a:ext>
             </a:extLst>
           </p:cNvPr>
@@ -13989,7 +13989,7 @@
           <p:cNvPr id="13" name="">
             <a:extLst xmlns:a="http://schemas.openxmlformats.org/drawingml/2006/main">
               <a:ext uri="{FF2B5EF4-FFF2-40B4-BE49-F238E27FC236}">
-                <a16:creationId xmlns:a16="http://schemas.microsoft.com/office/drawing/2014/main" id="{F4B92989-1A71-4759-8C40-22795D643C3D}"/>
+                <a16:creationId xmlns:a16="http://schemas.microsoft.com/office/drawing/2014/main" id="{17B6013C-A235-43B1-9932-9E0B67F96F14}"/>
               </a:ext>
             </a:extLst>
           </p:cNvPr>
@@ -14030,7 +14030,7 @@
           <p:cNvPr id="14" name="">
             <a:extLst xmlns:a="http://schemas.openxmlformats.org/drawingml/2006/main">
               <a:ext uri="{FF2B5EF4-FFF2-40B4-BE49-F238E27FC236}">
-                <a16:creationId xmlns:a16="http://schemas.microsoft.com/office/drawing/2014/main" id="{C425A085-103D-4838-9DBC-A8A197B5A282}"/>
+                <a16:creationId xmlns:a16="http://schemas.microsoft.com/office/drawing/2014/main" id="{B172E289-3EB1-4CD0-9717-958A64B80928}"/>
               </a:ext>
             </a:extLst>
           </p:cNvPr>
@@ -14080,7 +14080,7 @@
           <p:cNvPr id="15" name="">
             <a:extLst xmlns:a="http://schemas.openxmlformats.org/drawingml/2006/main">
               <a:ext uri="{FF2B5EF4-FFF2-40B4-BE49-F238E27FC236}">
-                <a16:creationId xmlns:a16="http://schemas.microsoft.com/office/drawing/2014/main" id="{9EF38E10-A386-430A-8D7B-BEB5F170045E}"/>
+                <a16:creationId xmlns:a16="http://schemas.microsoft.com/office/drawing/2014/main" id="{5FA8BEC0-92C7-41FB-9553-9B22781C78A0}"/>
               </a:ext>
             </a:extLst>
           </p:cNvPr>
@@ -14120,7 +14120,7 @@
                   <a:srgbClr val="526174"/>
                 </a:solidFill>
               </a:rPr>
-              <a:t>normalize</a:t>
+              <a:t>input</a:t>
             </a:r>
           </a:p>
         </p:txBody>
@@ -14130,7 +14130,7 @@
           <p:cNvPr id="16" name="">
             <a:extLst xmlns:a="http://schemas.openxmlformats.org/drawingml/2006/main">
               <a:ext uri="{FF2B5EF4-FFF2-40B4-BE49-F238E27FC236}">
-                <a16:creationId xmlns:a16="http://schemas.microsoft.com/office/drawing/2014/main" id="{D9EFC611-389B-4DD5-8F1F-79C3B1ECD443}"/>
+                <a16:creationId xmlns:a16="http://schemas.microsoft.com/office/drawing/2014/main" id="{62F3FF52-73A0-4AFD-A1BD-FED654AC28A5}"/>
               </a:ext>
             </a:extLst>
           </p:cNvPr>
@@ -14163,7 +14163,7 @@
           <p:cNvPr id="17" name="">
             <a:extLst xmlns:a="http://schemas.openxmlformats.org/drawingml/2006/main">
               <a:ext uri="{FF2B5EF4-FFF2-40B4-BE49-F238E27FC236}">
-                <a16:creationId xmlns:a16="http://schemas.microsoft.com/office/drawing/2014/main" id="{E99BFED5-C8C7-4766-AB91-87566523A44E}"/>
+                <a16:creationId xmlns:a16="http://schemas.microsoft.com/office/drawing/2014/main" id="{6B92B6C2-85A8-4C1E-B6F7-76357FAFA148}"/>
               </a:ext>
             </a:extLst>
           </p:cNvPr>
@@ -14230,7 +14230,7 @@
           <p:cNvPr id="18" name="">
             <a:extLst xmlns:a="http://schemas.openxmlformats.org/drawingml/2006/main">
               <a:ext uri="{FF2B5EF4-FFF2-40B4-BE49-F238E27FC236}">
-                <a16:creationId xmlns:a16="http://schemas.microsoft.com/office/drawing/2014/main" id="{484FADEB-96E4-4AEF-B82F-4E6AF82004F5}"/>
+                <a16:creationId xmlns:a16="http://schemas.microsoft.com/office/drawing/2014/main" id="{56C44641-4D74-4DE8-AC64-9E1A7F2B2BFA}"/>
               </a:ext>
             </a:extLst>
           </p:cNvPr>
@@ -14263,7 +14263,7 @@
           <p:cNvPr id="19" name="">
             <a:extLst xmlns:a="http://schemas.openxmlformats.org/drawingml/2006/main">
               <a:ext uri="{FF2B5EF4-FFF2-40B4-BE49-F238E27FC236}">
-                <a16:creationId xmlns:a16="http://schemas.microsoft.com/office/drawing/2014/main" id="{A9142BF5-0034-4EA2-801B-CAF3952E7BE6}"/>
+                <a16:creationId xmlns:a16="http://schemas.microsoft.com/office/drawing/2014/main" id="{DE66F663-7660-429B-B2D6-902C236EBD91}"/>
               </a:ext>
             </a:extLst>
           </p:cNvPr>
@@ -14330,7 +14330,7 @@
           <p:cNvPr id="20" name="">
             <a:extLst xmlns:a="http://schemas.openxmlformats.org/drawingml/2006/main">
               <a:ext uri="{FF2B5EF4-FFF2-40B4-BE49-F238E27FC236}">
-                <a16:creationId xmlns:a16="http://schemas.microsoft.com/office/drawing/2014/main" id="{A3FDDE26-0A1A-49FF-A1D6-848CD89880B3}"/>
+                <a16:creationId xmlns:a16="http://schemas.microsoft.com/office/drawing/2014/main" id="{90D15550-92FB-48EB-9B11-18D2F867E8FD}"/>
               </a:ext>
             </a:extLst>
           </p:cNvPr>
@@ -14363,7 +14363,7 @@
           <p:cNvPr id="21" name="">
             <a:extLst xmlns:a="http://schemas.openxmlformats.org/drawingml/2006/main">
               <a:ext uri="{FF2B5EF4-FFF2-40B4-BE49-F238E27FC236}">
-                <a16:creationId xmlns:a16="http://schemas.microsoft.com/office/drawing/2014/main" id="{E89D0D8B-143E-4036-9518-3753B2A97311}"/>
+                <a16:creationId xmlns:a16="http://schemas.microsoft.com/office/drawing/2014/main" id="{105B0032-8B6C-4BA9-81D6-78A4C14685BA}"/>
               </a:ext>
             </a:extLst>
           </p:cNvPr>
@@ -14430,7 +14430,7 @@
           <p:cNvPr id="22" name="">
             <a:extLst xmlns:a="http://schemas.openxmlformats.org/drawingml/2006/main">
               <a:ext uri="{FF2B5EF4-FFF2-40B4-BE49-F238E27FC236}">
-                <a16:creationId xmlns:a16="http://schemas.microsoft.com/office/drawing/2014/main" id="{E33FC659-DEB8-4456-A209-389AFF1CAF16}"/>
+                <a16:creationId xmlns:a16="http://schemas.microsoft.com/office/drawing/2014/main" id="{13C0FF05-5AD9-40ED-8533-E63CD5841F6A}"/>
               </a:ext>
             </a:extLst>
           </p:cNvPr>
@@ -14480,7 +14480,7 @@
           <p:cNvPr id="23" name="">
             <a:extLst xmlns:a="http://schemas.openxmlformats.org/drawingml/2006/main">
               <a:ext uri="{FF2B5EF4-FFF2-40B4-BE49-F238E27FC236}">
-                <a16:creationId xmlns:a16="http://schemas.microsoft.com/office/drawing/2014/main" id="{049FFDE3-C19F-4AC1-B6CF-B8D41A483B0A}"/>
+                <a16:creationId xmlns:a16="http://schemas.microsoft.com/office/drawing/2014/main" id="{3FDD1E85-FBDE-457C-B6F1-6B776865EC0E}"/>
               </a:ext>
             </a:extLst>
           </p:cNvPr>
@@ -14530,7 +14530,7 @@
           <p:cNvPr id="24" name="">
             <a:extLst xmlns:a="http://schemas.openxmlformats.org/drawingml/2006/main">
               <a:ext uri="{FF2B5EF4-FFF2-40B4-BE49-F238E27FC236}">
-                <a16:creationId xmlns:a16="http://schemas.microsoft.com/office/drawing/2014/main" id="{594A78BA-E7B8-46AE-B242-E0D9B98E72CD}"/>
+                <a16:creationId xmlns:a16="http://schemas.microsoft.com/office/drawing/2014/main" id="{1382C31C-BFA8-4F0F-92CF-C73E9C13D72E}"/>
               </a:ext>
             </a:extLst>
           </p:cNvPr>
@@ -14580,7 +14580,7 @@
           <p:cNvPr id="25" name="">
             <a:extLst xmlns:a="http://schemas.openxmlformats.org/drawingml/2006/main">
               <a:ext uri="{FF2B5EF4-FFF2-40B4-BE49-F238E27FC236}">
-                <a16:creationId xmlns:a16="http://schemas.microsoft.com/office/drawing/2014/main" id="{885CCC30-9336-4803-B73B-7CF450A9368C}"/>
+                <a16:creationId xmlns:a16="http://schemas.microsoft.com/office/drawing/2014/main" id="{1F6BB66D-0D3C-46B1-BDB8-F951B3B8048E}"/>
               </a:ext>
             </a:extLst>
           </p:cNvPr>
@@ -14630,7 +14630,7 @@
           <p:cNvPr id="26" name="">
             <a:extLst xmlns:a="http://schemas.openxmlformats.org/drawingml/2006/main">
               <a:ext uri="{FF2B5EF4-FFF2-40B4-BE49-F238E27FC236}">
-                <a16:creationId xmlns:a16="http://schemas.microsoft.com/office/drawing/2014/main" id="{0BD7D5DD-1FBC-49CF-B6A4-D54C444B0FBE}"/>
+                <a16:creationId xmlns:a16="http://schemas.microsoft.com/office/drawing/2014/main" id="{621DD55A-DDD3-4BFB-BE9F-1CB7F445E838}"/>
               </a:ext>
             </a:extLst>
           </p:cNvPr>
@@ -14680,7 +14680,7 @@
           <p:cNvPr id="27" name="">
             <a:extLst xmlns:a="http://schemas.openxmlformats.org/drawingml/2006/main">
               <a:ext uri="{FF2B5EF4-FFF2-40B4-BE49-F238E27FC236}">
-                <a16:creationId xmlns:a16="http://schemas.microsoft.com/office/drawing/2014/main" id="{AF10906D-D499-48B8-A41A-226BDEF26000}"/>
+                <a16:creationId xmlns:a16="http://schemas.microsoft.com/office/drawing/2014/main" id="{4EF5576D-8393-4672-AD30-951C6E1B6612}"/>
               </a:ext>
             </a:extLst>
           </p:cNvPr>
@@ -14730,7 +14730,7 @@
           <p:cNvPr id="28" name="">
             <a:extLst xmlns:a="http://schemas.openxmlformats.org/drawingml/2006/main">
               <a:ext uri="{FF2B5EF4-FFF2-40B4-BE49-F238E27FC236}">
-                <a16:creationId xmlns:a16="http://schemas.microsoft.com/office/drawing/2014/main" id="{93F8E1E4-F5D1-402C-83C2-86AF6A25CD38}"/>
+                <a16:creationId xmlns:a16="http://schemas.microsoft.com/office/drawing/2014/main" id="{6809E94B-D065-40E7-8856-437D2F4EDFD0}"/>
               </a:ext>
             </a:extLst>
           </p:cNvPr>
@@ -14742,11 +14742,11 @@
         <p:spPr>
           <a:xfrm xmlns:a="http://schemas.openxmlformats.org/drawingml/2006/main">
             <a:off x="2038350" y="3733800"/>
-            <a:ext cx="1676400" cy="1104900"/>
+            <a:ext cx="1676400" cy="1428750"/>
           </a:xfrm>
           <a:prstGeom xmlns:a="http://schemas.openxmlformats.org/drawingml/2006/main" prst="roundRect">
             <a:avLst>
-              <a:gd name="adj" fmla="val 12069"/>
+              <a:gd name="adj" fmla="val 9333"/>
             </a:avLst>
           </a:prstGeom>
           <a:solidFill xmlns:a="http://schemas.openxmlformats.org/drawingml/2006/main">
@@ -14765,19 +14765,19 @@
           <p:cNvPr id="29" name="">
             <a:extLst xmlns:a="http://schemas.openxmlformats.org/drawingml/2006/main">
               <a:ext uri="{FF2B5EF4-FFF2-40B4-BE49-F238E27FC236}">
-                <a16:creationId xmlns:a16="http://schemas.microsoft.com/office/drawing/2014/main" id="{5D78A324-1506-4C02-AEDD-251DC7502272}"/>
-              </a:ext>
-            </a:extLst>
-          </p:cNvPr>
-          <p:cNvSpPr>
-            <a:spLocks xmlns:a="http://schemas.openxmlformats.org/drawingml/2006/main" noGrp="1"/>
-          </p:cNvSpPr>
-          <p:nvPr/>
-        </p:nvSpPr>
-        <p:spPr>
-          <a:xfrm xmlns:a="http://schemas.openxmlformats.org/drawingml/2006/main">
-            <a:off x="2171700" y="3914775"/>
-            <a:ext cx="1409700" cy="266700"/>
+                <a16:creationId xmlns:a16="http://schemas.microsoft.com/office/drawing/2014/main" id="{375CD964-FD1A-4C44-8F0E-69328803C962}"/>
+              </a:ext>
+            </a:extLst>
+          </p:cNvPr>
+          <p:cNvSpPr>
+            <a:spLocks xmlns:a="http://schemas.openxmlformats.org/drawingml/2006/main" noGrp="1"/>
+          </p:cNvSpPr>
+          <p:nvPr/>
+        </p:nvSpPr>
+        <p:spPr>
+          <a:xfrm xmlns:a="http://schemas.openxmlformats.org/drawingml/2006/main">
+            <a:off x="2171700" y="3848100"/>
+            <a:ext cx="1409700" cy="457200"/>
           </a:xfrm>
           <a:prstGeom xmlns:a="http://schemas.openxmlformats.org/drawingml/2006/main" prst="rect">
             <a:avLst/>
@@ -14793,19 +14793,36 @@
           <a:lstStyle xmlns:a="http://schemas.openxmlformats.org/drawingml/2006/main"/>
           <a:p xmlns:a="http://schemas.openxmlformats.org/drawingml/2006/main">
             <a:pPr algn="ctr">
-              <a:defRPr sz="1425" b="1">
+              <a:defRPr sz="1350" b="1">
                 <a:solidFill>
                   <a:srgbClr val="0F172A"/>
                 </a:solidFill>
               </a:defRPr>
             </a:pPr>
             <a:r>
-              <a:rPr sz="1425" b="1">
+              <a:rPr sz="1350" b="1">
                 <a:solidFill>
                   <a:srgbClr val="0F172A"/>
                 </a:solidFill>
               </a:rPr>
-              <a:t>Context verifier</a:t>
+              <a:t>Context</a:t>
+            </a:r>
+          </a:p>
+          <a:p xmlns:a="http://schemas.openxmlformats.org/drawingml/2006/main">
+            <a:pPr algn="ctr">
+              <a:defRPr sz="1350" b="1">
+                <a:solidFill>
+                  <a:srgbClr val="0F172A"/>
+                </a:solidFill>
+              </a:defRPr>
+            </a:pPr>
+            <a:r>
+              <a:rPr sz="1350" b="1">
+                <a:solidFill>
+                  <a:srgbClr val="0F172A"/>
+                </a:solidFill>
+              </a:rPr>
+              <a:t>verifier</a:t>
             </a:r>
           </a:p>
         </p:txBody>
@@ -14815,19 +14832,19 @@
           <p:cNvPr id="30" name="">
             <a:extLst xmlns:a="http://schemas.openxmlformats.org/drawingml/2006/main">
               <a:ext uri="{FF2B5EF4-FFF2-40B4-BE49-F238E27FC236}">
-                <a16:creationId xmlns:a16="http://schemas.microsoft.com/office/drawing/2014/main" id="{27066154-D9F7-490D-82A6-273F96E605F2}"/>
-              </a:ext>
-            </a:extLst>
-          </p:cNvPr>
-          <p:cNvSpPr>
-            <a:spLocks xmlns:a="http://schemas.openxmlformats.org/drawingml/2006/main" noGrp="1"/>
-          </p:cNvSpPr>
-          <p:nvPr/>
-        </p:nvSpPr>
-        <p:spPr>
-          <a:xfrm xmlns:a="http://schemas.openxmlformats.org/drawingml/2006/main">
-            <a:off x="2171700" y="4267200"/>
-            <a:ext cx="1409700" cy="438150"/>
+                <a16:creationId xmlns:a16="http://schemas.microsoft.com/office/drawing/2014/main" id="{B462505D-5F55-4299-8B44-D6E4C9CF89AD}"/>
+              </a:ext>
+            </a:extLst>
+          </p:cNvPr>
+          <p:cNvSpPr>
+            <a:spLocks xmlns:a="http://schemas.openxmlformats.org/drawingml/2006/main" noGrp="1"/>
+          </p:cNvSpPr>
+          <p:nvPr/>
+        </p:nvSpPr>
+        <p:spPr>
+          <a:xfrm xmlns:a="http://schemas.openxmlformats.org/drawingml/2006/main">
+            <a:off x="2171700" y="4438650"/>
+            <a:ext cx="1409700" cy="590550"/>
           </a:xfrm>
           <a:prstGeom xmlns:a="http://schemas.openxmlformats.org/drawingml/2006/main" prst="rect">
             <a:avLst/>
@@ -14843,19 +14860,36 @@
           <a:lstStyle xmlns:a="http://schemas.openxmlformats.org/drawingml/2006/main"/>
           <a:p xmlns:a="http://schemas.openxmlformats.org/drawingml/2006/main">
             <a:pPr algn="ctr">
-              <a:defRPr sz="1125" b="0">
-                <a:solidFill>
-                  <a:srgbClr val="526174"/>
-                </a:solidFill>
-              </a:defRPr>
-            </a:pPr>
-            <a:r>
-              <a:rPr sz="1125" b="0">
-                <a:solidFill>
-                  <a:srgbClr val="526174"/>
-                </a:solidFill>
-              </a:rPr>
-              <a:t>claim support, contradiction, extra claims</a:t>
+              <a:defRPr sz="1200" b="0">
+                <a:solidFill>
+                  <a:srgbClr val="526174"/>
+                </a:solidFill>
+              </a:defRPr>
+            </a:pPr>
+            <a:r>
+              <a:rPr sz="1200" b="0">
+                <a:solidFill>
+                  <a:srgbClr val="526174"/>
+                </a:solidFill>
+              </a:rPr>
+              <a:t>support or contradict</a:t>
+            </a:r>
+          </a:p>
+          <a:p xmlns:a="http://schemas.openxmlformats.org/drawingml/2006/main">
+            <a:pPr algn="ctr">
+              <a:defRPr sz="1200" b="0">
+                <a:solidFill>
+                  <a:srgbClr val="526174"/>
+                </a:solidFill>
+              </a:defRPr>
+            </a:pPr>
+            <a:r>
+              <a:rPr sz="1200" b="0">
+                <a:solidFill>
+                  <a:srgbClr val="526174"/>
+                </a:solidFill>
+              </a:rPr>
+              <a:t>extra-claim check</a:t>
             </a:r>
           </a:p>
         </p:txBody>
@@ -14865,7 +14899,7 @@
           <p:cNvPr id="31" name="">
             <a:extLst xmlns:a="http://schemas.openxmlformats.org/drawingml/2006/main">
               <a:ext uri="{FF2B5EF4-FFF2-40B4-BE49-F238E27FC236}">
-                <a16:creationId xmlns:a16="http://schemas.microsoft.com/office/drawing/2014/main" id="{594AAB0F-6A0F-48F7-96D6-0090EC2CB85E}"/>
+                <a16:creationId xmlns:a16="http://schemas.microsoft.com/office/drawing/2014/main" id="{0627C7A7-7E6B-49AD-AB18-CC8046052ADA}"/>
               </a:ext>
             </a:extLst>
           </p:cNvPr>
@@ -14877,11 +14911,11 @@
         <p:spPr>
           <a:xfrm xmlns:a="http://schemas.openxmlformats.org/drawingml/2006/main">
             <a:off x="3962400" y="3733800"/>
-            <a:ext cx="1676400" cy="1104900"/>
+            <a:ext cx="1676400" cy="1428750"/>
           </a:xfrm>
           <a:prstGeom xmlns:a="http://schemas.openxmlformats.org/drawingml/2006/main" prst="roundRect">
             <a:avLst>
-              <a:gd name="adj" fmla="val 12069"/>
+              <a:gd name="adj" fmla="val 9333"/>
             </a:avLst>
           </a:prstGeom>
           <a:solidFill xmlns:a="http://schemas.openxmlformats.org/drawingml/2006/main">
@@ -14900,19 +14934,19 @@
           <p:cNvPr id="32" name="">
             <a:extLst xmlns:a="http://schemas.openxmlformats.org/drawingml/2006/main">
               <a:ext uri="{FF2B5EF4-FFF2-40B4-BE49-F238E27FC236}">
-                <a16:creationId xmlns:a16="http://schemas.microsoft.com/office/drawing/2014/main" id="{F6B150F2-3E97-46EF-83A6-67DCA019BB29}"/>
-              </a:ext>
-            </a:extLst>
-          </p:cNvPr>
-          <p:cNvSpPr>
-            <a:spLocks xmlns:a="http://schemas.openxmlformats.org/drawingml/2006/main" noGrp="1"/>
-          </p:cNvSpPr>
-          <p:nvPr/>
-        </p:nvSpPr>
-        <p:spPr>
-          <a:xfrm xmlns:a="http://schemas.openxmlformats.org/drawingml/2006/main">
-            <a:off x="4095750" y="3914775"/>
-            <a:ext cx="1409700" cy="266700"/>
+                <a16:creationId xmlns:a16="http://schemas.microsoft.com/office/drawing/2014/main" id="{9B3690C3-94D3-4B7A-B0EF-7AD59563C39C}"/>
+              </a:ext>
+            </a:extLst>
+          </p:cNvPr>
+          <p:cNvSpPr>
+            <a:spLocks xmlns:a="http://schemas.openxmlformats.org/drawingml/2006/main" noGrp="1"/>
+          </p:cNvSpPr>
+          <p:nvPr/>
+        </p:nvSpPr>
+        <p:spPr>
+          <a:xfrm xmlns:a="http://schemas.openxmlformats.org/drawingml/2006/main">
+            <a:off x="4095750" y="3848100"/>
+            <a:ext cx="1409700" cy="457200"/>
           </a:xfrm>
           <a:prstGeom xmlns:a="http://schemas.openxmlformats.org/drawingml/2006/main" prst="rect">
             <a:avLst/>
@@ -14928,19 +14962,36 @@
           <a:lstStyle xmlns:a="http://schemas.openxmlformats.org/drawingml/2006/main"/>
           <a:p xmlns:a="http://schemas.openxmlformats.org/drawingml/2006/main">
             <a:pPr algn="ctr">
-              <a:defRPr sz="1425" b="1">
+              <a:defRPr sz="1350" b="1">
                 <a:solidFill>
                   <a:srgbClr val="0F172A"/>
                 </a:solidFill>
               </a:defRPr>
             </a:pPr>
             <a:r>
-              <a:rPr sz="1425" b="1">
+              <a:rPr sz="1350" b="1">
                 <a:solidFill>
                   <a:srgbClr val="0F172A"/>
                 </a:solidFill>
               </a:rPr>
-              <a:t>Structured solver</a:t>
+              <a:t>Structured</a:t>
+            </a:r>
+          </a:p>
+          <a:p xmlns:a="http://schemas.openxmlformats.org/drawingml/2006/main">
+            <a:pPr algn="ctr">
+              <a:defRPr sz="1350" b="1">
+                <a:solidFill>
+                  <a:srgbClr val="0F172A"/>
+                </a:solidFill>
+              </a:defRPr>
+            </a:pPr>
+            <a:r>
+              <a:rPr sz="1350" b="1">
+                <a:solidFill>
+                  <a:srgbClr val="0F172A"/>
+                </a:solidFill>
+              </a:rPr>
+              <a:t>solver</a:t>
             </a:r>
           </a:p>
         </p:txBody>
@@ -14950,19 +15001,19 @@
           <p:cNvPr id="33" name="">
             <a:extLst xmlns:a="http://schemas.openxmlformats.org/drawingml/2006/main">
               <a:ext uri="{FF2B5EF4-FFF2-40B4-BE49-F238E27FC236}">
-                <a16:creationId xmlns:a16="http://schemas.microsoft.com/office/drawing/2014/main" id="{91140818-E0A3-49A9-97CE-A6CFAD46109A}"/>
-              </a:ext>
-            </a:extLst>
-          </p:cNvPr>
-          <p:cNvSpPr>
-            <a:spLocks xmlns:a="http://schemas.openxmlformats.org/drawingml/2006/main" noGrp="1"/>
-          </p:cNvSpPr>
-          <p:nvPr/>
-        </p:nvSpPr>
-        <p:spPr>
-          <a:xfrm xmlns:a="http://schemas.openxmlformats.org/drawingml/2006/main">
-            <a:off x="4095750" y="4267200"/>
-            <a:ext cx="1409700" cy="438150"/>
+                <a16:creationId xmlns:a16="http://schemas.microsoft.com/office/drawing/2014/main" id="{11D396E4-6948-4AA5-9522-1488A8C2B5F1}"/>
+              </a:ext>
+            </a:extLst>
+          </p:cNvPr>
+          <p:cNvSpPr>
+            <a:spLocks xmlns:a="http://schemas.openxmlformats.org/drawingml/2006/main" noGrp="1"/>
+          </p:cNvSpPr>
+          <p:nvPr/>
+        </p:nvSpPr>
+        <p:spPr>
+          <a:xfrm xmlns:a="http://schemas.openxmlformats.org/drawingml/2006/main">
+            <a:off x="4095750" y="4438650"/>
+            <a:ext cx="1409700" cy="590550"/>
           </a:xfrm>
           <a:prstGeom xmlns:a="http://schemas.openxmlformats.org/drawingml/2006/main" prst="rect">
             <a:avLst/>
@@ -14978,19 +15029,36 @@
           <a:lstStyle xmlns:a="http://schemas.openxmlformats.org/drawingml/2006/main"/>
           <a:p xmlns:a="http://schemas.openxmlformats.org/drawingml/2006/main">
             <a:pPr algn="ctr">
-              <a:defRPr sz="1125" b="0">
-                <a:solidFill>
-                  <a:srgbClr val="526174"/>
-                </a:solidFill>
-              </a:defRPr>
-            </a:pPr>
-            <a:r>
-              <a:rPr sz="1125" b="0">
-                <a:solidFill>
-                  <a:srgbClr val="526174"/>
-                </a:solidFill>
-              </a:rPr>
-              <a:t>numbers, ranges, MCQ, morphology</a:t>
+              <a:defRPr sz="1200" b="0">
+                <a:solidFill>
+                  <a:srgbClr val="526174"/>
+                </a:solidFill>
+              </a:defRPr>
+            </a:pPr>
+            <a:r>
+              <a:rPr sz="1200" b="0">
+                <a:solidFill>
+                  <a:srgbClr val="526174"/>
+                </a:solidFill>
+              </a:rPr>
+              <a:t>numeric / MCQ</a:t>
+            </a:r>
+          </a:p>
+          <a:p xmlns:a="http://schemas.openxmlformats.org/drawingml/2006/main">
+            <a:pPr algn="ctr">
+              <a:defRPr sz="1200" b="0">
+                <a:solidFill>
+                  <a:srgbClr val="526174"/>
+                </a:solidFill>
+              </a:defRPr>
+            </a:pPr>
+            <a:r>
+              <a:rPr sz="1200" b="0">
+                <a:solidFill>
+                  <a:srgbClr val="526174"/>
+                </a:solidFill>
+              </a:rPr>
+              <a:t>morphology</a:t>
             </a:r>
           </a:p>
         </p:txBody>
@@ -15000,7 +15068,7 @@
           <p:cNvPr id="34" name="">
             <a:extLst xmlns:a="http://schemas.openxmlformats.org/drawingml/2006/main">
               <a:ext uri="{FF2B5EF4-FFF2-40B4-BE49-F238E27FC236}">
-                <a16:creationId xmlns:a16="http://schemas.microsoft.com/office/drawing/2014/main" id="{85A5A3FC-0EDC-4235-8CFF-F3F05E984B69}"/>
+                <a16:creationId xmlns:a16="http://schemas.microsoft.com/office/drawing/2014/main" id="{56717FF6-02BB-4322-97A1-C73AB1993A6E}"/>
               </a:ext>
             </a:extLst>
           </p:cNvPr>
@@ -15012,11 +15080,11 @@
         <p:spPr>
           <a:xfrm xmlns:a="http://schemas.openxmlformats.org/drawingml/2006/main">
             <a:off x="5886450" y="3733800"/>
-            <a:ext cx="1676400" cy="1104900"/>
+            <a:ext cx="1676400" cy="1428750"/>
           </a:xfrm>
           <a:prstGeom xmlns:a="http://schemas.openxmlformats.org/drawingml/2006/main" prst="roundRect">
             <a:avLst>
-              <a:gd name="adj" fmla="val 12069"/>
+              <a:gd name="adj" fmla="val 9333"/>
             </a:avLst>
           </a:prstGeom>
           <a:solidFill xmlns:a="http://schemas.openxmlformats.org/drawingml/2006/main">
@@ -15035,19 +15103,19 @@
           <p:cNvPr id="35" name="">
             <a:extLst xmlns:a="http://schemas.openxmlformats.org/drawingml/2006/main">
               <a:ext uri="{FF2B5EF4-FFF2-40B4-BE49-F238E27FC236}">
-                <a16:creationId xmlns:a16="http://schemas.microsoft.com/office/drawing/2014/main" id="{C46BA838-2D52-45E9-932D-6729DD6D9AF9}"/>
-              </a:ext>
-            </a:extLst>
-          </p:cNvPr>
-          <p:cNvSpPr>
-            <a:spLocks xmlns:a="http://schemas.openxmlformats.org/drawingml/2006/main" noGrp="1"/>
-          </p:cNvSpPr>
-          <p:nvPr/>
-        </p:nvSpPr>
-        <p:spPr>
-          <a:xfrm xmlns:a="http://schemas.openxmlformats.org/drawingml/2006/main">
-            <a:off x="6019800" y="3914775"/>
-            <a:ext cx="1409700" cy="266700"/>
+                <a16:creationId xmlns:a16="http://schemas.microsoft.com/office/drawing/2014/main" id="{40386537-AF7A-4FD6-8920-A5485A52937E}"/>
+              </a:ext>
+            </a:extLst>
+          </p:cNvPr>
+          <p:cNvSpPr>
+            <a:spLocks xmlns:a="http://schemas.openxmlformats.org/drawingml/2006/main" noGrp="1"/>
+          </p:cNvSpPr>
+          <p:nvPr/>
+        </p:nvSpPr>
+        <p:spPr>
+          <a:xfrm xmlns:a="http://schemas.openxmlformats.org/drawingml/2006/main">
+            <a:off x="6019800" y="3848100"/>
+            <a:ext cx="1409700" cy="457200"/>
           </a:xfrm>
           <a:prstGeom xmlns:a="http://schemas.openxmlformats.org/drawingml/2006/main" prst="rect">
             <a:avLst/>
@@ -15063,19 +15131,36 @@
           <a:lstStyle xmlns:a="http://schemas.openxmlformats.org/drawingml/2006/main"/>
           <a:p xmlns:a="http://schemas.openxmlformats.org/drawingml/2006/main">
             <a:pPr algn="ctr">
-              <a:defRPr sz="1425" b="1">
+              <a:defRPr sz="1350" b="1">
                 <a:solidFill>
                   <a:srgbClr val="0F172A"/>
                 </a:solidFill>
               </a:defRPr>
             </a:pPr>
             <a:r>
-              <a:rPr sz="1425" b="1">
+              <a:rPr sz="1350" b="1">
                 <a:solidFill>
                   <a:srgbClr val="0F172A"/>
                 </a:solidFill>
               </a:rPr>
-              <a:t>Typed evidence</a:t>
+              <a:t>Typed</a:t>
+            </a:r>
+          </a:p>
+          <a:p xmlns:a="http://schemas.openxmlformats.org/drawingml/2006/main">
+            <a:pPr algn="ctr">
+              <a:defRPr sz="1350" b="1">
+                <a:solidFill>
+                  <a:srgbClr val="0F172A"/>
+                </a:solidFill>
+              </a:defRPr>
+            </a:pPr>
+            <a:r>
+              <a:rPr sz="1350" b="1">
+                <a:solidFill>
+                  <a:srgbClr val="0F172A"/>
+                </a:solidFill>
+              </a:rPr>
+              <a:t>evidence</a:t>
             </a:r>
           </a:p>
         </p:txBody>
@@ -15085,19 +15170,19 @@
           <p:cNvPr id="36" name="">
             <a:extLst xmlns:a="http://schemas.openxmlformats.org/drawingml/2006/main">
               <a:ext uri="{FF2B5EF4-FFF2-40B4-BE49-F238E27FC236}">
-                <a16:creationId xmlns:a16="http://schemas.microsoft.com/office/drawing/2014/main" id="{0D5A5E75-4D99-4824-9A2D-2FB061CBDB50}"/>
-              </a:ext>
-            </a:extLst>
-          </p:cNvPr>
-          <p:cNvSpPr>
-            <a:spLocks xmlns:a="http://schemas.openxmlformats.org/drawingml/2006/main" noGrp="1"/>
-          </p:cNvSpPr>
-          <p:nvPr/>
-        </p:nvSpPr>
-        <p:spPr>
-          <a:xfrm xmlns:a="http://schemas.openxmlformats.org/drawingml/2006/main">
-            <a:off x="6019800" y="4267200"/>
-            <a:ext cx="1409700" cy="438150"/>
+                <a16:creationId xmlns:a16="http://schemas.microsoft.com/office/drawing/2014/main" id="{ADE2588D-42A5-4EB8-A816-0A91A203C763}"/>
+              </a:ext>
+            </a:extLst>
+          </p:cNvPr>
+          <p:cNvSpPr>
+            <a:spLocks xmlns:a="http://schemas.openxmlformats.org/drawingml/2006/main" noGrp="1"/>
+          </p:cNvSpPr>
+          <p:nvPr/>
+        </p:nvSpPr>
+        <p:spPr>
+          <a:xfrm xmlns:a="http://schemas.openxmlformats.org/drawingml/2006/main">
+            <a:off x="6019800" y="4438650"/>
+            <a:ext cx="1409700" cy="590550"/>
           </a:xfrm>
           <a:prstGeom xmlns:a="http://schemas.openxmlformats.org/drawingml/2006/main" prst="rect">
             <a:avLst/>
@@ -15113,19 +15198,36 @@
           <a:lstStyle xmlns:a="http://schemas.openxmlformats.org/drawingml/2006/main"/>
           <a:p xmlns:a="http://schemas.openxmlformats.org/drawingml/2006/main">
             <a:pPr algn="ctr">
-              <a:defRPr sz="1125" b="0">
-                <a:solidFill>
-                  <a:srgbClr val="526174"/>
-                </a:solidFill>
-              </a:defRPr>
-            </a:pPr>
-            <a:r>
-              <a:rPr sz="1125" b="0">
-                <a:solidFill>
-                  <a:srgbClr val="526174"/>
-                </a:solidFill>
-              </a:rPr>
-              <a:t>entity + predicate + value + provenance</a:t>
+              <a:defRPr sz="1200" b="0">
+                <a:solidFill>
+                  <a:srgbClr val="526174"/>
+                </a:solidFill>
+              </a:defRPr>
+            </a:pPr>
+            <a:r>
+              <a:rPr sz="1200" b="0">
+                <a:solidFill>
+                  <a:srgbClr val="526174"/>
+                </a:solidFill>
+              </a:rPr>
+              <a:t>entity + predicate</a:t>
+            </a:r>
+          </a:p>
+          <a:p xmlns:a="http://schemas.openxmlformats.org/drawingml/2006/main">
+            <a:pPr algn="ctr">
+              <a:defRPr sz="1200" b="0">
+                <a:solidFill>
+                  <a:srgbClr val="526174"/>
+                </a:solidFill>
+              </a:defRPr>
+            </a:pPr>
+            <a:r>
+              <a:rPr sz="1200" b="0">
+                <a:solidFill>
+                  <a:srgbClr val="526174"/>
+                </a:solidFill>
+              </a:rPr>
+              <a:t>value + provenance</a:t>
             </a:r>
           </a:p>
         </p:txBody>
@@ -15135,7 +15237,7 @@
           <p:cNvPr id="37" name="">
             <a:extLst xmlns:a="http://schemas.openxmlformats.org/drawingml/2006/main">
               <a:ext uri="{FF2B5EF4-FFF2-40B4-BE49-F238E27FC236}">
-                <a16:creationId xmlns:a16="http://schemas.microsoft.com/office/drawing/2014/main" id="{4BD14FB5-1A2E-4FF3-ADD5-938BA48A9B6B}"/>
+                <a16:creationId xmlns:a16="http://schemas.microsoft.com/office/drawing/2014/main" id="{CB4396FA-69BE-4165-BFF1-D76DECA1773B}"/>
               </a:ext>
             </a:extLst>
           </p:cNvPr>
@@ -15176,7 +15278,7 @@
           <p:cNvPr id="38" name="">
             <a:extLst xmlns:a="http://schemas.openxmlformats.org/drawingml/2006/main">
               <a:ext uri="{FF2B5EF4-FFF2-40B4-BE49-F238E27FC236}">
-                <a16:creationId xmlns:a16="http://schemas.microsoft.com/office/drawing/2014/main" id="{CE4A1F86-CCD6-49E4-B10C-0700B5917382}"/>
+                <a16:creationId xmlns:a16="http://schemas.microsoft.com/office/drawing/2014/main" id="{2C0549F3-A8EB-4D8E-95B6-584195AC5057}"/>
               </a:ext>
             </a:extLst>
           </p:cNvPr>
@@ -15226,7 +15328,7 @@
           <p:cNvPr id="39" name="">
             <a:extLst xmlns:a="http://schemas.openxmlformats.org/drawingml/2006/main">
               <a:ext uri="{FF2B5EF4-FFF2-40B4-BE49-F238E27FC236}">
-                <a16:creationId xmlns:a16="http://schemas.microsoft.com/office/drawing/2014/main" id="{B6DC2361-8F65-41E9-B2F9-9AFEE64ECBA2}"/>
+                <a16:creationId xmlns:a16="http://schemas.microsoft.com/office/drawing/2014/main" id="{1220B36B-3CF6-49CA-BC0A-7021512378AC}"/>
               </a:ext>
             </a:extLst>
           </p:cNvPr>
@@ -15276,7 +15378,7 @@
           <p:cNvPr id="40" name="">
             <a:extLst xmlns:a="http://schemas.openxmlformats.org/drawingml/2006/main">
               <a:ext uri="{FF2B5EF4-FFF2-40B4-BE49-F238E27FC236}">
-                <a16:creationId xmlns:a16="http://schemas.microsoft.com/office/drawing/2014/main" id="{3608E198-7916-4092-A002-C3A606D67D3E}"/>
+                <a16:creationId xmlns:a16="http://schemas.microsoft.com/office/drawing/2014/main" id="{D8DA7EBF-7B8E-490A-9701-A127CD26C3DA}"/>
               </a:ext>
             </a:extLst>
           </p:cNvPr>
@@ -15317,7 +15419,7 @@
           <p:cNvPr id="41" name="">
             <a:extLst xmlns:a="http://schemas.openxmlformats.org/drawingml/2006/main">
               <a:ext uri="{FF2B5EF4-FFF2-40B4-BE49-F238E27FC236}">
-                <a16:creationId xmlns:a16="http://schemas.microsoft.com/office/drawing/2014/main" id="{B2F7E994-E4AB-4411-BA3F-253FEAB0DE4B}"/>
+                <a16:creationId xmlns:a16="http://schemas.microsoft.com/office/drawing/2014/main" id="{BF333D8F-266D-447D-B1C8-21B9D919365E}"/>
               </a:ext>
             </a:extLst>
           </p:cNvPr>
@@ -15367,7 +15469,7 @@
           <p:cNvPr id="42" name="">
             <a:extLst xmlns:a="http://schemas.openxmlformats.org/drawingml/2006/main">
               <a:ext uri="{FF2B5EF4-FFF2-40B4-BE49-F238E27FC236}">
-                <a16:creationId xmlns:a16="http://schemas.microsoft.com/office/drawing/2014/main" id="{ADAFF6EE-7585-49D1-B9C8-7A32B4242570}"/>
+                <a16:creationId xmlns:a16="http://schemas.microsoft.com/office/drawing/2014/main" id="{D9A99948-8EF4-4ACC-97EE-D8F859D1C616}"/>
               </a:ext>
             </a:extLst>
           </p:cNvPr>
@@ -15434,18 +15536,18 @@
           <p:cNvPr id="43" name="">
             <a:extLst xmlns:a="http://schemas.openxmlformats.org/drawingml/2006/main">
               <a:ext uri="{FF2B5EF4-FFF2-40B4-BE49-F238E27FC236}">
-                <a16:creationId xmlns:a16="http://schemas.microsoft.com/office/drawing/2014/main" id="{1736F131-E38C-429A-868A-A8A6076ABA9B}"/>
-              </a:ext>
-            </a:extLst>
-          </p:cNvPr>
-          <p:cNvSpPr>
-            <a:spLocks xmlns:a="http://schemas.openxmlformats.org/drawingml/2006/main" noGrp="1"/>
-          </p:cNvSpPr>
-          <p:nvPr/>
-        </p:nvSpPr>
-        <p:spPr>
-          <a:xfrm xmlns:a="http://schemas.openxmlformats.org/drawingml/2006/main">
-            <a:off x="1562100" y="5219700"/>
+                <a16:creationId xmlns:a16="http://schemas.microsoft.com/office/drawing/2014/main" id="{3E4654EB-7366-4F69-A1FB-03B4ED98405A}"/>
+              </a:ext>
+            </a:extLst>
+          </p:cNvPr>
+          <p:cNvSpPr>
+            <a:spLocks xmlns:a="http://schemas.openxmlformats.org/drawingml/2006/main" noGrp="1"/>
+          </p:cNvSpPr>
+          <p:nvPr/>
+        </p:nvSpPr>
+        <p:spPr>
+          <a:xfrm xmlns:a="http://schemas.openxmlformats.org/drawingml/2006/main">
+            <a:off x="1562100" y="5391150"/>
             <a:ext cx="9067800" cy="590550"/>
           </a:xfrm>
           <a:prstGeom xmlns:a="http://schemas.openxmlformats.org/drawingml/2006/main" prst="roundRect">
@@ -15469,18 +15571,18 @@
           <p:cNvPr id="44" name="">
             <a:extLst xmlns:a="http://schemas.openxmlformats.org/drawingml/2006/main">
               <a:ext uri="{FF2B5EF4-FFF2-40B4-BE49-F238E27FC236}">
-                <a16:creationId xmlns:a16="http://schemas.microsoft.com/office/drawing/2014/main" id="{8A44D103-104E-45CC-B0C8-5176D1591B0F}"/>
-              </a:ext>
-            </a:extLst>
-          </p:cNvPr>
-          <p:cNvSpPr>
-            <a:spLocks xmlns:a="http://schemas.openxmlformats.org/drawingml/2006/main" noGrp="1"/>
-          </p:cNvSpPr>
-          <p:nvPr/>
-        </p:nvSpPr>
-        <p:spPr>
-          <a:xfrm xmlns:a="http://schemas.openxmlformats.org/drawingml/2006/main">
-            <a:off x="1790700" y="5381625"/>
+                <a16:creationId xmlns:a16="http://schemas.microsoft.com/office/drawing/2014/main" id="{4C1C49DB-8719-4702-A2AF-935E3C2F8D63}"/>
+              </a:ext>
+            </a:extLst>
+          </p:cNvPr>
+          <p:cNvSpPr>
+            <a:spLocks xmlns:a="http://schemas.openxmlformats.org/drawingml/2006/main" noGrp="1"/>
+          </p:cNvSpPr>
+          <p:nvPr/>
+        </p:nvSpPr>
+        <p:spPr>
+          <a:xfrm xmlns:a="http://schemas.openxmlformats.org/drawingml/2006/main">
+            <a:off x="1790700" y="5553075"/>
             <a:ext cx="1809750" cy="266700"/>
           </a:xfrm>
           <a:prstGeom xmlns:a="http://schemas.openxmlformats.org/drawingml/2006/main" prst="rect">
@@ -15519,18 +15621,18 @@
           <p:cNvPr id="45" name="">
             <a:extLst xmlns:a="http://schemas.openxmlformats.org/drawingml/2006/main">
               <a:ext uri="{FF2B5EF4-FFF2-40B4-BE49-F238E27FC236}">
-                <a16:creationId xmlns:a16="http://schemas.microsoft.com/office/drawing/2014/main" id="{841E3189-0C97-47C4-83E4-8D8EAE9CE331}"/>
-              </a:ext>
-            </a:extLst>
-          </p:cNvPr>
-          <p:cNvSpPr>
-            <a:spLocks xmlns:a="http://schemas.openxmlformats.org/drawingml/2006/main" noGrp="1"/>
-          </p:cNvSpPr>
-          <p:nvPr/>
-        </p:nvSpPr>
-        <p:spPr>
-          <a:xfrm xmlns:a="http://schemas.openxmlformats.org/drawingml/2006/main">
-            <a:off x="3562350" y="5381625"/>
+                <a16:creationId xmlns:a16="http://schemas.microsoft.com/office/drawing/2014/main" id="{BAF3BE9E-C18F-4A57-B278-21341D9312DB}"/>
+              </a:ext>
+            </a:extLst>
+          </p:cNvPr>
+          <p:cNvSpPr>
+            <a:spLocks xmlns:a="http://schemas.openxmlformats.org/drawingml/2006/main" noGrp="1"/>
+          </p:cNvSpPr>
+          <p:nvPr/>
+        </p:nvSpPr>
+        <p:spPr>
+          <a:xfrm xmlns:a="http://schemas.openxmlformats.org/drawingml/2006/main">
+            <a:off x="3562350" y="5553075"/>
             <a:ext cx="6743700" cy="266700"/>
           </a:xfrm>
           <a:prstGeom xmlns:a="http://schemas.openxmlformats.org/drawingml/2006/main" prst="rect">
@@ -15569,7 +15671,7 @@
           <p:cNvPr id="46" name="">
             <a:extLst xmlns:a="http://schemas.openxmlformats.org/drawingml/2006/main">
               <a:ext uri="{FF2B5EF4-FFF2-40B4-BE49-F238E27FC236}">
-                <a16:creationId xmlns:a16="http://schemas.microsoft.com/office/drawing/2014/main" id="{C540BCC5-0A63-4501-980F-34DDCC0E93E6}"/>
+                <a16:creationId xmlns:a16="http://schemas.microsoft.com/office/drawing/2014/main" id="{6C3A787B-FEA5-424E-B8A9-02CB892DE0B4}"/>
               </a:ext>
             </a:extLst>
           </p:cNvPr>
@@ -15600,7 +15702,7 @@
           <p:cNvPr id="47" name="source-4">
             <a:extLst xmlns:a="http://schemas.openxmlformats.org/drawingml/2006/main">
               <a:ext uri="{FF2B5EF4-FFF2-40B4-BE49-F238E27FC236}">
-                <a16:creationId xmlns:a16="http://schemas.microsoft.com/office/drawing/2014/main" id="{D000708C-C103-4FA5-AE30-21E43F822D41}"/>
+                <a16:creationId xmlns:a16="http://schemas.microsoft.com/office/drawing/2014/main" id="{28F74B62-7337-4C27-91BB-F900FB2E9AC8}"/>
               </a:ext>
             </a:extLst>
           </p:cNvPr>
@@ -15650,7 +15752,7 @@
           <p:cNvPr id="48" name="page-4">
             <a:extLst xmlns:a="http://schemas.openxmlformats.org/drawingml/2006/main">
               <a:ext uri="{FF2B5EF4-FFF2-40B4-BE49-F238E27FC236}">
-                <a16:creationId xmlns:a16="http://schemas.microsoft.com/office/drawing/2014/main" id="{5B6066D5-D911-4314-B54D-E47407EC30D5}"/>
+                <a16:creationId xmlns:a16="http://schemas.microsoft.com/office/drawing/2014/main" id="{872F1666-BF55-441B-B385-41DAD6FCF7EE}"/>
               </a:ext>
             </a:extLst>
           </p:cNvPr>
@@ -15698,7 +15800,7 @@
     </p:spTree>
     <p:extLst>
       <p:ext uri="{BB962C8B-B14F-4D97-AF65-F5344CB8AC3E}">
-        <p14:creationId xmlns:p14="http://schemas.microsoft.com/office/powerpoint/2010/main" val="1665815857"/>
+        <p14:creationId xmlns:p14="http://schemas.microsoft.com/office/powerpoint/2010/main" val="1574614631"/>
       </p:ext>
     </p:extLst>
   </p:cSld>
@@ -15729,7 +15831,7 @@
           <p:cNvPr id="43" name="kicker-5">
             <a:extLst xmlns:a="http://schemas.openxmlformats.org/drawingml/2006/main">
               <a:ext uri="{FF2B5EF4-FFF2-40B4-BE49-F238E27FC236}">
-                <a16:creationId xmlns:a16="http://schemas.microsoft.com/office/drawing/2014/main" id="{C6F25FA5-BD10-4050-9C5C-6C2559FC4556}"/>
+                <a16:creationId xmlns:a16="http://schemas.microsoft.com/office/drawing/2014/main" id="{F8FF1E25-2178-448A-9202-EF035DB75841}"/>
               </a:ext>
             </a:extLst>
           </p:cNvPr>
@@ -15779,7 +15881,7 @@
           <p:cNvPr id="2" name="title-5">
             <a:extLst xmlns:a="http://schemas.openxmlformats.org/drawingml/2006/main">
               <a:ext uri="{FF2B5EF4-FFF2-40B4-BE49-F238E27FC236}">
-                <a16:creationId xmlns:a16="http://schemas.microsoft.com/office/drawing/2014/main" id="{C7E74211-6776-46CB-B95C-576AACA41B91}"/>
+                <a16:creationId xmlns:a16="http://schemas.microsoft.com/office/drawing/2014/main" id="{8F0E0246-C29C-4EC7-8F5A-9B6381487441}"/>
               </a:ext>
             </a:extLst>
           </p:cNvPr>
@@ -15829,7 +15931,7 @@
           <p:cNvPr id="3" name="">
             <a:extLst xmlns:a="http://schemas.openxmlformats.org/drawingml/2006/main">
               <a:ext uri="{FF2B5EF4-FFF2-40B4-BE49-F238E27FC236}">
-                <a16:creationId xmlns:a16="http://schemas.microsoft.com/office/drawing/2014/main" id="{7E615A14-6C87-4583-BC1E-51B1C88FDEBD}"/>
+                <a16:creationId xmlns:a16="http://schemas.microsoft.com/office/drawing/2014/main" id="{FD134B1C-6D1B-4EF4-B8B2-23F1E9F85B4D}"/>
               </a:ext>
             </a:extLst>
           </p:cNvPr>
@@ -15860,7 +15962,7 @@
           <p:cNvPr id="4" name="">
             <a:extLst xmlns:a="http://schemas.openxmlformats.org/drawingml/2006/main">
               <a:ext uri="{FF2B5EF4-FFF2-40B4-BE49-F238E27FC236}">
-                <a16:creationId xmlns:a16="http://schemas.microsoft.com/office/drawing/2014/main" id="{F450B9BB-37CE-4940-BCBA-00B6EB6BEF77}"/>
+                <a16:creationId xmlns:a16="http://schemas.microsoft.com/office/drawing/2014/main" id="{0C840DEE-9D9E-48DF-9637-2C66D13C8620}"/>
               </a:ext>
             </a:extLst>
           </p:cNvPr>
@@ -15910,7 +16012,7 @@
           <p:cNvPr id="5" name="">
             <a:extLst xmlns:a="http://schemas.openxmlformats.org/drawingml/2006/main">
               <a:ext uri="{FF2B5EF4-FFF2-40B4-BE49-F238E27FC236}">
-                <a16:creationId xmlns:a16="http://schemas.microsoft.com/office/drawing/2014/main" id="{DF6F4BC9-E15A-4CC0-A25F-028C685EBB41}"/>
+                <a16:creationId xmlns:a16="http://schemas.microsoft.com/office/drawing/2014/main" id="{C1C12F6D-1B25-4797-A35F-8B078037B5DB}"/>
               </a:ext>
             </a:extLst>
           </p:cNvPr>
@@ -15951,7 +16053,7 @@
           <p:cNvPr id="6" name="">
             <a:extLst xmlns:a="http://schemas.openxmlformats.org/drawingml/2006/main">
               <a:ext uri="{FF2B5EF4-FFF2-40B4-BE49-F238E27FC236}">
-                <a16:creationId xmlns:a16="http://schemas.microsoft.com/office/drawing/2014/main" id="{F6502818-7E0A-439F-832A-C84C77C05302}"/>
+                <a16:creationId xmlns:a16="http://schemas.microsoft.com/office/drawing/2014/main" id="{AAF9E7BC-DFD1-4A6C-89EF-57AA68D5B603}"/>
               </a:ext>
             </a:extLst>
           </p:cNvPr>
@@ -16001,7 +16103,7 @@
           <p:cNvPr id="7" name="">
             <a:extLst xmlns:a="http://schemas.openxmlformats.org/drawingml/2006/main">
               <a:ext uri="{FF2B5EF4-FFF2-40B4-BE49-F238E27FC236}">
-                <a16:creationId xmlns:a16="http://schemas.microsoft.com/office/drawing/2014/main" id="{B6E06ACC-4A0B-4CF6-8884-3D32E71402E1}"/>
+                <a16:creationId xmlns:a16="http://schemas.microsoft.com/office/drawing/2014/main" id="{CF9515E7-2C83-4915-8E4D-BAC342F7C744}"/>
               </a:ext>
             </a:extLst>
           </p:cNvPr>
@@ -16036,7 +16138,7 @@
           <p:cNvPr id="8" name="">
             <a:extLst xmlns:a="http://schemas.openxmlformats.org/drawingml/2006/main">
               <a:ext uri="{FF2B5EF4-FFF2-40B4-BE49-F238E27FC236}">
-                <a16:creationId xmlns:a16="http://schemas.microsoft.com/office/drawing/2014/main" id="{B2BA65BD-7749-408E-A691-BE2070FB85CB}"/>
+                <a16:creationId xmlns:a16="http://schemas.microsoft.com/office/drawing/2014/main" id="{BB3E52E4-B256-412C-A66F-56A3AECA50FF}"/>
               </a:ext>
             </a:extLst>
           </p:cNvPr>
@@ -16086,7 +16188,7 @@
           <p:cNvPr id="9" name="">
             <a:extLst xmlns:a="http://schemas.openxmlformats.org/drawingml/2006/main">
               <a:ext uri="{FF2B5EF4-FFF2-40B4-BE49-F238E27FC236}">
-                <a16:creationId xmlns:a16="http://schemas.microsoft.com/office/drawing/2014/main" id="{D3FC1128-C8E5-46A8-9360-5F427F935C71}"/>
+                <a16:creationId xmlns:a16="http://schemas.microsoft.com/office/drawing/2014/main" id="{2E4C8E73-304E-4CC9-8F62-2DE845D979B3}"/>
               </a:ext>
             </a:extLst>
           </p:cNvPr>
@@ -16121,7 +16223,7 @@
           <p:cNvPr id="10" name="">
             <a:extLst xmlns:a="http://schemas.openxmlformats.org/drawingml/2006/main">
               <a:ext uri="{FF2B5EF4-FFF2-40B4-BE49-F238E27FC236}">
-                <a16:creationId xmlns:a16="http://schemas.microsoft.com/office/drawing/2014/main" id="{0E51BB58-C7BE-44F7-BD7B-4FCA3D49C0B8}"/>
+                <a16:creationId xmlns:a16="http://schemas.microsoft.com/office/drawing/2014/main" id="{B279AF08-5415-4A63-8F2B-45BD514CF7BE}"/>
               </a:ext>
             </a:extLst>
           </p:cNvPr>
@@ -16171,7 +16273,7 @@
           <p:cNvPr id="11" name="">
             <a:extLst xmlns:a="http://schemas.openxmlformats.org/drawingml/2006/main">
               <a:ext uri="{FF2B5EF4-FFF2-40B4-BE49-F238E27FC236}">
-                <a16:creationId xmlns:a16="http://schemas.microsoft.com/office/drawing/2014/main" id="{A4055746-8A37-4607-A8F9-AD4EDD780E15}"/>
+                <a16:creationId xmlns:a16="http://schemas.microsoft.com/office/drawing/2014/main" id="{E8098D6D-8229-45ED-9041-3C22808A3FDD}"/>
               </a:ext>
             </a:extLst>
           </p:cNvPr>
@@ -16206,7 +16308,7 @@
           <p:cNvPr id="12" name="">
             <a:extLst xmlns:a="http://schemas.openxmlformats.org/drawingml/2006/main">
               <a:ext uri="{FF2B5EF4-FFF2-40B4-BE49-F238E27FC236}">
-                <a16:creationId xmlns:a16="http://schemas.microsoft.com/office/drawing/2014/main" id="{D8F03750-34EC-496F-8D02-F0D106B5E463}"/>
+                <a16:creationId xmlns:a16="http://schemas.microsoft.com/office/drawing/2014/main" id="{6CA37010-9935-46D5-B675-5DA202C0CBB9}"/>
               </a:ext>
             </a:extLst>
           </p:cNvPr>
@@ -16256,7 +16358,7 @@
           <p:cNvPr id="13" name="">
             <a:extLst xmlns:a="http://schemas.openxmlformats.org/drawingml/2006/main">
               <a:ext uri="{FF2B5EF4-FFF2-40B4-BE49-F238E27FC236}">
-                <a16:creationId xmlns:a16="http://schemas.microsoft.com/office/drawing/2014/main" id="{2FD72DE5-4E76-4C5A-92B1-5F81525FA2F2}"/>
+                <a16:creationId xmlns:a16="http://schemas.microsoft.com/office/drawing/2014/main" id="{EE6D23A3-50CF-454F-B4FF-A72AD9DA3929}"/>
               </a:ext>
             </a:extLst>
           </p:cNvPr>
@@ -16297,7 +16399,7 @@
           <p:cNvPr id="14" name="">
             <a:extLst xmlns:a="http://schemas.openxmlformats.org/drawingml/2006/main">
               <a:ext uri="{FF2B5EF4-FFF2-40B4-BE49-F238E27FC236}">
-                <a16:creationId xmlns:a16="http://schemas.microsoft.com/office/drawing/2014/main" id="{4E1E1C43-00A3-4911-A420-C583CB7CF67B}"/>
+                <a16:creationId xmlns:a16="http://schemas.microsoft.com/office/drawing/2014/main" id="{551FDE58-F189-4B4B-B0AC-36289692F05F}"/>
               </a:ext>
             </a:extLst>
           </p:cNvPr>
@@ -16347,7 +16449,7 @@
           <p:cNvPr id="15" name="">
             <a:extLst xmlns:a="http://schemas.openxmlformats.org/drawingml/2006/main">
               <a:ext uri="{FF2B5EF4-FFF2-40B4-BE49-F238E27FC236}">
-                <a16:creationId xmlns:a16="http://schemas.microsoft.com/office/drawing/2014/main" id="{1961C03D-647E-4EB0-B912-FF5D6951B7E7}"/>
+                <a16:creationId xmlns:a16="http://schemas.microsoft.com/office/drawing/2014/main" id="{7D3B70B7-A087-43DF-A863-6794DDDB3BBE}"/>
               </a:ext>
             </a:extLst>
           </p:cNvPr>
@@ -16382,7 +16484,7 @@
           <p:cNvPr id="16" name="">
             <a:extLst xmlns:a="http://schemas.openxmlformats.org/drawingml/2006/main">
               <a:ext uri="{FF2B5EF4-FFF2-40B4-BE49-F238E27FC236}">
-                <a16:creationId xmlns:a16="http://schemas.microsoft.com/office/drawing/2014/main" id="{58F26D5B-FF01-49C2-B578-F6BF0C9188A0}"/>
+                <a16:creationId xmlns:a16="http://schemas.microsoft.com/office/drawing/2014/main" id="{B61ECC7D-BE91-4457-840A-A6486F66465F}"/>
               </a:ext>
             </a:extLst>
           </p:cNvPr>
@@ -16432,7 +16534,7 @@
           <p:cNvPr id="17" name="">
             <a:extLst xmlns:a="http://schemas.openxmlformats.org/drawingml/2006/main">
               <a:ext uri="{FF2B5EF4-FFF2-40B4-BE49-F238E27FC236}">
-                <a16:creationId xmlns:a16="http://schemas.microsoft.com/office/drawing/2014/main" id="{73BD301F-DBEC-4DA0-A11E-BD791A6A61CC}"/>
+                <a16:creationId xmlns:a16="http://schemas.microsoft.com/office/drawing/2014/main" id="{06AFBB58-1579-4AC5-AB4D-C87FDFBEBA2C}"/>
               </a:ext>
             </a:extLst>
           </p:cNvPr>
@@ -16467,7 +16569,7 @@
           <p:cNvPr id="18" name="">
             <a:extLst xmlns:a="http://schemas.openxmlformats.org/drawingml/2006/main">
               <a:ext uri="{FF2B5EF4-FFF2-40B4-BE49-F238E27FC236}">
-                <a16:creationId xmlns:a16="http://schemas.microsoft.com/office/drawing/2014/main" id="{4A05E970-D6CA-4C8D-BF1F-1C18DFA7502B}"/>
+                <a16:creationId xmlns:a16="http://schemas.microsoft.com/office/drawing/2014/main" id="{77C09E94-B428-4B1F-94F1-6EB712B084FE}"/>
               </a:ext>
             </a:extLst>
           </p:cNvPr>
@@ -16517,7 +16619,7 @@
           <p:cNvPr id="19" name="">
             <a:extLst xmlns:a="http://schemas.openxmlformats.org/drawingml/2006/main">
               <a:ext uri="{FF2B5EF4-FFF2-40B4-BE49-F238E27FC236}">
-                <a16:creationId xmlns:a16="http://schemas.microsoft.com/office/drawing/2014/main" id="{3C41C5BA-73C7-4EF4-B07B-00DFBE642A54}"/>
+                <a16:creationId xmlns:a16="http://schemas.microsoft.com/office/drawing/2014/main" id="{1C3C4B84-23EE-4CE6-8782-88BBCA2DF122}"/>
               </a:ext>
             </a:extLst>
           </p:cNvPr>
@@ -16552,7 +16654,7 @@
           <p:cNvPr id="20" name="">
             <a:extLst xmlns:a="http://schemas.openxmlformats.org/drawingml/2006/main">
               <a:ext uri="{FF2B5EF4-FFF2-40B4-BE49-F238E27FC236}">
-                <a16:creationId xmlns:a16="http://schemas.microsoft.com/office/drawing/2014/main" id="{3294EB34-EC29-48F6-BFB5-025C08C0CA74}"/>
+                <a16:creationId xmlns:a16="http://schemas.microsoft.com/office/drawing/2014/main" id="{BB1E9E56-762B-44AB-9E91-37D045D29CCB}"/>
               </a:ext>
             </a:extLst>
           </p:cNvPr>
@@ -16602,7 +16704,7 @@
           <p:cNvPr id="21" name="">
             <a:extLst xmlns:a="http://schemas.openxmlformats.org/drawingml/2006/main">
               <a:ext uri="{FF2B5EF4-FFF2-40B4-BE49-F238E27FC236}">
-                <a16:creationId xmlns:a16="http://schemas.microsoft.com/office/drawing/2014/main" id="{D5817ACE-BB6B-4F80-B2F9-D8FED57063E8}"/>
+                <a16:creationId xmlns:a16="http://schemas.microsoft.com/office/drawing/2014/main" id="{FCDA961D-4D4D-4B37-B66D-43BB82973601}"/>
               </a:ext>
             </a:extLst>
           </p:cNvPr>
@@ -16643,7 +16745,7 @@
           <p:cNvPr id="22" name="">
             <a:extLst xmlns:a="http://schemas.openxmlformats.org/drawingml/2006/main">
               <a:ext uri="{FF2B5EF4-FFF2-40B4-BE49-F238E27FC236}">
-                <a16:creationId xmlns:a16="http://schemas.microsoft.com/office/drawing/2014/main" id="{EE59EBE2-01FF-4414-A3F0-6C4680E8435A}"/>
+                <a16:creationId xmlns:a16="http://schemas.microsoft.com/office/drawing/2014/main" id="{C8571F26-3A12-43BE-9329-695CB505A6AF}"/>
               </a:ext>
             </a:extLst>
           </p:cNvPr>
@@ -16693,7 +16795,7 @@
           <p:cNvPr id="23" name="">
             <a:extLst xmlns:a="http://schemas.openxmlformats.org/drawingml/2006/main">
               <a:ext uri="{FF2B5EF4-FFF2-40B4-BE49-F238E27FC236}">
-                <a16:creationId xmlns:a16="http://schemas.microsoft.com/office/drawing/2014/main" id="{61DCE1CF-ED90-48CA-A397-0AF2EB5402A6}"/>
+                <a16:creationId xmlns:a16="http://schemas.microsoft.com/office/drawing/2014/main" id="{027186A3-7665-4B9A-9B54-13549B40D534}"/>
               </a:ext>
             </a:extLst>
           </p:cNvPr>
@@ -16728,7 +16830,7 @@
           <p:cNvPr id="24" name="">
             <a:extLst xmlns:a="http://schemas.openxmlformats.org/drawingml/2006/main">
               <a:ext uri="{FF2B5EF4-FFF2-40B4-BE49-F238E27FC236}">
-                <a16:creationId xmlns:a16="http://schemas.microsoft.com/office/drawing/2014/main" id="{D64B5CC5-ACC9-4E59-9F4D-CD077E665E54}"/>
+                <a16:creationId xmlns:a16="http://schemas.microsoft.com/office/drawing/2014/main" id="{5AD20CDB-6C73-46E0-AB81-EE1459BDA508}"/>
               </a:ext>
             </a:extLst>
           </p:cNvPr>
@@ -16778,7 +16880,7 @@
           <p:cNvPr id="25" name="">
             <a:extLst xmlns:a="http://schemas.openxmlformats.org/drawingml/2006/main">
               <a:ext uri="{FF2B5EF4-FFF2-40B4-BE49-F238E27FC236}">
-                <a16:creationId xmlns:a16="http://schemas.microsoft.com/office/drawing/2014/main" id="{0C71AFF1-D362-4852-9E8C-3E7387549583}"/>
+                <a16:creationId xmlns:a16="http://schemas.microsoft.com/office/drawing/2014/main" id="{9755C83D-A961-4FD0-8443-285125EB5744}"/>
               </a:ext>
             </a:extLst>
           </p:cNvPr>
@@ -16813,7 +16915,7 @@
           <p:cNvPr id="26" name="">
             <a:extLst xmlns:a="http://schemas.openxmlformats.org/drawingml/2006/main">
               <a:ext uri="{FF2B5EF4-FFF2-40B4-BE49-F238E27FC236}">
-                <a16:creationId xmlns:a16="http://schemas.microsoft.com/office/drawing/2014/main" id="{A1660401-9BBD-4A40-B31C-A3C5A35F9197}"/>
+                <a16:creationId xmlns:a16="http://schemas.microsoft.com/office/drawing/2014/main" id="{ED58E9C2-77B0-43C4-B1DD-B94ED92E7679}"/>
               </a:ext>
             </a:extLst>
           </p:cNvPr>
@@ -16863,7 +16965,7 @@
           <p:cNvPr id="27" name="">
             <a:extLst xmlns:a="http://schemas.openxmlformats.org/drawingml/2006/main">
               <a:ext uri="{FF2B5EF4-FFF2-40B4-BE49-F238E27FC236}">
-                <a16:creationId xmlns:a16="http://schemas.microsoft.com/office/drawing/2014/main" id="{A40680A6-FA28-400A-9A3A-7DA24B9D09C7}"/>
+                <a16:creationId xmlns:a16="http://schemas.microsoft.com/office/drawing/2014/main" id="{5F3A56D1-0943-42C7-8695-B7C1DC1442AD}"/>
               </a:ext>
             </a:extLst>
           </p:cNvPr>
@@ -16898,7 +17000,7 @@
           <p:cNvPr id="28" name="">
             <a:extLst xmlns:a="http://schemas.openxmlformats.org/drawingml/2006/main">
               <a:ext uri="{FF2B5EF4-FFF2-40B4-BE49-F238E27FC236}">
-                <a16:creationId xmlns:a16="http://schemas.microsoft.com/office/drawing/2014/main" id="{214EAFF9-066F-471C-81D1-2C21105EA3E1}"/>
+                <a16:creationId xmlns:a16="http://schemas.microsoft.com/office/drawing/2014/main" id="{CD71874C-BA57-43BB-A0C4-81FDAF425377}"/>
               </a:ext>
             </a:extLst>
           </p:cNvPr>
@@ -16948,7 +17050,7 @@
           <p:cNvPr id="29" name="">
             <a:extLst xmlns:a="http://schemas.openxmlformats.org/drawingml/2006/main">
               <a:ext uri="{FF2B5EF4-FFF2-40B4-BE49-F238E27FC236}">
-                <a16:creationId xmlns:a16="http://schemas.microsoft.com/office/drawing/2014/main" id="{7ADBA59F-DE06-4901-BFBD-1B2781775DD6}"/>
+                <a16:creationId xmlns:a16="http://schemas.microsoft.com/office/drawing/2014/main" id="{9DA4F7F5-5033-4FB7-83AA-E1EE246B9FFA}"/>
               </a:ext>
             </a:extLst>
           </p:cNvPr>
@@ -16989,7 +17091,7 @@
           <p:cNvPr id="30" name="">
             <a:extLst xmlns:a="http://schemas.openxmlformats.org/drawingml/2006/main">
               <a:ext uri="{FF2B5EF4-FFF2-40B4-BE49-F238E27FC236}">
-                <a16:creationId xmlns:a16="http://schemas.microsoft.com/office/drawing/2014/main" id="{4F0D8EC6-EB81-4768-8A2C-39CDCCE1D467}"/>
+                <a16:creationId xmlns:a16="http://schemas.microsoft.com/office/drawing/2014/main" id="{33C4FA95-95E8-488F-8781-C2F197A0F254}"/>
               </a:ext>
             </a:extLst>
           </p:cNvPr>
@@ -17039,7 +17141,7 @@
           <p:cNvPr id="31" name="">
             <a:extLst xmlns:a="http://schemas.openxmlformats.org/drawingml/2006/main">
               <a:ext uri="{FF2B5EF4-FFF2-40B4-BE49-F238E27FC236}">
-                <a16:creationId xmlns:a16="http://schemas.microsoft.com/office/drawing/2014/main" id="{5CEA030E-84D5-4566-8B04-FD90164E174F}"/>
+                <a16:creationId xmlns:a16="http://schemas.microsoft.com/office/drawing/2014/main" id="{BD60530C-1345-4D87-A3BD-A186EDD40C34}"/>
               </a:ext>
             </a:extLst>
           </p:cNvPr>
@@ -17074,7 +17176,7 @@
           <p:cNvPr id="32" name="">
             <a:extLst xmlns:a="http://schemas.openxmlformats.org/drawingml/2006/main">
               <a:ext uri="{FF2B5EF4-FFF2-40B4-BE49-F238E27FC236}">
-                <a16:creationId xmlns:a16="http://schemas.microsoft.com/office/drawing/2014/main" id="{A15A6251-A808-47D7-99C4-40ABF6C9DD7F}"/>
+                <a16:creationId xmlns:a16="http://schemas.microsoft.com/office/drawing/2014/main" id="{F50266F0-F734-4293-837A-E562839ED5D8}"/>
               </a:ext>
             </a:extLst>
           </p:cNvPr>
@@ -17124,7 +17226,7 @@
           <p:cNvPr id="33" name="">
             <a:extLst xmlns:a="http://schemas.openxmlformats.org/drawingml/2006/main">
               <a:ext uri="{FF2B5EF4-FFF2-40B4-BE49-F238E27FC236}">
-                <a16:creationId xmlns:a16="http://schemas.microsoft.com/office/drawing/2014/main" id="{DFF8DD7C-39E0-41D5-91D9-8F3EEA13947C}"/>
+                <a16:creationId xmlns:a16="http://schemas.microsoft.com/office/drawing/2014/main" id="{7BB8BAF5-CA46-4E82-B9C4-8813605C938F}"/>
               </a:ext>
             </a:extLst>
           </p:cNvPr>
@@ -17159,7 +17261,7 @@
           <p:cNvPr id="34" name="">
             <a:extLst xmlns:a="http://schemas.openxmlformats.org/drawingml/2006/main">
               <a:ext uri="{FF2B5EF4-FFF2-40B4-BE49-F238E27FC236}">
-                <a16:creationId xmlns:a16="http://schemas.microsoft.com/office/drawing/2014/main" id="{F7982384-7168-4C87-966B-8A3436DE02F5}"/>
+                <a16:creationId xmlns:a16="http://schemas.microsoft.com/office/drawing/2014/main" id="{C2ED947D-56AD-4E78-9D5B-1A3249BA2F6B}"/>
               </a:ext>
             </a:extLst>
           </p:cNvPr>
@@ -17209,7 +17311,7 @@
           <p:cNvPr id="35" name="">
             <a:extLst xmlns:a="http://schemas.openxmlformats.org/drawingml/2006/main">
               <a:ext uri="{FF2B5EF4-FFF2-40B4-BE49-F238E27FC236}">
-                <a16:creationId xmlns:a16="http://schemas.microsoft.com/office/drawing/2014/main" id="{1CBB7645-5ED5-459F-B48D-700FE7F5351A}"/>
+                <a16:creationId xmlns:a16="http://schemas.microsoft.com/office/drawing/2014/main" id="{DE206D6B-24BA-4A59-B782-798D9DA34810}"/>
               </a:ext>
             </a:extLst>
           </p:cNvPr>
@@ -17244,7 +17346,7 @@
           <p:cNvPr id="36" name="">
             <a:extLst xmlns:a="http://schemas.openxmlformats.org/drawingml/2006/main">
               <a:ext uri="{FF2B5EF4-FFF2-40B4-BE49-F238E27FC236}">
-                <a16:creationId xmlns:a16="http://schemas.microsoft.com/office/drawing/2014/main" id="{C0BE3AC8-74B5-4D51-9103-AF7D42433CAC}"/>
+                <a16:creationId xmlns:a16="http://schemas.microsoft.com/office/drawing/2014/main" id="{96D3620D-21BA-4D95-BF9A-7118E03183F2}"/>
               </a:ext>
             </a:extLst>
           </p:cNvPr>
@@ -17294,7 +17396,7 @@
           <p:cNvPr id="37" name="">
             <a:extLst xmlns:a="http://schemas.openxmlformats.org/drawingml/2006/main">
               <a:ext uri="{FF2B5EF4-FFF2-40B4-BE49-F238E27FC236}">
-                <a16:creationId xmlns:a16="http://schemas.microsoft.com/office/drawing/2014/main" id="{7D682935-6A05-4E40-B52D-D92D68EBF4D1}"/>
+                <a16:creationId xmlns:a16="http://schemas.microsoft.com/office/drawing/2014/main" id="{8547267E-BAA3-4912-96FF-49BBC1FE5095}"/>
               </a:ext>
             </a:extLst>
           </p:cNvPr>
@@ -17329,7 +17431,7 @@
           <p:cNvPr id="38" name="">
             <a:extLst xmlns:a="http://schemas.openxmlformats.org/drawingml/2006/main">
               <a:ext uri="{FF2B5EF4-FFF2-40B4-BE49-F238E27FC236}">
-                <a16:creationId xmlns:a16="http://schemas.microsoft.com/office/drawing/2014/main" id="{4DBD602C-C064-45D8-AA52-F670DAA04A06}"/>
+                <a16:creationId xmlns:a16="http://schemas.microsoft.com/office/drawing/2014/main" id="{FD80591C-C629-47FF-9861-706DA81EB3DA}"/>
               </a:ext>
             </a:extLst>
           </p:cNvPr>
@@ -17379,7 +17481,7 @@
           <p:cNvPr id="39" name="">
             <a:extLst xmlns:a="http://schemas.openxmlformats.org/drawingml/2006/main">
               <a:ext uri="{FF2B5EF4-FFF2-40B4-BE49-F238E27FC236}">
-                <a16:creationId xmlns:a16="http://schemas.microsoft.com/office/drawing/2014/main" id="{8BA8AB26-4FED-4CE9-8580-B20263C0CD69}"/>
+                <a16:creationId xmlns:a16="http://schemas.microsoft.com/office/drawing/2014/main" id="{FAF24D1A-C5E0-46AD-BEF0-DF82691B445C}"/>
               </a:ext>
             </a:extLst>
           </p:cNvPr>
@@ -17429,7 +17531,7 @@
           <p:cNvPr id="40" name="">
             <a:extLst xmlns:a="http://schemas.openxmlformats.org/drawingml/2006/main">
               <a:ext uri="{FF2B5EF4-FFF2-40B4-BE49-F238E27FC236}">
-                <a16:creationId xmlns:a16="http://schemas.microsoft.com/office/drawing/2014/main" id="{D1128C4A-F5B7-4B56-8FA7-32B68573A858}"/>
+                <a16:creationId xmlns:a16="http://schemas.microsoft.com/office/drawing/2014/main" id="{40B65139-B7DC-467B-A68F-E48CAB1FE5BB}"/>
               </a:ext>
             </a:extLst>
           </p:cNvPr>
@@ -17460,7 +17562,7 @@
           <p:cNvPr id="41" name="source-5">
             <a:extLst xmlns:a="http://schemas.openxmlformats.org/drawingml/2006/main">
               <a:ext uri="{FF2B5EF4-FFF2-40B4-BE49-F238E27FC236}">
-                <a16:creationId xmlns:a16="http://schemas.microsoft.com/office/drawing/2014/main" id="{98C2067E-FD16-47F6-A6C7-9EC43B485BC6}"/>
+                <a16:creationId xmlns:a16="http://schemas.microsoft.com/office/drawing/2014/main" id="{0FC3120E-1AD4-4381-9D23-8E1AD2C487A0}"/>
               </a:ext>
             </a:extLst>
           </p:cNvPr>
@@ -17510,7 +17612,7 @@
           <p:cNvPr id="42" name="page-5">
             <a:extLst xmlns:a="http://schemas.openxmlformats.org/drawingml/2006/main">
               <a:ext uri="{FF2B5EF4-FFF2-40B4-BE49-F238E27FC236}">
-                <a16:creationId xmlns:a16="http://schemas.microsoft.com/office/drawing/2014/main" id="{207AA954-0048-41AB-9274-22A6A1ADC1D0}"/>
+                <a16:creationId xmlns:a16="http://schemas.microsoft.com/office/drawing/2014/main" id="{1C6F8E49-4462-47B6-AC5B-8F9E6602FB02}"/>
               </a:ext>
             </a:extLst>
           </p:cNvPr>
@@ -17558,7 +17660,7 @@
     </p:spTree>
     <p:extLst>
       <p:ext uri="{BB962C8B-B14F-4D97-AF65-F5344CB8AC3E}">
-        <p14:creationId xmlns:p14="http://schemas.microsoft.com/office/powerpoint/2010/main" val="1938352261"/>
+        <p14:creationId xmlns:p14="http://schemas.microsoft.com/office/powerpoint/2010/main" val="856713630"/>
       </p:ext>
     </p:extLst>
   </p:cSld>
@@ -17589,7 +17691,7 @@
           <p:cNvPr id="29" name="kicker-6">
             <a:extLst xmlns:a="http://schemas.openxmlformats.org/drawingml/2006/main">
               <a:ext uri="{FF2B5EF4-FFF2-40B4-BE49-F238E27FC236}">
-                <a16:creationId xmlns:a16="http://schemas.microsoft.com/office/drawing/2014/main" id="{998B9B09-474A-477B-ACAD-1AF9DCAF4A00}"/>
+                <a16:creationId xmlns:a16="http://schemas.microsoft.com/office/drawing/2014/main" id="{9E9D6F30-2CB1-4684-8FB7-164B9EB1E746}"/>
               </a:ext>
             </a:extLst>
           </p:cNvPr>
@@ -17639,7 +17741,7 @@
           <p:cNvPr id="2" name="title-6">
             <a:extLst xmlns:a="http://schemas.openxmlformats.org/drawingml/2006/main">
               <a:ext uri="{FF2B5EF4-FFF2-40B4-BE49-F238E27FC236}">
-                <a16:creationId xmlns:a16="http://schemas.microsoft.com/office/drawing/2014/main" id="{FC5E57D5-62EC-46D8-B1F9-19C02CA493C5}"/>
+                <a16:creationId xmlns:a16="http://schemas.microsoft.com/office/drawing/2014/main" id="{861C7854-4B04-4F01-A158-F4DBB335B2CF}"/>
               </a:ext>
             </a:extLst>
           </p:cNvPr>
@@ -17689,7 +17791,7 @@
           <p:cNvPr id="3" name="">
             <a:extLst xmlns:a="http://schemas.openxmlformats.org/drawingml/2006/main">
               <a:ext uri="{FF2B5EF4-FFF2-40B4-BE49-F238E27FC236}">
-                <a16:creationId xmlns:a16="http://schemas.microsoft.com/office/drawing/2014/main" id="{A44EF8E9-B779-4964-BD29-D29501A7724A}"/>
+                <a16:creationId xmlns:a16="http://schemas.microsoft.com/office/drawing/2014/main" id="{08CFBDE4-3CB7-457C-BC0F-DA30EEBC1BC4}"/>
               </a:ext>
             </a:extLst>
           </p:cNvPr>
@@ -17720,7 +17822,7 @@
           <p:cNvPr id="4" name="">
             <a:extLst xmlns:a="http://schemas.openxmlformats.org/drawingml/2006/main">
               <a:ext uri="{FF2B5EF4-FFF2-40B4-BE49-F238E27FC236}">
-                <a16:creationId xmlns:a16="http://schemas.microsoft.com/office/drawing/2014/main" id="{95FB90B0-7FFA-4B16-BA92-55B454E7CC0C}"/>
+                <a16:creationId xmlns:a16="http://schemas.microsoft.com/office/drawing/2014/main" id="{1BE8D659-0F65-4C59-A91F-4A2CE3F22847}"/>
               </a:ext>
             </a:extLst>
           </p:cNvPr>
@@ -17770,7 +17872,7 @@
           <p:cNvPr id="5" name="">
             <a:extLst xmlns:a="http://schemas.openxmlformats.org/drawingml/2006/main">
               <a:ext uri="{FF2B5EF4-FFF2-40B4-BE49-F238E27FC236}">
-                <a16:creationId xmlns:a16="http://schemas.microsoft.com/office/drawing/2014/main" id="{5A33C448-8664-407B-A524-36FCA7F99E6B}"/>
+                <a16:creationId xmlns:a16="http://schemas.microsoft.com/office/drawing/2014/main" id="{149DD6F4-BCD2-4151-B12D-BB2669E28DC7}"/>
               </a:ext>
             </a:extLst>
           </p:cNvPr>
@@ -17801,7 +17903,7 @@
           <p:cNvPr id="6" name="">
             <a:extLst xmlns:a="http://schemas.openxmlformats.org/drawingml/2006/main">
               <a:ext uri="{FF2B5EF4-FFF2-40B4-BE49-F238E27FC236}">
-                <a16:creationId xmlns:a16="http://schemas.microsoft.com/office/drawing/2014/main" id="{CFCDB668-10C0-4ADC-AF91-CF0A44EDEB7E}"/>
+                <a16:creationId xmlns:a16="http://schemas.microsoft.com/office/drawing/2014/main" id="{6D2EC7D0-62B9-4E31-A7DA-C7C852C772EE}"/>
               </a:ext>
             </a:extLst>
           </p:cNvPr>
@@ -17851,7 +17953,7 @@
           <p:cNvPr id="7" name="">
             <a:extLst xmlns:a="http://schemas.openxmlformats.org/drawingml/2006/main">
               <a:ext uri="{FF2B5EF4-FFF2-40B4-BE49-F238E27FC236}">
-                <a16:creationId xmlns:a16="http://schemas.microsoft.com/office/drawing/2014/main" id="{6A5CB29C-7D5A-408B-8D9A-3C1E636C8960}"/>
+                <a16:creationId xmlns:a16="http://schemas.microsoft.com/office/drawing/2014/main" id="{8A55E3D8-3DEA-43D5-B1F9-3A94A00E98DC}"/>
               </a:ext>
             </a:extLst>
           </p:cNvPr>
@@ -17901,7 +18003,7 @@
           <p:cNvPr id="8" name="">
             <a:extLst xmlns:a="http://schemas.openxmlformats.org/drawingml/2006/main">
               <a:ext uri="{FF2B5EF4-FFF2-40B4-BE49-F238E27FC236}">
-                <a16:creationId xmlns:a16="http://schemas.microsoft.com/office/drawing/2014/main" id="{5B94B40C-2D59-4CB0-A36C-66474CDD816E}"/>
+                <a16:creationId xmlns:a16="http://schemas.microsoft.com/office/drawing/2014/main" id="{C8238018-5EF5-448E-BC82-68D950CDFE72}"/>
               </a:ext>
             </a:extLst>
           </p:cNvPr>
@@ -17951,7 +18053,7 @@
           <p:cNvPr id="9" name="">
             <a:extLst xmlns:a="http://schemas.openxmlformats.org/drawingml/2006/main">
               <a:ext uri="{FF2B5EF4-FFF2-40B4-BE49-F238E27FC236}">
-                <a16:creationId xmlns:a16="http://schemas.microsoft.com/office/drawing/2014/main" id="{20F9245C-3204-4FAC-9110-80EB463C5E95}"/>
+                <a16:creationId xmlns:a16="http://schemas.microsoft.com/office/drawing/2014/main" id="{AA548B5B-F280-4ACF-AC23-CFC27C67C4A3}"/>
               </a:ext>
             </a:extLst>
           </p:cNvPr>
@@ -17982,7 +18084,7 @@
           <p:cNvPr id="10" name="">
             <a:extLst xmlns:a="http://schemas.openxmlformats.org/drawingml/2006/main">
               <a:ext uri="{FF2B5EF4-FFF2-40B4-BE49-F238E27FC236}">
-                <a16:creationId xmlns:a16="http://schemas.microsoft.com/office/drawing/2014/main" id="{27B21F7F-3E3A-41B7-8FFC-7E8E020F0ECC}"/>
+                <a16:creationId xmlns:a16="http://schemas.microsoft.com/office/drawing/2014/main" id="{81441D11-12FA-4B9D-9B61-1B8D1D626F95}"/>
               </a:ext>
             </a:extLst>
           </p:cNvPr>
@@ -18032,7 +18134,7 @@
           <p:cNvPr id="11" name="">
             <a:extLst xmlns:a="http://schemas.openxmlformats.org/drawingml/2006/main">
               <a:ext uri="{FF2B5EF4-FFF2-40B4-BE49-F238E27FC236}">
-                <a16:creationId xmlns:a16="http://schemas.microsoft.com/office/drawing/2014/main" id="{C1F8B548-B9FF-4829-BDAE-4893DE880D46}"/>
+                <a16:creationId xmlns:a16="http://schemas.microsoft.com/office/drawing/2014/main" id="{CEB3D333-514F-42F1-A35D-BB085AB02E55}"/>
               </a:ext>
             </a:extLst>
           </p:cNvPr>
@@ -18082,7 +18184,7 @@
           <p:cNvPr id="12" name="">
             <a:extLst xmlns:a="http://schemas.openxmlformats.org/drawingml/2006/main">
               <a:ext uri="{FF2B5EF4-FFF2-40B4-BE49-F238E27FC236}">
-                <a16:creationId xmlns:a16="http://schemas.microsoft.com/office/drawing/2014/main" id="{665456B5-E1B1-4372-93AA-630A6D6BCEE4}"/>
+                <a16:creationId xmlns:a16="http://schemas.microsoft.com/office/drawing/2014/main" id="{8D07FAF2-1251-439A-80FD-16A9B0D64D1E}"/>
               </a:ext>
             </a:extLst>
           </p:cNvPr>
@@ -18132,7 +18234,7 @@
           <p:cNvPr id="13" name="">
             <a:extLst xmlns:a="http://schemas.openxmlformats.org/drawingml/2006/main">
               <a:ext uri="{FF2B5EF4-FFF2-40B4-BE49-F238E27FC236}">
-                <a16:creationId xmlns:a16="http://schemas.microsoft.com/office/drawing/2014/main" id="{DB3E29F7-4161-4B3D-86C4-198FF6FEE76F}"/>
+                <a16:creationId xmlns:a16="http://schemas.microsoft.com/office/drawing/2014/main" id="{F5C05688-C7D8-496B-9A68-FCB8DA86D4A2}"/>
               </a:ext>
             </a:extLst>
           </p:cNvPr>
@@ -18163,7 +18265,7 @@
           <p:cNvPr id="14" name="">
             <a:extLst xmlns:a="http://schemas.openxmlformats.org/drawingml/2006/main">
               <a:ext uri="{FF2B5EF4-FFF2-40B4-BE49-F238E27FC236}">
-                <a16:creationId xmlns:a16="http://schemas.microsoft.com/office/drawing/2014/main" id="{2E43A9D6-8B3C-4151-9C83-111AA1DDA6AE}"/>
+                <a16:creationId xmlns:a16="http://schemas.microsoft.com/office/drawing/2014/main" id="{2A01818C-9356-4621-8BE5-69E3919A080E}"/>
               </a:ext>
             </a:extLst>
           </p:cNvPr>
@@ -18213,7 +18315,7 @@
           <p:cNvPr id="15" name="">
             <a:extLst xmlns:a="http://schemas.openxmlformats.org/drawingml/2006/main">
               <a:ext uri="{FF2B5EF4-FFF2-40B4-BE49-F238E27FC236}">
-                <a16:creationId xmlns:a16="http://schemas.microsoft.com/office/drawing/2014/main" id="{C2D2D38C-05DD-4A9A-8D4B-4D492BE96E56}"/>
+                <a16:creationId xmlns:a16="http://schemas.microsoft.com/office/drawing/2014/main" id="{795FF76D-0893-42EE-9BA2-B7A2EA102CF0}"/>
               </a:ext>
             </a:extLst>
           </p:cNvPr>
@@ -18263,7 +18365,7 @@
           <p:cNvPr id="16" name="">
             <a:extLst xmlns:a="http://schemas.openxmlformats.org/drawingml/2006/main">
               <a:ext uri="{FF2B5EF4-FFF2-40B4-BE49-F238E27FC236}">
-                <a16:creationId xmlns:a16="http://schemas.microsoft.com/office/drawing/2014/main" id="{7675DB32-6BFA-4396-B11F-E6D713D2C183}"/>
+                <a16:creationId xmlns:a16="http://schemas.microsoft.com/office/drawing/2014/main" id="{B94BE237-F543-4A93-B676-8863F49DE4D5}"/>
               </a:ext>
             </a:extLst>
           </p:cNvPr>
@@ -18313,7 +18415,7 @@
           <p:cNvPr id="17" name="">
             <a:extLst xmlns:a="http://schemas.openxmlformats.org/drawingml/2006/main">
               <a:ext uri="{FF2B5EF4-FFF2-40B4-BE49-F238E27FC236}">
-                <a16:creationId xmlns:a16="http://schemas.microsoft.com/office/drawing/2014/main" id="{AE9D8E3E-E98F-4093-A923-1EA1D763E200}"/>
+                <a16:creationId xmlns:a16="http://schemas.microsoft.com/office/drawing/2014/main" id="{545F08B1-DDF4-4445-98B6-B1233E53A2CA}"/>
               </a:ext>
             </a:extLst>
           </p:cNvPr>
@@ -18344,7 +18446,7 @@
           <p:cNvPr id="18" name="">
             <a:extLst xmlns:a="http://schemas.openxmlformats.org/drawingml/2006/main">
               <a:ext uri="{FF2B5EF4-FFF2-40B4-BE49-F238E27FC236}">
-                <a16:creationId xmlns:a16="http://schemas.microsoft.com/office/drawing/2014/main" id="{3F1F136D-6A7E-4BF2-AB26-CBE63ED9436E}"/>
+                <a16:creationId xmlns:a16="http://schemas.microsoft.com/office/drawing/2014/main" id="{B214D0DD-98C0-4E0A-B45E-E6D1B0160ED7}"/>
               </a:ext>
             </a:extLst>
           </p:cNvPr>
@@ -18394,7 +18496,7 @@
           <p:cNvPr id="19" name="">
             <a:extLst xmlns:a="http://schemas.openxmlformats.org/drawingml/2006/main">
               <a:ext uri="{FF2B5EF4-FFF2-40B4-BE49-F238E27FC236}">
-                <a16:creationId xmlns:a16="http://schemas.microsoft.com/office/drawing/2014/main" id="{330A8D3C-011D-4428-A409-2BF7EFCDD9B8}"/>
+                <a16:creationId xmlns:a16="http://schemas.microsoft.com/office/drawing/2014/main" id="{CD09B0FB-1C81-485E-95A4-03C79574218E}"/>
               </a:ext>
             </a:extLst>
           </p:cNvPr>
@@ -18444,7 +18546,7 @@
           <p:cNvPr id="20" name="">
             <a:extLst xmlns:a="http://schemas.openxmlformats.org/drawingml/2006/main">
               <a:ext uri="{FF2B5EF4-FFF2-40B4-BE49-F238E27FC236}">
-                <a16:creationId xmlns:a16="http://schemas.microsoft.com/office/drawing/2014/main" id="{A1CA48E0-ED8E-4C67-A15C-21CE86AC29C2}"/>
+                <a16:creationId xmlns:a16="http://schemas.microsoft.com/office/drawing/2014/main" id="{CDF48D01-9FCE-44F2-9686-392795754D30}"/>
               </a:ext>
             </a:extLst>
           </p:cNvPr>
@@ -18494,7 +18596,7 @@
           <p:cNvPr id="21" name="">
             <a:extLst xmlns:a="http://schemas.openxmlformats.org/drawingml/2006/main">
               <a:ext uri="{FF2B5EF4-FFF2-40B4-BE49-F238E27FC236}">
-                <a16:creationId xmlns:a16="http://schemas.microsoft.com/office/drawing/2014/main" id="{A4D7BA8C-5172-4F13-B52E-EE25E7780099}"/>
+                <a16:creationId xmlns:a16="http://schemas.microsoft.com/office/drawing/2014/main" id="{CC625386-8013-412F-9782-4B2FD9BF61D1}"/>
               </a:ext>
             </a:extLst>
           </p:cNvPr>
@@ -18525,7 +18627,7 @@
           <p:cNvPr id="22" name="">
             <a:extLst xmlns:a="http://schemas.openxmlformats.org/drawingml/2006/main">
               <a:ext uri="{FF2B5EF4-FFF2-40B4-BE49-F238E27FC236}">
-                <a16:creationId xmlns:a16="http://schemas.microsoft.com/office/drawing/2014/main" id="{0A41A0F8-65C4-493B-BF06-7D42283A6FF8}"/>
+                <a16:creationId xmlns:a16="http://schemas.microsoft.com/office/drawing/2014/main" id="{28FCC4BE-4A84-43EA-9AE6-C6DA91BDC850}"/>
               </a:ext>
             </a:extLst>
           </p:cNvPr>
@@ -18575,7 +18677,7 @@
           <p:cNvPr id="23" name="">
             <a:extLst xmlns:a="http://schemas.openxmlformats.org/drawingml/2006/main">
               <a:ext uri="{FF2B5EF4-FFF2-40B4-BE49-F238E27FC236}">
-                <a16:creationId xmlns:a16="http://schemas.microsoft.com/office/drawing/2014/main" id="{3EE5DD6A-5210-4D3F-865F-954E04584445}"/>
+                <a16:creationId xmlns:a16="http://schemas.microsoft.com/office/drawing/2014/main" id="{B17018DD-6A95-40B8-89EF-676F4A5C1822}"/>
               </a:ext>
             </a:extLst>
           </p:cNvPr>
@@ -18625,7 +18727,7 @@
           <p:cNvPr id="24" name="">
             <a:extLst xmlns:a="http://schemas.openxmlformats.org/drawingml/2006/main">
               <a:ext uri="{FF2B5EF4-FFF2-40B4-BE49-F238E27FC236}">
-                <a16:creationId xmlns:a16="http://schemas.microsoft.com/office/drawing/2014/main" id="{07E0164A-21EB-4E58-89DD-A789940441C6}"/>
+                <a16:creationId xmlns:a16="http://schemas.microsoft.com/office/drawing/2014/main" id="{ECAD9EEE-FC2C-48E4-8813-080064D39591}"/>
               </a:ext>
             </a:extLst>
           </p:cNvPr>
@@ -18675,7 +18777,7 @@
           <p:cNvPr id="25" name="">
             <a:extLst xmlns:a="http://schemas.openxmlformats.org/drawingml/2006/main">
               <a:ext uri="{FF2B5EF4-FFF2-40B4-BE49-F238E27FC236}">
-                <a16:creationId xmlns:a16="http://schemas.microsoft.com/office/drawing/2014/main" id="{0634C5EF-2516-4271-9740-FDEC7A8CA877}"/>
+                <a16:creationId xmlns:a16="http://schemas.microsoft.com/office/drawing/2014/main" id="{4E19AB2C-0307-493C-8292-D22B7ADF9310}"/>
               </a:ext>
             </a:extLst>
           </p:cNvPr>
@@ -18725,7 +18827,7 @@
           <p:cNvPr id="26" name="">
             <a:extLst xmlns:a="http://schemas.openxmlformats.org/drawingml/2006/main">
               <a:ext uri="{FF2B5EF4-FFF2-40B4-BE49-F238E27FC236}">
-                <a16:creationId xmlns:a16="http://schemas.microsoft.com/office/drawing/2014/main" id="{D38C2242-26D4-4D2A-9DBF-15378EF2FBE1}"/>
+                <a16:creationId xmlns:a16="http://schemas.microsoft.com/office/drawing/2014/main" id="{A8616531-92E3-4F0B-8B54-571FFFA26CA7}"/>
               </a:ext>
             </a:extLst>
           </p:cNvPr>
@@ -18756,7 +18858,7 @@
           <p:cNvPr id="27" name="source-6">
             <a:extLst xmlns:a="http://schemas.openxmlformats.org/drawingml/2006/main">
               <a:ext uri="{FF2B5EF4-FFF2-40B4-BE49-F238E27FC236}">
-                <a16:creationId xmlns:a16="http://schemas.microsoft.com/office/drawing/2014/main" id="{782F1095-357A-4C24-8164-B1486FA20F83}"/>
+                <a16:creationId xmlns:a16="http://schemas.microsoft.com/office/drawing/2014/main" id="{CA24D0B8-A520-4BCD-A3DA-15240F1670DD}"/>
               </a:ext>
             </a:extLst>
           </p:cNvPr>
@@ -18806,7 +18908,7 @@
           <p:cNvPr id="28" name="page-6">
             <a:extLst xmlns:a="http://schemas.openxmlformats.org/drawingml/2006/main">
               <a:ext uri="{FF2B5EF4-FFF2-40B4-BE49-F238E27FC236}">
-                <a16:creationId xmlns:a16="http://schemas.microsoft.com/office/drawing/2014/main" id="{47DEEAFD-084B-416E-B88B-1D36DC530B72}"/>
+                <a16:creationId xmlns:a16="http://schemas.microsoft.com/office/drawing/2014/main" id="{A8BBB73F-12B5-465B-A87C-CCD5CD2BCE36}"/>
               </a:ext>
             </a:extLst>
           </p:cNvPr>
@@ -18854,7 +18956,7 @@
     </p:spTree>
     <p:extLst>
       <p:ext uri="{BB962C8B-B14F-4D97-AF65-F5344CB8AC3E}">
-        <p14:creationId xmlns:p14="http://schemas.microsoft.com/office/powerpoint/2010/main" val="2064369203"/>
+        <p14:creationId xmlns:p14="http://schemas.microsoft.com/office/powerpoint/2010/main" val="515648656"/>
       </p:ext>
     </p:extLst>
   </p:cSld>
@@ -18885,7 +18987,7 @@
           <p:cNvPr id="40" name="kicker-7">
             <a:extLst xmlns:a="http://schemas.openxmlformats.org/drawingml/2006/main">
               <a:ext uri="{FF2B5EF4-FFF2-40B4-BE49-F238E27FC236}">
-                <a16:creationId xmlns:a16="http://schemas.microsoft.com/office/drawing/2014/main" id="{C740484A-8072-4A81-AAD3-9AABF3CAB1B7}"/>
+                <a16:creationId xmlns:a16="http://schemas.microsoft.com/office/drawing/2014/main" id="{01772880-4530-4E1C-BB5C-654E585FE9ED}"/>
               </a:ext>
             </a:extLst>
           </p:cNvPr>
@@ -18935,7 +19037,7 @@
           <p:cNvPr id="2" name="title-7">
             <a:extLst xmlns:a="http://schemas.openxmlformats.org/drawingml/2006/main">
               <a:ext uri="{FF2B5EF4-FFF2-40B4-BE49-F238E27FC236}">
-                <a16:creationId xmlns:a16="http://schemas.microsoft.com/office/drawing/2014/main" id="{E6AC2839-FE22-4A91-ADCE-7F930E33964D}"/>
+                <a16:creationId xmlns:a16="http://schemas.microsoft.com/office/drawing/2014/main" id="{8B5787E1-85FE-4E5B-91AE-DAF0F9A7AAE9}"/>
               </a:ext>
             </a:extLst>
           </p:cNvPr>
@@ -18985,7 +19087,7 @@
           <p:cNvPr id="3" name="">
             <a:extLst xmlns:a="http://schemas.openxmlformats.org/drawingml/2006/main">
               <a:ext uri="{FF2B5EF4-FFF2-40B4-BE49-F238E27FC236}">
-                <a16:creationId xmlns:a16="http://schemas.microsoft.com/office/drawing/2014/main" id="{709B4B3F-B75D-4875-A7A8-73B41DD893B3}"/>
+                <a16:creationId xmlns:a16="http://schemas.microsoft.com/office/drawing/2014/main" id="{03FCFD45-1447-485E-8E00-3902E417B1A8}"/>
               </a:ext>
             </a:extLst>
           </p:cNvPr>
@@ -19016,7 +19118,7 @@
           <p:cNvPr id="4" name="">
             <a:extLst xmlns:a="http://schemas.openxmlformats.org/drawingml/2006/main">
               <a:ext uri="{FF2B5EF4-FFF2-40B4-BE49-F238E27FC236}">
-                <a16:creationId xmlns:a16="http://schemas.microsoft.com/office/drawing/2014/main" id="{98B3F5C8-8ACB-4EF0-9620-8FF2B1BE65E2}"/>
+                <a16:creationId xmlns:a16="http://schemas.microsoft.com/office/drawing/2014/main" id="{44D45DB6-00A5-4F8C-862D-B751E112C287}"/>
               </a:ext>
             </a:extLst>
           </p:cNvPr>
@@ -19066,7 +19168,7 @@
           <p:cNvPr id="5" name="">
             <a:extLst xmlns:a="http://schemas.openxmlformats.org/drawingml/2006/main">
               <a:ext uri="{FF2B5EF4-FFF2-40B4-BE49-F238E27FC236}">
-                <a16:creationId xmlns:a16="http://schemas.microsoft.com/office/drawing/2014/main" id="{63F1D27D-41D2-40DF-8800-C0C8768132BC}"/>
+                <a16:creationId xmlns:a16="http://schemas.microsoft.com/office/drawing/2014/main" id="{A40383BA-4CB9-4797-B8CF-EFDCD2DAFC17}"/>
               </a:ext>
             </a:extLst>
           </p:cNvPr>
@@ -19099,7 +19201,7 @@
           <p:cNvPr id="6" name="">
             <a:extLst xmlns:a="http://schemas.openxmlformats.org/drawingml/2006/main">
               <a:ext uri="{FF2B5EF4-FFF2-40B4-BE49-F238E27FC236}">
-                <a16:creationId xmlns:a16="http://schemas.microsoft.com/office/drawing/2014/main" id="{E2494BB0-B355-4EEB-B581-D2D431EF3869}"/>
+                <a16:creationId xmlns:a16="http://schemas.microsoft.com/office/drawing/2014/main" id="{1DBF4821-46A1-4CDA-89F2-7335E267EF72}"/>
               </a:ext>
             </a:extLst>
           </p:cNvPr>
@@ -19132,7 +19234,7 @@
           <p:cNvPr id="7" name="">
             <a:extLst xmlns:a="http://schemas.openxmlformats.org/drawingml/2006/main">
               <a:ext uri="{FF2B5EF4-FFF2-40B4-BE49-F238E27FC236}">
-                <a16:creationId xmlns:a16="http://schemas.microsoft.com/office/drawing/2014/main" id="{D89EA9FA-DF42-48DB-A4E8-2D771BE478F8}"/>
+                <a16:creationId xmlns:a16="http://schemas.microsoft.com/office/drawing/2014/main" id="{6265AFE7-D69D-42D8-9168-38BE3F2E60E7}"/>
               </a:ext>
             </a:extLst>
           </p:cNvPr>
@@ -19165,7 +19267,7 @@
           <p:cNvPr id="8" name="">
             <a:extLst xmlns:a="http://schemas.openxmlformats.org/drawingml/2006/main">
               <a:ext uri="{FF2B5EF4-FFF2-40B4-BE49-F238E27FC236}">
-                <a16:creationId xmlns:a16="http://schemas.microsoft.com/office/drawing/2014/main" id="{B47BF12D-82D8-415A-B1F9-24F6427D452A}"/>
+                <a16:creationId xmlns:a16="http://schemas.microsoft.com/office/drawing/2014/main" id="{D27B047C-DF42-46D3-8390-5EFFE412C5B4}"/>
               </a:ext>
             </a:extLst>
           </p:cNvPr>
@@ -19198,7 +19300,7 @@
           <p:cNvPr id="9" name="">
             <a:extLst xmlns:a="http://schemas.openxmlformats.org/drawingml/2006/main">
               <a:ext uri="{FF2B5EF4-FFF2-40B4-BE49-F238E27FC236}">
-                <a16:creationId xmlns:a16="http://schemas.microsoft.com/office/drawing/2014/main" id="{FC6C5D57-8766-43EA-82B8-0A962AAB39CF}"/>
+                <a16:creationId xmlns:a16="http://schemas.microsoft.com/office/drawing/2014/main" id="{44E1D405-FE4E-49F4-BBB8-F7816ED85D8B}"/>
               </a:ext>
             </a:extLst>
           </p:cNvPr>
@@ -19233,7 +19335,7 @@
           <p:cNvPr id="10" name="">
             <a:extLst xmlns:a="http://schemas.openxmlformats.org/drawingml/2006/main">
               <a:ext uri="{FF2B5EF4-FFF2-40B4-BE49-F238E27FC236}">
-                <a16:creationId xmlns:a16="http://schemas.microsoft.com/office/drawing/2014/main" id="{924D1394-DA32-435B-89AB-3D4FE107ABFE}"/>
+                <a16:creationId xmlns:a16="http://schemas.microsoft.com/office/drawing/2014/main" id="{9F708037-9619-495A-8AB5-403DE9E87080}"/>
               </a:ext>
             </a:extLst>
           </p:cNvPr>
@@ -19283,7 +19385,7 @@
           <p:cNvPr id="11" name="">
             <a:extLst xmlns:a="http://schemas.openxmlformats.org/drawingml/2006/main">
               <a:ext uri="{FF2B5EF4-FFF2-40B4-BE49-F238E27FC236}">
-                <a16:creationId xmlns:a16="http://schemas.microsoft.com/office/drawing/2014/main" id="{D2AC484C-D0D6-45B7-8C29-0E125BE12425}"/>
+                <a16:creationId xmlns:a16="http://schemas.microsoft.com/office/drawing/2014/main" id="{C42DCBCA-C916-4A89-B4C4-EF6293E23EC8}"/>
               </a:ext>
             </a:extLst>
           </p:cNvPr>
@@ -19350,7 +19452,7 @@
           <p:cNvPr id="12" name="">
             <a:extLst xmlns:a="http://schemas.openxmlformats.org/drawingml/2006/main">
               <a:ext uri="{FF2B5EF4-FFF2-40B4-BE49-F238E27FC236}">
-                <a16:creationId xmlns:a16="http://schemas.microsoft.com/office/drawing/2014/main" id="{3CFFCF7A-E65B-4873-9DB4-C2766F9195ED}"/>
+                <a16:creationId xmlns:a16="http://schemas.microsoft.com/office/drawing/2014/main" id="{14D88BB0-FCB0-4C33-A49B-85E3AA5576F3}"/>
               </a:ext>
             </a:extLst>
           </p:cNvPr>
@@ -19385,7 +19487,7 @@
           <p:cNvPr id="13" name="">
             <a:extLst xmlns:a="http://schemas.openxmlformats.org/drawingml/2006/main">
               <a:ext uri="{FF2B5EF4-FFF2-40B4-BE49-F238E27FC236}">
-                <a16:creationId xmlns:a16="http://schemas.microsoft.com/office/drawing/2014/main" id="{E9C3F44A-9452-493B-88B6-B229F6633FF4}"/>
+                <a16:creationId xmlns:a16="http://schemas.microsoft.com/office/drawing/2014/main" id="{1AE7AF38-629F-4A6E-A3D3-3101A23027EC}"/>
               </a:ext>
             </a:extLst>
           </p:cNvPr>
@@ -19435,7 +19537,7 @@
           <p:cNvPr id="14" name="">
             <a:extLst xmlns:a="http://schemas.openxmlformats.org/drawingml/2006/main">
               <a:ext uri="{FF2B5EF4-FFF2-40B4-BE49-F238E27FC236}">
-                <a16:creationId xmlns:a16="http://schemas.microsoft.com/office/drawing/2014/main" id="{9E5F6CD0-18E4-4567-B132-C8ECA975BFED}"/>
+                <a16:creationId xmlns:a16="http://schemas.microsoft.com/office/drawing/2014/main" id="{5A057EC6-A9FB-494C-9421-52C4F685773C}"/>
               </a:ext>
             </a:extLst>
           </p:cNvPr>
@@ -19502,7 +19604,7 @@
           <p:cNvPr id="15" name="">
             <a:extLst xmlns:a="http://schemas.openxmlformats.org/drawingml/2006/main">
               <a:ext uri="{FF2B5EF4-FFF2-40B4-BE49-F238E27FC236}">
-                <a16:creationId xmlns:a16="http://schemas.microsoft.com/office/drawing/2014/main" id="{3D5EFACE-A813-4EDB-AA12-6DE44C9FE017}"/>
+                <a16:creationId xmlns:a16="http://schemas.microsoft.com/office/drawing/2014/main" id="{6D141B21-ABF5-4DC7-BC63-24AB820C210D}"/>
               </a:ext>
             </a:extLst>
           </p:cNvPr>
@@ -19537,7 +19639,7 @@
           <p:cNvPr id="16" name="">
             <a:extLst xmlns:a="http://schemas.openxmlformats.org/drawingml/2006/main">
               <a:ext uri="{FF2B5EF4-FFF2-40B4-BE49-F238E27FC236}">
-                <a16:creationId xmlns:a16="http://schemas.microsoft.com/office/drawing/2014/main" id="{526E8575-11F7-4857-8273-2CEC83C8DE9B}"/>
+                <a16:creationId xmlns:a16="http://schemas.microsoft.com/office/drawing/2014/main" id="{3CDC6B84-6F53-41E3-9768-3244B171D886}"/>
               </a:ext>
             </a:extLst>
           </p:cNvPr>
@@ -19587,7 +19689,7 @@
           <p:cNvPr id="17" name="">
             <a:extLst xmlns:a="http://schemas.openxmlformats.org/drawingml/2006/main">
               <a:ext uri="{FF2B5EF4-FFF2-40B4-BE49-F238E27FC236}">
-                <a16:creationId xmlns:a16="http://schemas.microsoft.com/office/drawing/2014/main" id="{C98D969D-1ED1-4397-BE2D-8C5DDA601E30}"/>
+                <a16:creationId xmlns:a16="http://schemas.microsoft.com/office/drawing/2014/main" id="{B53D4538-6D2B-498E-B605-3DC98EFB7297}"/>
               </a:ext>
             </a:extLst>
           </p:cNvPr>
@@ -19654,7 +19756,7 @@
           <p:cNvPr id="18" name="">
             <a:extLst xmlns:a="http://schemas.openxmlformats.org/drawingml/2006/main">
               <a:ext uri="{FF2B5EF4-FFF2-40B4-BE49-F238E27FC236}">
-                <a16:creationId xmlns:a16="http://schemas.microsoft.com/office/drawing/2014/main" id="{1BBFC45B-8643-44DC-AF6D-57EC21B72C07}"/>
+                <a16:creationId xmlns:a16="http://schemas.microsoft.com/office/drawing/2014/main" id="{AE68AF65-5C1E-4CEE-A6BD-F70D4FCB0F2F}"/>
               </a:ext>
             </a:extLst>
           </p:cNvPr>
@@ -19689,7 +19791,7 @@
           <p:cNvPr id="19" name="">
             <a:extLst xmlns:a="http://schemas.openxmlformats.org/drawingml/2006/main">
               <a:ext uri="{FF2B5EF4-FFF2-40B4-BE49-F238E27FC236}">
-                <a16:creationId xmlns:a16="http://schemas.microsoft.com/office/drawing/2014/main" id="{94C30E75-E690-408A-8403-7AA412C4EA68}"/>
+                <a16:creationId xmlns:a16="http://schemas.microsoft.com/office/drawing/2014/main" id="{311A136F-2F12-405E-A2FE-069CA9C4A4AC}"/>
               </a:ext>
             </a:extLst>
           </p:cNvPr>
@@ -19739,7 +19841,7 @@
           <p:cNvPr id="20" name="">
             <a:extLst xmlns:a="http://schemas.openxmlformats.org/drawingml/2006/main">
               <a:ext uri="{FF2B5EF4-FFF2-40B4-BE49-F238E27FC236}">
-                <a16:creationId xmlns:a16="http://schemas.microsoft.com/office/drawing/2014/main" id="{A1637672-2234-4BB2-9209-5D90BE82D06A}"/>
+                <a16:creationId xmlns:a16="http://schemas.microsoft.com/office/drawing/2014/main" id="{6240F159-DB0B-4C36-A44F-0BDBFBDCD32B}"/>
               </a:ext>
             </a:extLst>
           </p:cNvPr>
@@ -19806,7 +19908,7 @@
           <p:cNvPr id="21" name="">
             <a:extLst xmlns:a="http://schemas.openxmlformats.org/drawingml/2006/main">
               <a:ext uri="{FF2B5EF4-FFF2-40B4-BE49-F238E27FC236}">
-                <a16:creationId xmlns:a16="http://schemas.microsoft.com/office/drawing/2014/main" id="{54A7F979-BB55-4FCC-954B-BFBC98BA7D94}"/>
+                <a16:creationId xmlns:a16="http://schemas.microsoft.com/office/drawing/2014/main" id="{63252277-635E-4704-9BE4-BCC887E1BD1C}"/>
               </a:ext>
             </a:extLst>
           </p:cNvPr>
@@ -19847,7 +19949,7 @@
           <p:cNvPr id="22" name="">
             <a:extLst xmlns:a="http://schemas.openxmlformats.org/drawingml/2006/main">
               <a:ext uri="{FF2B5EF4-FFF2-40B4-BE49-F238E27FC236}">
-                <a16:creationId xmlns:a16="http://schemas.microsoft.com/office/drawing/2014/main" id="{158FE1EF-7B7A-4527-9791-C62061A88534}"/>
+                <a16:creationId xmlns:a16="http://schemas.microsoft.com/office/drawing/2014/main" id="{656F169C-5D3B-43AE-91FC-E829E90D21F8}"/>
               </a:ext>
             </a:extLst>
           </p:cNvPr>
@@ -19897,7 +19999,7 @@
           <p:cNvPr id="23" name="">
             <a:extLst xmlns:a="http://schemas.openxmlformats.org/drawingml/2006/main">
               <a:ext uri="{FF2B5EF4-FFF2-40B4-BE49-F238E27FC236}">
-                <a16:creationId xmlns:a16="http://schemas.microsoft.com/office/drawing/2014/main" id="{B8754653-10EF-4072-8783-59F1897CD505}"/>
+                <a16:creationId xmlns:a16="http://schemas.microsoft.com/office/drawing/2014/main" id="{19257DA8-C2D2-48FC-B40A-28431DDF5035}"/>
               </a:ext>
             </a:extLst>
           </p:cNvPr>
@@ -19937,7 +20039,7 @@
                   <a:srgbClr val="526174"/>
                 </a:solidFill>
               </a:rPr>
-              <a:t>support / contradict</a:t>
+              <a:t>S support / C contradict</a:t>
             </a:r>
           </a:p>
           <a:p xmlns:a="http://schemas.openxmlformats.org/drawingml/2006/main">
@@ -19954,7 +20056,7 @@
                   <a:srgbClr val="526174"/>
                 </a:solidFill>
               </a:rPr>
-              <a:t>/ unknown</a:t>
+              <a:t>/ U unknown</a:t>
             </a:r>
           </a:p>
         </p:txBody>
@@ -19964,7 +20066,7 @@
           <p:cNvPr id="24" name="">
             <a:extLst xmlns:a="http://schemas.openxmlformats.org/drawingml/2006/main">
               <a:ext uri="{FF2B5EF4-FFF2-40B4-BE49-F238E27FC236}">
-                <a16:creationId xmlns:a16="http://schemas.microsoft.com/office/drawing/2014/main" id="{719A3B89-DFDB-479F-9850-1CB05F9C673D}"/>
+                <a16:creationId xmlns:a16="http://schemas.microsoft.com/office/drawing/2014/main" id="{74A9B410-9C9E-494D-BCEB-4E2E6E548336}"/>
               </a:ext>
             </a:extLst>
           </p:cNvPr>
@@ -20014,7 +20116,7 @@
           <p:cNvPr id="25" name="">
             <a:extLst xmlns:a="http://schemas.openxmlformats.org/drawingml/2006/main">
               <a:ext uri="{FF2B5EF4-FFF2-40B4-BE49-F238E27FC236}">
-                <a16:creationId xmlns:a16="http://schemas.microsoft.com/office/drawing/2014/main" id="{C6E4035B-00C6-4021-8E6C-BB7766B5BC9E}"/>
+                <a16:creationId xmlns:a16="http://schemas.microsoft.com/office/drawing/2014/main" id="{48DEFCBF-E71C-4ED9-A1AA-F878E46F0A2A}"/>
               </a:ext>
             </a:extLst>
           </p:cNvPr>
@@ -20049,7 +20151,7 @@
           <p:cNvPr id="26" name="">
             <a:extLst xmlns:a="http://schemas.openxmlformats.org/drawingml/2006/main">
               <a:ext uri="{FF2B5EF4-FFF2-40B4-BE49-F238E27FC236}">
-                <a16:creationId xmlns:a16="http://schemas.microsoft.com/office/drawing/2014/main" id="{1E53F26A-A65D-4A9D-B78F-4EBB38F9F452}"/>
+                <a16:creationId xmlns:a16="http://schemas.microsoft.com/office/drawing/2014/main" id="{1BCBAFB4-037E-45B8-8F9F-95CE29709B71}"/>
               </a:ext>
             </a:extLst>
           </p:cNvPr>
@@ -20099,7 +20201,7 @@
           <p:cNvPr id="27" name="">
             <a:extLst xmlns:a="http://schemas.openxmlformats.org/drawingml/2006/main">
               <a:ext uri="{FF2B5EF4-FFF2-40B4-BE49-F238E27FC236}">
-                <a16:creationId xmlns:a16="http://schemas.microsoft.com/office/drawing/2014/main" id="{2B05D140-1625-487E-9AF9-FF8873906772}"/>
+                <a16:creationId xmlns:a16="http://schemas.microsoft.com/office/drawing/2014/main" id="{EB5C4F10-E23C-495D-B506-12B6B5FFC01D}"/>
               </a:ext>
             </a:extLst>
           </p:cNvPr>
@@ -20139,7 +20241,7 @@
                   <a:srgbClr val="0F172A"/>
                 </a:solidFill>
               </a:rPr>
-              <a:t>exists i: state(ci) = contradict</a:t>
+              <a:t>exists i: state(ci) = C</a:t>
             </a:r>
           </a:p>
         </p:txBody>
@@ -20149,7 +20251,7 @@
           <p:cNvPr id="28" name="">
             <a:extLst xmlns:a="http://schemas.openxmlformats.org/drawingml/2006/main">
               <a:ext uri="{FF2B5EF4-FFF2-40B4-BE49-F238E27FC236}">
-                <a16:creationId xmlns:a16="http://schemas.microsoft.com/office/drawing/2014/main" id="{3BDBABC5-7DA9-4F21-8D30-333679DB0242}"/>
+                <a16:creationId xmlns:a16="http://schemas.microsoft.com/office/drawing/2014/main" id="{7572C33C-646C-4C17-887D-1D093DFD0A41}"/>
               </a:ext>
             </a:extLst>
           </p:cNvPr>
@@ -20199,7 +20301,7 @@
           <p:cNvPr id="29" name="">
             <a:extLst xmlns:a="http://schemas.openxmlformats.org/drawingml/2006/main">
               <a:ext uri="{FF2B5EF4-FFF2-40B4-BE49-F238E27FC236}">
-                <a16:creationId xmlns:a16="http://schemas.microsoft.com/office/drawing/2014/main" id="{EB681483-BFAD-41E0-B1D5-944F48C6B5FE}"/>
+                <a16:creationId xmlns:a16="http://schemas.microsoft.com/office/drawing/2014/main" id="{CE4CB502-DECD-44D1-A56E-12383CD558B1}"/>
               </a:ext>
             </a:extLst>
           </p:cNvPr>
@@ -20230,7 +20332,7 @@
           <p:cNvPr id="30" name="">
             <a:extLst xmlns:a="http://schemas.openxmlformats.org/drawingml/2006/main">
               <a:ext uri="{FF2B5EF4-FFF2-40B4-BE49-F238E27FC236}">
-                <a16:creationId xmlns:a16="http://schemas.microsoft.com/office/drawing/2014/main" id="{71BF6129-6076-483F-B130-B9BF22FCC3E7}"/>
+                <a16:creationId xmlns:a16="http://schemas.microsoft.com/office/drawing/2014/main" id="{39507756-A50D-418C-A718-CB69FBCE8EFC}"/>
               </a:ext>
             </a:extLst>
           </p:cNvPr>
@@ -20280,7 +20382,7 @@
           <p:cNvPr id="31" name="">
             <a:extLst xmlns:a="http://schemas.openxmlformats.org/drawingml/2006/main">
               <a:ext uri="{FF2B5EF4-FFF2-40B4-BE49-F238E27FC236}">
-                <a16:creationId xmlns:a16="http://schemas.microsoft.com/office/drawing/2014/main" id="{4E608F2F-69CD-46A9-9D20-32923F1D19B4}"/>
+                <a16:creationId xmlns:a16="http://schemas.microsoft.com/office/drawing/2014/main" id="{41CAE3AB-1CD0-4204-B968-9B58CE1D0971}"/>
               </a:ext>
             </a:extLst>
           </p:cNvPr>
@@ -20320,7 +20422,7 @@
                   <a:srgbClr val="0F172A"/>
                 </a:solidFill>
               </a:rPr>
-              <a:t>for all i: state(ci) = support; no extra factual claim</a:t>
+              <a:t>for all i: state(ci) = S; no extra factual claim</a:t>
             </a:r>
           </a:p>
         </p:txBody>
@@ -20330,7 +20432,7 @@
           <p:cNvPr id="32" name="">
             <a:extLst xmlns:a="http://schemas.openxmlformats.org/drawingml/2006/main">
               <a:ext uri="{FF2B5EF4-FFF2-40B4-BE49-F238E27FC236}">
-                <a16:creationId xmlns:a16="http://schemas.microsoft.com/office/drawing/2014/main" id="{A6349AEA-7364-4477-848D-CAE363A3FE66}"/>
+                <a16:creationId xmlns:a16="http://schemas.microsoft.com/office/drawing/2014/main" id="{972D00FB-F6E1-4CB1-BBEC-045C2441EC45}"/>
               </a:ext>
             </a:extLst>
           </p:cNvPr>
@@ -20380,7 +20482,7 @@
           <p:cNvPr id="33" name="">
             <a:extLst xmlns:a="http://schemas.openxmlformats.org/drawingml/2006/main">
               <a:ext uri="{FF2B5EF4-FFF2-40B4-BE49-F238E27FC236}">
-                <a16:creationId xmlns:a16="http://schemas.microsoft.com/office/drawing/2014/main" id="{E3865589-F548-4E3D-8529-B5223EF11AF2}"/>
+                <a16:creationId xmlns:a16="http://schemas.microsoft.com/office/drawing/2014/main" id="{5E13C481-AAA3-4C68-9C71-BDA29B586042}"/>
               </a:ext>
             </a:extLst>
           </p:cNvPr>
@@ -20411,7 +20513,7 @@
           <p:cNvPr id="34" name="">
             <a:extLst xmlns:a="http://schemas.openxmlformats.org/drawingml/2006/main">
               <a:ext uri="{FF2B5EF4-FFF2-40B4-BE49-F238E27FC236}">
-                <a16:creationId xmlns:a16="http://schemas.microsoft.com/office/drawing/2014/main" id="{7B7C2377-839C-4A57-884D-836C335A443E}"/>
+                <a16:creationId xmlns:a16="http://schemas.microsoft.com/office/drawing/2014/main" id="{F73AF534-2F5B-485F-A7D7-14F3046F9B66}"/>
               </a:ext>
             </a:extLst>
           </p:cNvPr>
@@ -20461,7 +20563,7 @@
           <p:cNvPr id="35" name="">
             <a:extLst xmlns:a="http://schemas.openxmlformats.org/drawingml/2006/main">
               <a:ext uri="{FF2B5EF4-FFF2-40B4-BE49-F238E27FC236}">
-                <a16:creationId xmlns:a16="http://schemas.microsoft.com/office/drawing/2014/main" id="{892C139C-6A4D-4AFD-953A-39B76F685B8F}"/>
+                <a16:creationId xmlns:a16="http://schemas.microsoft.com/office/drawing/2014/main" id="{BB40F332-2B7E-49E9-A5D8-881F31DFF9BD}"/>
               </a:ext>
             </a:extLst>
           </p:cNvPr>
@@ -20511,7 +20613,7 @@
           <p:cNvPr id="36" name="">
             <a:extLst xmlns:a="http://schemas.openxmlformats.org/drawingml/2006/main">
               <a:ext uri="{FF2B5EF4-FFF2-40B4-BE49-F238E27FC236}">
-                <a16:creationId xmlns:a16="http://schemas.microsoft.com/office/drawing/2014/main" id="{04548B0E-AEA9-44E3-BF35-228A70EBBB41}"/>
+                <a16:creationId xmlns:a16="http://schemas.microsoft.com/office/drawing/2014/main" id="{79333D69-BCCB-4FEB-88C5-C9441A99BC7E}"/>
               </a:ext>
             </a:extLst>
           </p:cNvPr>
@@ -20561,7 +20663,7 @@
           <p:cNvPr id="37" name="">
             <a:extLst xmlns:a="http://schemas.openxmlformats.org/drawingml/2006/main">
               <a:ext uri="{FF2B5EF4-FFF2-40B4-BE49-F238E27FC236}">
-                <a16:creationId xmlns:a16="http://schemas.microsoft.com/office/drawing/2014/main" id="{B106F90C-EA62-4947-9CF2-B1F793BFAB04}"/>
+                <a16:creationId xmlns:a16="http://schemas.microsoft.com/office/drawing/2014/main" id="{78A43A7B-457A-44A1-9841-7F3AD6332F6C}"/>
               </a:ext>
             </a:extLst>
           </p:cNvPr>
@@ -20592,7 +20694,7 @@
           <p:cNvPr id="38" name="source-7">
             <a:extLst xmlns:a="http://schemas.openxmlformats.org/drawingml/2006/main">
               <a:ext uri="{FF2B5EF4-FFF2-40B4-BE49-F238E27FC236}">
-                <a16:creationId xmlns:a16="http://schemas.microsoft.com/office/drawing/2014/main" id="{99548027-F782-418B-BA9D-0D27B0B276CC}"/>
+                <a16:creationId xmlns:a16="http://schemas.microsoft.com/office/drawing/2014/main" id="{00AF63F6-0F40-4059-B77A-AB38DA2DF405}"/>
               </a:ext>
             </a:extLst>
           </p:cNvPr>
@@ -20632,7 +20734,7 @@
                   <a:srgbClr val="526174"/>
                 </a:solidFill>
               </a:rPr>
-              <a:t>[3] Context-faithfulness task design  [7] v91 clause and claim verifier</a:t>
+              <a:t>Report Fig. 2a  |  [3] Context-faithfulness design  [7] v91 clause and claim verifier</a:t>
             </a:r>
           </a:p>
         </p:txBody>
@@ -20642,7 +20744,7 @@
           <p:cNvPr id="39" name="page-7">
             <a:extLst xmlns:a="http://schemas.openxmlformats.org/drawingml/2006/main">
               <a:ext uri="{FF2B5EF4-FFF2-40B4-BE49-F238E27FC236}">
-                <a16:creationId xmlns:a16="http://schemas.microsoft.com/office/drawing/2014/main" id="{A1BA36DA-F5B7-4C03-9A81-35D065DA57E7}"/>
+                <a16:creationId xmlns:a16="http://schemas.microsoft.com/office/drawing/2014/main" id="{4E8D4855-39AF-4891-B48F-29CC2DECAEB0}"/>
               </a:ext>
             </a:extLst>
           </p:cNvPr>
@@ -20690,7 +20792,7 @@
     </p:spTree>
     <p:extLst>
       <p:ext uri="{BB962C8B-B14F-4D97-AF65-F5344CB8AC3E}">
-        <p14:creationId xmlns:p14="http://schemas.microsoft.com/office/powerpoint/2010/main" val="604397222"/>
+        <p14:creationId xmlns:p14="http://schemas.microsoft.com/office/powerpoint/2010/main" val="1161098434"/>
       </p:ext>
     </p:extLst>
   </p:cSld>
@@ -20721,7 +20823,7 @@
           <p:cNvPr id="20" name="kicker-8">
             <a:extLst xmlns:a="http://schemas.openxmlformats.org/drawingml/2006/main">
               <a:ext uri="{FF2B5EF4-FFF2-40B4-BE49-F238E27FC236}">
-                <a16:creationId xmlns:a16="http://schemas.microsoft.com/office/drawing/2014/main" id="{18A7C5C0-4E42-416F-AA5F-61CAD978E86D}"/>
+                <a16:creationId xmlns:a16="http://schemas.microsoft.com/office/drawing/2014/main" id="{357EE582-102B-4726-BD93-690AC1F26329}"/>
               </a:ext>
             </a:extLst>
           </p:cNvPr>
@@ -20771,7 +20873,7 @@
           <p:cNvPr id="2" name="title-8">
             <a:extLst xmlns:a="http://schemas.openxmlformats.org/drawingml/2006/main">
               <a:ext uri="{FF2B5EF4-FFF2-40B4-BE49-F238E27FC236}">
-                <a16:creationId xmlns:a16="http://schemas.microsoft.com/office/drawing/2014/main" id="{B47EEB21-14BE-4E7F-9F09-1EE80CCF5F93}"/>
+                <a16:creationId xmlns:a16="http://schemas.microsoft.com/office/drawing/2014/main" id="{5BA37C50-A1C7-4451-AEF1-67EC987348A9}"/>
               </a:ext>
             </a:extLst>
           </p:cNvPr>
@@ -20821,7 +20923,7 @@
           <p:cNvPr id="3" name="">
             <a:extLst xmlns:a="http://schemas.openxmlformats.org/drawingml/2006/main">
               <a:ext uri="{FF2B5EF4-FFF2-40B4-BE49-F238E27FC236}">
-                <a16:creationId xmlns:a16="http://schemas.microsoft.com/office/drawing/2014/main" id="{57CBC113-3131-43BE-956D-F54976E933E1}"/>
+                <a16:creationId xmlns:a16="http://schemas.microsoft.com/office/drawing/2014/main" id="{3E4A880F-7D1B-461A-BC03-17C66ADB1146}"/>
               </a:ext>
             </a:extLst>
           </p:cNvPr>
@@ -20852,7 +20954,7 @@
           <p:cNvPr id="4" name="">
             <a:extLst xmlns:a="http://schemas.openxmlformats.org/drawingml/2006/main">
               <a:ext uri="{FF2B5EF4-FFF2-40B4-BE49-F238E27FC236}">
-                <a16:creationId xmlns:a16="http://schemas.microsoft.com/office/drawing/2014/main" id="{EB6BF604-117B-4F46-B90C-3A96D18A3382}"/>
+                <a16:creationId xmlns:a16="http://schemas.microsoft.com/office/drawing/2014/main" id="{1F98FB0D-0149-46F6-93F0-3B3D5140BF88}"/>
               </a:ext>
             </a:extLst>
           </p:cNvPr>
@@ -20902,7 +21004,7 @@
           <p:cNvPr id="5" name="">
             <a:extLst xmlns:a="http://schemas.openxmlformats.org/drawingml/2006/main">
               <a:ext uri="{FF2B5EF4-FFF2-40B4-BE49-F238E27FC236}">
-                <a16:creationId xmlns:a16="http://schemas.microsoft.com/office/drawing/2014/main" id="{2DED919A-3658-4EEB-9E12-8E956502783E}"/>
+                <a16:creationId xmlns:a16="http://schemas.microsoft.com/office/drawing/2014/main" id="{D99D3352-48F9-4CDB-BB6F-5C375F259A0F}"/>
               </a:ext>
             </a:extLst>
           </p:cNvPr>
@@ -20943,7 +21045,7 @@
           <p:cNvPr id="6" name="">
             <a:extLst xmlns:a="http://schemas.openxmlformats.org/drawingml/2006/main">
               <a:ext uri="{FF2B5EF4-FFF2-40B4-BE49-F238E27FC236}">
-                <a16:creationId xmlns:a16="http://schemas.microsoft.com/office/drawing/2014/main" id="{5B0820F0-5A5C-4FDD-AC56-1128F64CA1EF}"/>
+                <a16:creationId xmlns:a16="http://schemas.microsoft.com/office/drawing/2014/main" id="{8E86E3D1-C2E2-455B-B7FE-8B308FE717C4}"/>
               </a:ext>
             </a:extLst>
           </p:cNvPr>
@@ -20993,7 +21095,7 @@
           <p:cNvPr id="7" name="">
             <a:extLst xmlns:a="http://schemas.openxmlformats.org/drawingml/2006/main">
               <a:ext uri="{FF2B5EF4-FFF2-40B4-BE49-F238E27FC236}">
-                <a16:creationId xmlns:a16="http://schemas.microsoft.com/office/drawing/2014/main" id="{5ACD71EA-BC70-4D59-8B7F-518D8A0BD9C9}"/>
+                <a16:creationId xmlns:a16="http://schemas.microsoft.com/office/drawing/2014/main" id="{0E35DBE4-97B1-4FB2-A64D-C26970C04056}"/>
               </a:ext>
             </a:extLst>
           </p:cNvPr>
@@ -21043,7 +21145,7 @@
           <p:cNvPr id="8" name="">
             <a:extLst xmlns:a="http://schemas.openxmlformats.org/drawingml/2006/main">
               <a:ext uri="{FF2B5EF4-FFF2-40B4-BE49-F238E27FC236}">
-                <a16:creationId xmlns:a16="http://schemas.microsoft.com/office/drawing/2014/main" id="{D32665CF-E724-4A51-8E33-4DD84CD20343}"/>
+                <a16:creationId xmlns:a16="http://schemas.microsoft.com/office/drawing/2014/main" id="{68311AFD-E037-4BA9-A092-FD2882275D0E}"/>
               </a:ext>
             </a:extLst>
           </p:cNvPr>
@@ -21093,7 +21195,7 @@
           <p:cNvPr id="9" name="">
             <a:extLst xmlns:a="http://schemas.openxmlformats.org/drawingml/2006/main">
               <a:ext uri="{FF2B5EF4-FFF2-40B4-BE49-F238E27FC236}">
-                <a16:creationId xmlns:a16="http://schemas.microsoft.com/office/drawing/2014/main" id="{F7E3F22A-A477-4F3A-BFCC-7591307B1B8B}"/>
+                <a16:creationId xmlns:a16="http://schemas.microsoft.com/office/drawing/2014/main" id="{BFCEBA5F-04C3-40A9-B4B1-D5A260CD7BD2}"/>
               </a:ext>
             </a:extLst>
           </p:cNvPr>
@@ -21143,7 +21245,7 @@
           <p:cNvPr id="10" name="">
             <a:extLst xmlns:a="http://schemas.openxmlformats.org/drawingml/2006/main">
               <a:ext uri="{FF2B5EF4-FFF2-40B4-BE49-F238E27FC236}">
-                <a16:creationId xmlns:a16="http://schemas.microsoft.com/office/drawing/2014/main" id="{501AB780-43D3-4196-AC14-859EB8F2A1B8}"/>
+                <a16:creationId xmlns:a16="http://schemas.microsoft.com/office/drawing/2014/main" id="{34E933C2-B039-4E89-BB19-5E29F1CCC2A8}"/>
               </a:ext>
             </a:extLst>
           </p:cNvPr>
@@ -21184,7 +21286,7 @@
           <p:cNvPr id="11" name="">
             <a:extLst xmlns:a="http://schemas.openxmlformats.org/drawingml/2006/main">
               <a:ext uri="{FF2B5EF4-FFF2-40B4-BE49-F238E27FC236}">
-                <a16:creationId xmlns:a16="http://schemas.microsoft.com/office/drawing/2014/main" id="{0DCCF604-1E46-401D-AB91-C7F53B595F31}"/>
+                <a16:creationId xmlns:a16="http://schemas.microsoft.com/office/drawing/2014/main" id="{F88F2B7A-3FB5-42D3-86C2-62BF1B77D869}"/>
               </a:ext>
             </a:extLst>
           </p:cNvPr>
@@ -21234,7 +21336,7 @@
           <p:cNvPr id="12" name="">
             <a:extLst xmlns:a="http://schemas.openxmlformats.org/drawingml/2006/main">
               <a:ext uri="{FF2B5EF4-FFF2-40B4-BE49-F238E27FC236}">
-                <a16:creationId xmlns:a16="http://schemas.microsoft.com/office/drawing/2014/main" id="{D85254BD-20EF-4BF6-AAFC-0F3B9C2CDF9F}"/>
+                <a16:creationId xmlns:a16="http://schemas.microsoft.com/office/drawing/2014/main" id="{C23B3953-73E6-49C3-BCFD-56BFE044A61C}"/>
               </a:ext>
             </a:extLst>
           </p:cNvPr>
@@ -21284,7 +21386,7 @@
           <p:cNvPr id="13" name="">
             <a:extLst xmlns:a="http://schemas.openxmlformats.org/drawingml/2006/main">
               <a:ext uri="{FF2B5EF4-FFF2-40B4-BE49-F238E27FC236}">
-                <a16:creationId xmlns:a16="http://schemas.microsoft.com/office/drawing/2014/main" id="{92DCBB82-6E1D-4736-9D22-3E5F8D48AEF8}"/>
+                <a16:creationId xmlns:a16="http://schemas.microsoft.com/office/drawing/2014/main" id="{43C2CA70-5715-4A93-A8FE-B25EE5A0604B}"/>
               </a:ext>
             </a:extLst>
           </p:cNvPr>
@@ -21334,7 +21436,7 @@
           <p:cNvPr id="14" name="">
             <a:extLst xmlns:a="http://schemas.openxmlformats.org/drawingml/2006/main">
               <a:ext uri="{FF2B5EF4-FFF2-40B4-BE49-F238E27FC236}">
-                <a16:creationId xmlns:a16="http://schemas.microsoft.com/office/drawing/2014/main" id="{F4A62FAB-75E3-4410-A4D6-08F468E5541E}"/>
+                <a16:creationId xmlns:a16="http://schemas.microsoft.com/office/drawing/2014/main" id="{310D4246-0ABA-45DA-8F98-B86E5C6C1B75}"/>
               </a:ext>
             </a:extLst>
           </p:cNvPr>
@@ -21384,7 +21486,7 @@
           <p:cNvPr id="15" name="">
             <a:extLst xmlns:a="http://schemas.openxmlformats.org/drawingml/2006/main">
               <a:ext uri="{FF2B5EF4-FFF2-40B4-BE49-F238E27FC236}">
-                <a16:creationId xmlns:a16="http://schemas.microsoft.com/office/drawing/2014/main" id="{CA659970-0DEE-4219-80F3-886A27B502C9}"/>
+                <a16:creationId xmlns:a16="http://schemas.microsoft.com/office/drawing/2014/main" id="{0449E9E3-9E69-4581-B678-ED43A682DCE5}"/>
               </a:ext>
             </a:extLst>
           </p:cNvPr>
@@ -21419,7 +21521,7 @@
           <p:cNvPr id="16" name="">
             <a:extLst xmlns:a="http://schemas.openxmlformats.org/drawingml/2006/main">
               <a:ext uri="{FF2B5EF4-FFF2-40B4-BE49-F238E27FC236}">
-                <a16:creationId xmlns:a16="http://schemas.microsoft.com/office/drawing/2014/main" id="{60CC11CC-C33C-4D80-80A7-8B66FC1653A1}"/>
+                <a16:creationId xmlns:a16="http://schemas.microsoft.com/office/drawing/2014/main" id="{20D2E5B5-2B0D-4D28-A6EA-D31BEFBF349F}"/>
               </a:ext>
             </a:extLst>
           </p:cNvPr>
@@ -21469,7 +21571,7 @@
           <p:cNvPr id="17" name="">
             <a:extLst xmlns:a="http://schemas.openxmlformats.org/drawingml/2006/main">
               <a:ext uri="{FF2B5EF4-FFF2-40B4-BE49-F238E27FC236}">
-                <a16:creationId xmlns:a16="http://schemas.microsoft.com/office/drawing/2014/main" id="{BC0D63BE-234D-47C5-8ED5-89FFF4DC697D}"/>
+                <a16:creationId xmlns:a16="http://schemas.microsoft.com/office/drawing/2014/main" id="{F6D94704-B023-46FF-AFAD-F481DF5BC673}"/>
               </a:ext>
             </a:extLst>
           </p:cNvPr>
@@ -21500,7 +21602,7 @@
           <p:cNvPr id="18" name="source-8">
             <a:extLst xmlns:a="http://schemas.openxmlformats.org/drawingml/2006/main">
               <a:ext uri="{FF2B5EF4-FFF2-40B4-BE49-F238E27FC236}">
-                <a16:creationId xmlns:a16="http://schemas.microsoft.com/office/drawing/2014/main" id="{63983B02-AE9D-4E05-8138-3378AFEE237F}"/>
+                <a16:creationId xmlns:a16="http://schemas.microsoft.com/office/drawing/2014/main" id="{A9FBDFA7-E522-4E73-B9DE-8F1A34F6C02D}"/>
               </a:ext>
             </a:extLst>
           </p:cNvPr>
@@ -21550,7 +21652,7 @@
           <p:cNvPr id="19" name="page-8">
             <a:extLst xmlns:a="http://schemas.openxmlformats.org/drawingml/2006/main">
               <a:ext uri="{FF2B5EF4-FFF2-40B4-BE49-F238E27FC236}">
-                <a16:creationId xmlns:a16="http://schemas.microsoft.com/office/drawing/2014/main" id="{B180A76D-7059-4B18-82CE-FAA46C66E843}"/>
+                <a16:creationId xmlns:a16="http://schemas.microsoft.com/office/drawing/2014/main" id="{6C6E730D-6A18-48B8-97F8-5F6343F37E19}"/>
               </a:ext>
             </a:extLst>
           </p:cNvPr>
@@ -21598,7 +21700,7 @@
     </p:spTree>
     <p:extLst>
       <p:ext uri="{BB962C8B-B14F-4D97-AF65-F5344CB8AC3E}">
-        <p14:creationId xmlns:p14="http://schemas.microsoft.com/office/powerpoint/2010/main" val="1376066605"/>
+        <p14:creationId xmlns:p14="http://schemas.microsoft.com/office/powerpoint/2010/main" val="331821385"/>
       </p:ext>
     </p:extLst>
   </p:cSld>
@@ -21629,7 +21731,7 @@
           <p:cNvPr id="53" name="kicker-9">
             <a:extLst xmlns:a="http://schemas.openxmlformats.org/drawingml/2006/main">
               <a:ext uri="{FF2B5EF4-FFF2-40B4-BE49-F238E27FC236}">
-                <a16:creationId xmlns:a16="http://schemas.microsoft.com/office/drawing/2014/main" id="{6CC98ABD-4CEE-4922-A70E-86870D6EBFC0}"/>
+                <a16:creationId xmlns:a16="http://schemas.microsoft.com/office/drawing/2014/main" id="{8AD3F104-83CB-43B2-9AFD-F0132AE43D3C}"/>
               </a:ext>
             </a:extLst>
           </p:cNvPr>
@@ -21679,7 +21781,7 @@
           <p:cNvPr id="2" name="title-9">
             <a:extLst xmlns:a="http://schemas.openxmlformats.org/drawingml/2006/main">
               <a:ext uri="{FF2B5EF4-FFF2-40B4-BE49-F238E27FC236}">
-                <a16:creationId xmlns:a16="http://schemas.microsoft.com/office/drawing/2014/main" id="{AF0A7F00-CBF4-4C8B-BE46-ABC9D655BBAE}"/>
+                <a16:creationId xmlns:a16="http://schemas.microsoft.com/office/drawing/2014/main" id="{7D8A7457-1AD7-4CD7-BAB1-C670117E1EFA}"/>
               </a:ext>
             </a:extLst>
           </p:cNvPr>
@@ -21729,7 +21831,7 @@
           <p:cNvPr id="3" name="">
             <a:extLst xmlns:a="http://schemas.openxmlformats.org/drawingml/2006/main">
               <a:ext uri="{FF2B5EF4-FFF2-40B4-BE49-F238E27FC236}">
-                <a16:creationId xmlns:a16="http://schemas.microsoft.com/office/drawing/2014/main" id="{B0804F74-5FF9-43EF-B8A7-0804325E1DA2}"/>
+                <a16:creationId xmlns:a16="http://schemas.microsoft.com/office/drawing/2014/main" id="{A58220DC-BA2B-44A7-A925-D78C9BAC5EAA}"/>
               </a:ext>
             </a:extLst>
           </p:cNvPr>
@@ -21760,7 +21862,7 @@
           <p:cNvPr id="4" name="">
             <a:extLst xmlns:a="http://schemas.openxmlformats.org/drawingml/2006/main">
               <a:ext uri="{FF2B5EF4-FFF2-40B4-BE49-F238E27FC236}">
-                <a16:creationId xmlns:a16="http://schemas.microsoft.com/office/drawing/2014/main" id="{80B121D6-77A3-4DD8-8DDE-2D2A76CABFEF}"/>
+                <a16:creationId xmlns:a16="http://schemas.microsoft.com/office/drawing/2014/main" id="{8FC137F4-B5C0-4568-A02A-F48A9AC2CD40}"/>
               </a:ext>
             </a:extLst>
           </p:cNvPr>
@@ -21800,7 +21902,7 @@
                   <a:srgbClr val="526174"/>
                 </a:solidFill>
               </a:rPr>
-              <a:t>The trace preserved why a row was resolved, which source supported it, and which relation was tested.</a:t>
+              <a:t>The trace records why a row was resolved, its source, and the relation that was tested.</a:t>
             </a:r>
           </a:p>
         </p:txBody>
@@ -21810,7 +21912,7 @@
           <p:cNvPr id="5" name="">
             <a:extLst xmlns:a="http://schemas.openxmlformats.org/drawingml/2006/main">
               <a:ext uri="{FF2B5EF4-FFF2-40B4-BE49-F238E27FC236}">
-                <a16:creationId xmlns:a16="http://schemas.microsoft.com/office/drawing/2014/main" id="{848C9508-E432-4136-8BE9-C20F595B56C2}"/>
+                <a16:creationId xmlns:a16="http://schemas.microsoft.com/office/drawing/2014/main" id="{AA52126B-F14C-449A-AD59-DC9B9544CC4F}"/>
               </a:ext>
             </a:extLst>
           </p:cNvPr>
@@ -21843,7 +21945,7 @@
           <p:cNvPr id="6" name="">
             <a:extLst xmlns:a="http://schemas.openxmlformats.org/drawingml/2006/main">
               <a:ext uri="{FF2B5EF4-FFF2-40B4-BE49-F238E27FC236}">
-                <a16:creationId xmlns:a16="http://schemas.microsoft.com/office/drawing/2014/main" id="{BBF72ED0-916C-4065-BCB9-D97BEF4993BB}"/>
+                <a16:creationId xmlns:a16="http://schemas.microsoft.com/office/drawing/2014/main" id="{86C11473-003D-48DF-84F7-1B76454E5AD5}"/>
               </a:ext>
             </a:extLst>
           </p:cNvPr>
@@ -21876,7 +21978,7 @@
           <p:cNvPr id="7" name="">
             <a:extLst xmlns:a="http://schemas.openxmlformats.org/drawingml/2006/main">
               <a:ext uri="{FF2B5EF4-FFF2-40B4-BE49-F238E27FC236}">
-                <a16:creationId xmlns:a16="http://schemas.microsoft.com/office/drawing/2014/main" id="{E3443B2C-C6B6-4074-A4B6-03EA78BD11BE}"/>
+                <a16:creationId xmlns:a16="http://schemas.microsoft.com/office/drawing/2014/main" id="{B225E947-BDAD-4AA2-A47D-4D3AF19A5C5C}"/>
               </a:ext>
             </a:extLst>
           </p:cNvPr>
@@ -21917,7 +22019,7 @@
           <p:cNvPr id="8" name="">
             <a:extLst xmlns:a="http://schemas.openxmlformats.org/drawingml/2006/main">
               <a:ext uri="{FF2B5EF4-FFF2-40B4-BE49-F238E27FC236}">
-                <a16:creationId xmlns:a16="http://schemas.microsoft.com/office/drawing/2014/main" id="{CA91D556-0511-4B98-8B46-9BF0E5744817}"/>
+                <a16:creationId xmlns:a16="http://schemas.microsoft.com/office/drawing/2014/main" id="{DEB94FBE-3B17-4D12-BAFB-6A0889D984AE}"/>
               </a:ext>
             </a:extLst>
           </p:cNvPr>
@@ -21984,7 +22086,7 @@
           <p:cNvPr id="9" name="">
             <a:extLst xmlns:a="http://schemas.openxmlformats.org/drawingml/2006/main">
               <a:ext uri="{FF2B5EF4-FFF2-40B4-BE49-F238E27FC236}">
-                <a16:creationId xmlns:a16="http://schemas.microsoft.com/office/drawing/2014/main" id="{E1EC0BEF-873B-4556-966B-4F2AE976E804}"/>
+                <a16:creationId xmlns:a16="http://schemas.microsoft.com/office/drawing/2014/main" id="{141EEAA1-3510-4556-89E6-940E894E108F}"/>
               </a:ext>
             </a:extLst>
           </p:cNvPr>
@@ -22034,7 +22136,7 @@
           <p:cNvPr id="10" name="">
             <a:extLst xmlns:a="http://schemas.openxmlformats.org/drawingml/2006/main">
               <a:ext uri="{FF2B5EF4-FFF2-40B4-BE49-F238E27FC236}">
-                <a16:creationId xmlns:a16="http://schemas.microsoft.com/office/drawing/2014/main" id="{A66945AA-13D2-4C19-AB70-BEA21021D770}"/>
+                <a16:creationId xmlns:a16="http://schemas.microsoft.com/office/drawing/2014/main" id="{B8E3E0A1-9C36-4340-8F97-6E459C01232A}"/>
               </a:ext>
             </a:extLst>
           </p:cNvPr>
@@ -22084,7 +22186,7 @@
           <p:cNvPr id="11" name="">
             <a:extLst xmlns:a="http://schemas.openxmlformats.org/drawingml/2006/main">
               <a:ext uri="{FF2B5EF4-FFF2-40B4-BE49-F238E27FC236}">
-                <a16:creationId xmlns:a16="http://schemas.microsoft.com/office/drawing/2014/main" id="{4E7AC492-0042-4652-8B54-1F4371101C7B}"/>
+                <a16:creationId xmlns:a16="http://schemas.microsoft.com/office/drawing/2014/main" id="{0883E38E-C23B-4A35-815E-B8F5B267EEDD}"/>
               </a:ext>
             </a:extLst>
           </p:cNvPr>
@@ -22134,7 +22236,7 @@
           <p:cNvPr id="12" name="">
             <a:extLst xmlns:a="http://schemas.openxmlformats.org/drawingml/2006/main">
               <a:ext uri="{FF2B5EF4-FFF2-40B4-BE49-F238E27FC236}">
-                <a16:creationId xmlns:a16="http://schemas.microsoft.com/office/drawing/2014/main" id="{664E6C89-6D34-4A73-BD14-DBDF695EE3D7}"/>
+                <a16:creationId xmlns:a16="http://schemas.microsoft.com/office/drawing/2014/main" id="{907EC476-C80A-49B0-B639-4CD9F4E52141}"/>
               </a:ext>
             </a:extLst>
           </p:cNvPr>
@@ -22184,7 +22286,7 @@
           <p:cNvPr id="13" name="">
             <a:extLst xmlns:a="http://schemas.openxmlformats.org/drawingml/2006/main">
               <a:ext uri="{FF2B5EF4-FFF2-40B4-BE49-F238E27FC236}">
-                <a16:creationId xmlns:a16="http://schemas.microsoft.com/office/drawing/2014/main" id="{2FFDFE5E-7755-4906-89C3-2496C81E28B4}"/>
+                <a16:creationId xmlns:a16="http://schemas.microsoft.com/office/drawing/2014/main" id="{FDB27A90-A4AD-4694-9E79-E9A9CEFEE5BF}"/>
               </a:ext>
             </a:extLst>
           </p:cNvPr>
@@ -22234,7 +22336,7 @@
           <p:cNvPr id="14" name="">
             <a:extLst xmlns:a="http://schemas.openxmlformats.org/drawingml/2006/main">
               <a:ext uri="{FF2B5EF4-FFF2-40B4-BE49-F238E27FC236}">
-                <a16:creationId xmlns:a16="http://schemas.microsoft.com/office/drawing/2014/main" id="{399C816D-6FC9-4DFD-89B6-94DC5D0E4AC2}"/>
+                <a16:creationId xmlns:a16="http://schemas.microsoft.com/office/drawing/2014/main" id="{18A77B24-16BC-45AA-824D-1BE0BDC9580A}"/>
               </a:ext>
             </a:extLst>
           </p:cNvPr>
@@ -22284,7 +22386,7 @@
           <p:cNvPr id="15" name="">
             <a:extLst xmlns:a="http://schemas.openxmlformats.org/drawingml/2006/main">
               <a:ext uri="{FF2B5EF4-FFF2-40B4-BE49-F238E27FC236}">
-                <a16:creationId xmlns:a16="http://schemas.microsoft.com/office/drawing/2014/main" id="{9A4D6D1D-8AA2-47F4-90A7-8C93133822DC}"/>
+                <a16:creationId xmlns:a16="http://schemas.microsoft.com/office/drawing/2014/main" id="{C13CDDDB-FDC0-47B5-BFCB-9885DDCDBC05}"/>
               </a:ext>
             </a:extLst>
           </p:cNvPr>
@@ -22334,7 +22436,7 @@
           <p:cNvPr id="16" name="">
             <a:extLst xmlns:a="http://schemas.openxmlformats.org/drawingml/2006/main">
               <a:ext uri="{FF2B5EF4-FFF2-40B4-BE49-F238E27FC236}">
-                <a16:creationId xmlns:a16="http://schemas.microsoft.com/office/drawing/2014/main" id="{64C593A6-EA0F-4D94-9423-ECFD559C8BFC}"/>
+                <a16:creationId xmlns:a16="http://schemas.microsoft.com/office/drawing/2014/main" id="{27B82AC4-4C95-43A0-87C3-A76DFAA867B6}"/>
               </a:ext>
             </a:extLst>
           </p:cNvPr>
@@ -22384,7 +22486,7 @@
           <p:cNvPr id="17" name="">
             <a:extLst xmlns:a="http://schemas.openxmlformats.org/drawingml/2006/main">
               <a:ext uri="{FF2B5EF4-FFF2-40B4-BE49-F238E27FC236}">
-                <a16:creationId xmlns:a16="http://schemas.microsoft.com/office/drawing/2014/main" id="{73644616-E2AA-4611-BB58-BC0D1CBACADF}"/>
+                <a16:creationId xmlns:a16="http://schemas.microsoft.com/office/drawing/2014/main" id="{D94CB622-31D1-42E4-BA5D-ADE7FA358C83}"/>
               </a:ext>
             </a:extLst>
           </p:cNvPr>
@@ -22434,7 +22536,7 @@
           <p:cNvPr id="18" name="">
             <a:extLst xmlns:a="http://schemas.openxmlformats.org/drawingml/2006/main">
               <a:ext uri="{FF2B5EF4-FFF2-40B4-BE49-F238E27FC236}">
-                <a16:creationId xmlns:a16="http://schemas.microsoft.com/office/drawing/2014/main" id="{271BFDDE-31CC-4055-BDF7-31F1BD271C4D}"/>
+                <a16:creationId xmlns:a16="http://schemas.microsoft.com/office/drawing/2014/main" id="{55636F9F-C231-4562-93A8-8ECFB647EF3C}"/>
               </a:ext>
             </a:extLst>
           </p:cNvPr>
@@ -22484,7 +22586,7 @@
           <p:cNvPr id="19" name="">
             <a:extLst xmlns:a="http://schemas.openxmlformats.org/drawingml/2006/main">
               <a:ext uri="{FF2B5EF4-FFF2-40B4-BE49-F238E27FC236}">
-                <a16:creationId xmlns:a16="http://schemas.microsoft.com/office/drawing/2014/main" id="{70C0E713-4A07-4CF3-9066-729C70E7025E}"/>
+                <a16:creationId xmlns:a16="http://schemas.microsoft.com/office/drawing/2014/main" id="{F6324A3A-EE7D-4A0F-82A1-A85A7E2501B1}"/>
               </a:ext>
             </a:extLst>
           </p:cNvPr>
@@ -22534,7 +22636,7 @@
           <p:cNvPr id="20" name="">
             <a:extLst xmlns:a="http://schemas.openxmlformats.org/drawingml/2006/main">
               <a:ext uri="{FF2B5EF4-FFF2-40B4-BE49-F238E27FC236}">
-                <a16:creationId xmlns:a16="http://schemas.microsoft.com/office/drawing/2014/main" id="{FE8C2D67-129F-47F8-818A-0C5B38A08D44}"/>
+                <a16:creationId xmlns:a16="http://schemas.microsoft.com/office/drawing/2014/main" id="{AC7A6007-DCFD-4EDE-8D96-A371B287F29C}"/>
               </a:ext>
             </a:extLst>
           </p:cNvPr>
@@ -22584,7 +22686,7 @@
           <p:cNvPr id="21" name="">
             <a:extLst xmlns:a="http://schemas.openxmlformats.org/drawingml/2006/main">
               <a:ext uri="{FF2B5EF4-FFF2-40B4-BE49-F238E27FC236}">
-                <a16:creationId xmlns:a16="http://schemas.microsoft.com/office/drawing/2014/main" id="{21C7AB76-DA03-47B5-8629-2BC0ECB20883}"/>
+                <a16:creationId xmlns:a16="http://schemas.microsoft.com/office/drawing/2014/main" id="{EC8BDB3C-ECF3-4E84-BCFD-2E8950881E37}"/>
               </a:ext>
             </a:extLst>
           </p:cNvPr>
@@ -22634,7 +22736,7 @@
           <p:cNvPr id="22" name="">
             <a:extLst xmlns:a="http://schemas.openxmlformats.org/drawingml/2006/main">
               <a:ext uri="{FF2B5EF4-FFF2-40B4-BE49-F238E27FC236}">
-                <a16:creationId xmlns:a16="http://schemas.microsoft.com/office/drawing/2014/main" id="{FD96F9CA-9421-4570-89A3-6D1976CB6F2C}"/>
+                <a16:creationId xmlns:a16="http://schemas.microsoft.com/office/drawing/2014/main" id="{94F05C96-BFF5-4260-8E60-EE821D792970}"/>
               </a:ext>
             </a:extLst>
           </p:cNvPr>
@@ -22669,7 +22771,7 @@
           <p:cNvPr id="23" name="">
             <a:extLst xmlns:a="http://schemas.openxmlformats.org/drawingml/2006/main">
               <a:ext uri="{FF2B5EF4-FFF2-40B4-BE49-F238E27FC236}">
-                <a16:creationId xmlns:a16="http://schemas.microsoft.com/office/drawing/2014/main" id="{DD1BE053-3407-4134-9DB8-D273B6959AA0}"/>
+                <a16:creationId xmlns:a16="http://schemas.microsoft.com/office/drawing/2014/main" id="{BFEAC778-43D0-49F1-B21B-96FAFEA7F4C8}"/>
               </a:ext>
             </a:extLst>
           </p:cNvPr>
@@ -22719,7 +22821,7 @@
           <p:cNvPr id="24" name="">
             <a:extLst xmlns:a="http://schemas.openxmlformats.org/drawingml/2006/main">
               <a:ext uri="{FF2B5EF4-FFF2-40B4-BE49-F238E27FC236}">
-                <a16:creationId xmlns:a16="http://schemas.microsoft.com/office/drawing/2014/main" id="{1EC24C8A-A2DB-4992-BDB5-0A0FA24916CF}"/>
+                <a16:creationId xmlns:a16="http://schemas.microsoft.com/office/drawing/2014/main" id="{C700943D-C615-47AE-973F-B7AB89976A02}"/>
               </a:ext>
             </a:extLst>
           </p:cNvPr>
@@ -22769,7 +22871,7 @@
           <p:cNvPr id="25" name="">
             <a:extLst xmlns:a="http://schemas.openxmlformats.org/drawingml/2006/main">
               <a:ext uri="{FF2B5EF4-FFF2-40B4-BE49-F238E27FC236}">
-                <a16:creationId xmlns:a16="http://schemas.microsoft.com/office/drawing/2014/main" id="{05349849-5318-4408-91FE-2816165A77A4}"/>
+                <a16:creationId xmlns:a16="http://schemas.microsoft.com/office/drawing/2014/main" id="{22EDB344-1B04-458C-866B-631A787AE18D}"/>
               </a:ext>
             </a:extLst>
           </p:cNvPr>
@@ -22819,7 +22921,7 @@
           <p:cNvPr id="26" name="">
             <a:extLst xmlns:a="http://schemas.openxmlformats.org/drawingml/2006/main">
               <a:ext uri="{FF2B5EF4-FFF2-40B4-BE49-F238E27FC236}">
-                <a16:creationId xmlns:a16="http://schemas.microsoft.com/office/drawing/2014/main" id="{BA2F588F-1B2E-4182-B45B-BD339F1C1524}"/>
+                <a16:creationId xmlns:a16="http://schemas.microsoft.com/office/drawing/2014/main" id="{668016B2-8509-44AF-90D1-674C09D34CC6}"/>
               </a:ext>
             </a:extLst>
           </p:cNvPr>
@@ -22854,7 +22956,7 @@
           <p:cNvPr id="27" name="">
             <a:extLst xmlns:a="http://schemas.openxmlformats.org/drawingml/2006/main">
               <a:ext uri="{FF2B5EF4-FFF2-40B4-BE49-F238E27FC236}">
-                <a16:creationId xmlns:a16="http://schemas.microsoft.com/office/drawing/2014/main" id="{4B6FC9AB-14E2-435E-B814-15BDF65FFE17}"/>
+                <a16:creationId xmlns:a16="http://schemas.microsoft.com/office/drawing/2014/main" id="{A2E8142F-9C3D-4BD0-8847-4B1BF930272D}"/>
               </a:ext>
             </a:extLst>
           </p:cNvPr>
@@ -22904,7 +23006,7 @@
           <p:cNvPr id="28" name="">
             <a:extLst xmlns:a="http://schemas.openxmlformats.org/drawingml/2006/main">
               <a:ext uri="{FF2B5EF4-FFF2-40B4-BE49-F238E27FC236}">
-                <a16:creationId xmlns:a16="http://schemas.microsoft.com/office/drawing/2014/main" id="{26ADC0D6-C5F2-4A1B-8EF6-86C908A53FFD}"/>
+                <a16:creationId xmlns:a16="http://schemas.microsoft.com/office/drawing/2014/main" id="{0F7989DE-9F34-4BF3-A301-8F28D4C68012}"/>
               </a:ext>
             </a:extLst>
           </p:cNvPr>
@@ -22954,7 +23056,7 @@
           <p:cNvPr id="29" name="">
             <a:extLst xmlns:a="http://schemas.openxmlformats.org/drawingml/2006/main">
               <a:ext uri="{FF2B5EF4-FFF2-40B4-BE49-F238E27FC236}">
-                <a16:creationId xmlns:a16="http://schemas.microsoft.com/office/drawing/2014/main" id="{9DECAF76-D273-40EB-803F-676C8A86BED9}"/>
+                <a16:creationId xmlns:a16="http://schemas.microsoft.com/office/drawing/2014/main" id="{724662D6-C208-4163-8458-70ABCDF0BD88}"/>
               </a:ext>
             </a:extLst>
           </p:cNvPr>
@@ -23004,7 +23106,7 @@
           <p:cNvPr id="30" name="">
             <a:extLst xmlns:a="http://schemas.openxmlformats.org/drawingml/2006/main">
               <a:ext uri="{FF2B5EF4-FFF2-40B4-BE49-F238E27FC236}">
-                <a16:creationId xmlns:a16="http://schemas.microsoft.com/office/drawing/2014/main" id="{C63993A1-3253-4C8E-AEAD-948BE1EC3FDB}"/>
+                <a16:creationId xmlns:a16="http://schemas.microsoft.com/office/drawing/2014/main" id="{23176FBD-DDC2-41BD-8341-F5EDA1BC4499}"/>
               </a:ext>
             </a:extLst>
           </p:cNvPr>
@@ -23039,7 +23141,7 @@
           <p:cNvPr id="31" name="">
             <a:extLst xmlns:a="http://schemas.openxmlformats.org/drawingml/2006/main">
               <a:ext uri="{FF2B5EF4-FFF2-40B4-BE49-F238E27FC236}">
-                <a16:creationId xmlns:a16="http://schemas.microsoft.com/office/drawing/2014/main" id="{181FB6B7-0739-4BD3-9A84-D493BF6747FF}"/>
+                <a16:creationId xmlns:a16="http://schemas.microsoft.com/office/drawing/2014/main" id="{8FD1A307-8213-4F96-91AB-F063223FADAD}"/>
               </a:ext>
             </a:extLst>
           </p:cNvPr>
@@ -23089,7 +23191,7 @@
           <p:cNvPr id="32" name="">
             <a:extLst xmlns:a="http://schemas.openxmlformats.org/drawingml/2006/main">
               <a:ext uri="{FF2B5EF4-FFF2-40B4-BE49-F238E27FC236}">
-                <a16:creationId xmlns:a16="http://schemas.microsoft.com/office/drawing/2014/main" id="{477BCC53-8355-41F5-8DAE-1A852854A743}"/>
+                <a16:creationId xmlns:a16="http://schemas.microsoft.com/office/drawing/2014/main" id="{A1C8188A-8D03-4BB9-ABCD-F6F8BB1D7AE0}"/>
               </a:ext>
             </a:extLst>
           </p:cNvPr>
@@ -23139,7 +23241,7 @@
           <p:cNvPr id="33" name="">
             <a:extLst xmlns:a="http://schemas.openxmlformats.org/drawingml/2006/main">
               <a:ext uri="{FF2B5EF4-FFF2-40B4-BE49-F238E27FC236}">
-                <a16:creationId xmlns:a16="http://schemas.microsoft.com/office/drawing/2014/main" id="{BE5FA0AF-D003-4376-B706-43D74A828416}"/>
+                <a16:creationId xmlns:a16="http://schemas.microsoft.com/office/drawing/2014/main" id="{14867A1F-D2CF-441B-BDD1-9B4920E40BA6}"/>
               </a:ext>
             </a:extLst>
           </p:cNvPr>
@@ -23189,7 +23291,7 @@
           <p:cNvPr id="34" name="">
             <a:extLst xmlns:a="http://schemas.openxmlformats.org/drawingml/2006/main">
               <a:ext uri="{FF2B5EF4-FFF2-40B4-BE49-F238E27FC236}">
-                <a16:creationId xmlns:a16="http://schemas.microsoft.com/office/drawing/2014/main" id="{5B8F3F91-5F0D-412D-ABFA-83EE3198DD78}"/>
+                <a16:creationId xmlns:a16="http://schemas.microsoft.com/office/drawing/2014/main" id="{257BFE8A-A035-4760-AE1B-CB5A9CBCCDD1}"/>
               </a:ext>
             </a:extLst>
           </p:cNvPr>
@@ -23224,7 +23326,7 @@
           <p:cNvPr id="35" name="">
             <a:extLst xmlns:a="http://schemas.openxmlformats.org/drawingml/2006/main">
               <a:ext uri="{FF2B5EF4-FFF2-40B4-BE49-F238E27FC236}">
-                <a16:creationId xmlns:a16="http://schemas.microsoft.com/office/drawing/2014/main" id="{D87EF4A3-1036-4914-8FAC-324F02E13A1D}"/>
+                <a16:creationId xmlns:a16="http://schemas.microsoft.com/office/drawing/2014/main" id="{30DFF3C6-7AB3-47FF-9B78-A8BDAB5D6B30}"/>
               </a:ext>
             </a:extLst>
           </p:cNvPr>
@@ -23274,7 +23376,7 @@
           <p:cNvPr id="36" name="">
             <a:extLst xmlns:a="http://schemas.openxmlformats.org/drawingml/2006/main">
               <a:ext uri="{FF2B5EF4-FFF2-40B4-BE49-F238E27FC236}">
-                <a16:creationId xmlns:a16="http://schemas.microsoft.com/office/drawing/2014/main" id="{2C76D3A6-16EF-4A86-A1E2-19A66675F129}"/>
+                <a16:creationId xmlns:a16="http://schemas.microsoft.com/office/drawing/2014/main" id="{6C76F90B-3C6B-4F19-A6D6-694F4826AD42}"/>
               </a:ext>
             </a:extLst>
           </p:cNvPr>
@@ -23324,7 +23426,7 @@
           <p:cNvPr id="37" name="">
             <a:extLst xmlns:a="http://schemas.openxmlformats.org/drawingml/2006/main">
               <a:ext uri="{FF2B5EF4-FFF2-40B4-BE49-F238E27FC236}">
-                <a16:creationId xmlns:a16="http://schemas.microsoft.com/office/drawing/2014/main" id="{457C46DC-00B3-479C-908E-F1B62AEDDFA9}"/>
+                <a16:creationId xmlns:a16="http://schemas.microsoft.com/office/drawing/2014/main" id="{4695F2C1-9B05-4866-A659-382D0D3CAC5F}"/>
               </a:ext>
             </a:extLst>
           </p:cNvPr>
@@ -23374,7 +23476,7 @@
           <p:cNvPr id="38" name="">
             <a:extLst xmlns:a="http://schemas.openxmlformats.org/drawingml/2006/main">
               <a:ext uri="{FF2B5EF4-FFF2-40B4-BE49-F238E27FC236}">
-                <a16:creationId xmlns:a16="http://schemas.microsoft.com/office/drawing/2014/main" id="{E529170A-D23E-40E2-9E07-B09A863E1582}"/>
+                <a16:creationId xmlns:a16="http://schemas.microsoft.com/office/drawing/2014/main" id="{D437C131-8400-4BF6-875E-49C23321052B}"/>
               </a:ext>
             </a:extLst>
           </p:cNvPr>
@@ -23424,7 +23526,7 @@
           <p:cNvPr id="39" name="">
             <a:extLst xmlns:a="http://schemas.openxmlformats.org/drawingml/2006/main">
               <a:ext uri="{FF2B5EF4-FFF2-40B4-BE49-F238E27FC236}">
-                <a16:creationId xmlns:a16="http://schemas.microsoft.com/office/drawing/2014/main" id="{C3DBDF5C-0EE0-43D9-8B31-7E211559AA14}"/>
+                <a16:creationId xmlns:a16="http://schemas.microsoft.com/office/drawing/2014/main" id="{62D268B5-2C0A-4E59-A30E-6C4A6742BD37}"/>
               </a:ext>
             </a:extLst>
           </p:cNvPr>
@@ -23465,7 +23567,7 @@
           <p:cNvPr id="40" name="">
             <a:extLst xmlns:a="http://schemas.openxmlformats.org/drawingml/2006/main">
               <a:ext uri="{FF2B5EF4-FFF2-40B4-BE49-F238E27FC236}">
-                <a16:creationId xmlns:a16="http://schemas.microsoft.com/office/drawing/2014/main" id="{6A7EDBA0-DF7C-44E7-95B6-42DFBF248C43}"/>
+                <a16:creationId xmlns:a16="http://schemas.microsoft.com/office/drawing/2014/main" id="{715CE841-5858-4FF1-8CEF-23FBC6AD9506}"/>
               </a:ext>
             </a:extLst>
           </p:cNvPr>
@@ -23515,7 +23617,7 @@
           <p:cNvPr id="41" name="">
             <a:extLst xmlns:a="http://schemas.openxmlformats.org/drawingml/2006/main">
               <a:ext uri="{FF2B5EF4-FFF2-40B4-BE49-F238E27FC236}">
-                <a16:creationId xmlns:a16="http://schemas.microsoft.com/office/drawing/2014/main" id="{83E69D4B-E83C-48BE-B462-5E59DDFA1A0A}"/>
+                <a16:creationId xmlns:a16="http://schemas.microsoft.com/office/drawing/2014/main" id="{EA3C2D63-06E4-44C5-875B-0CDFF9785B63}"/>
               </a:ext>
             </a:extLst>
           </p:cNvPr>
@@ -23565,7 +23667,7 @@
           <p:cNvPr id="42" name="">
             <a:extLst xmlns:a="http://schemas.openxmlformats.org/drawingml/2006/main">
               <a:ext uri="{FF2B5EF4-FFF2-40B4-BE49-F238E27FC236}">
-                <a16:creationId xmlns:a16="http://schemas.microsoft.com/office/drawing/2014/main" id="{DB0B1E46-918D-4CFD-AB9B-E4A9989193CA}"/>
+                <a16:creationId xmlns:a16="http://schemas.microsoft.com/office/drawing/2014/main" id="{B1468A85-E125-42A7-A31A-E7BA620CAA30}"/>
               </a:ext>
             </a:extLst>
           </p:cNvPr>
@@ -23615,7 +23717,7 @@
           <p:cNvPr id="43" name="">
             <a:extLst xmlns:a="http://schemas.openxmlformats.org/drawingml/2006/main">
               <a:ext uri="{FF2B5EF4-FFF2-40B4-BE49-F238E27FC236}">
-                <a16:creationId xmlns:a16="http://schemas.microsoft.com/office/drawing/2014/main" id="{F97E5C44-FBEA-49EF-B7C0-953518B8336C}"/>
+                <a16:creationId xmlns:a16="http://schemas.microsoft.com/office/drawing/2014/main" id="{A12C57EF-A6A1-4957-ABD6-D6A64A692120}"/>
               </a:ext>
             </a:extLst>
           </p:cNvPr>
@@ -23665,7 +23767,7 @@
           <p:cNvPr id="44" name="">
             <a:extLst xmlns:a="http://schemas.openxmlformats.org/drawingml/2006/main">
               <a:ext uri="{FF2B5EF4-FFF2-40B4-BE49-F238E27FC236}">
-                <a16:creationId xmlns:a16="http://schemas.microsoft.com/office/drawing/2014/main" id="{0D2EE264-3CC0-4EE9-B920-26D122220839}"/>
+                <a16:creationId xmlns:a16="http://schemas.microsoft.com/office/drawing/2014/main" id="{7BFAB026-DFAF-44F1-85F0-85D47F13057F}"/>
               </a:ext>
             </a:extLst>
           </p:cNvPr>
@@ -23715,7 +23817,7 @@
           <p:cNvPr id="45" name="">
             <a:extLst xmlns:a="http://schemas.openxmlformats.org/drawingml/2006/main">
               <a:ext uri="{FF2B5EF4-FFF2-40B4-BE49-F238E27FC236}">
-                <a16:creationId xmlns:a16="http://schemas.microsoft.com/office/drawing/2014/main" id="{88D0C46F-3FA5-439C-BBD6-D24333772EB4}"/>
+                <a16:creationId xmlns:a16="http://schemas.microsoft.com/office/drawing/2014/main" id="{6BEE5CED-0F1D-4509-84C3-124D2334119E}"/>
               </a:ext>
             </a:extLst>
           </p:cNvPr>
@@ -23765,7 +23867,7 @@
           <p:cNvPr id="46" name="">
             <a:extLst xmlns:a="http://schemas.openxmlformats.org/drawingml/2006/main">
               <a:ext uri="{FF2B5EF4-FFF2-40B4-BE49-F238E27FC236}">
-                <a16:creationId xmlns:a16="http://schemas.microsoft.com/office/drawing/2014/main" id="{2B9A1AE2-7E33-4D3A-989E-45008E10541A}"/>
+                <a16:creationId xmlns:a16="http://schemas.microsoft.com/office/drawing/2014/main" id="{C8802C1B-A25D-4FF4-B9F7-7425C77FCD4D}"/>
               </a:ext>
             </a:extLst>
           </p:cNvPr>
@@ -23815,7 +23917,7 @@
           <p:cNvPr id="47" name="">
             <a:extLst xmlns:a="http://schemas.openxmlformats.org/drawingml/2006/main">
               <a:ext uri="{FF2B5EF4-FFF2-40B4-BE49-F238E27FC236}">
-                <a16:creationId xmlns:a16="http://schemas.microsoft.com/office/drawing/2014/main" id="{80AF8EA7-875B-48E9-BC94-385BF44FE17C}"/>
+                <a16:creationId xmlns:a16="http://schemas.microsoft.com/office/drawing/2014/main" id="{EB2455B2-1295-4EDE-86C1-FD41FC0279B2}"/>
               </a:ext>
             </a:extLst>
           </p:cNvPr>
@@ -23865,7 +23967,7 @@
           <p:cNvPr id="48" name="">
             <a:extLst xmlns:a="http://schemas.openxmlformats.org/drawingml/2006/main">
               <a:ext uri="{FF2B5EF4-FFF2-40B4-BE49-F238E27FC236}">
-                <a16:creationId xmlns:a16="http://schemas.microsoft.com/office/drawing/2014/main" id="{551FEFB1-D167-44F5-A791-1278BF3672D1}"/>
+                <a16:creationId xmlns:a16="http://schemas.microsoft.com/office/drawing/2014/main" id="{AB7C7665-0E3D-4F2D-89E3-3A551488E0B7}"/>
               </a:ext>
             </a:extLst>
           </p:cNvPr>
@@ -23915,19 +24017,19 @@
           <p:cNvPr id="49" name="">
             <a:extLst xmlns:a="http://schemas.openxmlformats.org/drawingml/2006/main">
               <a:ext uri="{FF2B5EF4-FFF2-40B4-BE49-F238E27FC236}">
-                <a16:creationId xmlns:a16="http://schemas.microsoft.com/office/drawing/2014/main" id="{74C797E1-9A42-49B6-9ACD-8B56E640562B}"/>
-              </a:ext>
-            </a:extLst>
-          </p:cNvPr>
-          <p:cNvSpPr>
-            <a:spLocks xmlns:a="http://schemas.openxmlformats.org/drawingml/2006/main" noGrp="1"/>
-          </p:cNvSpPr>
-          <p:nvPr/>
-        </p:nvSpPr>
-        <p:spPr>
-          <a:xfrm xmlns:a="http://schemas.openxmlformats.org/drawingml/2006/main">
-            <a:off x="8610600" y="4552950"/>
-            <a:ext cx="2571750" cy="228600"/>
+                <a16:creationId xmlns:a16="http://schemas.microsoft.com/office/drawing/2014/main" id="{344CE914-A061-4D4D-8461-E20DD1BE4481}"/>
+              </a:ext>
+            </a:extLst>
+          </p:cNvPr>
+          <p:cNvSpPr>
+            <a:spLocks xmlns:a="http://schemas.openxmlformats.org/drawingml/2006/main" noGrp="1"/>
+          </p:cNvSpPr>
+          <p:nvPr/>
+        </p:nvSpPr>
+        <p:spPr>
+          <a:xfrm xmlns:a="http://schemas.openxmlformats.org/drawingml/2006/main">
+            <a:off x="8515350" y="4552950"/>
+            <a:ext cx="2762250" cy="228600"/>
           </a:xfrm>
           <a:prstGeom xmlns:a="http://schemas.openxmlformats.org/drawingml/2006/main" prst="rect">
             <a:avLst/>
@@ -23955,7 +24057,7 @@
                   <a:srgbClr val="B5483A"/>
                 </a:solidFill>
               </a:rPr>
-              <a:t>If any gate fails: verdict = null</a:t>
+              <a:t>If any gate fails: abstain (verdict = null)</a:t>
             </a:r>
           </a:p>
         </p:txBody>
@@ -23965,7 +24067,7 @@
           <p:cNvPr id="50" name="">
             <a:extLst xmlns:a="http://schemas.openxmlformats.org/drawingml/2006/main">
               <a:ext uri="{FF2B5EF4-FFF2-40B4-BE49-F238E27FC236}">
-                <a16:creationId xmlns:a16="http://schemas.microsoft.com/office/drawing/2014/main" id="{F29E018C-735D-4305-95EB-880EAAFFB00E}"/>
+                <a16:creationId xmlns:a16="http://schemas.microsoft.com/office/drawing/2014/main" id="{21DD76FA-6D99-4340-9F1C-54E02A2719E2}"/>
               </a:ext>
             </a:extLst>
           </p:cNvPr>
@@ -23996,7 +24098,7 @@
           <p:cNvPr id="51" name="source-9">
             <a:extLst xmlns:a="http://schemas.openxmlformats.org/drawingml/2006/main">
               <a:ext uri="{FF2B5EF4-FFF2-40B4-BE49-F238E27FC236}">
-                <a16:creationId xmlns:a16="http://schemas.microsoft.com/office/drawing/2014/main" id="{4B14FF23-1659-4DD1-89C7-E4A44CB3F878}"/>
+                <a16:creationId xmlns:a16="http://schemas.microsoft.com/office/drawing/2014/main" id="{007FA0AB-A5D1-4C98-9D9F-1B993EEDAA2A}"/>
               </a:ext>
             </a:extLst>
           </p:cNvPr>
@@ -24036,7 +24138,7 @@
                   <a:srgbClr val="526174"/>
                 </a:solidFill>
               </a:rPr>
-              <a:t>[7] v91 evidence schema, provenance ledger and row-level decision trace</a:t>
+              <a:t>Report Fig. 2b  |  [7] v91 evidence schema, provenance ledger and decision trace</a:t>
             </a:r>
           </a:p>
         </p:txBody>
@@ -24046,7 +24148,7 @@
           <p:cNvPr id="52" name="page-9">
             <a:extLst xmlns:a="http://schemas.openxmlformats.org/drawingml/2006/main">
               <a:ext uri="{FF2B5EF4-FFF2-40B4-BE49-F238E27FC236}">
-                <a16:creationId xmlns:a16="http://schemas.microsoft.com/office/drawing/2014/main" id="{04E68293-96CF-413D-9471-B6F06AD5A850}"/>
+                <a16:creationId xmlns:a16="http://schemas.microsoft.com/office/drawing/2014/main" id="{7EECDA61-7623-44C7-9EF9-8EA40F248751}"/>
               </a:ext>
             </a:extLst>
           </p:cNvPr>
@@ -24094,7 +24196,7 @@
     </p:spTree>
     <p:extLst>
       <p:ext uri="{BB962C8B-B14F-4D97-AF65-F5344CB8AC3E}">
-        <p14:creationId xmlns:p14="http://schemas.microsoft.com/office/powerpoint/2010/main" val="99722256"/>
+        <p14:creationId xmlns:p14="http://schemas.microsoft.com/office/powerpoint/2010/main" val="679945275"/>
       </p:ext>
     </p:extLst>
   </p:cSld>

</xml_diff>

<commit_message>
Correct dual-GPU inference wording
</commit_message>
<xml_diff>
--- a/presentation/Huntrix_Final_Presentation.pptx
+++ b/presentation/Huntrix_Final_Presentation.pptx
@@ -2,27 +2,27 @@
 <file path=ppt/presentation.xml><?xml version="1.0" encoding="utf-8"?>
 <p:presentation xmlns:p="http://schemas.openxmlformats.org/presentationml/2006/main">
   <p:sldMasterIdLst>
-    <p:sldMasterId xmlns:r="http://schemas.openxmlformats.org/officeDocument/2006/relationships" id="2147483648" r:id="R11bf963690cd4735"/>
+    <p:sldMasterId xmlns:r="http://schemas.openxmlformats.org/officeDocument/2006/relationships" id="2147483648" r:id="Rce9f940102c44ed7"/>
   </p:sldMasterIdLst>
   <p:notesMasterIdLst>
-    <p:notesMasterId xmlns:r="http://schemas.openxmlformats.org/officeDocument/2006/relationships" r:id="R0217c067ef3c4449"/>
+    <p:notesMasterId xmlns:r="http://schemas.openxmlformats.org/officeDocument/2006/relationships" r:id="R1273ba06c7da4852"/>
   </p:notesMasterIdLst>
   <p:sldIdLst>
-    <p:sldId xmlns:r="http://schemas.openxmlformats.org/officeDocument/2006/relationships" id="256" r:id="R8ad2650efd26416e"/>
-    <p:sldId xmlns:r="http://schemas.openxmlformats.org/officeDocument/2006/relationships" id="257" r:id="R38a1feb13f9b4b80"/>
-    <p:sldId xmlns:r="http://schemas.openxmlformats.org/officeDocument/2006/relationships" id="258" r:id="Re6d85dd85c0c4fe4"/>
-    <p:sldId xmlns:r="http://schemas.openxmlformats.org/officeDocument/2006/relationships" id="259" r:id="R27c0da09a0e44901"/>
-    <p:sldId xmlns:r="http://schemas.openxmlformats.org/officeDocument/2006/relationships" id="260" r:id="Rb2298d725b944ba4"/>
-    <p:sldId xmlns:r="http://schemas.openxmlformats.org/officeDocument/2006/relationships" id="261" r:id="R5350ec769c654582"/>
-    <p:sldId xmlns:r="http://schemas.openxmlformats.org/officeDocument/2006/relationships" id="262" r:id="Rd35e48e6d0a64744"/>
-    <p:sldId xmlns:r="http://schemas.openxmlformats.org/officeDocument/2006/relationships" id="263" r:id="R34ed931335164514"/>
-    <p:sldId xmlns:r="http://schemas.openxmlformats.org/officeDocument/2006/relationships" id="264" r:id="R97a3999478124ddf"/>
-    <p:sldId xmlns:r="http://schemas.openxmlformats.org/officeDocument/2006/relationships" id="265" r:id="R545902f9a46148d8"/>
-    <p:sldId xmlns:r="http://schemas.openxmlformats.org/officeDocument/2006/relationships" id="266" r:id="Rfec95f3464f14100"/>
-    <p:sldId xmlns:r="http://schemas.openxmlformats.org/officeDocument/2006/relationships" id="267" r:id="R2661459780d74f92"/>
-    <p:sldId xmlns:r="http://schemas.openxmlformats.org/officeDocument/2006/relationships" id="268" r:id="R8d56247bfeb84fb7"/>
-    <p:sldId xmlns:r="http://schemas.openxmlformats.org/officeDocument/2006/relationships" id="269" r:id="Reabcd67a04fd415a"/>
-    <p:sldId xmlns:r="http://schemas.openxmlformats.org/officeDocument/2006/relationships" id="270" r:id="Rfb842422b8c64077"/>
+    <p:sldId xmlns:r="http://schemas.openxmlformats.org/officeDocument/2006/relationships" id="256" r:id="R29363b378e324677"/>
+    <p:sldId xmlns:r="http://schemas.openxmlformats.org/officeDocument/2006/relationships" id="257" r:id="R0f1a184b86b249bf"/>
+    <p:sldId xmlns:r="http://schemas.openxmlformats.org/officeDocument/2006/relationships" id="258" r:id="Rf0a9f2ed086445bf"/>
+    <p:sldId xmlns:r="http://schemas.openxmlformats.org/officeDocument/2006/relationships" id="259" r:id="R90fa7263adb949a3"/>
+    <p:sldId xmlns:r="http://schemas.openxmlformats.org/officeDocument/2006/relationships" id="260" r:id="Re9189a3256a54018"/>
+    <p:sldId xmlns:r="http://schemas.openxmlformats.org/officeDocument/2006/relationships" id="261" r:id="Rd08406c8fac545c8"/>
+    <p:sldId xmlns:r="http://schemas.openxmlformats.org/officeDocument/2006/relationships" id="262" r:id="R8ac512196e2543a9"/>
+    <p:sldId xmlns:r="http://schemas.openxmlformats.org/officeDocument/2006/relationships" id="263" r:id="R64042761e1174aab"/>
+    <p:sldId xmlns:r="http://schemas.openxmlformats.org/officeDocument/2006/relationships" id="264" r:id="Ra33af1f652b94f3c"/>
+    <p:sldId xmlns:r="http://schemas.openxmlformats.org/officeDocument/2006/relationships" id="265" r:id="Rd1ec57c334184421"/>
+    <p:sldId xmlns:r="http://schemas.openxmlformats.org/officeDocument/2006/relationships" id="266" r:id="R91c29b80b3834bad"/>
+    <p:sldId xmlns:r="http://schemas.openxmlformats.org/officeDocument/2006/relationships" id="267" r:id="R55a1bf1609eb49e0"/>
+    <p:sldId xmlns:r="http://schemas.openxmlformats.org/officeDocument/2006/relationships" id="268" r:id="R7b9be203b8cd4abd"/>
+    <p:sldId xmlns:r="http://schemas.openxmlformats.org/officeDocument/2006/relationships" id="269" r:id="R5f42ecc1757c4f3e"/>
+    <p:sldId xmlns:r="http://schemas.openxmlformats.org/officeDocument/2006/relationships" id="270" r:id="Ra5efd66682b94b78"/>
   </p:sldIdLst>
   <p:sldSz cx="12192000" cy="6858000"/>
   <p:notesSz cx="6858000" cy="9144000"/>
@@ -886,7 +886,7 @@
           </a:p>
           <a:p xmlns:a="http://schemas.openxmlformats.org/drawingml/2006/main">
             <a:r>
-              <a:t>We treated reproducibility as a result, not an administrative detail. The codebase had 249 automated tests, including 225 deterministic controls. The notebook reads the organizer's literal test path, loads pinned model, runtime, and evidence assets, and uses a fixed row, prompt, and batch schedule. Two llama.cpp servers run on the two T4 GPUs. The final validator preserves incoming IDs and writes exactly id and label. Three full runs produced byte-identical files, the frozen hash matched the scored CSV, and the organizer-run notebook validated 5,000 Phase 2 rows in 3 hours and 52 minutes. These checks establish execution integrity; they do not substitute for an unreleased Phase 2 accuracy score. Orny will cover the measured deployment run next.</a:t>
+              <a:t>We treated reproducibility as a result, not an administrative detail. The codebase had 249 automated tests, including 225 deterministic controls. The notebook reads the organizer's literal test path, loads pinned model, runtime, and evidence assets, and uses a fixed row, prompt, and batch schedule. One local llama.cpp server tensor-splits the model equally across the two T4 GPUs. The final validator preserves incoming IDs and writes exactly id and label. Three full runs produced byte-identical files, the frozen hash matched the scored CSV, and the organizer-run notebook validated 5,000 Phase 2 rows in 3 hours and 52 minutes. These checks establish execution integrity; they do not substitute for an unreleased Phase 2 accuracy score. Orny will cover the measured deployment run next.</a:t>
             </a:r>
           </a:p>
           <a:p xmlns:a="http://schemas.openxmlformats.org/drawingml/2006/main">
@@ -2124,7 +2124,7 @@
   </p:cSld>
   <p:clrMap bg1="lt1" tx1="dk1" bg2="lt2" tx2="dk2" accent1="accent1" accent2="accent2" accent3="accent3" accent4="accent4" accent5="accent5" accent6="accent6" hlink="hlink" folHlink="folHlink"/>
   <p:sldLayoutIdLst>
-    <p:sldLayoutId xmlns:r="http://schemas.openxmlformats.org/officeDocument/2006/relationships" id="2147483649" r:id="R6ec450965d7b4837"/>
+    <p:sldLayoutId xmlns:r="http://schemas.openxmlformats.org/officeDocument/2006/relationships" id="2147483649" r:id="R4eb144b1fe084aee"/>
   </p:sldLayoutIdLst>
   <p:txStyles>
     <p:titleStyle>
@@ -2675,7 +2675,7 @@
           <p:cNvPr id="14" name="">
             <a:extLst xmlns:a="http://schemas.openxmlformats.org/drawingml/2006/main">
               <a:ext uri="{FF2B5EF4-FFF2-40B4-BE49-F238E27FC236}">
-                <a16:creationId xmlns:a16="http://schemas.microsoft.com/office/drawing/2014/main" id="{43D76688-30DB-4ECC-B3E0-87C84F8A2681}"/>
+                <a16:creationId xmlns:a16="http://schemas.microsoft.com/office/drawing/2014/main" id="{A6A8DF26-6BE0-42CF-B3E8-E67F43CFB698}"/>
               </a:ext>
             </a:extLst>
           </p:cNvPr>
@@ -2708,7 +2708,7 @@
           <p:cNvPr id="2" name="">
             <a:extLst xmlns:a="http://schemas.openxmlformats.org/drawingml/2006/main">
               <a:ext uri="{FF2B5EF4-FFF2-40B4-BE49-F238E27FC236}">
-                <a16:creationId xmlns:a16="http://schemas.microsoft.com/office/drawing/2014/main" id="{59F289B5-58AD-4DAC-9BF8-3CAA3054C22A}"/>
+                <a16:creationId xmlns:a16="http://schemas.microsoft.com/office/drawing/2014/main" id="{35EB80A1-2A0C-4F10-B1B1-0CC577C3AEB4}"/>
               </a:ext>
             </a:extLst>
           </p:cNvPr>
@@ -2758,7 +2758,7 @@
           <p:cNvPr id="3" name="">
             <a:extLst xmlns:a="http://schemas.openxmlformats.org/drawingml/2006/main">
               <a:ext uri="{FF2B5EF4-FFF2-40B4-BE49-F238E27FC236}">
-                <a16:creationId xmlns:a16="http://schemas.microsoft.com/office/drawing/2014/main" id="{08486AE8-E86A-4169-8639-D142A2AA6170}"/>
+                <a16:creationId xmlns:a16="http://schemas.microsoft.com/office/drawing/2014/main" id="{CE18E8FE-B679-4334-8E19-DDFA025F5A45}"/>
               </a:ext>
             </a:extLst>
           </p:cNvPr>
@@ -2825,7 +2825,7 @@
           <p:cNvPr id="4" name="">
             <a:extLst xmlns:a="http://schemas.openxmlformats.org/drawingml/2006/main">
               <a:ext uri="{FF2B5EF4-FFF2-40B4-BE49-F238E27FC236}">
-                <a16:creationId xmlns:a16="http://schemas.microsoft.com/office/drawing/2014/main" id="{F8914E24-62FC-4F21-8F5D-080E5C0D9A45}"/>
+                <a16:creationId xmlns:a16="http://schemas.microsoft.com/office/drawing/2014/main" id="{7B6A14FA-74DF-4F2F-B211-DD00B34642B8}"/>
               </a:ext>
             </a:extLst>
           </p:cNvPr>
@@ -2875,7 +2875,7 @@
           <p:cNvPr id="5" name="">
             <a:extLst xmlns:a="http://schemas.openxmlformats.org/drawingml/2006/main">
               <a:ext uri="{FF2B5EF4-FFF2-40B4-BE49-F238E27FC236}">
-                <a16:creationId xmlns:a16="http://schemas.microsoft.com/office/drawing/2014/main" id="{BE1B868D-029B-4441-94C2-E21AA301B747}"/>
+                <a16:creationId xmlns:a16="http://schemas.microsoft.com/office/drawing/2014/main" id="{A7E234C8-EE93-4461-8539-AE508AD455F3}"/>
               </a:ext>
             </a:extLst>
           </p:cNvPr>
@@ -2906,7 +2906,7 @@
           <p:cNvPr id="6" name="">
             <a:extLst xmlns:a="http://schemas.openxmlformats.org/drawingml/2006/main">
               <a:ext uri="{FF2B5EF4-FFF2-40B4-BE49-F238E27FC236}">
-                <a16:creationId xmlns:a16="http://schemas.microsoft.com/office/drawing/2014/main" id="{A8E58D90-0384-45E2-A34F-68D90091058A}"/>
+                <a16:creationId xmlns:a16="http://schemas.microsoft.com/office/drawing/2014/main" id="{6A5A1960-7CFE-4B14-8CDF-1DAA66E5EF42}"/>
               </a:ext>
             </a:extLst>
           </p:cNvPr>
@@ -2947,7 +2947,7 @@
           <p:cNvPr id="7" name="">
             <a:extLst xmlns:a="http://schemas.openxmlformats.org/drawingml/2006/main">
               <a:ext uri="{FF2B5EF4-FFF2-40B4-BE49-F238E27FC236}">
-                <a16:creationId xmlns:a16="http://schemas.microsoft.com/office/drawing/2014/main" id="{A7178157-106C-4C75-B186-67B6D6F2956F}"/>
+                <a16:creationId xmlns:a16="http://schemas.microsoft.com/office/drawing/2014/main" id="{44042306-E46F-4B58-9D04-D6B0D654154C}"/>
               </a:ext>
             </a:extLst>
           </p:cNvPr>
@@ -2997,7 +2997,7 @@
           <p:cNvPr id="8" name="">
             <a:extLst xmlns:a="http://schemas.openxmlformats.org/drawingml/2006/main">
               <a:ext uri="{FF2B5EF4-FFF2-40B4-BE49-F238E27FC236}">
-                <a16:creationId xmlns:a16="http://schemas.microsoft.com/office/drawing/2014/main" id="{E3F768C2-913D-4D7B-8F53-58D8BB8122E2}"/>
+                <a16:creationId xmlns:a16="http://schemas.microsoft.com/office/drawing/2014/main" id="{A3918071-8E5A-497A-A13F-45323B3D2334}"/>
               </a:ext>
             </a:extLst>
           </p:cNvPr>
@@ -3047,7 +3047,7 @@
           <p:cNvPr id="9" name="">
             <a:extLst xmlns:a="http://schemas.openxmlformats.org/drawingml/2006/main">
               <a:ext uri="{FF2B5EF4-FFF2-40B4-BE49-F238E27FC236}">
-                <a16:creationId xmlns:a16="http://schemas.microsoft.com/office/drawing/2014/main" id="{92D9F731-8832-42BD-85B9-DB4C57F52F6E}"/>
+                <a16:creationId xmlns:a16="http://schemas.microsoft.com/office/drawing/2014/main" id="{82F4C6A0-B57B-4034-ADA6-2561B683440A}"/>
               </a:ext>
             </a:extLst>
           </p:cNvPr>
@@ -3097,7 +3097,7 @@
           <p:cNvPr id="10" name="">
             <a:extLst xmlns:a="http://schemas.openxmlformats.org/drawingml/2006/main">
               <a:ext uri="{FF2B5EF4-FFF2-40B4-BE49-F238E27FC236}">
-                <a16:creationId xmlns:a16="http://schemas.microsoft.com/office/drawing/2014/main" id="{E23C90AD-9E0E-4ED0-95EC-23A57F912436}"/>
+                <a16:creationId xmlns:a16="http://schemas.microsoft.com/office/drawing/2014/main" id="{4DC3A532-DF95-45D8-85FA-958E99802C7C}"/>
               </a:ext>
             </a:extLst>
           </p:cNvPr>
@@ -3147,7 +3147,7 @@
           <p:cNvPr id="11" name="">
             <a:extLst xmlns:a="http://schemas.openxmlformats.org/drawingml/2006/main">
               <a:ext uri="{FF2B5EF4-FFF2-40B4-BE49-F238E27FC236}">
-                <a16:creationId xmlns:a16="http://schemas.microsoft.com/office/drawing/2014/main" id="{B77F63F0-4A77-477B-93EE-760DD4E5FCCA}"/>
+                <a16:creationId xmlns:a16="http://schemas.microsoft.com/office/drawing/2014/main" id="{C67A41FD-3413-45FC-AA7D-E7B5F25C0407}"/>
               </a:ext>
             </a:extLst>
           </p:cNvPr>
@@ -3197,7 +3197,7 @@
           <p:cNvPr id="12" name="">
             <a:extLst xmlns:a="http://schemas.openxmlformats.org/drawingml/2006/main">
               <a:ext uri="{FF2B5EF4-FFF2-40B4-BE49-F238E27FC236}">
-                <a16:creationId xmlns:a16="http://schemas.microsoft.com/office/drawing/2014/main" id="{11543071-AF00-4274-B3A6-66D8C8856581}"/>
+                <a16:creationId xmlns:a16="http://schemas.microsoft.com/office/drawing/2014/main" id="{31357488-84AD-44C2-80C8-4D93FAB28305}"/>
               </a:ext>
             </a:extLst>
           </p:cNvPr>
@@ -3247,7 +3247,7 @@
           <p:cNvPr id="13" name="">
             <a:extLst xmlns:a="http://schemas.openxmlformats.org/drawingml/2006/main">
               <a:ext uri="{FF2B5EF4-FFF2-40B4-BE49-F238E27FC236}">
-                <a16:creationId xmlns:a16="http://schemas.microsoft.com/office/drawing/2014/main" id="{D13F67FC-9CBA-4C40-B87A-851729F38FF2}"/>
+                <a16:creationId xmlns:a16="http://schemas.microsoft.com/office/drawing/2014/main" id="{C7BEE67A-BC27-41F8-8F6A-82E50970D98B}"/>
               </a:ext>
             </a:extLst>
           </p:cNvPr>
@@ -3295,7 +3295,7 @@
     </p:spTree>
     <p:extLst>
       <p:ext uri="{BB962C8B-B14F-4D97-AF65-F5344CB8AC3E}">
-        <p14:creationId xmlns:p14="http://schemas.microsoft.com/office/powerpoint/2010/main" val="748174429"/>
+        <p14:creationId xmlns:p14="http://schemas.microsoft.com/office/powerpoint/2010/main" val="716758062"/>
       </p:ext>
     </p:extLst>
   </p:cSld>
@@ -3326,7 +3326,7 @@
           <p:cNvPr id="46" name="kicker-10">
             <a:extLst xmlns:a="http://schemas.openxmlformats.org/drawingml/2006/main">
               <a:ext uri="{FF2B5EF4-FFF2-40B4-BE49-F238E27FC236}">
-                <a16:creationId xmlns:a16="http://schemas.microsoft.com/office/drawing/2014/main" id="{3AC843AD-A3CE-4DA0-B233-481F65AE9321}"/>
+                <a16:creationId xmlns:a16="http://schemas.microsoft.com/office/drawing/2014/main" id="{70DE1D79-8DC7-43D6-9761-6E4E60C79C5C}"/>
               </a:ext>
             </a:extLst>
           </p:cNvPr>
@@ -3376,7 +3376,7 @@
           <p:cNvPr id="2" name="title-10">
             <a:extLst xmlns:a="http://schemas.openxmlformats.org/drawingml/2006/main">
               <a:ext uri="{FF2B5EF4-FFF2-40B4-BE49-F238E27FC236}">
-                <a16:creationId xmlns:a16="http://schemas.microsoft.com/office/drawing/2014/main" id="{8B28E146-9D9D-446F-A72B-E16785E4E4AA}"/>
+                <a16:creationId xmlns:a16="http://schemas.microsoft.com/office/drawing/2014/main" id="{1365A60E-E84E-4C00-AE43-7E62CB205D7C}"/>
               </a:ext>
             </a:extLst>
           </p:cNvPr>
@@ -3426,7 +3426,7 @@
           <p:cNvPr id="3" name="">
             <a:extLst xmlns:a="http://schemas.openxmlformats.org/drawingml/2006/main">
               <a:ext uri="{FF2B5EF4-FFF2-40B4-BE49-F238E27FC236}">
-                <a16:creationId xmlns:a16="http://schemas.microsoft.com/office/drawing/2014/main" id="{77EC139D-9799-4111-A3F9-9ED245152D74}"/>
+                <a16:creationId xmlns:a16="http://schemas.microsoft.com/office/drawing/2014/main" id="{3C47268A-662D-4394-849C-AAF822479811}"/>
               </a:ext>
             </a:extLst>
           </p:cNvPr>
@@ -3457,7 +3457,7 @@
           <p:cNvPr id="4" name="">
             <a:extLst xmlns:a="http://schemas.openxmlformats.org/drawingml/2006/main">
               <a:ext uri="{FF2B5EF4-FFF2-40B4-BE49-F238E27FC236}">
-                <a16:creationId xmlns:a16="http://schemas.microsoft.com/office/drawing/2014/main" id="{F452D128-7B08-4A4E-B617-EB8C9E46C170}"/>
+                <a16:creationId xmlns:a16="http://schemas.microsoft.com/office/drawing/2014/main" id="{045D304B-EA3C-4248-9DF7-8D4EFAC312A5}"/>
               </a:ext>
             </a:extLst>
           </p:cNvPr>
@@ -3507,7 +3507,7 @@
           <p:cNvPr id="5" name="">
             <a:extLst xmlns:a="http://schemas.openxmlformats.org/drawingml/2006/main">
               <a:ext uri="{FF2B5EF4-FFF2-40B4-BE49-F238E27FC236}">
-                <a16:creationId xmlns:a16="http://schemas.microsoft.com/office/drawing/2014/main" id="{412F9771-D60B-48FF-90E6-1C52D547EB4F}"/>
+                <a16:creationId xmlns:a16="http://schemas.microsoft.com/office/drawing/2014/main" id="{C6228EE5-54FA-45E2-B593-1FE151A053BA}"/>
               </a:ext>
             </a:extLst>
           </p:cNvPr>
@@ -3557,7 +3557,7 @@
           <p:cNvPr id="6" name="">
             <a:extLst xmlns:a="http://schemas.openxmlformats.org/drawingml/2006/main">
               <a:ext uri="{FF2B5EF4-FFF2-40B4-BE49-F238E27FC236}">
-                <a16:creationId xmlns:a16="http://schemas.microsoft.com/office/drawing/2014/main" id="{676B7B64-2A44-4713-AB37-0C57F4BFC309}"/>
+                <a16:creationId xmlns:a16="http://schemas.microsoft.com/office/drawing/2014/main" id="{F08ABB47-7095-4A05-AC0E-6E719ECD2BEA}"/>
               </a:ext>
             </a:extLst>
           </p:cNvPr>
@@ -3607,7 +3607,7 @@
           <p:cNvPr id="7" name="">
             <a:extLst xmlns:a="http://schemas.openxmlformats.org/drawingml/2006/main">
               <a:ext uri="{FF2B5EF4-FFF2-40B4-BE49-F238E27FC236}">
-                <a16:creationId xmlns:a16="http://schemas.microsoft.com/office/drawing/2014/main" id="{5E4DAF76-D452-4F24-9BAA-AC272D4CAE1C}"/>
+                <a16:creationId xmlns:a16="http://schemas.microsoft.com/office/drawing/2014/main" id="{D0E29E5F-02F0-47B4-A94D-4085E3FB43E2}"/>
               </a:ext>
             </a:extLst>
           </p:cNvPr>
@@ -3657,7 +3657,7 @@
           <p:cNvPr id="8" name="">
             <a:extLst xmlns:a="http://schemas.openxmlformats.org/drawingml/2006/main">
               <a:ext uri="{FF2B5EF4-FFF2-40B4-BE49-F238E27FC236}">
-                <a16:creationId xmlns:a16="http://schemas.microsoft.com/office/drawing/2014/main" id="{AA26756E-CF5B-436F-9963-5FF4FF33F14A}"/>
+                <a16:creationId xmlns:a16="http://schemas.microsoft.com/office/drawing/2014/main" id="{ECD69B70-C1AC-4014-9A36-50D942417569}"/>
               </a:ext>
             </a:extLst>
           </p:cNvPr>
@@ -3707,7 +3707,7 @@
           <p:cNvPr id="9" name="">
             <a:extLst xmlns:a="http://schemas.openxmlformats.org/drawingml/2006/main">
               <a:ext uri="{FF2B5EF4-FFF2-40B4-BE49-F238E27FC236}">
-                <a16:creationId xmlns:a16="http://schemas.microsoft.com/office/drawing/2014/main" id="{35D5895F-23A3-4C28-A141-7A3B3FC955E4}"/>
+                <a16:creationId xmlns:a16="http://schemas.microsoft.com/office/drawing/2014/main" id="{73B804FA-64A6-4B82-B1A8-4F1FB355F668}"/>
               </a:ext>
             </a:extLst>
           </p:cNvPr>
@@ -3738,7 +3738,7 @@
           <p:cNvPr id="10" name="">
             <a:extLst xmlns:a="http://schemas.openxmlformats.org/drawingml/2006/main">
               <a:ext uri="{FF2B5EF4-FFF2-40B4-BE49-F238E27FC236}">
-                <a16:creationId xmlns:a16="http://schemas.microsoft.com/office/drawing/2014/main" id="{C9A0BEE7-D113-4744-B1B8-CB56BDFAE9DA}"/>
+                <a16:creationId xmlns:a16="http://schemas.microsoft.com/office/drawing/2014/main" id="{40BC6826-8277-467A-B9CF-A767D2B30ABF}"/>
               </a:ext>
             </a:extLst>
           </p:cNvPr>
@@ -3788,7 +3788,7 @@
           <p:cNvPr id="11" name="">
             <a:extLst xmlns:a="http://schemas.openxmlformats.org/drawingml/2006/main">
               <a:ext uri="{FF2B5EF4-FFF2-40B4-BE49-F238E27FC236}">
-                <a16:creationId xmlns:a16="http://schemas.microsoft.com/office/drawing/2014/main" id="{B797EA7D-67C9-4CCB-8628-F31044D18387}"/>
+                <a16:creationId xmlns:a16="http://schemas.microsoft.com/office/drawing/2014/main" id="{82471643-58C3-4CF7-8C46-3ADB607B6EB2}"/>
               </a:ext>
             </a:extLst>
           </p:cNvPr>
@@ -3838,7 +3838,7 @@
           <p:cNvPr id="12" name="">
             <a:extLst xmlns:a="http://schemas.openxmlformats.org/drawingml/2006/main">
               <a:ext uri="{FF2B5EF4-FFF2-40B4-BE49-F238E27FC236}">
-                <a16:creationId xmlns:a16="http://schemas.microsoft.com/office/drawing/2014/main" id="{45FF2E4F-C7E9-44DE-B13E-19E403EBCF73}"/>
+                <a16:creationId xmlns:a16="http://schemas.microsoft.com/office/drawing/2014/main" id="{E51D2073-5BA9-40FD-87E0-6428604E7466}"/>
               </a:ext>
             </a:extLst>
           </p:cNvPr>
@@ -3888,7 +3888,7 @@
           <p:cNvPr id="13" name="">
             <a:extLst xmlns:a="http://schemas.openxmlformats.org/drawingml/2006/main">
               <a:ext uri="{FF2B5EF4-FFF2-40B4-BE49-F238E27FC236}">
-                <a16:creationId xmlns:a16="http://schemas.microsoft.com/office/drawing/2014/main" id="{E375585D-212B-4D98-8E6A-DF9F65EDD68C}"/>
+                <a16:creationId xmlns:a16="http://schemas.microsoft.com/office/drawing/2014/main" id="{32BF2E88-70E7-43C4-A35A-6F2143D5A47A}"/>
               </a:ext>
             </a:extLst>
           </p:cNvPr>
@@ -3938,7 +3938,7 @@
           <p:cNvPr id="14" name="">
             <a:extLst xmlns:a="http://schemas.openxmlformats.org/drawingml/2006/main">
               <a:ext uri="{FF2B5EF4-FFF2-40B4-BE49-F238E27FC236}">
-                <a16:creationId xmlns:a16="http://schemas.microsoft.com/office/drawing/2014/main" id="{EAE052E0-5646-4DA1-85D0-5DA53686C9EE}"/>
+                <a16:creationId xmlns:a16="http://schemas.microsoft.com/office/drawing/2014/main" id="{4051CF53-48E8-4E69-B5EA-A73FE2A7D748}"/>
               </a:ext>
             </a:extLst>
           </p:cNvPr>
@@ -3969,7 +3969,7 @@
           <p:cNvPr id="15" name="">
             <a:extLst xmlns:a="http://schemas.openxmlformats.org/drawingml/2006/main">
               <a:ext uri="{FF2B5EF4-FFF2-40B4-BE49-F238E27FC236}">
-                <a16:creationId xmlns:a16="http://schemas.microsoft.com/office/drawing/2014/main" id="{BED1FB13-60FD-4420-A6B8-69C7082A408D}"/>
+                <a16:creationId xmlns:a16="http://schemas.microsoft.com/office/drawing/2014/main" id="{CC148678-77FC-47A3-B554-06C8358E5111}"/>
               </a:ext>
             </a:extLst>
           </p:cNvPr>
@@ -4019,7 +4019,7 @@
           <p:cNvPr id="16" name="">
             <a:extLst xmlns:a="http://schemas.openxmlformats.org/drawingml/2006/main">
               <a:ext uri="{FF2B5EF4-FFF2-40B4-BE49-F238E27FC236}">
-                <a16:creationId xmlns:a16="http://schemas.microsoft.com/office/drawing/2014/main" id="{F784AB21-423D-4E3F-B13E-AE3544648FD1}"/>
+                <a16:creationId xmlns:a16="http://schemas.microsoft.com/office/drawing/2014/main" id="{DF54593B-AC23-47E8-9FFC-50FBB5F6575D}"/>
               </a:ext>
             </a:extLst>
           </p:cNvPr>
@@ -4069,7 +4069,7 @@
           <p:cNvPr id="17" name="">
             <a:extLst xmlns:a="http://schemas.openxmlformats.org/drawingml/2006/main">
               <a:ext uri="{FF2B5EF4-FFF2-40B4-BE49-F238E27FC236}">
-                <a16:creationId xmlns:a16="http://schemas.microsoft.com/office/drawing/2014/main" id="{64A07AFD-6180-4F98-9172-04DD1C6890AB}"/>
+                <a16:creationId xmlns:a16="http://schemas.microsoft.com/office/drawing/2014/main" id="{756C660D-8537-4B83-8AC7-038C7B37B023}"/>
               </a:ext>
             </a:extLst>
           </p:cNvPr>
@@ -4119,7 +4119,7 @@
           <p:cNvPr id="18" name="">
             <a:extLst xmlns:a="http://schemas.openxmlformats.org/drawingml/2006/main">
               <a:ext uri="{FF2B5EF4-FFF2-40B4-BE49-F238E27FC236}">
-                <a16:creationId xmlns:a16="http://schemas.microsoft.com/office/drawing/2014/main" id="{768CBE50-EEC7-4312-832A-87425541B01B}"/>
+                <a16:creationId xmlns:a16="http://schemas.microsoft.com/office/drawing/2014/main" id="{5CB67B70-7A6F-48C1-B90D-F935A9F2BC21}"/>
               </a:ext>
             </a:extLst>
           </p:cNvPr>
@@ -4169,7 +4169,7 @@
           <p:cNvPr id="19" name="">
             <a:extLst xmlns:a="http://schemas.openxmlformats.org/drawingml/2006/main">
               <a:ext uri="{FF2B5EF4-FFF2-40B4-BE49-F238E27FC236}">
-                <a16:creationId xmlns:a16="http://schemas.microsoft.com/office/drawing/2014/main" id="{A02BB92A-D7B2-433F-956C-8A57103F408B}"/>
+                <a16:creationId xmlns:a16="http://schemas.microsoft.com/office/drawing/2014/main" id="{74E5D18F-E1C2-4EC5-8946-3EAE8CBC7531}"/>
               </a:ext>
             </a:extLst>
           </p:cNvPr>
@@ -4200,7 +4200,7 @@
           <p:cNvPr id="20" name="">
             <a:extLst xmlns:a="http://schemas.openxmlformats.org/drawingml/2006/main">
               <a:ext uri="{FF2B5EF4-FFF2-40B4-BE49-F238E27FC236}">
-                <a16:creationId xmlns:a16="http://schemas.microsoft.com/office/drawing/2014/main" id="{86A31BF7-0FCC-49BD-9A81-EEA531A83581}"/>
+                <a16:creationId xmlns:a16="http://schemas.microsoft.com/office/drawing/2014/main" id="{EDB9081F-6888-4BC1-B41A-295A47474768}"/>
               </a:ext>
             </a:extLst>
           </p:cNvPr>
@@ -4233,7 +4233,7 @@
           <p:cNvPr id="21" name="">
             <a:extLst xmlns:a="http://schemas.openxmlformats.org/drawingml/2006/main">
               <a:ext uri="{FF2B5EF4-FFF2-40B4-BE49-F238E27FC236}">
-                <a16:creationId xmlns:a16="http://schemas.microsoft.com/office/drawing/2014/main" id="{572046AD-A3FB-4DAC-B848-01F373AB4030}"/>
+                <a16:creationId xmlns:a16="http://schemas.microsoft.com/office/drawing/2014/main" id="{319312EF-363E-4DAD-9545-7906F12331C8}"/>
               </a:ext>
             </a:extLst>
           </p:cNvPr>
@@ -4283,7 +4283,7 @@
           <p:cNvPr id="22" name="">
             <a:extLst xmlns:a="http://schemas.openxmlformats.org/drawingml/2006/main">
               <a:ext uri="{FF2B5EF4-FFF2-40B4-BE49-F238E27FC236}">
-                <a16:creationId xmlns:a16="http://schemas.microsoft.com/office/drawing/2014/main" id="{FF30C5AA-3A26-4929-9636-904305A561D0}"/>
+                <a16:creationId xmlns:a16="http://schemas.microsoft.com/office/drawing/2014/main" id="{67F113F1-1B36-45F2-97A8-600DDAD0C6C8}"/>
               </a:ext>
             </a:extLst>
           </p:cNvPr>
@@ -4333,7 +4333,7 @@
           <p:cNvPr id="23" name="">
             <a:extLst xmlns:a="http://schemas.openxmlformats.org/drawingml/2006/main">
               <a:ext uri="{FF2B5EF4-FFF2-40B4-BE49-F238E27FC236}">
-                <a16:creationId xmlns:a16="http://schemas.microsoft.com/office/drawing/2014/main" id="{81508BDA-9B8D-4F38-A113-04FBD4D89D8A}"/>
+                <a16:creationId xmlns:a16="http://schemas.microsoft.com/office/drawing/2014/main" id="{932C4F4C-5B6C-4D5C-9214-209BD07098ED}"/>
               </a:ext>
             </a:extLst>
           </p:cNvPr>
@@ -4383,7 +4383,7 @@
           <p:cNvPr id="24" name="">
             <a:extLst xmlns:a="http://schemas.openxmlformats.org/drawingml/2006/main">
               <a:ext uri="{FF2B5EF4-FFF2-40B4-BE49-F238E27FC236}">
-                <a16:creationId xmlns:a16="http://schemas.microsoft.com/office/drawing/2014/main" id="{E42B7F01-7795-45FD-A9B5-DC81ACFA1C4B}"/>
+                <a16:creationId xmlns:a16="http://schemas.microsoft.com/office/drawing/2014/main" id="{3C236A13-B93B-46FD-939A-36EEF4B776B9}"/>
               </a:ext>
             </a:extLst>
           </p:cNvPr>
@@ -4433,7 +4433,7 @@
           <p:cNvPr id="25" name="">
             <a:extLst xmlns:a="http://schemas.openxmlformats.org/drawingml/2006/main">
               <a:ext uri="{FF2B5EF4-FFF2-40B4-BE49-F238E27FC236}">
-                <a16:creationId xmlns:a16="http://schemas.microsoft.com/office/drawing/2014/main" id="{CC4F298E-110C-4E7C-AE7F-2EDCA492A1CF}"/>
+                <a16:creationId xmlns:a16="http://schemas.microsoft.com/office/drawing/2014/main" id="{B12F059F-383F-49FA-9F3E-F0B5EFA473C5}"/>
               </a:ext>
             </a:extLst>
           </p:cNvPr>
@@ -4464,7 +4464,7 @@
           <p:cNvPr id="26" name="">
             <a:extLst xmlns:a="http://schemas.openxmlformats.org/drawingml/2006/main">
               <a:ext uri="{FF2B5EF4-FFF2-40B4-BE49-F238E27FC236}">
-                <a16:creationId xmlns:a16="http://schemas.microsoft.com/office/drawing/2014/main" id="{F9DF75E8-073A-4F6E-9BD3-2FBA528E2165}"/>
+                <a16:creationId xmlns:a16="http://schemas.microsoft.com/office/drawing/2014/main" id="{3DA98BE0-6DE4-4B31-8C9D-F58611F2C8E0}"/>
               </a:ext>
             </a:extLst>
           </p:cNvPr>
@@ -4514,7 +4514,7 @@
           <p:cNvPr id="27" name="">
             <a:extLst xmlns:a="http://schemas.openxmlformats.org/drawingml/2006/main">
               <a:ext uri="{FF2B5EF4-FFF2-40B4-BE49-F238E27FC236}">
-                <a16:creationId xmlns:a16="http://schemas.microsoft.com/office/drawing/2014/main" id="{2B0C58CE-F2C9-4DB2-A6D5-A3AF13F4BBA4}"/>
+                <a16:creationId xmlns:a16="http://schemas.microsoft.com/office/drawing/2014/main" id="{EF79539B-E7EB-42D6-866A-3A21377BA7CE}"/>
               </a:ext>
             </a:extLst>
           </p:cNvPr>
@@ -4564,7 +4564,7 @@
           <p:cNvPr id="28" name="">
             <a:extLst xmlns:a="http://schemas.openxmlformats.org/drawingml/2006/main">
               <a:ext uri="{FF2B5EF4-FFF2-40B4-BE49-F238E27FC236}">
-                <a16:creationId xmlns:a16="http://schemas.microsoft.com/office/drawing/2014/main" id="{6D692095-6588-4E00-AFD1-BF5B36B2336E}"/>
+                <a16:creationId xmlns:a16="http://schemas.microsoft.com/office/drawing/2014/main" id="{F28035BB-0D79-43B6-A2E5-26B313048C16}"/>
               </a:ext>
             </a:extLst>
           </p:cNvPr>
@@ -4614,7 +4614,7 @@
           <p:cNvPr id="29" name="">
             <a:extLst xmlns:a="http://schemas.openxmlformats.org/drawingml/2006/main">
               <a:ext uri="{FF2B5EF4-FFF2-40B4-BE49-F238E27FC236}">
-                <a16:creationId xmlns:a16="http://schemas.microsoft.com/office/drawing/2014/main" id="{A2F62089-5C9D-4C6D-817E-10472506CCF1}"/>
+                <a16:creationId xmlns:a16="http://schemas.microsoft.com/office/drawing/2014/main" id="{7F693F92-3733-4DB2-90B0-B6085BE41E75}"/>
               </a:ext>
             </a:extLst>
           </p:cNvPr>
@@ -4664,7 +4664,7 @@
           <p:cNvPr id="30" name="">
             <a:extLst xmlns:a="http://schemas.openxmlformats.org/drawingml/2006/main">
               <a:ext uri="{FF2B5EF4-FFF2-40B4-BE49-F238E27FC236}">
-                <a16:creationId xmlns:a16="http://schemas.microsoft.com/office/drawing/2014/main" id="{8DFAA2CB-D389-4DBA-851F-011CAADF6333}"/>
+                <a16:creationId xmlns:a16="http://schemas.microsoft.com/office/drawing/2014/main" id="{8D850C4A-65C5-4EC4-90DD-8702C4D00FC0}"/>
               </a:ext>
             </a:extLst>
           </p:cNvPr>
@@ -4695,7 +4695,7 @@
           <p:cNvPr id="31" name="">
             <a:extLst xmlns:a="http://schemas.openxmlformats.org/drawingml/2006/main">
               <a:ext uri="{FF2B5EF4-FFF2-40B4-BE49-F238E27FC236}">
-                <a16:creationId xmlns:a16="http://schemas.microsoft.com/office/drawing/2014/main" id="{337139E0-9E34-464B-8CD5-9470D60A4043}"/>
+                <a16:creationId xmlns:a16="http://schemas.microsoft.com/office/drawing/2014/main" id="{4933FA2A-2C4C-44C1-BD05-CAF058C3CC51}"/>
               </a:ext>
             </a:extLst>
           </p:cNvPr>
@@ -4745,7 +4745,7 @@
           <p:cNvPr id="32" name="">
             <a:extLst xmlns:a="http://schemas.openxmlformats.org/drawingml/2006/main">
               <a:ext uri="{FF2B5EF4-FFF2-40B4-BE49-F238E27FC236}">
-                <a16:creationId xmlns:a16="http://schemas.microsoft.com/office/drawing/2014/main" id="{4DE41B78-C91F-4E8C-9102-FB2D9D1A997F}"/>
+                <a16:creationId xmlns:a16="http://schemas.microsoft.com/office/drawing/2014/main" id="{6DC67C3E-91B1-4714-A545-3DB3C04FA1DA}"/>
               </a:ext>
             </a:extLst>
           </p:cNvPr>
@@ -4795,7 +4795,7 @@
           <p:cNvPr id="33" name="">
             <a:extLst xmlns:a="http://schemas.openxmlformats.org/drawingml/2006/main">
               <a:ext uri="{FF2B5EF4-FFF2-40B4-BE49-F238E27FC236}">
-                <a16:creationId xmlns:a16="http://schemas.microsoft.com/office/drawing/2014/main" id="{81248FE7-BB71-4AD1-8195-AFAFA37B35FF}"/>
+                <a16:creationId xmlns:a16="http://schemas.microsoft.com/office/drawing/2014/main" id="{11166A62-E6A0-4C5B-B17D-EFB7990A9FB9}"/>
               </a:ext>
             </a:extLst>
           </p:cNvPr>
@@ -4845,7 +4845,7 @@
           <p:cNvPr id="34" name="">
             <a:extLst xmlns:a="http://schemas.openxmlformats.org/drawingml/2006/main">
               <a:ext uri="{FF2B5EF4-FFF2-40B4-BE49-F238E27FC236}">
-                <a16:creationId xmlns:a16="http://schemas.microsoft.com/office/drawing/2014/main" id="{AD12388A-5FB8-40E4-8E89-2E8D1A1C4774}"/>
+                <a16:creationId xmlns:a16="http://schemas.microsoft.com/office/drawing/2014/main" id="{BE0991A4-AE6C-4C95-B379-A6166A5E715E}"/>
               </a:ext>
             </a:extLst>
           </p:cNvPr>
@@ -4895,7 +4895,7 @@
           <p:cNvPr id="35" name="">
             <a:extLst xmlns:a="http://schemas.openxmlformats.org/drawingml/2006/main">
               <a:ext uri="{FF2B5EF4-FFF2-40B4-BE49-F238E27FC236}">
-                <a16:creationId xmlns:a16="http://schemas.microsoft.com/office/drawing/2014/main" id="{2F8DFBC7-3926-431F-B606-7F6DDD33589F}"/>
+                <a16:creationId xmlns:a16="http://schemas.microsoft.com/office/drawing/2014/main" id="{6D0D048E-1EFB-4CFA-B52E-5C5D70E2C7BE}"/>
               </a:ext>
             </a:extLst>
           </p:cNvPr>
@@ -4926,7 +4926,7 @@
           <p:cNvPr id="36" name="">
             <a:extLst xmlns:a="http://schemas.openxmlformats.org/drawingml/2006/main">
               <a:ext uri="{FF2B5EF4-FFF2-40B4-BE49-F238E27FC236}">
-                <a16:creationId xmlns:a16="http://schemas.microsoft.com/office/drawing/2014/main" id="{57BB7DD9-A6A2-4FE8-8FEC-14F12D5B4F92}"/>
+                <a16:creationId xmlns:a16="http://schemas.microsoft.com/office/drawing/2014/main" id="{BC334C9B-56F2-48D5-AA12-285571825044}"/>
               </a:ext>
             </a:extLst>
           </p:cNvPr>
@@ -4959,7 +4959,7 @@
           <p:cNvPr id="37" name="">
             <a:extLst xmlns:a="http://schemas.openxmlformats.org/drawingml/2006/main">
               <a:ext uri="{FF2B5EF4-FFF2-40B4-BE49-F238E27FC236}">
-                <a16:creationId xmlns:a16="http://schemas.microsoft.com/office/drawing/2014/main" id="{2BE7B9F3-7D60-4998-9C7C-02CF2FA1BE1E}"/>
+                <a16:creationId xmlns:a16="http://schemas.microsoft.com/office/drawing/2014/main" id="{4DA894E2-5D6A-4D38-A0D5-E0FAA5BCFEE6}"/>
               </a:ext>
             </a:extLst>
           </p:cNvPr>
@@ -5009,7 +5009,7 @@
           <p:cNvPr id="38" name="">
             <a:extLst xmlns:a="http://schemas.openxmlformats.org/drawingml/2006/main">
               <a:ext uri="{FF2B5EF4-FFF2-40B4-BE49-F238E27FC236}">
-                <a16:creationId xmlns:a16="http://schemas.microsoft.com/office/drawing/2014/main" id="{71F82189-E913-429C-9128-ADB0DF1B754F}"/>
+                <a16:creationId xmlns:a16="http://schemas.microsoft.com/office/drawing/2014/main" id="{F8D14C7C-DC43-44C3-8F96-889B471D8A99}"/>
               </a:ext>
             </a:extLst>
           </p:cNvPr>
@@ -5059,7 +5059,7 @@
           <p:cNvPr id="39" name="">
             <a:extLst xmlns:a="http://schemas.openxmlformats.org/drawingml/2006/main">
               <a:ext uri="{FF2B5EF4-FFF2-40B4-BE49-F238E27FC236}">
-                <a16:creationId xmlns:a16="http://schemas.microsoft.com/office/drawing/2014/main" id="{B95AE6CD-AC93-4ADD-9950-B4C750AB2A1D}"/>
+                <a16:creationId xmlns:a16="http://schemas.microsoft.com/office/drawing/2014/main" id="{1EBD9334-F942-4086-BCB5-61A440EE63F9}"/>
               </a:ext>
             </a:extLst>
           </p:cNvPr>
@@ -5109,7 +5109,7 @@
           <p:cNvPr id="40" name="">
             <a:extLst xmlns:a="http://schemas.openxmlformats.org/drawingml/2006/main">
               <a:ext uri="{FF2B5EF4-FFF2-40B4-BE49-F238E27FC236}">
-                <a16:creationId xmlns:a16="http://schemas.microsoft.com/office/drawing/2014/main" id="{A34CDFF8-5DF8-4FA0-9119-D9B26BEB2BC8}"/>
+                <a16:creationId xmlns:a16="http://schemas.microsoft.com/office/drawing/2014/main" id="{1E35ADB7-6EBD-4DA8-9D12-1C5AF8F68226}"/>
               </a:ext>
             </a:extLst>
           </p:cNvPr>
@@ -5159,7 +5159,7 @@
           <p:cNvPr id="41" name="">
             <a:extLst xmlns:a="http://schemas.openxmlformats.org/drawingml/2006/main">
               <a:ext uri="{FF2B5EF4-FFF2-40B4-BE49-F238E27FC236}">
-                <a16:creationId xmlns:a16="http://schemas.microsoft.com/office/drawing/2014/main" id="{027A7892-6D8C-4CB6-8C84-37D5E90CEDC9}"/>
+                <a16:creationId xmlns:a16="http://schemas.microsoft.com/office/drawing/2014/main" id="{51F1E0C3-67AE-48EE-9DF0-1DB94A9A1594}"/>
               </a:ext>
             </a:extLst>
           </p:cNvPr>
@@ -5190,7 +5190,7 @@
           <p:cNvPr id="42" name="">
             <a:extLst xmlns:a="http://schemas.openxmlformats.org/drawingml/2006/main">
               <a:ext uri="{FF2B5EF4-FFF2-40B4-BE49-F238E27FC236}">
-                <a16:creationId xmlns:a16="http://schemas.microsoft.com/office/drawing/2014/main" id="{AE17730E-1F8C-478E-8E05-2D2EBFA0C761}"/>
+                <a16:creationId xmlns:a16="http://schemas.microsoft.com/office/drawing/2014/main" id="{9A0EB313-E1E1-4998-A094-F58FE7597B66}"/>
               </a:ext>
             </a:extLst>
           </p:cNvPr>
@@ -5240,7 +5240,7 @@
           <p:cNvPr id="43" name="">
             <a:extLst xmlns:a="http://schemas.openxmlformats.org/drawingml/2006/main">
               <a:ext uri="{FF2B5EF4-FFF2-40B4-BE49-F238E27FC236}">
-                <a16:creationId xmlns:a16="http://schemas.microsoft.com/office/drawing/2014/main" id="{AA797152-7205-4D21-B62C-A388ED477A65}"/>
+                <a16:creationId xmlns:a16="http://schemas.microsoft.com/office/drawing/2014/main" id="{35BCF703-F8C1-4209-B95A-10EC8329E39E}"/>
               </a:ext>
             </a:extLst>
           </p:cNvPr>
@@ -5271,7 +5271,7 @@
           <p:cNvPr id="44" name="source-10">
             <a:extLst xmlns:a="http://schemas.openxmlformats.org/drawingml/2006/main">
               <a:ext uri="{FF2B5EF4-FFF2-40B4-BE49-F238E27FC236}">
-                <a16:creationId xmlns:a16="http://schemas.microsoft.com/office/drawing/2014/main" id="{53BBD1E0-D9B6-4119-923E-BFE0CC0CDA30}"/>
+                <a16:creationId xmlns:a16="http://schemas.microsoft.com/office/drawing/2014/main" id="{C325922F-B7FF-4972-85F3-E668293137C7}"/>
               </a:ext>
             </a:extLst>
           </p:cNvPr>
@@ -5321,7 +5321,7 @@
           <p:cNvPr id="45" name="page-10">
             <a:extLst xmlns:a="http://schemas.openxmlformats.org/drawingml/2006/main">
               <a:ext uri="{FF2B5EF4-FFF2-40B4-BE49-F238E27FC236}">
-                <a16:creationId xmlns:a16="http://schemas.microsoft.com/office/drawing/2014/main" id="{594BBB29-4F41-4B9A-A753-5D32C1FC4EBD}"/>
+                <a16:creationId xmlns:a16="http://schemas.microsoft.com/office/drawing/2014/main" id="{48E3BAE2-DC47-4C85-BFB1-CF4EB19F643C}"/>
               </a:ext>
             </a:extLst>
           </p:cNvPr>
@@ -5369,7 +5369,7 @@
     </p:spTree>
     <p:extLst>
       <p:ext uri="{BB962C8B-B14F-4D97-AF65-F5344CB8AC3E}">
-        <p14:creationId xmlns:p14="http://schemas.microsoft.com/office/powerpoint/2010/main" val="479778527"/>
+        <p14:creationId xmlns:p14="http://schemas.microsoft.com/office/powerpoint/2010/main" val="2139972927"/>
       </p:ext>
     </p:extLst>
   </p:cSld>
@@ -5400,7 +5400,7 @@
           <p:cNvPr id="29" name="kicker-11">
             <a:extLst xmlns:a="http://schemas.openxmlformats.org/drawingml/2006/main">
               <a:ext uri="{FF2B5EF4-FFF2-40B4-BE49-F238E27FC236}">
-                <a16:creationId xmlns:a16="http://schemas.microsoft.com/office/drawing/2014/main" id="{B1FB8196-35BD-4375-97AA-98E15B0B94C5}"/>
+                <a16:creationId xmlns:a16="http://schemas.microsoft.com/office/drawing/2014/main" id="{FBA6E5D5-3FD8-48FC-84C9-880965CBC98A}"/>
               </a:ext>
             </a:extLst>
           </p:cNvPr>
@@ -5450,7 +5450,7 @@
           <p:cNvPr id="2" name="title-11">
             <a:extLst xmlns:a="http://schemas.openxmlformats.org/drawingml/2006/main">
               <a:ext uri="{FF2B5EF4-FFF2-40B4-BE49-F238E27FC236}">
-                <a16:creationId xmlns:a16="http://schemas.microsoft.com/office/drawing/2014/main" id="{6E9CAA59-CA9E-4579-A267-B29951B3FE27}"/>
+                <a16:creationId xmlns:a16="http://schemas.microsoft.com/office/drawing/2014/main" id="{5A9C8C4D-3902-4BE8-AF24-CB099C51556C}"/>
               </a:ext>
             </a:extLst>
           </p:cNvPr>
@@ -5500,7 +5500,7 @@
           <p:cNvPr id="3" name="">
             <a:extLst xmlns:a="http://schemas.openxmlformats.org/drawingml/2006/main">
               <a:ext uri="{FF2B5EF4-FFF2-40B4-BE49-F238E27FC236}">
-                <a16:creationId xmlns:a16="http://schemas.microsoft.com/office/drawing/2014/main" id="{081C9B27-2041-46C3-9FA5-9D8082D04326}"/>
+                <a16:creationId xmlns:a16="http://schemas.microsoft.com/office/drawing/2014/main" id="{FBE5D8CB-5EAE-49FF-8076-0F178199F79A}"/>
               </a:ext>
             </a:extLst>
           </p:cNvPr>
@@ -5531,7 +5531,7 @@
           <p:cNvPr id="4" name="">
             <a:extLst xmlns:a="http://schemas.openxmlformats.org/drawingml/2006/main">
               <a:ext uri="{FF2B5EF4-FFF2-40B4-BE49-F238E27FC236}">
-                <a16:creationId xmlns:a16="http://schemas.microsoft.com/office/drawing/2014/main" id="{518B2198-B367-4824-8605-138FF95725AC}"/>
+                <a16:creationId xmlns:a16="http://schemas.microsoft.com/office/drawing/2014/main" id="{AB23159F-2413-4BF4-BDFE-FB86E247005D}"/>
               </a:ext>
             </a:extLst>
           </p:cNvPr>
@@ -5581,7 +5581,7 @@
           <p:cNvPr id="5" name="">
             <a:extLst xmlns:a="http://schemas.openxmlformats.org/drawingml/2006/main">
               <a:ext uri="{FF2B5EF4-FFF2-40B4-BE49-F238E27FC236}">
-                <a16:creationId xmlns:a16="http://schemas.microsoft.com/office/drawing/2014/main" id="{959BBE0D-D927-4AAA-B655-C026F6D563C1}"/>
+                <a16:creationId xmlns:a16="http://schemas.microsoft.com/office/drawing/2014/main" id="{B1010340-9A9A-4496-93C2-BF0D34567949}"/>
               </a:ext>
             </a:extLst>
           </p:cNvPr>
@@ -5631,7 +5631,7 @@
           <p:cNvPr id="6" name="">
             <a:extLst xmlns:a="http://schemas.openxmlformats.org/drawingml/2006/main">
               <a:ext uri="{FF2B5EF4-FFF2-40B4-BE49-F238E27FC236}">
-                <a16:creationId xmlns:a16="http://schemas.microsoft.com/office/drawing/2014/main" id="{7DF709EB-2B21-4997-97A0-E88A193E98EF}"/>
+                <a16:creationId xmlns:a16="http://schemas.microsoft.com/office/drawing/2014/main" id="{0E84A8EA-2E4B-4EB7-A89F-91D797C3AA03}"/>
               </a:ext>
             </a:extLst>
           </p:cNvPr>
@@ -5681,7 +5681,7 @@
           <p:cNvPr id="7" name="">
             <a:extLst xmlns:a="http://schemas.openxmlformats.org/drawingml/2006/main">
               <a:ext uri="{FF2B5EF4-FFF2-40B4-BE49-F238E27FC236}">
-                <a16:creationId xmlns:a16="http://schemas.microsoft.com/office/drawing/2014/main" id="{94933982-2649-46E6-AF73-29B8E16C3E4A}"/>
+                <a16:creationId xmlns:a16="http://schemas.microsoft.com/office/drawing/2014/main" id="{2A21159E-1664-448E-A0AA-04FCB2DAFFB9}"/>
               </a:ext>
             </a:extLst>
           </p:cNvPr>
@@ -5731,7 +5731,7 @@
           <p:cNvPr id="8" name="">
             <a:extLst xmlns:a="http://schemas.openxmlformats.org/drawingml/2006/main">
               <a:ext uri="{FF2B5EF4-FFF2-40B4-BE49-F238E27FC236}">
-                <a16:creationId xmlns:a16="http://schemas.microsoft.com/office/drawing/2014/main" id="{D60437A7-BCDC-43F6-B5D8-5B9A2A0379EA}"/>
+                <a16:creationId xmlns:a16="http://schemas.microsoft.com/office/drawing/2014/main" id="{0565CAA6-8237-4885-80BA-A476B44D36CD}"/>
               </a:ext>
             </a:extLst>
           </p:cNvPr>
@@ -5762,7 +5762,7 @@
           <p:cNvPr id="9" name="">
             <a:extLst xmlns:a="http://schemas.openxmlformats.org/drawingml/2006/main">
               <a:ext uri="{FF2B5EF4-FFF2-40B4-BE49-F238E27FC236}">
-                <a16:creationId xmlns:a16="http://schemas.microsoft.com/office/drawing/2014/main" id="{00A88FEB-DE8B-4C6D-A8E3-B527510BD269}"/>
+                <a16:creationId xmlns:a16="http://schemas.microsoft.com/office/drawing/2014/main" id="{FFB3AE57-E655-4D9F-847B-EDE301283FB5}"/>
               </a:ext>
             </a:extLst>
           </p:cNvPr>
@@ -5812,7 +5812,7 @@
           <p:cNvPr id="10" name="">
             <a:extLst xmlns:a="http://schemas.openxmlformats.org/drawingml/2006/main">
               <a:ext uri="{FF2B5EF4-FFF2-40B4-BE49-F238E27FC236}">
-                <a16:creationId xmlns:a16="http://schemas.microsoft.com/office/drawing/2014/main" id="{491A13E5-29B5-48DC-8C31-591CF590344A}"/>
+                <a16:creationId xmlns:a16="http://schemas.microsoft.com/office/drawing/2014/main" id="{D530B28B-4CFF-493B-8D5C-35E6FD7671CF}"/>
               </a:ext>
             </a:extLst>
           </p:cNvPr>
@@ -5862,7 +5862,7 @@
           <p:cNvPr id="11" name="">
             <a:extLst xmlns:a="http://schemas.openxmlformats.org/drawingml/2006/main">
               <a:ext uri="{FF2B5EF4-FFF2-40B4-BE49-F238E27FC236}">
-                <a16:creationId xmlns:a16="http://schemas.microsoft.com/office/drawing/2014/main" id="{1B4E8E40-7D97-4ABA-81A8-4CB2FE3123F3}"/>
+                <a16:creationId xmlns:a16="http://schemas.microsoft.com/office/drawing/2014/main" id="{98972ACF-F41F-4443-BA6D-CCB32007930A}"/>
               </a:ext>
             </a:extLst>
           </p:cNvPr>
@@ -5912,7 +5912,7 @@
           <p:cNvPr id="12" name="">
             <a:extLst xmlns:a="http://schemas.openxmlformats.org/drawingml/2006/main">
               <a:ext uri="{FF2B5EF4-FFF2-40B4-BE49-F238E27FC236}">
-                <a16:creationId xmlns:a16="http://schemas.microsoft.com/office/drawing/2014/main" id="{869CB84D-7386-4032-8438-F6E5BE9834A9}"/>
+                <a16:creationId xmlns:a16="http://schemas.microsoft.com/office/drawing/2014/main" id="{9E0EB938-7E6F-4D27-BBAF-D44E5347D685}"/>
               </a:ext>
             </a:extLst>
           </p:cNvPr>
@@ -5943,7 +5943,7 @@
           <p:cNvPr id="13" name="">
             <a:extLst xmlns:a="http://schemas.openxmlformats.org/drawingml/2006/main">
               <a:ext uri="{FF2B5EF4-FFF2-40B4-BE49-F238E27FC236}">
-                <a16:creationId xmlns:a16="http://schemas.microsoft.com/office/drawing/2014/main" id="{38FD1C48-BBFA-4CC2-A81E-FBD6FAA143ED}"/>
+                <a16:creationId xmlns:a16="http://schemas.microsoft.com/office/drawing/2014/main" id="{DD35140A-910A-48A9-BD35-7E4E08C89826}"/>
               </a:ext>
             </a:extLst>
           </p:cNvPr>
@@ -5993,7 +5993,7 @@
           <p:cNvPr id="14" name="">
             <a:extLst xmlns:a="http://schemas.openxmlformats.org/drawingml/2006/main">
               <a:ext uri="{FF2B5EF4-FFF2-40B4-BE49-F238E27FC236}">
-                <a16:creationId xmlns:a16="http://schemas.microsoft.com/office/drawing/2014/main" id="{C91A6282-5FB2-40CE-A7E1-F5CD89C6262E}"/>
+                <a16:creationId xmlns:a16="http://schemas.microsoft.com/office/drawing/2014/main" id="{A28039F2-D0EA-4383-9E35-B19709EEFED3}"/>
               </a:ext>
             </a:extLst>
           </p:cNvPr>
@@ -6043,7 +6043,7 @@
           <p:cNvPr id="15" name="">
             <a:extLst xmlns:a="http://schemas.openxmlformats.org/drawingml/2006/main">
               <a:ext uri="{FF2B5EF4-FFF2-40B4-BE49-F238E27FC236}">
-                <a16:creationId xmlns:a16="http://schemas.microsoft.com/office/drawing/2014/main" id="{BCCD39D5-5C15-4776-ADDD-4F97C8802CB1}"/>
+                <a16:creationId xmlns:a16="http://schemas.microsoft.com/office/drawing/2014/main" id="{727DD5F1-E643-4D99-8A8A-AF94F7BC26AA}"/>
               </a:ext>
             </a:extLst>
           </p:cNvPr>
@@ -6093,7 +6093,7 @@
           <p:cNvPr id="16" name="">
             <a:extLst xmlns:a="http://schemas.openxmlformats.org/drawingml/2006/main">
               <a:ext uri="{FF2B5EF4-FFF2-40B4-BE49-F238E27FC236}">
-                <a16:creationId xmlns:a16="http://schemas.microsoft.com/office/drawing/2014/main" id="{FFDE1175-AE03-43CF-8D7D-3339A4A46F87}"/>
+                <a16:creationId xmlns:a16="http://schemas.microsoft.com/office/drawing/2014/main" id="{C2AECBDC-1D0D-49F0-8B40-D633C812FE49}"/>
               </a:ext>
             </a:extLst>
           </p:cNvPr>
@@ -6124,7 +6124,7 @@
           <p:cNvPr id="17" name="">
             <a:extLst xmlns:a="http://schemas.openxmlformats.org/drawingml/2006/main">
               <a:ext uri="{FF2B5EF4-FFF2-40B4-BE49-F238E27FC236}">
-                <a16:creationId xmlns:a16="http://schemas.microsoft.com/office/drawing/2014/main" id="{3CD8566A-6BB0-4E19-A5A5-929AA54286E0}"/>
+                <a16:creationId xmlns:a16="http://schemas.microsoft.com/office/drawing/2014/main" id="{167CDB02-8DF0-4CD6-8BE0-AAB639163919}"/>
               </a:ext>
             </a:extLst>
           </p:cNvPr>
@@ -6174,7 +6174,7 @@
           <p:cNvPr id="18" name="">
             <a:extLst xmlns:a="http://schemas.openxmlformats.org/drawingml/2006/main">
               <a:ext uri="{FF2B5EF4-FFF2-40B4-BE49-F238E27FC236}">
-                <a16:creationId xmlns:a16="http://schemas.microsoft.com/office/drawing/2014/main" id="{8D58B294-71E7-4E0B-B46E-84E2C66EF55E}"/>
+                <a16:creationId xmlns:a16="http://schemas.microsoft.com/office/drawing/2014/main" id="{363C1570-8C19-4F0F-9E37-4839B6A7C60F}"/>
               </a:ext>
             </a:extLst>
           </p:cNvPr>
@@ -6224,7 +6224,7 @@
           <p:cNvPr id="19" name="">
             <a:extLst xmlns:a="http://schemas.openxmlformats.org/drawingml/2006/main">
               <a:ext uri="{FF2B5EF4-FFF2-40B4-BE49-F238E27FC236}">
-                <a16:creationId xmlns:a16="http://schemas.microsoft.com/office/drawing/2014/main" id="{B7C5CB8E-CC89-49B0-A212-18118C0B6F02}"/>
+                <a16:creationId xmlns:a16="http://schemas.microsoft.com/office/drawing/2014/main" id="{1E3B809B-72FC-43C9-8B62-085B63D9DE29}"/>
               </a:ext>
             </a:extLst>
           </p:cNvPr>
@@ -6274,7 +6274,7 @@
           <p:cNvPr id="20" name="">
             <a:extLst xmlns:a="http://schemas.openxmlformats.org/drawingml/2006/main">
               <a:ext uri="{FF2B5EF4-FFF2-40B4-BE49-F238E27FC236}">
-                <a16:creationId xmlns:a16="http://schemas.microsoft.com/office/drawing/2014/main" id="{2060C77C-1ADE-4176-A6DC-75C34E578FD9}"/>
+                <a16:creationId xmlns:a16="http://schemas.microsoft.com/office/drawing/2014/main" id="{9A1AA02E-B891-4133-A939-2FD48E9ED555}"/>
               </a:ext>
             </a:extLst>
           </p:cNvPr>
@@ -6305,7 +6305,7 @@
           <p:cNvPr id="21" name="">
             <a:extLst xmlns:a="http://schemas.openxmlformats.org/drawingml/2006/main">
               <a:ext uri="{FF2B5EF4-FFF2-40B4-BE49-F238E27FC236}">
-                <a16:creationId xmlns:a16="http://schemas.microsoft.com/office/drawing/2014/main" id="{510EB884-EFD2-4C2F-A51D-568800D3D01F}"/>
+                <a16:creationId xmlns:a16="http://schemas.microsoft.com/office/drawing/2014/main" id="{5F831E87-D104-47BC-A892-BCD479F7B849}"/>
               </a:ext>
             </a:extLst>
           </p:cNvPr>
@@ -6355,7 +6355,7 @@
           <p:cNvPr id="22" name="">
             <a:extLst xmlns:a="http://schemas.openxmlformats.org/drawingml/2006/main">
               <a:ext uri="{FF2B5EF4-FFF2-40B4-BE49-F238E27FC236}">
-                <a16:creationId xmlns:a16="http://schemas.microsoft.com/office/drawing/2014/main" id="{30C67547-33DD-4428-BDCE-CFB4211F242B}"/>
+                <a16:creationId xmlns:a16="http://schemas.microsoft.com/office/drawing/2014/main" id="{9D0D269E-1B19-4849-BE54-1C086F6E7148}"/>
               </a:ext>
             </a:extLst>
           </p:cNvPr>
@@ -6405,7 +6405,7 @@
           <p:cNvPr id="23" name="">
             <a:extLst xmlns:a="http://schemas.openxmlformats.org/drawingml/2006/main">
               <a:ext uri="{FF2B5EF4-FFF2-40B4-BE49-F238E27FC236}">
-                <a16:creationId xmlns:a16="http://schemas.microsoft.com/office/drawing/2014/main" id="{64D0C37B-5085-4A73-9905-54B006244ADF}"/>
+                <a16:creationId xmlns:a16="http://schemas.microsoft.com/office/drawing/2014/main" id="{F6C55C9B-1E86-477F-8151-26BC09102323}"/>
               </a:ext>
             </a:extLst>
           </p:cNvPr>
@@ -6455,7 +6455,7 @@
           <p:cNvPr id="24" name="">
             <a:extLst xmlns:a="http://schemas.openxmlformats.org/drawingml/2006/main">
               <a:ext uri="{FF2B5EF4-FFF2-40B4-BE49-F238E27FC236}">
-                <a16:creationId xmlns:a16="http://schemas.microsoft.com/office/drawing/2014/main" id="{E91B4482-2992-4585-9DB0-40F4EF4A6751}"/>
+                <a16:creationId xmlns:a16="http://schemas.microsoft.com/office/drawing/2014/main" id="{744243E3-375E-4DA4-93AA-4294E593C452}"/>
               </a:ext>
             </a:extLst>
           </p:cNvPr>
@@ -6486,7 +6486,7 @@
           <p:cNvPr id="25" name="">
             <a:extLst xmlns:a="http://schemas.openxmlformats.org/drawingml/2006/main">
               <a:ext uri="{FF2B5EF4-FFF2-40B4-BE49-F238E27FC236}">
-                <a16:creationId xmlns:a16="http://schemas.microsoft.com/office/drawing/2014/main" id="{9FB644CC-0279-4678-A5C8-3500B207616F}"/>
+                <a16:creationId xmlns:a16="http://schemas.microsoft.com/office/drawing/2014/main" id="{29EFD0DC-B388-4476-A62A-338BC2C07F9D}"/>
               </a:ext>
             </a:extLst>
           </p:cNvPr>
@@ -6536,7 +6536,7 @@
           <p:cNvPr id="26" name="">
             <a:extLst xmlns:a="http://schemas.openxmlformats.org/drawingml/2006/main">
               <a:ext uri="{FF2B5EF4-FFF2-40B4-BE49-F238E27FC236}">
-                <a16:creationId xmlns:a16="http://schemas.microsoft.com/office/drawing/2014/main" id="{FD35979E-4FD6-4569-A8AE-997C318BAAB5}"/>
+                <a16:creationId xmlns:a16="http://schemas.microsoft.com/office/drawing/2014/main" id="{606B725C-818B-44BD-9619-91C2C55B01B6}"/>
               </a:ext>
             </a:extLst>
           </p:cNvPr>
@@ -6567,7 +6567,7 @@
           <p:cNvPr id="27" name="source-11">
             <a:extLst xmlns:a="http://schemas.openxmlformats.org/drawingml/2006/main">
               <a:ext uri="{FF2B5EF4-FFF2-40B4-BE49-F238E27FC236}">
-                <a16:creationId xmlns:a16="http://schemas.microsoft.com/office/drawing/2014/main" id="{7F857251-9D7D-4079-B284-3A3AAF80ADFF}"/>
+                <a16:creationId xmlns:a16="http://schemas.microsoft.com/office/drawing/2014/main" id="{F6268502-DD88-4C8E-AFC2-F3735EDC5F3A}"/>
               </a:ext>
             </a:extLst>
           </p:cNvPr>
@@ -6617,7 +6617,7 @@
           <p:cNvPr id="28" name="page-11">
             <a:extLst xmlns:a="http://schemas.openxmlformats.org/drawingml/2006/main">
               <a:ext uri="{FF2B5EF4-FFF2-40B4-BE49-F238E27FC236}">
-                <a16:creationId xmlns:a16="http://schemas.microsoft.com/office/drawing/2014/main" id="{9320CC10-F809-497E-A309-F4F22D3E62E6}"/>
+                <a16:creationId xmlns:a16="http://schemas.microsoft.com/office/drawing/2014/main" id="{BA6637E6-7E5D-4167-8869-67A5BAC6055C}"/>
               </a:ext>
             </a:extLst>
           </p:cNvPr>
@@ -6665,7 +6665,7 @@
     </p:spTree>
     <p:extLst>
       <p:ext uri="{BB962C8B-B14F-4D97-AF65-F5344CB8AC3E}">
-        <p14:creationId xmlns:p14="http://schemas.microsoft.com/office/powerpoint/2010/main" val="1696174444"/>
+        <p14:creationId xmlns:p14="http://schemas.microsoft.com/office/powerpoint/2010/main" val="837753142"/>
       </p:ext>
     </p:extLst>
   </p:cSld>
@@ -6696,7 +6696,7 @@
           <p:cNvPr id="38" name="kicker-12">
             <a:extLst xmlns:a="http://schemas.openxmlformats.org/drawingml/2006/main">
               <a:ext uri="{FF2B5EF4-FFF2-40B4-BE49-F238E27FC236}">
-                <a16:creationId xmlns:a16="http://schemas.microsoft.com/office/drawing/2014/main" id="{6EE241FD-B3F5-4966-A090-A2392538B923}"/>
+                <a16:creationId xmlns:a16="http://schemas.microsoft.com/office/drawing/2014/main" id="{F660AC61-5E47-4BC2-83AF-4DD649132A83}"/>
               </a:ext>
             </a:extLst>
           </p:cNvPr>
@@ -6746,7 +6746,7 @@
           <p:cNvPr id="2" name="title-12">
             <a:extLst xmlns:a="http://schemas.openxmlformats.org/drawingml/2006/main">
               <a:ext uri="{FF2B5EF4-FFF2-40B4-BE49-F238E27FC236}">
-                <a16:creationId xmlns:a16="http://schemas.microsoft.com/office/drawing/2014/main" id="{D5B598CF-4483-4512-BF91-3E0D0F903C1B}"/>
+                <a16:creationId xmlns:a16="http://schemas.microsoft.com/office/drawing/2014/main" id="{99DAA247-2AA8-45DE-B216-3587BDB93210}"/>
               </a:ext>
             </a:extLst>
           </p:cNvPr>
@@ -6796,7 +6796,7 @@
           <p:cNvPr id="3" name="">
             <a:extLst xmlns:a="http://schemas.openxmlformats.org/drawingml/2006/main">
               <a:ext uri="{FF2B5EF4-FFF2-40B4-BE49-F238E27FC236}">
-                <a16:creationId xmlns:a16="http://schemas.microsoft.com/office/drawing/2014/main" id="{37FF2751-381A-46CC-A46A-936DB35581EC}"/>
+                <a16:creationId xmlns:a16="http://schemas.microsoft.com/office/drawing/2014/main" id="{25EFA620-8FF6-47B9-BD17-7C606C939C86}"/>
               </a:ext>
             </a:extLst>
           </p:cNvPr>
@@ -6827,7 +6827,7 @@
           <p:cNvPr id="4" name="">
             <a:extLst xmlns:a="http://schemas.openxmlformats.org/drawingml/2006/main">
               <a:ext uri="{FF2B5EF4-FFF2-40B4-BE49-F238E27FC236}">
-                <a16:creationId xmlns:a16="http://schemas.microsoft.com/office/drawing/2014/main" id="{779314D1-6504-452B-8C91-04AEB1C4DEB6}"/>
+                <a16:creationId xmlns:a16="http://schemas.microsoft.com/office/drawing/2014/main" id="{E3792FF5-2CF9-407D-971C-4C2B98D6FC63}"/>
               </a:ext>
             </a:extLst>
           </p:cNvPr>
@@ -6877,7 +6877,7 @@
           <p:cNvPr id="5" name="">
             <a:extLst xmlns:a="http://schemas.openxmlformats.org/drawingml/2006/main">
               <a:ext uri="{FF2B5EF4-FFF2-40B4-BE49-F238E27FC236}">
-                <a16:creationId xmlns:a16="http://schemas.microsoft.com/office/drawing/2014/main" id="{0D86809F-E898-4036-BB62-DF322CC2FF3D}"/>
+                <a16:creationId xmlns:a16="http://schemas.microsoft.com/office/drawing/2014/main" id="{E91B8C04-A6A5-40F0-A67D-06296EFC8C79}"/>
               </a:ext>
             </a:extLst>
           </p:cNvPr>
@@ -6927,7 +6927,7 @@
           <p:cNvPr id="6" name="">
             <a:extLst xmlns:a="http://schemas.openxmlformats.org/drawingml/2006/main">
               <a:ext uri="{FF2B5EF4-FFF2-40B4-BE49-F238E27FC236}">
-                <a16:creationId xmlns:a16="http://schemas.microsoft.com/office/drawing/2014/main" id="{BCA6545E-E9C6-4D15-8353-57CBB1E0B376}"/>
+                <a16:creationId xmlns:a16="http://schemas.microsoft.com/office/drawing/2014/main" id="{05049A46-07B5-450A-9D97-9AB90827F5CD}"/>
               </a:ext>
             </a:extLst>
           </p:cNvPr>
@@ -6977,7 +6977,7 @@
           <p:cNvPr id="7" name="">
             <a:extLst xmlns:a="http://schemas.openxmlformats.org/drawingml/2006/main">
               <a:ext uri="{FF2B5EF4-FFF2-40B4-BE49-F238E27FC236}">
-                <a16:creationId xmlns:a16="http://schemas.microsoft.com/office/drawing/2014/main" id="{D1F1AC82-3E96-4080-B4FB-23741F9A8CEE}"/>
+                <a16:creationId xmlns:a16="http://schemas.microsoft.com/office/drawing/2014/main" id="{9A1AA8E5-D4AB-4C10-9269-0391D0919160}"/>
               </a:ext>
             </a:extLst>
           </p:cNvPr>
@@ -7027,7 +7027,7 @@
           <p:cNvPr id="8" name="">
             <a:extLst xmlns:a="http://schemas.openxmlformats.org/drawingml/2006/main">
               <a:ext uri="{FF2B5EF4-FFF2-40B4-BE49-F238E27FC236}">
-                <a16:creationId xmlns:a16="http://schemas.microsoft.com/office/drawing/2014/main" id="{7C1EACEC-283C-4249-8426-5784585FF157}"/>
+                <a16:creationId xmlns:a16="http://schemas.microsoft.com/office/drawing/2014/main" id="{264B21FE-76D4-48C7-917B-E1AF42BFBDBA}"/>
               </a:ext>
             </a:extLst>
           </p:cNvPr>
@@ -7077,7 +7077,7 @@
           <p:cNvPr id="9" name="">
             <a:extLst xmlns:a="http://schemas.openxmlformats.org/drawingml/2006/main">
               <a:ext uri="{FF2B5EF4-FFF2-40B4-BE49-F238E27FC236}">
-                <a16:creationId xmlns:a16="http://schemas.microsoft.com/office/drawing/2014/main" id="{33F3E5D6-4ECE-47B6-BF11-97EC664B3F6C}"/>
+                <a16:creationId xmlns:a16="http://schemas.microsoft.com/office/drawing/2014/main" id="{3D0AC9AA-B7BF-4895-AB08-541EB4024DEB}"/>
               </a:ext>
             </a:extLst>
           </p:cNvPr>
@@ -7127,7 +7127,7 @@
           <p:cNvPr id="10" name="">
             <a:extLst xmlns:a="http://schemas.openxmlformats.org/drawingml/2006/main">
               <a:ext uri="{FF2B5EF4-FFF2-40B4-BE49-F238E27FC236}">
-                <a16:creationId xmlns:a16="http://schemas.microsoft.com/office/drawing/2014/main" id="{D7579689-4904-40B0-96B5-9F11CDE70142}"/>
+                <a16:creationId xmlns:a16="http://schemas.microsoft.com/office/drawing/2014/main" id="{4B703288-FB36-4BB7-A351-19BC27DB1DB6}"/>
               </a:ext>
             </a:extLst>
           </p:cNvPr>
@@ -7177,7 +7177,7 @@
           <p:cNvPr id="11" name="">
             <a:extLst xmlns:a="http://schemas.openxmlformats.org/drawingml/2006/main">
               <a:ext uri="{FF2B5EF4-FFF2-40B4-BE49-F238E27FC236}">
-                <a16:creationId xmlns:a16="http://schemas.microsoft.com/office/drawing/2014/main" id="{C7E0DB84-2512-4DE4-A1F8-5087CC17C456}"/>
+                <a16:creationId xmlns:a16="http://schemas.microsoft.com/office/drawing/2014/main" id="{588BDC76-8B0B-403A-B801-28D1B7ED4A40}"/>
               </a:ext>
             </a:extLst>
           </p:cNvPr>
@@ -7227,7 +7227,7 @@
           <p:cNvPr id="12" name="">
             <a:extLst xmlns:a="http://schemas.openxmlformats.org/drawingml/2006/main">
               <a:ext uri="{FF2B5EF4-FFF2-40B4-BE49-F238E27FC236}">
-                <a16:creationId xmlns:a16="http://schemas.microsoft.com/office/drawing/2014/main" id="{4A38923B-D927-4BF2-A5A4-DB65BFF1DDAC}"/>
+                <a16:creationId xmlns:a16="http://schemas.microsoft.com/office/drawing/2014/main" id="{7829D50C-D8A2-45A8-897C-10082E6554D1}"/>
               </a:ext>
             </a:extLst>
           </p:cNvPr>
@@ -7277,7 +7277,7 @@
           <p:cNvPr id="13" name="">
             <a:extLst xmlns:a="http://schemas.openxmlformats.org/drawingml/2006/main">
               <a:ext uri="{FF2B5EF4-FFF2-40B4-BE49-F238E27FC236}">
-                <a16:creationId xmlns:a16="http://schemas.microsoft.com/office/drawing/2014/main" id="{06CC9697-D9A3-4A9F-9398-13D63EAD6CBD}"/>
+                <a16:creationId xmlns:a16="http://schemas.microsoft.com/office/drawing/2014/main" id="{0AC59BB1-EA8F-42E7-8421-3851A1715F5C}"/>
               </a:ext>
             </a:extLst>
           </p:cNvPr>
@@ -7308,7 +7308,7 @@
           <p:cNvPr id="14" name="">
             <a:extLst xmlns:a="http://schemas.openxmlformats.org/drawingml/2006/main">
               <a:ext uri="{FF2B5EF4-FFF2-40B4-BE49-F238E27FC236}">
-                <a16:creationId xmlns:a16="http://schemas.microsoft.com/office/drawing/2014/main" id="{3C46421E-15FF-4812-90E6-0074C264DB58}"/>
+                <a16:creationId xmlns:a16="http://schemas.microsoft.com/office/drawing/2014/main" id="{2397DAD1-EA95-4861-BAF1-4B8568438CA7}"/>
               </a:ext>
             </a:extLst>
           </p:cNvPr>
@@ -7341,7 +7341,7 @@
           <p:cNvPr id="15" name="">
             <a:extLst xmlns:a="http://schemas.openxmlformats.org/drawingml/2006/main">
               <a:ext uri="{FF2B5EF4-FFF2-40B4-BE49-F238E27FC236}">
-                <a16:creationId xmlns:a16="http://schemas.microsoft.com/office/drawing/2014/main" id="{45D0BE5B-D41E-4667-8365-E3C0C807CA18}"/>
+                <a16:creationId xmlns:a16="http://schemas.microsoft.com/office/drawing/2014/main" id="{C031D5D7-F883-4015-9C07-297919EE7431}"/>
               </a:ext>
             </a:extLst>
           </p:cNvPr>
@@ -7374,7 +7374,7 @@
           <p:cNvPr id="16" name="">
             <a:extLst xmlns:a="http://schemas.openxmlformats.org/drawingml/2006/main">
               <a:ext uri="{FF2B5EF4-FFF2-40B4-BE49-F238E27FC236}">
-                <a16:creationId xmlns:a16="http://schemas.microsoft.com/office/drawing/2014/main" id="{7F60DAAF-2158-46CE-8C7F-5D335AA3BBA8}"/>
+                <a16:creationId xmlns:a16="http://schemas.microsoft.com/office/drawing/2014/main" id="{BD2B6089-6177-4D2F-AFD3-6D89327060A5}"/>
               </a:ext>
             </a:extLst>
           </p:cNvPr>
@@ -7407,7 +7407,7 @@
           <p:cNvPr id="17" name="">
             <a:extLst xmlns:a="http://schemas.openxmlformats.org/drawingml/2006/main">
               <a:ext uri="{FF2B5EF4-FFF2-40B4-BE49-F238E27FC236}">
-                <a16:creationId xmlns:a16="http://schemas.microsoft.com/office/drawing/2014/main" id="{363D88D1-73FF-4D67-A5EC-7038964080FF}"/>
+                <a16:creationId xmlns:a16="http://schemas.microsoft.com/office/drawing/2014/main" id="{AE27FDFA-5D0D-4D74-BA0F-FA7FDFE3F36A}"/>
               </a:ext>
             </a:extLst>
           </p:cNvPr>
@@ -7440,7 +7440,7 @@
           <p:cNvPr id="18" name="">
             <a:extLst xmlns:a="http://schemas.openxmlformats.org/drawingml/2006/main">
               <a:ext uri="{FF2B5EF4-FFF2-40B4-BE49-F238E27FC236}">
-                <a16:creationId xmlns:a16="http://schemas.microsoft.com/office/drawing/2014/main" id="{005D6101-60EA-4AA2-8DA4-41E35EBFF2C3}"/>
+                <a16:creationId xmlns:a16="http://schemas.microsoft.com/office/drawing/2014/main" id="{6FA8D2E3-F33F-442A-A477-EF3CECFE4059}"/>
               </a:ext>
             </a:extLst>
           </p:cNvPr>
@@ -7475,7 +7475,7 @@
           <p:cNvPr id="19" name="">
             <a:extLst xmlns:a="http://schemas.openxmlformats.org/drawingml/2006/main">
               <a:ext uri="{FF2B5EF4-FFF2-40B4-BE49-F238E27FC236}">
-                <a16:creationId xmlns:a16="http://schemas.microsoft.com/office/drawing/2014/main" id="{94DC7EFB-088F-4BE3-859C-87FC0825A901}"/>
+                <a16:creationId xmlns:a16="http://schemas.microsoft.com/office/drawing/2014/main" id="{85FAC507-243B-45F5-9FB6-3E7403B0CD4B}"/>
               </a:ext>
             </a:extLst>
           </p:cNvPr>
@@ -7525,7 +7525,7 @@
           <p:cNvPr id="20" name="">
             <a:extLst xmlns:a="http://schemas.openxmlformats.org/drawingml/2006/main">
               <a:ext uri="{FF2B5EF4-FFF2-40B4-BE49-F238E27FC236}">
-                <a16:creationId xmlns:a16="http://schemas.microsoft.com/office/drawing/2014/main" id="{4C2AEA5F-55AB-426C-A670-9FD9D95F9E87}"/>
+                <a16:creationId xmlns:a16="http://schemas.microsoft.com/office/drawing/2014/main" id="{06653A2D-471B-445D-8C38-8679B0EB94C7}"/>
               </a:ext>
             </a:extLst>
           </p:cNvPr>
@@ -7575,7 +7575,7 @@
           <p:cNvPr id="21" name="">
             <a:extLst xmlns:a="http://schemas.openxmlformats.org/drawingml/2006/main">
               <a:ext uri="{FF2B5EF4-FFF2-40B4-BE49-F238E27FC236}">
-                <a16:creationId xmlns:a16="http://schemas.microsoft.com/office/drawing/2014/main" id="{8563C266-FD0C-4FF9-9ED3-524C6C66A801}"/>
+                <a16:creationId xmlns:a16="http://schemas.microsoft.com/office/drawing/2014/main" id="{CC0C5B61-1E1D-457F-B2E1-FFEEA5675179}"/>
               </a:ext>
             </a:extLst>
           </p:cNvPr>
@@ -7610,7 +7610,7 @@
           <p:cNvPr id="22" name="">
             <a:extLst xmlns:a="http://schemas.openxmlformats.org/drawingml/2006/main">
               <a:ext uri="{FF2B5EF4-FFF2-40B4-BE49-F238E27FC236}">
-                <a16:creationId xmlns:a16="http://schemas.microsoft.com/office/drawing/2014/main" id="{9FE2ED66-CC8D-4CBE-8EC1-765285538339}"/>
+                <a16:creationId xmlns:a16="http://schemas.microsoft.com/office/drawing/2014/main" id="{13AF7728-E64D-4A47-B229-2AD4932B324D}"/>
               </a:ext>
             </a:extLst>
           </p:cNvPr>
@@ -7660,7 +7660,7 @@
           <p:cNvPr id="23" name="">
             <a:extLst xmlns:a="http://schemas.openxmlformats.org/drawingml/2006/main">
               <a:ext uri="{FF2B5EF4-FFF2-40B4-BE49-F238E27FC236}">
-                <a16:creationId xmlns:a16="http://schemas.microsoft.com/office/drawing/2014/main" id="{2B88C854-467A-4823-BA75-B19132050E91}"/>
+                <a16:creationId xmlns:a16="http://schemas.microsoft.com/office/drawing/2014/main" id="{375A5280-EC9F-4D70-B7E6-CDB50D4ED65B}"/>
               </a:ext>
             </a:extLst>
           </p:cNvPr>
@@ -7710,7 +7710,7 @@
           <p:cNvPr id="24" name="">
             <a:extLst xmlns:a="http://schemas.openxmlformats.org/drawingml/2006/main">
               <a:ext uri="{FF2B5EF4-FFF2-40B4-BE49-F238E27FC236}">
-                <a16:creationId xmlns:a16="http://schemas.microsoft.com/office/drawing/2014/main" id="{D3B97C54-5A67-4081-B5DD-8612F0FD843C}"/>
+                <a16:creationId xmlns:a16="http://schemas.microsoft.com/office/drawing/2014/main" id="{E564E088-86FB-4B00-ACA6-707780E24F97}"/>
               </a:ext>
             </a:extLst>
           </p:cNvPr>
@@ -7745,7 +7745,7 @@
           <p:cNvPr id="25" name="">
             <a:extLst xmlns:a="http://schemas.openxmlformats.org/drawingml/2006/main">
               <a:ext uri="{FF2B5EF4-FFF2-40B4-BE49-F238E27FC236}">
-                <a16:creationId xmlns:a16="http://schemas.microsoft.com/office/drawing/2014/main" id="{8836464D-35DD-4BE6-8972-B9995EE68777}"/>
+                <a16:creationId xmlns:a16="http://schemas.microsoft.com/office/drawing/2014/main" id="{8C7611AC-ADF7-44AE-9DB6-17FD7144F0B9}"/>
               </a:ext>
             </a:extLst>
           </p:cNvPr>
@@ -7795,7 +7795,7 @@
           <p:cNvPr id="26" name="">
             <a:extLst xmlns:a="http://schemas.openxmlformats.org/drawingml/2006/main">
               <a:ext uri="{FF2B5EF4-FFF2-40B4-BE49-F238E27FC236}">
-                <a16:creationId xmlns:a16="http://schemas.microsoft.com/office/drawing/2014/main" id="{301CFEE0-6E4B-474E-9574-C2CA006867B3}"/>
+                <a16:creationId xmlns:a16="http://schemas.microsoft.com/office/drawing/2014/main" id="{FC78B84C-7EC7-4962-8407-09CA6DACC0BF}"/>
               </a:ext>
             </a:extLst>
           </p:cNvPr>
@@ -7845,7 +7845,7 @@
           <p:cNvPr id="27" name="">
             <a:extLst xmlns:a="http://schemas.openxmlformats.org/drawingml/2006/main">
               <a:ext uri="{FF2B5EF4-FFF2-40B4-BE49-F238E27FC236}">
-                <a16:creationId xmlns:a16="http://schemas.microsoft.com/office/drawing/2014/main" id="{2CC3FBCA-90DB-4C23-848B-B5345A916D89}"/>
+                <a16:creationId xmlns:a16="http://schemas.microsoft.com/office/drawing/2014/main" id="{533904A5-743B-41F1-A58B-43C5E77DA6BF}"/>
               </a:ext>
             </a:extLst>
           </p:cNvPr>
@@ -7880,7 +7880,7 @@
           <p:cNvPr id="28" name="">
             <a:extLst xmlns:a="http://schemas.openxmlformats.org/drawingml/2006/main">
               <a:ext uri="{FF2B5EF4-FFF2-40B4-BE49-F238E27FC236}">
-                <a16:creationId xmlns:a16="http://schemas.microsoft.com/office/drawing/2014/main" id="{9653B0D4-18A4-440C-839E-2BE7D711A93A}"/>
+                <a16:creationId xmlns:a16="http://schemas.microsoft.com/office/drawing/2014/main" id="{09C81864-2CB0-43B7-8A47-A68C1C005237}"/>
               </a:ext>
             </a:extLst>
           </p:cNvPr>
@@ -7930,7 +7930,7 @@
           <p:cNvPr id="29" name="">
             <a:extLst xmlns:a="http://schemas.openxmlformats.org/drawingml/2006/main">
               <a:ext uri="{FF2B5EF4-FFF2-40B4-BE49-F238E27FC236}">
-                <a16:creationId xmlns:a16="http://schemas.microsoft.com/office/drawing/2014/main" id="{F6C143AE-08D1-4B6E-A0EB-200325F42EC4}"/>
+                <a16:creationId xmlns:a16="http://schemas.microsoft.com/office/drawing/2014/main" id="{49980477-90FD-4BAA-8CF9-6363F296D606}"/>
               </a:ext>
             </a:extLst>
           </p:cNvPr>
@@ -7970,7 +7970,7 @@
                   <a:srgbClr val="526174"/>
                 </a:solidFill>
               </a:rPr>
-              <a:t>two llama.cpp servers</a:t>
+              <a:t>one tensor-split server</a:t>
             </a:r>
           </a:p>
         </p:txBody>
@@ -7980,7 +7980,7 @@
           <p:cNvPr id="30" name="">
             <a:extLst xmlns:a="http://schemas.openxmlformats.org/drawingml/2006/main">
               <a:ext uri="{FF2B5EF4-FFF2-40B4-BE49-F238E27FC236}">
-                <a16:creationId xmlns:a16="http://schemas.microsoft.com/office/drawing/2014/main" id="{BE8DD848-3808-41EF-8278-D807FFA8AD15}"/>
+                <a16:creationId xmlns:a16="http://schemas.microsoft.com/office/drawing/2014/main" id="{DAFC78E8-8B93-4CFA-B394-C1EFECCCFE78}"/>
               </a:ext>
             </a:extLst>
           </p:cNvPr>
@@ -8021,7 +8021,7 @@
           <p:cNvPr id="31" name="">
             <a:extLst xmlns:a="http://schemas.openxmlformats.org/drawingml/2006/main">
               <a:ext uri="{FF2B5EF4-FFF2-40B4-BE49-F238E27FC236}">
-                <a16:creationId xmlns:a16="http://schemas.microsoft.com/office/drawing/2014/main" id="{5B174CCF-D887-4477-A1D6-0845E32D326A}"/>
+                <a16:creationId xmlns:a16="http://schemas.microsoft.com/office/drawing/2014/main" id="{ECC142BB-B95E-47C3-8AC5-D719E2CF1714}"/>
               </a:ext>
             </a:extLst>
           </p:cNvPr>
@@ -8071,7 +8071,7 @@
           <p:cNvPr id="32" name="">
             <a:extLst xmlns:a="http://schemas.openxmlformats.org/drawingml/2006/main">
               <a:ext uri="{FF2B5EF4-FFF2-40B4-BE49-F238E27FC236}">
-                <a16:creationId xmlns:a16="http://schemas.microsoft.com/office/drawing/2014/main" id="{3626B0AE-6CAA-49C0-AF86-3E7946E662F2}"/>
+                <a16:creationId xmlns:a16="http://schemas.microsoft.com/office/drawing/2014/main" id="{16BC243C-310A-40F1-A23F-0BF4410891B4}"/>
               </a:ext>
             </a:extLst>
           </p:cNvPr>
@@ -8121,7 +8121,7 @@
           <p:cNvPr id="33" name="">
             <a:extLst xmlns:a="http://schemas.openxmlformats.org/drawingml/2006/main">
               <a:ext uri="{FF2B5EF4-FFF2-40B4-BE49-F238E27FC236}">
-                <a16:creationId xmlns:a16="http://schemas.microsoft.com/office/drawing/2014/main" id="{A816063C-E34A-4C2B-8039-AF1DBBD64BB3}"/>
+                <a16:creationId xmlns:a16="http://schemas.microsoft.com/office/drawing/2014/main" id="{A3AC2E9A-D42A-4A34-9DDA-ABA050314487}"/>
               </a:ext>
             </a:extLst>
           </p:cNvPr>
@@ -8156,7 +8156,7 @@
           <p:cNvPr id="34" name="">
             <a:extLst xmlns:a="http://schemas.openxmlformats.org/drawingml/2006/main">
               <a:ext uri="{FF2B5EF4-FFF2-40B4-BE49-F238E27FC236}">
-                <a16:creationId xmlns:a16="http://schemas.microsoft.com/office/drawing/2014/main" id="{67405F95-BB47-4F88-A722-39DCD8BABD32}"/>
+                <a16:creationId xmlns:a16="http://schemas.microsoft.com/office/drawing/2014/main" id="{889EFA5D-820B-45C1-BF34-43618FD75B69}"/>
               </a:ext>
             </a:extLst>
           </p:cNvPr>
@@ -8206,7 +8206,7 @@
           <p:cNvPr id="35" name="">
             <a:extLst xmlns:a="http://schemas.openxmlformats.org/drawingml/2006/main">
               <a:ext uri="{FF2B5EF4-FFF2-40B4-BE49-F238E27FC236}">
-                <a16:creationId xmlns:a16="http://schemas.microsoft.com/office/drawing/2014/main" id="{3494FE30-7037-497E-AB28-0535FBE436F3}"/>
+                <a16:creationId xmlns:a16="http://schemas.microsoft.com/office/drawing/2014/main" id="{66E131D1-0821-437A-9046-5B6D7076AA49}"/>
               </a:ext>
             </a:extLst>
           </p:cNvPr>
@@ -8237,7 +8237,7 @@
           <p:cNvPr id="36" name="source-12">
             <a:extLst xmlns:a="http://schemas.openxmlformats.org/drawingml/2006/main">
               <a:ext uri="{FF2B5EF4-FFF2-40B4-BE49-F238E27FC236}">
-                <a16:creationId xmlns:a16="http://schemas.microsoft.com/office/drawing/2014/main" id="{75ADA748-1DBB-4C61-95A4-CC283D6CB6BC}"/>
+                <a16:creationId xmlns:a16="http://schemas.microsoft.com/office/drawing/2014/main" id="{0EE445F5-A6B8-4771-8E53-AF9BF4D97631}"/>
               </a:ext>
             </a:extLst>
           </p:cNvPr>
@@ -8287,7 +8287,7 @@
           <p:cNvPr id="37" name="page-12">
             <a:extLst xmlns:a="http://schemas.openxmlformats.org/drawingml/2006/main">
               <a:ext uri="{FF2B5EF4-FFF2-40B4-BE49-F238E27FC236}">
-                <a16:creationId xmlns:a16="http://schemas.microsoft.com/office/drawing/2014/main" id="{140B6EF1-DA5E-49F8-8543-F30A547A1A3D}"/>
+                <a16:creationId xmlns:a16="http://schemas.microsoft.com/office/drawing/2014/main" id="{F85D3633-A603-4AAD-A9E8-B6A038D9750F}"/>
               </a:ext>
             </a:extLst>
           </p:cNvPr>
@@ -8335,7 +8335,7 @@
     </p:spTree>
     <p:extLst>
       <p:ext uri="{BB962C8B-B14F-4D97-AF65-F5344CB8AC3E}">
-        <p14:creationId xmlns:p14="http://schemas.microsoft.com/office/powerpoint/2010/main" val="297978320"/>
+        <p14:creationId xmlns:p14="http://schemas.microsoft.com/office/powerpoint/2010/main" val="1722569808"/>
       </p:ext>
     </p:extLst>
   </p:cSld>
@@ -8366,7 +8366,7 @@
           <p:cNvPr id="36" name="kicker-13">
             <a:extLst xmlns:a="http://schemas.openxmlformats.org/drawingml/2006/main">
               <a:ext uri="{FF2B5EF4-FFF2-40B4-BE49-F238E27FC236}">
-                <a16:creationId xmlns:a16="http://schemas.microsoft.com/office/drawing/2014/main" id="{4F0925FF-D63C-41DF-9C81-8B4C99DD24CC}"/>
+                <a16:creationId xmlns:a16="http://schemas.microsoft.com/office/drawing/2014/main" id="{1515D7EA-7C1E-424C-9365-9E703170CF46}"/>
               </a:ext>
             </a:extLst>
           </p:cNvPr>
@@ -8416,7 +8416,7 @@
           <p:cNvPr id="2" name="title-13">
             <a:extLst xmlns:a="http://schemas.openxmlformats.org/drawingml/2006/main">
               <a:ext uri="{FF2B5EF4-FFF2-40B4-BE49-F238E27FC236}">
-                <a16:creationId xmlns:a16="http://schemas.microsoft.com/office/drawing/2014/main" id="{BAEC52EB-98AD-40E4-9762-50F23A048229}"/>
+                <a16:creationId xmlns:a16="http://schemas.microsoft.com/office/drawing/2014/main" id="{9CBDE1AC-996D-4140-B259-DE951A849DF7}"/>
               </a:ext>
             </a:extLst>
           </p:cNvPr>
@@ -8466,7 +8466,7 @@
           <p:cNvPr id="3" name="">
             <a:extLst xmlns:a="http://schemas.openxmlformats.org/drawingml/2006/main">
               <a:ext uri="{FF2B5EF4-FFF2-40B4-BE49-F238E27FC236}">
-                <a16:creationId xmlns:a16="http://schemas.microsoft.com/office/drawing/2014/main" id="{A87B29CB-9D11-451C-81F0-A29C2B030892}"/>
+                <a16:creationId xmlns:a16="http://schemas.microsoft.com/office/drawing/2014/main" id="{3F85B47B-9034-4171-8DE0-E26C64512BE2}"/>
               </a:ext>
             </a:extLst>
           </p:cNvPr>
@@ -8497,7 +8497,7 @@
           <p:cNvPr id="4" name="">
             <a:extLst xmlns:a="http://schemas.openxmlformats.org/drawingml/2006/main">
               <a:ext uri="{FF2B5EF4-FFF2-40B4-BE49-F238E27FC236}">
-                <a16:creationId xmlns:a16="http://schemas.microsoft.com/office/drawing/2014/main" id="{9556537E-0E13-4D91-B54A-4F9CF86928F1}"/>
+                <a16:creationId xmlns:a16="http://schemas.microsoft.com/office/drawing/2014/main" id="{99A8B2D2-345A-4001-ACFB-90DD8BD36ED4}"/>
               </a:ext>
             </a:extLst>
           </p:cNvPr>
@@ -8547,7 +8547,7 @@
           <p:cNvPr id="5" name="">
             <a:extLst xmlns:a="http://schemas.openxmlformats.org/drawingml/2006/main">
               <a:ext uri="{FF2B5EF4-FFF2-40B4-BE49-F238E27FC236}">
-                <a16:creationId xmlns:a16="http://schemas.microsoft.com/office/drawing/2014/main" id="{FA2DF732-31F2-4913-B0F3-1445065781D1}"/>
+                <a16:creationId xmlns:a16="http://schemas.microsoft.com/office/drawing/2014/main" id="{F4F23D1D-E1EF-47E0-9F17-AA0FF61629CA}"/>
               </a:ext>
             </a:extLst>
           </p:cNvPr>
@@ -8597,7 +8597,7 @@
           <p:cNvPr id="6" name="">
             <a:extLst xmlns:a="http://schemas.openxmlformats.org/drawingml/2006/main">
               <a:ext uri="{FF2B5EF4-FFF2-40B4-BE49-F238E27FC236}">
-                <a16:creationId xmlns:a16="http://schemas.microsoft.com/office/drawing/2014/main" id="{530E7A19-3234-4947-941D-13BC7A305519}"/>
+                <a16:creationId xmlns:a16="http://schemas.microsoft.com/office/drawing/2014/main" id="{DDEC418C-6FEF-49FC-ABD6-5D70DA6E4243}"/>
               </a:ext>
             </a:extLst>
           </p:cNvPr>
@@ -8647,7 +8647,7 @@
           <p:cNvPr id="7" name="">
             <a:extLst xmlns:a="http://schemas.openxmlformats.org/drawingml/2006/main">
               <a:ext uri="{FF2B5EF4-FFF2-40B4-BE49-F238E27FC236}">
-                <a16:creationId xmlns:a16="http://schemas.microsoft.com/office/drawing/2014/main" id="{BD096722-3AEA-4901-B8D7-D7A9D6860794}"/>
+                <a16:creationId xmlns:a16="http://schemas.microsoft.com/office/drawing/2014/main" id="{67F1B708-C6AE-4794-AB6B-C81E80CFAAD7}"/>
               </a:ext>
             </a:extLst>
           </p:cNvPr>
@@ -8697,7 +8697,7 @@
           <p:cNvPr id="8" name="">
             <a:extLst xmlns:a="http://schemas.openxmlformats.org/drawingml/2006/main">
               <a:ext uri="{FF2B5EF4-FFF2-40B4-BE49-F238E27FC236}">
-                <a16:creationId xmlns:a16="http://schemas.microsoft.com/office/drawing/2014/main" id="{F15EC09F-61F1-43A4-9BFB-2342B11F3AEA}"/>
+                <a16:creationId xmlns:a16="http://schemas.microsoft.com/office/drawing/2014/main" id="{361C308C-08C1-423D-A8FF-BDA70BBAB123}"/>
               </a:ext>
             </a:extLst>
           </p:cNvPr>
@@ -8747,7 +8747,7 @@
           <p:cNvPr id="9" name="">
             <a:extLst xmlns:a="http://schemas.openxmlformats.org/drawingml/2006/main">
               <a:ext uri="{FF2B5EF4-FFF2-40B4-BE49-F238E27FC236}">
-                <a16:creationId xmlns:a16="http://schemas.microsoft.com/office/drawing/2014/main" id="{BEEBD44D-FAC8-44AA-A102-F603D4CF55E5}"/>
+                <a16:creationId xmlns:a16="http://schemas.microsoft.com/office/drawing/2014/main" id="{0DE803D9-85D5-4C74-8917-D21B6D2B8322}"/>
               </a:ext>
             </a:extLst>
           </p:cNvPr>
@@ -8797,7 +8797,7 @@
           <p:cNvPr id="10" name="">
             <a:extLst xmlns:a="http://schemas.openxmlformats.org/drawingml/2006/main">
               <a:ext uri="{FF2B5EF4-FFF2-40B4-BE49-F238E27FC236}">
-                <a16:creationId xmlns:a16="http://schemas.microsoft.com/office/drawing/2014/main" id="{52D6E79E-C53A-480C-B423-D5ABF51BBE2A}"/>
+                <a16:creationId xmlns:a16="http://schemas.microsoft.com/office/drawing/2014/main" id="{81A1FF96-D508-482B-B3E1-50C3C04F1BE8}"/>
               </a:ext>
             </a:extLst>
           </p:cNvPr>
@@ -8847,7 +8847,7 @@
           <p:cNvPr id="11" name="">
             <a:extLst xmlns:a="http://schemas.openxmlformats.org/drawingml/2006/main">
               <a:ext uri="{FF2B5EF4-FFF2-40B4-BE49-F238E27FC236}">
-                <a16:creationId xmlns:a16="http://schemas.microsoft.com/office/drawing/2014/main" id="{F82AD70C-080F-4FA2-B802-BEB6F31A4289}"/>
+                <a16:creationId xmlns:a16="http://schemas.microsoft.com/office/drawing/2014/main" id="{80A785F7-F043-46DD-B629-5563143EA3F8}"/>
               </a:ext>
             </a:extLst>
           </p:cNvPr>
@@ -8897,7 +8897,7 @@
           <p:cNvPr id="12" name="">
             <a:extLst xmlns:a="http://schemas.openxmlformats.org/drawingml/2006/main">
               <a:ext uri="{FF2B5EF4-FFF2-40B4-BE49-F238E27FC236}">
-                <a16:creationId xmlns:a16="http://schemas.microsoft.com/office/drawing/2014/main" id="{8F41056D-2639-4ADA-B82C-6C338F7F0D09}"/>
+                <a16:creationId xmlns:a16="http://schemas.microsoft.com/office/drawing/2014/main" id="{9745065D-18A3-49F5-B422-FE791C5815D4}"/>
               </a:ext>
             </a:extLst>
           </p:cNvPr>
@@ -8947,7 +8947,7 @@
           <p:cNvPr id="13" name="">
             <a:extLst xmlns:a="http://schemas.openxmlformats.org/drawingml/2006/main">
               <a:ext uri="{FF2B5EF4-FFF2-40B4-BE49-F238E27FC236}">
-                <a16:creationId xmlns:a16="http://schemas.microsoft.com/office/drawing/2014/main" id="{54580C3C-6906-4322-A423-AD90A562010C}"/>
+                <a16:creationId xmlns:a16="http://schemas.microsoft.com/office/drawing/2014/main" id="{F13DCB45-6328-46C7-9F78-A93788098544}"/>
               </a:ext>
             </a:extLst>
           </p:cNvPr>
@@ -8997,7 +8997,7 @@
           <p:cNvPr id="14" name="">
             <a:extLst xmlns:a="http://schemas.openxmlformats.org/drawingml/2006/main">
               <a:ext uri="{FF2B5EF4-FFF2-40B4-BE49-F238E27FC236}">
-                <a16:creationId xmlns:a16="http://schemas.microsoft.com/office/drawing/2014/main" id="{54411068-7CD7-48BE-B215-362545888E11}"/>
+                <a16:creationId xmlns:a16="http://schemas.microsoft.com/office/drawing/2014/main" id="{B818CCB0-86F6-442F-BFD2-A4A73F082115}"/>
               </a:ext>
             </a:extLst>
           </p:cNvPr>
@@ -9047,7 +9047,7 @@
           <p:cNvPr id="15" name="">
             <a:extLst xmlns:a="http://schemas.openxmlformats.org/drawingml/2006/main">
               <a:ext uri="{FF2B5EF4-FFF2-40B4-BE49-F238E27FC236}">
-                <a16:creationId xmlns:a16="http://schemas.microsoft.com/office/drawing/2014/main" id="{DB6D9406-FB0F-43D8-BFCD-F7C0A7F153C5}"/>
+                <a16:creationId xmlns:a16="http://schemas.microsoft.com/office/drawing/2014/main" id="{AC90211E-356E-4FF0-8C9C-8F3F3A8B5F66}"/>
               </a:ext>
             </a:extLst>
           </p:cNvPr>
@@ -9097,7 +9097,7 @@
           <p:cNvPr id="16" name="">
             <a:extLst xmlns:a="http://schemas.openxmlformats.org/drawingml/2006/main">
               <a:ext uri="{FF2B5EF4-FFF2-40B4-BE49-F238E27FC236}">
-                <a16:creationId xmlns:a16="http://schemas.microsoft.com/office/drawing/2014/main" id="{AA6B7CD9-D6F3-4A2A-AE84-9C7BD4C941C9}"/>
+                <a16:creationId xmlns:a16="http://schemas.microsoft.com/office/drawing/2014/main" id="{6A46EC01-E823-45CA-9BF2-4838B5F9BFC8}"/>
               </a:ext>
             </a:extLst>
           </p:cNvPr>
@@ -9128,7 +9128,7 @@
           <p:cNvPr id="17" name="">
             <a:extLst xmlns:a="http://schemas.openxmlformats.org/drawingml/2006/main">
               <a:ext uri="{FF2B5EF4-FFF2-40B4-BE49-F238E27FC236}">
-                <a16:creationId xmlns:a16="http://schemas.microsoft.com/office/drawing/2014/main" id="{69426C21-44FE-440B-A5C0-EEEEB5ED1921}"/>
+                <a16:creationId xmlns:a16="http://schemas.microsoft.com/office/drawing/2014/main" id="{C29F6B35-5C93-49F3-9D28-CAF25BF70D11}"/>
               </a:ext>
             </a:extLst>
           </p:cNvPr>
@@ -9178,7 +9178,7 @@
           <p:cNvPr id="18" name="">
             <a:extLst xmlns:a="http://schemas.openxmlformats.org/drawingml/2006/main">
               <a:ext uri="{FF2B5EF4-FFF2-40B4-BE49-F238E27FC236}">
-                <a16:creationId xmlns:a16="http://schemas.microsoft.com/office/drawing/2014/main" id="{565BA578-819B-4701-9686-718627C38015}"/>
+                <a16:creationId xmlns:a16="http://schemas.microsoft.com/office/drawing/2014/main" id="{8CC1E3D9-14ED-44EB-97B0-4F749CA76901}"/>
               </a:ext>
             </a:extLst>
           </p:cNvPr>
@@ -9228,7 +9228,7 @@
           <p:cNvPr id="19" name="">
             <a:extLst xmlns:a="http://schemas.openxmlformats.org/drawingml/2006/main">
               <a:ext uri="{FF2B5EF4-FFF2-40B4-BE49-F238E27FC236}">
-                <a16:creationId xmlns:a16="http://schemas.microsoft.com/office/drawing/2014/main" id="{7CA0700B-4FEB-4287-A7EB-F9BC85FE0755}"/>
+                <a16:creationId xmlns:a16="http://schemas.microsoft.com/office/drawing/2014/main" id="{78220494-A5A4-48E8-80F9-A264D5CAF2ED}"/>
               </a:ext>
             </a:extLst>
           </p:cNvPr>
@@ -9278,7 +9278,7 @@
           <p:cNvPr id="20" name="">
             <a:extLst xmlns:a="http://schemas.openxmlformats.org/drawingml/2006/main">
               <a:ext uri="{FF2B5EF4-FFF2-40B4-BE49-F238E27FC236}">
-                <a16:creationId xmlns:a16="http://schemas.microsoft.com/office/drawing/2014/main" id="{25112948-15F1-42BA-8C54-DF7BB4913153}"/>
+                <a16:creationId xmlns:a16="http://schemas.microsoft.com/office/drawing/2014/main" id="{1696F7E3-707D-428A-8F7C-18B3B033B65F}"/>
               </a:ext>
             </a:extLst>
           </p:cNvPr>
@@ -9309,7 +9309,7 @@
           <p:cNvPr id="21" name="">
             <a:extLst xmlns:a="http://schemas.openxmlformats.org/drawingml/2006/main">
               <a:ext uri="{FF2B5EF4-FFF2-40B4-BE49-F238E27FC236}">
-                <a16:creationId xmlns:a16="http://schemas.microsoft.com/office/drawing/2014/main" id="{783E1EA8-9043-44D9-A788-926544F85E47}"/>
+                <a16:creationId xmlns:a16="http://schemas.microsoft.com/office/drawing/2014/main" id="{D92A2359-2E7A-4443-8169-79B97E0C2059}"/>
               </a:ext>
             </a:extLst>
           </p:cNvPr>
@@ -9359,7 +9359,7 @@
           <p:cNvPr id="22" name="">
             <a:extLst xmlns:a="http://schemas.openxmlformats.org/drawingml/2006/main">
               <a:ext uri="{FF2B5EF4-FFF2-40B4-BE49-F238E27FC236}">
-                <a16:creationId xmlns:a16="http://schemas.microsoft.com/office/drawing/2014/main" id="{E795F9C1-84B9-49A5-A638-0E1468F4ECEA}"/>
+                <a16:creationId xmlns:a16="http://schemas.microsoft.com/office/drawing/2014/main" id="{6B385DE0-BA4A-471A-B834-285082D85A1D}"/>
               </a:ext>
             </a:extLst>
           </p:cNvPr>
@@ -9409,7 +9409,7 @@
           <p:cNvPr id="23" name="">
             <a:extLst xmlns:a="http://schemas.openxmlformats.org/drawingml/2006/main">
               <a:ext uri="{FF2B5EF4-FFF2-40B4-BE49-F238E27FC236}">
-                <a16:creationId xmlns:a16="http://schemas.microsoft.com/office/drawing/2014/main" id="{BA4095CB-6B0B-4551-B3F9-5143C78E1A2A}"/>
+                <a16:creationId xmlns:a16="http://schemas.microsoft.com/office/drawing/2014/main" id="{9E799F49-DE36-456A-8043-2345AB2A4E41}"/>
               </a:ext>
             </a:extLst>
           </p:cNvPr>
@@ -9459,7 +9459,7 @@
           <p:cNvPr id="24" name="">
             <a:extLst xmlns:a="http://schemas.openxmlformats.org/drawingml/2006/main">
               <a:ext uri="{FF2B5EF4-FFF2-40B4-BE49-F238E27FC236}">
-                <a16:creationId xmlns:a16="http://schemas.microsoft.com/office/drawing/2014/main" id="{23220E38-34E7-4481-96CF-F9E1FA9F662C}"/>
+                <a16:creationId xmlns:a16="http://schemas.microsoft.com/office/drawing/2014/main" id="{301E4E6E-0361-460F-A7F6-EADE60375C1D}"/>
               </a:ext>
             </a:extLst>
           </p:cNvPr>
@@ -9490,7 +9490,7 @@
           <p:cNvPr id="25" name="">
             <a:extLst xmlns:a="http://schemas.openxmlformats.org/drawingml/2006/main">
               <a:ext uri="{FF2B5EF4-FFF2-40B4-BE49-F238E27FC236}">
-                <a16:creationId xmlns:a16="http://schemas.microsoft.com/office/drawing/2014/main" id="{9F0CE583-2E1A-41B7-AB75-7A42997ECA72}"/>
+                <a16:creationId xmlns:a16="http://schemas.microsoft.com/office/drawing/2014/main" id="{A6E36677-D556-495A-8379-7F9A40FA2D6F}"/>
               </a:ext>
             </a:extLst>
           </p:cNvPr>
@@ -9540,7 +9540,7 @@
           <p:cNvPr id="26" name="">
             <a:extLst xmlns:a="http://schemas.openxmlformats.org/drawingml/2006/main">
               <a:ext uri="{FF2B5EF4-FFF2-40B4-BE49-F238E27FC236}">
-                <a16:creationId xmlns:a16="http://schemas.microsoft.com/office/drawing/2014/main" id="{348DB725-7CC1-4B9D-80B6-1F04951A09C9}"/>
+                <a16:creationId xmlns:a16="http://schemas.microsoft.com/office/drawing/2014/main" id="{EA15D5F2-CF9F-4A69-B1AB-FDCFC0CF9CBE}"/>
               </a:ext>
             </a:extLst>
           </p:cNvPr>
@@ -9590,7 +9590,7 @@
           <p:cNvPr id="27" name="">
             <a:extLst xmlns:a="http://schemas.openxmlformats.org/drawingml/2006/main">
               <a:ext uri="{FF2B5EF4-FFF2-40B4-BE49-F238E27FC236}">
-                <a16:creationId xmlns:a16="http://schemas.microsoft.com/office/drawing/2014/main" id="{8CAB0A78-F14D-4777-8F25-58F74E0EF6C6}"/>
+                <a16:creationId xmlns:a16="http://schemas.microsoft.com/office/drawing/2014/main" id="{77AFDDF9-CB7A-43A3-9D9E-6ED4A10C3A7B}"/>
               </a:ext>
             </a:extLst>
           </p:cNvPr>
@@ -9640,7 +9640,7 @@
           <p:cNvPr id="28" name="">
             <a:extLst xmlns:a="http://schemas.openxmlformats.org/drawingml/2006/main">
               <a:ext uri="{FF2B5EF4-FFF2-40B4-BE49-F238E27FC236}">
-                <a16:creationId xmlns:a16="http://schemas.microsoft.com/office/drawing/2014/main" id="{49CB55D9-3688-4DA9-897F-78BC40BC03CC}"/>
+                <a16:creationId xmlns:a16="http://schemas.microsoft.com/office/drawing/2014/main" id="{C16E0CB5-88DB-4755-B5D3-7D0910A9EB32}"/>
               </a:ext>
             </a:extLst>
           </p:cNvPr>
@@ -9671,7 +9671,7 @@
           <p:cNvPr id="29" name="">
             <a:extLst xmlns:a="http://schemas.openxmlformats.org/drawingml/2006/main">
               <a:ext uri="{FF2B5EF4-FFF2-40B4-BE49-F238E27FC236}">
-                <a16:creationId xmlns:a16="http://schemas.microsoft.com/office/drawing/2014/main" id="{E2C49810-BA8D-49E0-9556-E657945EAECA}"/>
+                <a16:creationId xmlns:a16="http://schemas.microsoft.com/office/drawing/2014/main" id="{C6C40E55-62DE-4F90-A086-92F2D927155B}"/>
               </a:ext>
             </a:extLst>
           </p:cNvPr>
@@ -9706,7 +9706,7 @@
           <p:cNvPr id="30" name="">
             <a:extLst xmlns:a="http://schemas.openxmlformats.org/drawingml/2006/main">
               <a:ext uri="{FF2B5EF4-FFF2-40B4-BE49-F238E27FC236}">
-                <a16:creationId xmlns:a16="http://schemas.microsoft.com/office/drawing/2014/main" id="{AC997BCA-C5FE-4AC9-9FA8-0D44C4394420}"/>
+                <a16:creationId xmlns:a16="http://schemas.microsoft.com/office/drawing/2014/main" id="{18ED38FA-5DAA-4734-A0DC-F859F6756EF2}"/>
               </a:ext>
             </a:extLst>
           </p:cNvPr>
@@ -9741,7 +9741,7 @@
           <p:cNvPr id="31" name="">
             <a:extLst xmlns:a="http://schemas.openxmlformats.org/drawingml/2006/main">
               <a:ext uri="{FF2B5EF4-FFF2-40B4-BE49-F238E27FC236}">
-                <a16:creationId xmlns:a16="http://schemas.microsoft.com/office/drawing/2014/main" id="{590E2693-47C5-4B19-9485-95678716B1E3}"/>
+                <a16:creationId xmlns:a16="http://schemas.microsoft.com/office/drawing/2014/main" id="{63C8B2DA-DDDF-4534-B6FF-EE531BB7D501}"/>
               </a:ext>
             </a:extLst>
           </p:cNvPr>
@@ -9791,7 +9791,7 @@
           <p:cNvPr id="32" name="">
             <a:extLst xmlns:a="http://schemas.openxmlformats.org/drawingml/2006/main">
               <a:ext uri="{FF2B5EF4-FFF2-40B4-BE49-F238E27FC236}">
-                <a16:creationId xmlns:a16="http://schemas.microsoft.com/office/drawing/2014/main" id="{1BFC5038-6355-4020-A30B-686ABCEBFC8C}"/>
+                <a16:creationId xmlns:a16="http://schemas.microsoft.com/office/drawing/2014/main" id="{A36BCA44-7F28-4598-BBA0-4707B77B62A5}"/>
               </a:ext>
             </a:extLst>
           </p:cNvPr>
@@ -9841,7 +9841,7 @@
           <p:cNvPr id="33" name="">
             <a:extLst xmlns:a="http://schemas.openxmlformats.org/drawingml/2006/main">
               <a:ext uri="{FF2B5EF4-FFF2-40B4-BE49-F238E27FC236}">
-                <a16:creationId xmlns:a16="http://schemas.microsoft.com/office/drawing/2014/main" id="{1E19B147-EA64-4E72-BF34-9BE6756AAA91}"/>
+                <a16:creationId xmlns:a16="http://schemas.microsoft.com/office/drawing/2014/main" id="{35FBF6CB-E886-4974-846F-255370A4F363}"/>
               </a:ext>
             </a:extLst>
           </p:cNvPr>
@@ -9872,7 +9872,7 @@
           <p:cNvPr id="34" name="source-13">
             <a:extLst xmlns:a="http://schemas.openxmlformats.org/drawingml/2006/main">
               <a:ext uri="{FF2B5EF4-FFF2-40B4-BE49-F238E27FC236}">
-                <a16:creationId xmlns:a16="http://schemas.microsoft.com/office/drawing/2014/main" id="{77FA829E-912E-4E87-B553-88F0F8EF3719}"/>
+                <a16:creationId xmlns:a16="http://schemas.microsoft.com/office/drawing/2014/main" id="{BFC6A061-DF5B-495E-A48F-0FFD1211856D}"/>
               </a:ext>
             </a:extLst>
           </p:cNvPr>
@@ -9922,7 +9922,7 @@
           <p:cNvPr id="35" name="page-13">
             <a:extLst xmlns:a="http://schemas.openxmlformats.org/drawingml/2006/main">
               <a:ext uri="{FF2B5EF4-FFF2-40B4-BE49-F238E27FC236}">
-                <a16:creationId xmlns:a16="http://schemas.microsoft.com/office/drawing/2014/main" id="{B0CDF350-BAAE-4A27-8BE8-B27377E139BB}"/>
+                <a16:creationId xmlns:a16="http://schemas.microsoft.com/office/drawing/2014/main" id="{54D3B0D4-1D47-428C-9E2B-904D05515CA0}"/>
               </a:ext>
             </a:extLst>
           </p:cNvPr>
@@ -9970,7 +9970,7 @@
     </p:spTree>
     <p:extLst>
       <p:ext uri="{BB962C8B-B14F-4D97-AF65-F5344CB8AC3E}">
-        <p14:creationId xmlns:p14="http://schemas.microsoft.com/office/powerpoint/2010/main" val="214535152"/>
+        <p14:creationId xmlns:p14="http://schemas.microsoft.com/office/powerpoint/2010/main" val="79480487"/>
       </p:ext>
     </p:extLst>
   </p:cSld>
@@ -10001,7 +10001,7 @@
           <p:cNvPr id="31" name="kicker-14">
             <a:extLst xmlns:a="http://schemas.openxmlformats.org/drawingml/2006/main">
               <a:ext uri="{FF2B5EF4-FFF2-40B4-BE49-F238E27FC236}">
-                <a16:creationId xmlns:a16="http://schemas.microsoft.com/office/drawing/2014/main" id="{204E41B4-0AB3-4E62-B86B-B6BF39AAEEA7}"/>
+                <a16:creationId xmlns:a16="http://schemas.microsoft.com/office/drawing/2014/main" id="{7898B36C-2C17-4FA9-BC6A-0D01F26EC5F5}"/>
               </a:ext>
             </a:extLst>
           </p:cNvPr>
@@ -10051,7 +10051,7 @@
           <p:cNvPr id="2" name="title-14">
             <a:extLst xmlns:a="http://schemas.openxmlformats.org/drawingml/2006/main">
               <a:ext uri="{FF2B5EF4-FFF2-40B4-BE49-F238E27FC236}">
-                <a16:creationId xmlns:a16="http://schemas.microsoft.com/office/drawing/2014/main" id="{33D22248-C749-4568-BBAD-4FB002D3BED0}"/>
+                <a16:creationId xmlns:a16="http://schemas.microsoft.com/office/drawing/2014/main" id="{E1FA00B2-9F61-4CD6-8714-670B16042757}"/>
               </a:ext>
             </a:extLst>
           </p:cNvPr>
@@ -10101,7 +10101,7 @@
           <p:cNvPr id="3" name="">
             <a:extLst xmlns:a="http://schemas.openxmlformats.org/drawingml/2006/main">
               <a:ext uri="{FF2B5EF4-FFF2-40B4-BE49-F238E27FC236}">
-                <a16:creationId xmlns:a16="http://schemas.microsoft.com/office/drawing/2014/main" id="{67DC9051-E8DE-4005-A1BA-DE3D8876B524}"/>
+                <a16:creationId xmlns:a16="http://schemas.microsoft.com/office/drawing/2014/main" id="{F1D2DA00-8135-4FC2-8DD1-5ED1F949EC55}"/>
               </a:ext>
             </a:extLst>
           </p:cNvPr>
@@ -10132,7 +10132,7 @@
           <p:cNvPr id="4" name="">
             <a:extLst xmlns:a="http://schemas.openxmlformats.org/drawingml/2006/main">
               <a:ext uri="{FF2B5EF4-FFF2-40B4-BE49-F238E27FC236}">
-                <a16:creationId xmlns:a16="http://schemas.microsoft.com/office/drawing/2014/main" id="{B07D1D22-2985-4BD0-9147-DFD837A3C96C}"/>
+                <a16:creationId xmlns:a16="http://schemas.microsoft.com/office/drawing/2014/main" id="{937652AF-533C-46B0-936E-4DDE5982FAC1}"/>
               </a:ext>
             </a:extLst>
           </p:cNvPr>
@@ -10182,7 +10182,7 @@
           <p:cNvPr id="5" name="">
             <a:extLst xmlns:a="http://schemas.openxmlformats.org/drawingml/2006/main">
               <a:ext uri="{FF2B5EF4-FFF2-40B4-BE49-F238E27FC236}">
-                <a16:creationId xmlns:a16="http://schemas.microsoft.com/office/drawing/2014/main" id="{7058B5BE-8E57-437E-8D00-06743DD78FC1}"/>
+                <a16:creationId xmlns:a16="http://schemas.microsoft.com/office/drawing/2014/main" id="{D86C0F2D-5369-48DE-B292-43C5413DBC76}"/>
               </a:ext>
             </a:extLst>
           </p:cNvPr>
@@ -10232,7 +10232,7 @@
           <p:cNvPr id="6" name="">
             <a:extLst xmlns:a="http://schemas.openxmlformats.org/drawingml/2006/main">
               <a:ext uri="{FF2B5EF4-FFF2-40B4-BE49-F238E27FC236}">
-                <a16:creationId xmlns:a16="http://schemas.microsoft.com/office/drawing/2014/main" id="{346159A5-F43C-47B7-846E-7529ADD37A0B}"/>
+                <a16:creationId xmlns:a16="http://schemas.microsoft.com/office/drawing/2014/main" id="{DBA22544-F6E8-40A1-99A7-97BD1413F865}"/>
               </a:ext>
             </a:extLst>
           </p:cNvPr>
@@ -10282,7 +10282,7 @@
           <p:cNvPr id="7" name="">
             <a:extLst xmlns:a="http://schemas.openxmlformats.org/drawingml/2006/main">
               <a:ext uri="{FF2B5EF4-FFF2-40B4-BE49-F238E27FC236}">
-                <a16:creationId xmlns:a16="http://schemas.microsoft.com/office/drawing/2014/main" id="{0368F1B9-C0D3-4227-9C59-72276C5347EB}"/>
+                <a16:creationId xmlns:a16="http://schemas.microsoft.com/office/drawing/2014/main" id="{66837C75-E250-448F-8CC1-81F0EA41F4BA}"/>
               </a:ext>
             </a:extLst>
           </p:cNvPr>
@@ -10313,7 +10313,7 @@
           <p:cNvPr id="8" name="">
             <a:extLst xmlns:a="http://schemas.openxmlformats.org/drawingml/2006/main">
               <a:ext uri="{FF2B5EF4-FFF2-40B4-BE49-F238E27FC236}">
-                <a16:creationId xmlns:a16="http://schemas.microsoft.com/office/drawing/2014/main" id="{4D5285D0-C897-4DD2-8490-685683500199}"/>
+                <a16:creationId xmlns:a16="http://schemas.microsoft.com/office/drawing/2014/main" id="{F48A290B-F30C-48FA-9CC3-300B0EF9B466}"/>
               </a:ext>
             </a:extLst>
           </p:cNvPr>
@@ -10363,7 +10363,7 @@
           <p:cNvPr id="9" name="">
             <a:extLst xmlns:a="http://schemas.openxmlformats.org/drawingml/2006/main">
               <a:ext uri="{FF2B5EF4-FFF2-40B4-BE49-F238E27FC236}">
-                <a16:creationId xmlns:a16="http://schemas.microsoft.com/office/drawing/2014/main" id="{8432D533-DCAF-48F5-B0F3-BE5A377D6ABB}"/>
+                <a16:creationId xmlns:a16="http://schemas.microsoft.com/office/drawing/2014/main" id="{1A516C28-5D76-4721-BF70-C535191608A1}"/>
               </a:ext>
             </a:extLst>
           </p:cNvPr>
@@ -10413,7 +10413,7 @@
           <p:cNvPr id="10" name="">
             <a:extLst xmlns:a="http://schemas.openxmlformats.org/drawingml/2006/main">
               <a:ext uri="{FF2B5EF4-FFF2-40B4-BE49-F238E27FC236}">
-                <a16:creationId xmlns:a16="http://schemas.microsoft.com/office/drawing/2014/main" id="{726665ED-3FF7-45D8-AD72-27D998026D1E}"/>
+                <a16:creationId xmlns:a16="http://schemas.microsoft.com/office/drawing/2014/main" id="{94941702-B6A1-4DF5-974A-723D57DFF41F}"/>
               </a:ext>
             </a:extLst>
           </p:cNvPr>
@@ -10444,7 +10444,7 @@
           <p:cNvPr id="11" name="">
             <a:extLst xmlns:a="http://schemas.openxmlformats.org/drawingml/2006/main">
               <a:ext uri="{FF2B5EF4-FFF2-40B4-BE49-F238E27FC236}">
-                <a16:creationId xmlns:a16="http://schemas.microsoft.com/office/drawing/2014/main" id="{E0BEE000-23D1-457F-B1AE-DDA9DA10DB5D}"/>
+                <a16:creationId xmlns:a16="http://schemas.microsoft.com/office/drawing/2014/main" id="{4EDA2D85-3F9B-4AA6-B5B6-DBF722A2E122}"/>
               </a:ext>
             </a:extLst>
           </p:cNvPr>
@@ -10494,7 +10494,7 @@
           <p:cNvPr id="12" name="">
             <a:extLst xmlns:a="http://schemas.openxmlformats.org/drawingml/2006/main">
               <a:ext uri="{FF2B5EF4-FFF2-40B4-BE49-F238E27FC236}">
-                <a16:creationId xmlns:a16="http://schemas.microsoft.com/office/drawing/2014/main" id="{324A62C0-224F-4ED2-A645-E05AB1AAB782}"/>
+                <a16:creationId xmlns:a16="http://schemas.microsoft.com/office/drawing/2014/main" id="{AD340C7F-F4D1-402B-B31B-49A49F24DA1F}"/>
               </a:ext>
             </a:extLst>
           </p:cNvPr>
@@ -10544,7 +10544,7 @@
           <p:cNvPr id="13" name="">
             <a:extLst xmlns:a="http://schemas.openxmlformats.org/drawingml/2006/main">
               <a:ext uri="{FF2B5EF4-FFF2-40B4-BE49-F238E27FC236}">
-                <a16:creationId xmlns:a16="http://schemas.microsoft.com/office/drawing/2014/main" id="{2FA7C9FB-B430-4144-97B8-4EBC4E2745EB}"/>
+                <a16:creationId xmlns:a16="http://schemas.microsoft.com/office/drawing/2014/main" id="{1280E1E0-4F88-4641-98FB-BD649F4B9E64}"/>
               </a:ext>
             </a:extLst>
           </p:cNvPr>
@@ -10575,7 +10575,7 @@
           <p:cNvPr id="14" name="">
             <a:extLst xmlns:a="http://schemas.openxmlformats.org/drawingml/2006/main">
               <a:ext uri="{FF2B5EF4-FFF2-40B4-BE49-F238E27FC236}">
-                <a16:creationId xmlns:a16="http://schemas.microsoft.com/office/drawing/2014/main" id="{37B52FB1-754B-4227-8B67-D1AC58072707}"/>
+                <a16:creationId xmlns:a16="http://schemas.microsoft.com/office/drawing/2014/main" id="{927C0264-7C1E-408F-8AF4-BF346F231730}"/>
               </a:ext>
             </a:extLst>
           </p:cNvPr>
@@ -10625,7 +10625,7 @@
           <p:cNvPr id="15" name="">
             <a:extLst xmlns:a="http://schemas.openxmlformats.org/drawingml/2006/main">
               <a:ext uri="{FF2B5EF4-FFF2-40B4-BE49-F238E27FC236}">
-                <a16:creationId xmlns:a16="http://schemas.microsoft.com/office/drawing/2014/main" id="{C733B452-33F9-450C-A357-B74345DB580D}"/>
+                <a16:creationId xmlns:a16="http://schemas.microsoft.com/office/drawing/2014/main" id="{10F51C8C-3815-4750-BB05-4CBBE3068C20}"/>
               </a:ext>
             </a:extLst>
           </p:cNvPr>
@@ -10675,7 +10675,7 @@
           <p:cNvPr id="16" name="">
             <a:extLst xmlns:a="http://schemas.openxmlformats.org/drawingml/2006/main">
               <a:ext uri="{FF2B5EF4-FFF2-40B4-BE49-F238E27FC236}">
-                <a16:creationId xmlns:a16="http://schemas.microsoft.com/office/drawing/2014/main" id="{F879FD96-5D6E-4CDB-BCE7-9A57D9BC3FE2}"/>
+                <a16:creationId xmlns:a16="http://schemas.microsoft.com/office/drawing/2014/main" id="{C9AEC63A-FD5C-453C-8CD6-60CD5E7A6069}"/>
               </a:ext>
             </a:extLst>
           </p:cNvPr>
@@ -10706,7 +10706,7 @@
           <p:cNvPr id="17" name="">
             <a:extLst xmlns:a="http://schemas.openxmlformats.org/drawingml/2006/main">
               <a:ext uri="{FF2B5EF4-FFF2-40B4-BE49-F238E27FC236}">
-                <a16:creationId xmlns:a16="http://schemas.microsoft.com/office/drawing/2014/main" id="{A7E263F6-4CBA-4727-8901-87DD0F3118FA}"/>
+                <a16:creationId xmlns:a16="http://schemas.microsoft.com/office/drawing/2014/main" id="{D1723AA7-B375-477F-AB07-268AE8F2EFE5}"/>
               </a:ext>
             </a:extLst>
           </p:cNvPr>
@@ -10739,7 +10739,7 @@
           <p:cNvPr id="18" name="">
             <a:extLst xmlns:a="http://schemas.openxmlformats.org/drawingml/2006/main">
               <a:ext uri="{FF2B5EF4-FFF2-40B4-BE49-F238E27FC236}">
-                <a16:creationId xmlns:a16="http://schemas.microsoft.com/office/drawing/2014/main" id="{97C324D5-7739-45F1-84CA-5185298969CD}"/>
+                <a16:creationId xmlns:a16="http://schemas.microsoft.com/office/drawing/2014/main" id="{FEF20AA6-0E65-4BA0-8217-AA867FE18D93}"/>
               </a:ext>
             </a:extLst>
           </p:cNvPr>
@@ -10772,7 +10772,7 @@
           <p:cNvPr id="19" name="">
             <a:extLst xmlns:a="http://schemas.openxmlformats.org/drawingml/2006/main">
               <a:ext uri="{FF2B5EF4-FFF2-40B4-BE49-F238E27FC236}">
-                <a16:creationId xmlns:a16="http://schemas.microsoft.com/office/drawing/2014/main" id="{7F2A78E1-7F71-4F96-A824-3A7251817AE7}"/>
+                <a16:creationId xmlns:a16="http://schemas.microsoft.com/office/drawing/2014/main" id="{93B6DF69-081D-4B90-86C6-FD19C42EDCDF}"/>
               </a:ext>
             </a:extLst>
           </p:cNvPr>
@@ -10813,7 +10813,7 @@
           <p:cNvPr id="20" name="">
             <a:extLst xmlns:a="http://schemas.openxmlformats.org/drawingml/2006/main">
               <a:ext uri="{FF2B5EF4-FFF2-40B4-BE49-F238E27FC236}">
-                <a16:creationId xmlns:a16="http://schemas.microsoft.com/office/drawing/2014/main" id="{0EBF6D08-FEF7-4DB0-AD9F-71DDD46B7298}"/>
+                <a16:creationId xmlns:a16="http://schemas.microsoft.com/office/drawing/2014/main" id="{8EED23B5-0773-4A3A-AC6E-6E175D1178C9}"/>
               </a:ext>
             </a:extLst>
           </p:cNvPr>
@@ -10863,7 +10863,7 @@
           <p:cNvPr id="21" name="">
             <a:extLst xmlns:a="http://schemas.openxmlformats.org/drawingml/2006/main">
               <a:ext uri="{FF2B5EF4-FFF2-40B4-BE49-F238E27FC236}">
-                <a16:creationId xmlns:a16="http://schemas.microsoft.com/office/drawing/2014/main" id="{0C24A7B3-3904-4705-B25D-0C27F330D1E4}"/>
+                <a16:creationId xmlns:a16="http://schemas.microsoft.com/office/drawing/2014/main" id="{79E4F740-8365-4B46-A6FA-859377D5F35B}"/>
               </a:ext>
             </a:extLst>
           </p:cNvPr>
@@ -10947,7 +10947,7 @@
           <p:cNvPr id="22" name="">
             <a:extLst xmlns:a="http://schemas.openxmlformats.org/drawingml/2006/main">
               <a:ext uri="{FF2B5EF4-FFF2-40B4-BE49-F238E27FC236}">
-                <a16:creationId xmlns:a16="http://schemas.microsoft.com/office/drawing/2014/main" id="{6931E669-9848-435F-BCB3-F17D30369600}"/>
+                <a16:creationId xmlns:a16="http://schemas.microsoft.com/office/drawing/2014/main" id="{B7FC16EF-370C-4042-B77A-FE7F4B05B1B4}"/>
               </a:ext>
             </a:extLst>
           </p:cNvPr>
@@ -10988,7 +10988,7 @@
           <p:cNvPr id="23" name="">
             <a:extLst xmlns:a="http://schemas.openxmlformats.org/drawingml/2006/main">
               <a:ext uri="{FF2B5EF4-FFF2-40B4-BE49-F238E27FC236}">
-                <a16:creationId xmlns:a16="http://schemas.microsoft.com/office/drawing/2014/main" id="{7BC533BD-EBC3-4178-A1F6-10310F613174}"/>
+                <a16:creationId xmlns:a16="http://schemas.microsoft.com/office/drawing/2014/main" id="{A2543E8D-C76C-4378-8C70-6CB3AD1BED34}"/>
               </a:ext>
             </a:extLst>
           </p:cNvPr>
@@ -11038,7 +11038,7 @@
           <p:cNvPr id="24" name="">
             <a:extLst xmlns:a="http://schemas.openxmlformats.org/drawingml/2006/main">
               <a:ext uri="{FF2B5EF4-FFF2-40B4-BE49-F238E27FC236}">
-                <a16:creationId xmlns:a16="http://schemas.microsoft.com/office/drawing/2014/main" id="{A8FAA560-59E7-4BBB-8153-EEF50EE86CAD}"/>
+                <a16:creationId xmlns:a16="http://schemas.microsoft.com/office/drawing/2014/main" id="{8C5E981E-3684-4EDC-890A-D3FF2122BFF8}"/>
               </a:ext>
             </a:extLst>
           </p:cNvPr>
@@ -11122,7 +11122,7 @@
           <p:cNvPr id="25" name="">
             <a:extLst xmlns:a="http://schemas.openxmlformats.org/drawingml/2006/main">
               <a:ext uri="{FF2B5EF4-FFF2-40B4-BE49-F238E27FC236}">
-                <a16:creationId xmlns:a16="http://schemas.microsoft.com/office/drawing/2014/main" id="{4CDFF960-A402-4AA2-B537-7EB73841F54F}"/>
+                <a16:creationId xmlns:a16="http://schemas.microsoft.com/office/drawing/2014/main" id="{751B1260-DF46-4828-B92D-B2C29E05BEDE}"/>
               </a:ext>
             </a:extLst>
           </p:cNvPr>
@@ -11157,7 +11157,7 @@
           <p:cNvPr id="26" name="">
             <a:extLst xmlns:a="http://schemas.openxmlformats.org/drawingml/2006/main">
               <a:ext uri="{FF2B5EF4-FFF2-40B4-BE49-F238E27FC236}">
-                <a16:creationId xmlns:a16="http://schemas.microsoft.com/office/drawing/2014/main" id="{7738BA59-DA16-4CEC-9BDA-5743D9F5A5E4}"/>
+                <a16:creationId xmlns:a16="http://schemas.microsoft.com/office/drawing/2014/main" id="{B6547CB1-52FC-4436-9DBE-F5FC4BE55915}"/>
               </a:ext>
             </a:extLst>
           </p:cNvPr>
@@ -11207,7 +11207,7 @@
           <p:cNvPr id="27" name="">
             <a:extLst xmlns:a="http://schemas.openxmlformats.org/drawingml/2006/main">
               <a:ext uri="{FF2B5EF4-FFF2-40B4-BE49-F238E27FC236}">
-                <a16:creationId xmlns:a16="http://schemas.microsoft.com/office/drawing/2014/main" id="{389D771E-15EC-446D-8CAB-65FA75BEC395}"/>
+                <a16:creationId xmlns:a16="http://schemas.microsoft.com/office/drawing/2014/main" id="{C4387042-6B0B-4701-B898-EDC0B5A37C7C}"/>
               </a:ext>
             </a:extLst>
           </p:cNvPr>
@@ -11257,7 +11257,7 @@
           <p:cNvPr id="28" name="">
             <a:extLst xmlns:a="http://schemas.openxmlformats.org/drawingml/2006/main">
               <a:ext uri="{FF2B5EF4-FFF2-40B4-BE49-F238E27FC236}">
-                <a16:creationId xmlns:a16="http://schemas.microsoft.com/office/drawing/2014/main" id="{D6D4E34F-C313-493E-BA5C-B33400457DA8}"/>
+                <a16:creationId xmlns:a16="http://schemas.microsoft.com/office/drawing/2014/main" id="{20E05A06-5957-4BD6-A7F7-9AAD3AB3A093}"/>
               </a:ext>
             </a:extLst>
           </p:cNvPr>
@@ -11288,7 +11288,7 @@
           <p:cNvPr id="29" name="source-14">
             <a:extLst xmlns:a="http://schemas.openxmlformats.org/drawingml/2006/main">
               <a:ext uri="{FF2B5EF4-FFF2-40B4-BE49-F238E27FC236}">
-                <a16:creationId xmlns:a16="http://schemas.microsoft.com/office/drawing/2014/main" id="{C38E3676-326B-48AC-9CA8-4BBE30EE9FC1}"/>
+                <a16:creationId xmlns:a16="http://schemas.microsoft.com/office/drawing/2014/main" id="{93F53662-130E-413B-975B-D87C85E9E307}"/>
               </a:ext>
             </a:extLst>
           </p:cNvPr>
@@ -11338,7 +11338,7 @@
           <p:cNvPr id="30" name="page-14">
             <a:extLst xmlns:a="http://schemas.openxmlformats.org/drawingml/2006/main">
               <a:ext uri="{FF2B5EF4-FFF2-40B4-BE49-F238E27FC236}">
-                <a16:creationId xmlns:a16="http://schemas.microsoft.com/office/drawing/2014/main" id="{9DDC9A6A-EEE8-4142-831F-CAEDED524330}"/>
+                <a16:creationId xmlns:a16="http://schemas.microsoft.com/office/drawing/2014/main" id="{68315756-396F-4268-A6A1-DE3FE1C54A55}"/>
               </a:ext>
             </a:extLst>
           </p:cNvPr>
@@ -11386,7 +11386,7 @@
     </p:spTree>
     <p:extLst>
       <p:ext uri="{BB962C8B-B14F-4D97-AF65-F5344CB8AC3E}">
-        <p14:creationId xmlns:p14="http://schemas.microsoft.com/office/powerpoint/2010/main" val="2015375305"/>
+        <p14:creationId xmlns:p14="http://schemas.microsoft.com/office/powerpoint/2010/main" val="624765838"/>
       </p:ext>
     </p:extLst>
   </p:cSld>
@@ -11417,7 +11417,7 @@
           <p:cNvPr id="17" name="">
             <a:extLst xmlns:a="http://schemas.openxmlformats.org/drawingml/2006/main">
               <a:ext uri="{FF2B5EF4-FFF2-40B4-BE49-F238E27FC236}">
-                <a16:creationId xmlns:a16="http://schemas.microsoft.com/office/drawing/2014/main" id="{EAA4EA97-56E2-4887-A72C-C97B3CB592DA}"/>
+                <a16:creationId xmlns:a16="http://schemas.microsoft.com/office/drawing/2014/main" id="{33C6C590-AC8D-4D41-809E-7E46F3144D4D}"/>
               </a:ext>
             </a:extLst>
           </p:cNvPr>
@@ -11467,7 +11467,7 @@
           <p:cNvPr id="2" name="">
             <a:extLst xmlns:a="http://schemas.openxmlformats.org/drawingml/2006/main">
               <a:ext uri="{FF2B5EF4-FFF2-40B4-BE49-F238E27FC236}">
-                <a16:creationId xmlns:a16="http://schemas.microsoft.com/office/drawing/2014/main" id="{0607CF53-F2B2-4D66-ACDA-479A876D0428}"/>
+                <a16:creationId xmlns:a16="http://schemas.microsoft.com/office/drawing/2014/main" id="{7701A439-0284-41A8-82FA-93596169CFD0}"/>
               </a:ext>
             </a:extLst>
           </p:cNvPr>
@@ -11534,7 +11534,7 @@
           <p:cNvPr id="3" name="">
             <a:extLst xmlns:a="http://schemas.openxmlformats.org/drawingml/2006/main">
               <a:ext uri="{FF2B5EF4-FFF2-40B4-BE49-F238E27FC236}">
-                <a16:creationId xmlns:a16="http://schemas.microsoft.com/office/drawing/2014/main" id="{3D1A3775-938A-48EB-949C-3F4CD8D4602A}"/>
+                <a16:creationId xmlns:a16="http://schemas.microsoft.com/office/drawing/2014/main" id="{E39312FA-DAE7-402C-9B1B-72ABD0FA420F}"/>
               </a:ext>
             </a:extLst>
           </p:cNvPr>
@@ -11575,7 +11575,7 @@
           <p:cNvPr id="4" name="">
             <a:extLst xmlns:a="http://schemas.openxmlformats.org/drawingml/2006/main">
               <a:ext uri="{FF2B5EF4-FFF2-40B4-BE49-F238E27FC236}">
-                <a16:creationId xmlns:a16="http://schemas.microsoft.com/office/drawing/2014/main" id="{57F20F22-EA22-4067-BB7A-7E3A30B117CD}"/>
+                <a16:creationId xmlns:a16="http://schemas.microsoft.com/office/drawing/2014/main" id="{9C9F5B7B-F077-4CFB-99B4-3607107AEA6E}"/>
               </a:ext>
             </a:extLst>
           </p:cNvPr>
@@ -11625,7 +11625,7 @@
           <p:cNvPr id="5" name="">
             <a:extLst xmlns:a="http://schemas.openxmlformats.org/drawingml/2006/main">
               <a:ext uri="{FF2B5EF4-FFF2-40B4-BE49-F238E27FC236}">
-                <a16:creationId xmlns:a16="http://schemas.microsoft.com/office/drawing/2014/main" id="{F8DF7111-172B-4E08-9CD0-C88B032FF15C}"/>
+                <a16:creationId xmlns:a16="http://schemas.microsoft.com/office/drawing/2014/main" id="{A34508EC-ADC8-47BD-944D-F8E4B8A94CBA}"/>
               </a:ext>
             </a:extLst>
           </p:cNvPr>
@@ -11709,7 +11709,7 @@
           <p:cNvPr id="6" name="">
             <a:extLst xmlns:a="http://schemas.openxmlformats.org/drawingml/2006/main">
               <a:ext uri="{FF2B5EF4-FFF2-40B4-BE49-F238E27FC236}">
-                <a16:creationId xmlns:a16="http://schemas.microsoft.com/office/drawing/2014/main" id="{61735506-3A2E-45D2-A89C-FE1730FCA7F5}"/>
+                <a16:creationId xmlns:a16="http://schemas.microsoft.com/office/drawing/2014/main" id="{6C419DA7-6A87-4599-97A5-DC8565EA9D06}"/>
               </a:ext>
             </a:extLst>
           </p:cNvPr>
@@ -11750,7 +11750,7 @@
           <p:cNvPr id="7" name="">
             <a:extLst xmlns:a="http://schemas.openxmlformats.org/drawingml/2006/main">
               <a:ext uri="{FF2B5EF4-FFF2-40B4-BE49-F238E27FC236}">
-                <a16:creationId xmlns:a16="http://schemas.microsoft.com/office/drawing/2014/main" id="{531C97A3-70DC-43B2-879B-CC23B61D7EED}"/>
+                <a16:creationId xmlns:a16="http://schemas.microsoft.com/office/drawing/2014/main" id="{6D87793E-5438-4392-A581-FB5DDAEC7C1C}"/>
               </a:ext>
             </a:extLst>
           </p:cNvPr>
@@ -11800,7 +11800,7 @@
           <p:cNvPr id="8" name="">
             <a:extLst xmlns:a="http://schemas.openxmlformats.org/drawingml/2006/main">
               <a:ext uri="{FF2B5EF4-FFF2-40B4-BE49-F238E27FC236}">
-                <a16:creationId xmlns:a16="http://schemas.microsoft.com/office/drawing/2014/main" id="{D24C6AB5-DFFD-44E1-9D2B-1F0336A40685}"/>
+                <a16:creationId xmlns:a16="http://schemas.microsoft.com/office/drawing/2014/main" id="{F9D7D7CC-E901-4166-8780-28A3997F008B}"/>
               </a:ext>
             </a:extLst>
           </p:cNvPr>
@@ -11884,7 +11884,7 @@
           <p:cNvPr id="9" name="">
             <a:extLst xmlns:a="http://schemas.openxmlformats.org/drawingml/2006/main">
               <a:ext uri="{FF2B5EF4-FFF2-40B4-BE49-F238E27FC236}">
-                <a16:creationId xmlns:a16="http://schemas.microsoft.com/office/drawing/2014/main" id="{22AADD0A-27CC-428D-BDAA-EE2BC6F3FC3B}"/>
+                <a16:creationId xmlns:a16="http://schemas.microsoft.com/office/drawing/2014/main" id="{8DE7FAC4-CFA3-447F-9C4E-1476C1FCDEB3}"/>
               </a:ext>
             </a:extLst>
           </p:cNvPr>
@@ -11925,7 +11925,7 @@
           <p:cNvPr id="10" name="">
             <a:extLst xmlns:a="http://schemas.openxmlformats.org/drawingml/2006/main">
               <a:ext uri="{FF2B5EF4-FFF2-40B4-BE49-F238E27FC236}">
-                <a16:creationId xmlns:a16="http://schemas.microsoft.com/office/drawing/2014/main" id="{E2BE4B63-E0A7-4B2B-BB9A-8F9CA32703E0}"/>
+                <a16:creationId xmlns:a16="http://schemas.microsoft.com/office/drawing/2014/main" id="{9E87CC63-2335-46D0-A6C8-2AD8472D2D98}"/>
               </a:ext>
             </a:extLst>
           </p:cNvPr>
@@ -11975,7 +11975,7 @@
           <p:cNvPr id="11" name="">
             <a:extLst xmlns:a="http://schemas.openxmlformats.org/drawingml/2006/main">
               <a:ext uri="{FF2B5EF4-FFF2-40B4-BE49-F238E27FC236}">
-                <a16:creationId xmlns:a16="http://schemas.microsoft.com/office/drawing/2014/main" id="{AD4BEC74-1BA4-434C-91F2-7462CF82D68F}"/>
+                <a16:creationId xmlns:a16="http://schemas.microsoft.com/office/drawing/2014/main" id="{538A2B92-C66B-49B4-9A54-4B7E3F42E171}"/>
               </a:ext>
             </a:extLst>
           </p:cNvPr>
@@ -12059,7 +12059,7 @@
           <p:cNvPr id="12" name="">
             <a:extLst xmlns:a="http://schemas.openxmlformats.org/drawingml/2006/main">
               <a:ext uri="{FF2B5EF4-FFF2-40B4-BE49-F238E27FC236}">
-                <a16:creationId xmlns:a16="http://schemas.microsoft.com/office/drawing/2014/main" id="{786A9C44-CD17-4F83-A08A-C4AB13DB389C}"/>
+                <a16:creationId xmlns:a16="http://schemas.microsoft.com/office/drawing/2014/main" id="{8744B878-38BB-41E7-9CDB-A47574C43C45}"/>
               </a:ext>
             </a:extLst>
           </p:cNvPr>
@@ -12109,7 +12109,7 @@
           <p:cNvPr id="13" name="">
             <a:extLst xmlns:a="http://schemas.openxmlformats.org/drawingml/2006/main">
               <a:ext uri="{FF2B5EF4-FFF2-40B4-BE49-F238E27FC236}">
-                <a16:creationId xmlns:a16="http://schemas.microsoft.com/office/drawing/2014/main" id="{9C5BBF95-AF3A-4FD8-8F83-E1523A5B0A86}"/>
+                <a16:creationId xmlns:a16="http://schemas.microsoft.com/office/drawing/2014/main" id="{B5222930-A972-4E65-8A69-CFE761388F8B}"/>
               </a:ext>
             </a:extLst>
           </p:cNvPr>
@@ -12159,7 +12159,7 @@
           <p:cNvPr id="14" name="">
             <a:extLst xmlns:a="http://schemas.openxmlformats.org/drawingml/2006/main">
               <a:ext uri="{FF2B5EF4-FFF2-40B4-BE49-F238E27FC236}">
-                <a16:creationId xmlns:a16="http://schemas.microsoft.com/office/drawing/2014/main" id="{2A13EE44-AB9C-4728-B205-D88F3A439212}"/>
+                <a16:creationId xmlns:a16="http://schemas.microsoft.com/office/drawing/2014/main" id="{F8781430-71AC-4AC8-AAE8-227D6612A7A4}"/>
               </a:ext>
             </a:extLst>
           </p:cNvPr>
@@ -12190,7 +12190,7 @@
           <p:cNvPr id="15" name="">
             <a:extLst xmlns:a="http://schemas.openxmlformats.org/drawingml/2006/main">
               <a:ext uri="{FF2B5EF4-FFF2-40B4-BE49-F238E27FC236}">
-                <a16:creationId xmlns:a16="http://schemas.microsoft.com/office/drawing/2014/main" id="{C98790EC-F6C2-42E0-A2A2-42F668B90E81}"/>
+                <a16:creationId xmlns:a16="http://schemas.microsoft.com/office/drawing/2014/main" id="{9D17B9C4-5AFB-4BEB-9DA4-65B1E25650A8}"/>
               </a:ext>
             </a:extLst>
           </p:cNvPr>
@@ -12240,7 +12240,7 @@
           <p:cNvPr id="16" name="">
             <a:extLst xmlns:a="http://schemas.openxmlformats.org/drawingml/2006/main">
               <a:ext uri="{FF2B5EF4-FFF2-40B4-BE49-F238E27FC236}">
-                <a16:creationId xmlns:a16="http://schemas.microsoft.com/office/drawing/2014/main" id="{EF66B6C3-9D25-4A10-ADC9-E718D4AEFEF2}"/>
+                <a16:creationId xmlns:a16="http://schemas.microsoft.com/office/drawing/2014/main" id="{37D8D58A-E0D4-4368-A6D1-D7F564E3069C}"/>
               </a:ext>
             </a:extLst>
           </p:cNvPr>
@@ -12288,7 +12288,7 @@
     </p:spTree>
     <p:extLst>
       <p:ext uri="{BB962C8B-B14F-4D97-AF65-F5344CB8AC3E}">
-        <p14:creationId xmlns:p14="http://schemas.microsoft.com/office/powerpoint/2010/main" val="310306253"/>
+        <p14:creationId xmlns:p14="http://schemas.microsoft.com/office/powerpoint/2010/main" val="1877395611"/>
       </p:ext>
     </p:extLst>
   </p:cSld>
@@ -12319,7 +12319,7 @@
           <p:cNvPr id="30" name="kicker-2">
             <a:extLst xmlns:a="http://schemas.openxmlformats.org/drawingml/2006/main">
               <a:ext uri="{FF2B5EF4-FFF2-40B4-BE49-F238E27FC236}">
-                <a16:creationId xmlns:a16="http://schemas.microsoft.com/office/drawing/2014/main" id="{DCADB9DD-228E-4341-9CE3-FC086C5E522B}"/>
+                <a16:creationId xmlns:a16="http://schemas.microsoft.com/office/drawing/2014/main" id="{8A1BB54D-40A7-4131-AA8F-94E7A2D7F3CB}"/>
               </a:ext>
             </a:extLst>
           </p:cNvPr>
@@ -12369,7 +12369,7 @@
           <p:cNvPr id="2" name="title-2">
             <a:extLst xmlns:a="http://schemas.openxmlformats.org/drawingml/2006/main">
               <a:ext uri="{FF2B5EF4-FFF2-40B4-BE49-F238E27FC236}">
-                <a16:creationId xmlns:a16="http://schemas.microsoft.com/office/drawing/2014/main" id="{E4295CBB-A57C-4788-B5B7-77BE147AD321}"/>
+                <a16:creationId xmlns:a16="http://schemas.microsoft.com/office/drawing/2014/main" id="{060DC2FB-6889-42E5-93C7-9FF171D9D7DA}"/>
               </a:ext>
             </a:extLst>
           </p:cNvPr>
@@ -12419,7 +12419,7 @@
           <p:cNvPr id="3" name="">
             <a:extLst xmlns:a="http://schemas.openxmlformats.org/drawingml/2006/main">
               <a:ext uri="{FF2B5EF4-FFF2-40B4-BE49-F238E27FC236}">
-                <a16:creationId xmlns:a16="http://schemas.microsoft.com/office/drawing/2014/main" id="{DA315E02-8E34-48FC-AA7A-AFD38C3410DE}"/>
+                <a16:creationId xmlns:a16="http://schemas.microsoft.com/office/drawing/2014/main" id="{EDB27EDC-74EF-4A95-9558-F53C6B6DE7C0}"/>
               </a:ext>
             </a:extLst>
           </p:cNvPr>
@@ -12450,7 +12450,7 @@
           <p:cNvPr id="4" name="">
             <a:extLst xmlns:a="http://schemas.openxmlformats.org/drawingml/2006/main">
               <a:ext uri="{FF2B5EF4-FFF2-40B4-BE49-F238E27FC236}">
-                <a16:creationId xmlns:a16="http://schemas.microsoft.com/office/drawing/2014/main" id="{622C3178-6D56-4103-A02D-A05BAE295222}"/>
+                <a16:creationId xmlns:a16="http://schemas.microsoft.com/office/drawing/2014/main" id="{09A126D8-0CCA-4EDD-9F5D-B10DE4601137}"/>
               </a:ext>
             </a:extLst>
           </p:cNvPr>
@@ -12500,7 +12500,7 @@
           <p:cNvPr id="5" name="">
             <a:extLst xmlns:a="http://schemas.openxmlformats.org/drawingml/2006/main">
               <a:ext uri="{FF2B5EF4-FFF2-40B4-BE49-F238E27FC236}">
-                <a16:creationId xmlns:a16="http://schemas.microsoft.com/office/drawing/2014/main" id="{36D7D194-2A59-4E0F-947B-AB48D5B3518F}"/>
+                <a16:creationId xmlns:a16="http://schemas.microsoft.com/office/drawing/2014/main" id="{6143A4ED-172B-4B5C-B499-167E92C9E556}"/>
               </a:ext>
             </a:extLst>
           </p:cNvPr>
@@ -12531,7 +12531,7 @@
           <p:cNvPr id="6" name="">
             <a:extLst xmlns:a="http://schemas.openxmlformats.org/drawingml/2006/main">
               <a:ext uri="{FF2B5EF4-FFF2-40B4-BE49-F238E27FC236}">
-                <a16:creationId xmlns:a16="http://schemas.microsoft.com/office/drawing/2014/main" id="{BA4BA442-0DEF-4F38-8614-EB22AFA2BDC2}"/>
+                <a16:creationId xmlns:a16="http://schemas.microsoft.com/office/drawing/2014/main" id="{D41AEE24-4490-427E-A8BF-D65DEEE6DEAA}"/>
               </a:ext>
             </a:extLst>
           </p:cNvPr>
@@ -12564,7 +12564,7 @@
           <p:cNvPr id="7" name="">
             <a:extLst xmlns:a="http://schemas.openxmlformats.org/drawingml/2006/main">
               <a:ext uri="{FF2B5EF4-FFF2-40B4-BE49-F238E27FC236}">
-                <a16:creationId xmlns:a16="http://schemas.microsoft.com/office/drawing/2014/main" id="{5B635084-AF76-4A31-AF3C-B7E431DFD184}"/>
+                <a16:creationId xmlns:a16="http://schemas.microsoft.com/office/drawing/2014/main" id="{AC6F6B49-4715-459D-9FF5-68AD69FACA12}"/>
               </a:ext>
             </a:extLst>
           </p:cNvPr>
@@ -12614,7 +12614,7 @@
           <p:cNvPr id="8" name="">
             <a:extLst xmlns:a="http://schemas.openxmlformats.org/drawingml/2006/main">
               <a:ext uri="{FF2B5EF4-FFF2-40B4-BE49-F238E27FC236}">
-                <a16:creationId xmlns:a16="http://schemas.microsoft.com/office/drawing/2014/main" id="{99BB40BF-B2A8-4617-835D-6FE10E7D2D0E}"/>
+                <a16:creationId xmlns:a16="http://schemas.microsoft.com/office/drawing/2014/main" id="{4992E8A9-6E74-48F0-8DF7-C045EF311DA8}"/>
               </a:ext>
             </a:extLst>
           </p:cNvPr>
@@ -12664,7 +12664,7 @@
           <p:cNvPr id="9" name="">
             <a:extLst xmlns:a="http://schemas.openxmlformats.org/drawingml/2006/main">
               <a:ext uri="{FF2B5EF4-FFF2-40B4-BE49-F238E27FC236}">
-                <a16:creationId xmlns:a16="http://schemas.microsoft.com/office/drawing/2014/main" id="{69D05B20-C0D3-4534-826B-BB7418A2C20E}"/>
+                <a16:creationId xmlns:a16="http://schemas.microsoft.com/office/drawing/2014/main" id="{320B7F74-FF4A-47B0-876E-66FE96C6ED56}"/>
               </a:ext>
             </a:extLst>
           </p:cNvPr>
@@ -12697,7 +12697,7 @@
           <p:cNvPr id="10" name="">
             <a:extLst xmlns:a="http://schemas.openxmlformats.org/drawingml/2006/main">
               <a:ext uri="{FF2B5EF4-FFF2-40B4-BE49-F238E27FC236}">
-                <a16:creationId xmlns:a16="http://schemas.microsoft.com/office/drawing/2014/main" id="{A4F39F8A-CE5C-4DEA-BE05-A6BBC3BC1D79}"/>
+                <a16:creationId xmlns:a16="http://schemas.microsoft.com/office/drawing/2014/main" id="{32FE9981-E1C6-47F2-AE38-42D01F71B9EA}"/>
               </a:ext>
             </a:extLst>
           </p:cNvPr>
@@ -12747,7 +12747,7 @@
           <p:cNvPr id="11" name="">
             <a:extLst xmlns:a="http://schemas.openxmlformats.org/drawingml/2006/main">
               <a:ext uri="{FF2B5EF4-FFF2-40B4-BE49-F238E27FC236}">
-                <a16:creationId xmlns:a16="http://schemas.microsoft.com/office/drawing/2014/main" id="{9256767C-1608-461D-BBD5-02EBDD6A3AFA}"/>
+                <a16:creationId xmlns:a16="http://schemas.microsoft.com/office/drawing/2014/main" id="{4A21850A-91D2-4E7B-893D-C329867B3676}"/>
               </a:ext>
             </a:extLst>
           </p:cNvPr>
@@ -12797,7 +12797,7 @@
           <p:cNvPr id="12" name="">
             <a:extLst xmlns:a="http://schemas.openxmlformats.org/drawingml/2006/main">
               <a:ext uri="{FF2B5EF4-FFF2-40B4-BE49-F238E27FC236}">
-                <a16:creationId xmlns:a16="http://schemas.microsoft.com/office/drawing/2014/main" id="{44F38037-96A5-4931-912A-BFF603BE6AA1}"/>
+                <a16:creationId xmlns:a16="http://schemas.microsoft.com/office/drawing/2014/main" id="{374201EA-216B-4CD8-92B0-E03D008B68F9}"/>
               </a:ext>
             </a:extLst>
           </p:cNvPr>
@@ -12830,7 +12830,7 @@
           <p:cNvPr id="13" name="">
             <a:extLst xmlns:a="http://schemas.openxmlformats.org/drawingml/2006/main">
               <a:ext uri="{FF2B5EF4-FFF2-40B4-BE49-F238E27FC236}">
-                <a16:creationId xmlns:a16="http://schemas.microsoft.com/office/drawing/2014/main" id="{38C7B6CC-819B-4B3B-BB00-6D87040097CF}"/>
+                <a16:creationId xmlns:a16="http://schemas.microsoft.com/office/drawing/2014/main" id="{D6667195-88F4-42D3-9089-212D43C279C1}"/>
               </a:ext>
             </a:extLst>
           </p:cNvPr>
@@ -12880,7 +12880,7 @@
           <p:cNvPr id="14" name="">
             <a:extLst xmlns:a="http://schemas.openxmlformats.org/drawingml/2006/main">
               <a:ext uri="{FF2B5EF4-FFF2-40B4-BE49-F238E27FC236}">
-                <a16:creationId xmlns:a16="http://schemas.microsoft.com/office/drawing/2014/main" id="{49D011EF-2DCE-4D82-8591-DB0072B8FAB8}"/>
+                <a16:creationId xmlns:a16="http://schemas.microsoft.com/office/drawing/2014/main" id="{1587C96D-B992-4EB6-83D5-52416EBF641E}"/>
               </a:ext>
             </a:extLst>
           </p:cNvPr>
@@ -12930,7 +12930,7 @@
           <p:cNvPr id="15" name="">
             <a:extLst xmlns:a="http://schemas.openxmlformats.org/drawingml/2006/main">
               <a:ext uri="{FF2B5EF4-FFF2-40B4-BE49-F238E27FC236}">
-                <a16:creationId xmlns:a16="http://schemas.microsoft.com/office/drawing/2014/main" id="{C1D5B4FE-D003-4D93-B365-A1FB9B39DE26}"/>
+                <a16:creationId xmlns:a16="http://schemas.microsoft.com/office/drawing/2014/main" id="{76FFA939-AB49-47F6-BFDA-ABD5021665C3}"/>
               </a:ext>
             </a:extLst>
           </p:cNvPr>
@@ -12963,7 +12963,7 @@
           <p:cNvPr id="16" name="">
             <a:extLst xmlns:a="http://schemas.openxmlformats.org/drawingml/2006/main">
               <a:ext uri="{FF2B5EF4-FFF2-40B4-BE49-F238E27FC236}">
-                <a16:creationId xmlns:a16="http://schemas.microsoft.com/office/drawing/2014/main" id="{10270F6E-5DDB-44AE-9280-985C5F315B87}"/>
+                <a16:creationId xmlns:a16="http://schemas.microsoft.com/office/drawing/2014/main" id="{E46BDF94-898E-4674-9B9C-DF712B9BA9E0}"/>
               </a:ext>
             </a:extLst>
           </p:cNvPr>
@@ -13013,7 +13013,7 @@
           <p:cNvPr id="17" name="">
             <a:extLst xmlns:a="http://schemas.openxmlformats.org/drawingml/2006/main">
               <a:ext uri="{FF2B5EF4-FFF2-40B4-BE49-F238E27FC236}">
-                <a16:creationId xmlns:a16="http://schemas.microsoft.com/office/drawing/2014/main" id="{4E8D6B65-DDAF-4140-A200-F0C9F870505E}"/>
+                <a16:creationId xmlns:a16="http://schemas.microsoft.com/office/drawing/2014/main" id="{6C84E3DB-508A-4453-9836-8F88E0BA42D0}"/>
               </a:ext>
             </a:extLst>
           </p:cNvPr>
@@ -13063,7 +13063,7 @@
           <p:cNvPr id="18" name="">
             <a:extLst xmlns:a="http://schemas.openxmlformats.org/drawingml/2006/main">
               <a:ext uri="{FF2B5EF4-FFF2-40B4-BE49-F238E27FC236}">
-                <a16:creationId xmlns:a16="http://schemas.microsoft.com/office/drawing/2014/main" id="{13674B16-6E6D-4457-9E05-5C746E4B7ECC}"/>
+                <a16:creationId xmlns:a16="http://schemas.microsoft.com/office/drawing/2014/main" id="{7BEEA1AE-8476-42EF-8289-A342032A6327}"/>
               </a:ext>
             </a:extLst>
           </p:cNvPr>
@@ -13096,7 +13096,7 @@
           <p:cNvPr id="19" name="">
             <a:extLst xmlns:a="http://schemas.openxmlformats.org/drawingml/2006/main">
               <a:ext uri="{FF2B5EF4-FFF2-40B4-BE49-F238E27FC236}">
-                <a16:creationId xmlns:a16="http://schemas.microsoft.com/office/drawing/2014/main" id="{B88AD7FA-1EE6-4A02-9A14-13C6F102FF1C}"/>
+                <a16:creationId xmlns:a16="http://schemas.microsoft.com/office/drawing/2014/main" id="{B6D57B8E-E03A-4013-A238-D6A167A3BF1A}"/>
               </a:ext>
             </a:extLst>
           </p:cNvPr>
@@ -13146,7 +13146,7 @@
           <p:cNvPr id="20" name="">
             <a:extLst xmlns:a="http://schemas.openxmlformats.org/drawingml/2006/main">
               <a:ext uri="{FF2B5EF4-FFF2-40B4-BE49-F238E27FC236}">
-                <a16:creationId xmlns:a16="http://schemas.microsoft.com/office/drawing/2014/main" id="{3F7B34FC-58BA-4606-B3DA-354032CEC1C1}"/>
+                <a16:creationId xmlns:a16="http://schemas.microsoft.com/office/drawing/2014/main" id="{D22F9F81-FB8E-4DF4-9B98-7B8D41E98F78}"/>
               </a:ext>
             </a:extLst>
           </p:cNvPr>
@@ -13196,7 +13196,7 @@
           <p:cNvPr id="21" name="">
             <a:extLst xmlns:a="http://schemas.openxmlformats.org/drawingml/2006/main">
               <a:ext uri="{FF2B5EF4-FFF2-40B4-BE49-F238E27FC236}">
-                <a16:creationId xmlns:a16="http://schemas.microsoft.com/office/drawing/2014/main" id="{CC28B880-2191-4DC6-9D72-57B9ABFB644A}"/>
+                <a16:creationId xmlns:a16="http://schemas.microsoft.com/office/drawing/2014/main" id="{81EC5322-2D30-4D7E-B95B-5C8F6DD955BF}"/>
               </a:ext>
             </a:extLst>
           </p:cNvPr>
@@ -13229,7 +13229,7 @@
           <p:cNvPr id="22" name="">
             <a:extLst xmlns:a="http://schemas.openxmlformats.org/drawingml/2006/main">
               <a:ext uri="{FF2B5EF4-FFF2-40B4-BE49-F238E27FC236}">
-                <a16:creationId xmlns:a16="http://schemas.microsoft.com/office/drawing/2014/main" id="{9326E735-F06D-4AAF-B87E-809AEFA0C1D6}"/>
+                <a16:creationId xmlns:a16="http://schemas.microsoft.com/office/drawing/2014/main" id="{F412CAF1-26A9-40F4-B12A-5C3756E349FB}"/>
               </a:ext>
             </a:extLst>
           </p:cNvPr>
@@ -13279,7 +13279,7 @@
           <p:cNvPr id="23" name="">
             <a:extLst xmlns:a="http://schemas.openxmlformats.org/drawingml/2006/main">
               <a:ext uri="{FF2B5EF4-FFF2-40B4-BE49-F238E27FC236}">
-                <a16:creationId xmlns:a16="http://schemas.microsoft.com/office/drawing/2014/main" id="{4EAF388B-0316-464B-B2D3-3413018B8BFB}"/>
+                <a16:creationId xmlns:a16="http://schemas.microsoft.com/office/drawing/2014/main" id="{CA05B86D-0377-4D0C-9038-E0680F05CF80}"/>
               </a:ext>
             </a:extLst>
           </p:cNvPr>
@@ -13329,7 +13329,7 @@
           <p:cNvPr id="24" name="">
             <a:extLst xmlns:a="http://schemas.openxmlformats.org/drawingml/2006/main">
               <a:ext uri="{FF2B5EF4-FFF2-40B4-BE49-F238E27FC236}">
-                <a16:creationId xmlns:a16="http://schemas.microsoft.com/office/drawing/2014/main" id="{7A1012C6-FF66-4EF6-9AEF-6450055CC780}"/>
+                <a16:creationId xmlns:a16="http://schemas.microsoft.com/office/drawing/2014/main" id="{D56080C3-CF35-4B55-9639-3E2776C3C9C4}"/>
               </a:ext>
             </a:extLst>
           </p:cNvPr>
@@ -13370,7 +13370,7 @@
           <p:cNvPr id="25" name="">
             <a:extLst xmlns:a="http://schemas.openxmlformats.org/drawingml/2006/main">
               <a:ext uri="{FF2B5EF4-FFF2-40B4-BE49-F238E27FC236}">
-                <a16:creationId xmlns:a16="http://schemas.microsoft.com/office/drawing/2014/main" id="{E62533B5-9F40-47C9-9FDB-FC45EB1D8E19}"/>
+                <a16:creationId xmlns:a16="http://schemas.microsoft.com/office/drawing/2014/main" id="{D2A535F5-EB34-4C5B-985D-9B257F9AA4FC}"/>
               </a:ext>
             </a:extLst>
           </p:cNvPr>
@@ -13420,7 +13420,7 @@
           <p:cNvPr id="26" name="">
             <a:extLst xmlns:a="http://schemas.openxmlformats.org/drawingml/2006/main">
               <a:ext uri="{FF2B5EF4-FFF2-40B4-BE49-F238E27FC236}">
-                <a16:creationId xmlns:a16="http://schemas.microsoft.com/office/drawing/2014/main" id="{DADFC95C-3B0B-4FBE-A116-8128AB46F881}"/>
+                <a16:creationId xmlns:a16="http://schemas.microsoft.com/office/drawing/2014/main" id="{BD307A9F-B5EB-417D-8907-D4BAF2600034}"/>
               </a:ext>
             </a:extLst>
           </p:cNvPr>
@@ -13470,7 +13470,7 @@
           <p:cNvPr id="27" name="">
             <a:extLst xmlns:a="http://schemas.openxmlformats.org/drawingml/2006/main">
               <a:ext uri="{FF2B5EF4-FFF2-40B4-BE49-F238E27FC236}">
-                <a16:creationId xmlns:a16="http://schemas.microsoft.com/office/drawing/2014/main" id="{F98560D1-C01C-4D6E-9696-1987AF4CC4B6}"/>
+                <a16:creationId xmlns:a16="http://schemas.microsoft.com/office/drawing/2014/main" id="{7F0C4C40-3F59-44C4-B185-9D0119689C2C}"/>
               </a:ext>
             </a:extLst>
           </p:cNvPr>
@@ -13501,7 +13501,7 @@
           <p:cNvPr id="28" name="source-2">
             <a:extLst xmlns:a="http://schemas.openxmlformats.org/drawingml/2006/main">
               <a:ext uri="{FF2B5EF4-FFF2-40B4-BE49-F238E27FC236}">
-                <a16:creationId xmlns:a16="http://schemas.microsoft.com/office/drawing/2014/main" id="{EF4A0242-4032-4D4A-9EAE-6D1AC47B3E13}"/>
+                <a16:creationId xmlns:a16="http://schemas.microsoft.com/office/drawing/2014/main" id="{0F979E75-7588-4B51-B64C-055E8C570851}"/>
               </a:ext>
             </a:extLst>
           </p:cNvPr>
@@ -13551,7 +13551,7 @@
           <p:cNvPr id="29" name="page-2">
             <a:extLst xmlns:a="http://schemas.openxmlformats.org/drawingml/2006/main">
               <a:ext uri="{FF2B5EF4-FFF2-40B4-BE49-F238E27FC236}">
-                <a16:creationId xmlns:a16="http://schemas.microsoft.com/office/drawing/2014/main" id="{298227C0-EF5E-4FD9-8C72-80A910353FDD}"/>
+                <a16:creationId xmlns:a16="http://schemas.microsoft.com/office/drawing/2014/main" id="{D99FF97B-59FE-470A-86EE-87C88F7A5130}"/>
               </a:ext>
             </a:extLst>
           </p:cNvPr>
@@ -13599,7 +13599,7 @@
     </p:spTree>
     <p:extLst>
       <p:ext uri="{BB962C8B-B14F-4D97-AF65-F5344CB8AC3E}">
-        <p14:creationId xmlns:p14="http://schemas.microsoft.com/office/powerpoint/2010/main" val="1644943122"/>
+        <p14:creationId xmlns:p14="http://schemas.microsoft.com/office/powerpoint/2010/main" val="2118966615"/>
       </p:ext>
     </p:extLst>
   </p:cSld>
@@ -13630,7 +13630,7 @@
           <p:cNvPr id="30" name="kicker-3">
             <a:extLst xmlns:a="http://schemas.openxmlformats.org/drawingml/2006/main">
               <a:ext uri="{FF2B5EF4-FFF2-40B4-BE49-F238E27FC236}">
-                <a16:creationId xmlns:a16="http://schemas.microsoft.com/office/drawing/2014/main" id="{22D880ED-10CC-4BEE-BA91-47A5ED67E3D1}"/>
+                <a16:creationId xmlns:a16="http://schemas.microsoft.com/office/drawing/2014/main" id="{B61467C4-E471-42F4-B02A-78A4F4875D79}"/>
               </a:ext>
             </a:extLst>
           </p:cNvPr>
@@ -13680,7 +13680,7 @@
           <p:cNvPr id="2" name="title-3">
             <a:extLst xmlns:a="http://schemas.openxmlformats.org/drawingml/2006/main">
               <a:ext uri="{FF2B5EF4-FFF2-40B4-BE49-F238E27FC236}">
-                <a16:creationId xmlns:a16="http://schemas.microsoft.com/office/drawing/2014/main" id="{F777AD0E-3BB7-4C9D-88AC-875166229A12}"/>
+                <a16:creationId xmlns:a16="http://schemas.microsoft.com/office/drawing/2014/main" id="{BE17C739-6F38-4040-B03A-1D3284D95192}"/>
               </a:ext>
             </a:extLst>
           </p:cNvPr>
@@ -13730,7 +13730,7 @@
           <p:cNvPr id="3" name="">
             <a:extLst xmlns:a="http://schemas.openxmlformats.org/drawingml/2006/main">
               <a:ext uri="{FF2B5EF4-FFF2-40B4-BE49-F238E27FC236}">
-                <a16:creationId xmlns:a16="http://schemas.microsoft.com/office/drawing/2014/main" id="{0AE714CA-9362-44BC-A990-87F984A26F82}"/>
+                <a16:creationId xmlns:a16="http://schemas.microsoft.com/office/drawing/2014/main" id="{FD940233-DFD4-4E34-8BC1-CF38F0B9C2F8}"/>
               </a:ext>
             </a:extLst>
           </p:cNvPr>
@@ -13761,7 +13761,7 @@
           <p:cNvPr id="4" name="">
             <a:extLst xmlns:a="http://schemas.openxmlformats.org/drawingml/2006/main">
               <a:ext uri="{FF2B5EF4-FFF2-40B4-BE49-F238E27FC236}">
-                <a16:creationId xmlns:a16="http://schemas.microsoft.com/office/drawing/2014/main" id="{72FE9599-983B-43B1-8FB8-1B42A58FBA5D}"/>
+                <a16:creationId xmlns:a16="http://schemas.microsoft.com/office/drawing/2014/main" id="{7BD6C581-8B52-4CC4-8E2D-4C81093CEB70}"/>
               </a:ext>
             </a:extLst>
           </p:cNvPr>
@@ -13811,7 +13811,7 @@
           <p:cNvPr id="5" name="">
             <a:extLst xmlns:a="http://schemas.openxmlformats.org/drawingml/2006/main">
               <a:ext uri="{FF2B5EF4-FFF2-40B4-BE49-F238E27FC236}">
-                <a16:creationId xmlns:a16="http://schemas.microsoft.com/office/drawing/2014/main" id="{067FC395-424A-4586-880A-23E2C6E12225}"/>
+                <a16:creationId xmlns:a16="http://schemas.microsoft.com/office/drawing/2014/main" id="{685AB5A2-68E5-488C-8288-AEDE338C88E1}"/>
               </a:ext>
             </a:extLst>
           </p:cNvPr>
@@ -13844,7 +13844,7 @@
           <p:cNvPr id="6" name="">
             <a:extLst xmlns:a="http://schemas.openxmlformats.org/drawingml/2006/main">
               <a:ext uri="{FF2B5EF4-FFF2-40B4-BE49-F238E27FC236}">
-                <a16:creationId xmlns:a16="http://schemas.microsoft.com/office/drawing/2014/main" id="{1B1F0CE2-B637-4196-9D1D-A9BF7DD05C92}"/>
+                <a16:creationId xmlns:a16="http://schemas.microsoft.com/office/drawing/2014/main" id="{2DDF67A9-B0A2-42BC-8B79-123C49302AFD}"/>
               </a:ext>
             </a:extLst>
           </p:cNvPr>
@@ -13877,7 +13877,7 @@
           <p:cNvPr id="7" name="">
             <a:extLst xmlns:a="http://schemas.openxmlformats.org/drawingml/2006/main">
               <a:ext uri="{FF2B5EF4-FFF2-40B4-BE49-F238E27FC236}">
-                <a16:creationId xmlns:a16="http://schemas.microsoft.com/office/drawing/2014/main" id="{B46E9A39-A209-4D89-B873-3740FE6C8E70}"/>
+                <a16:creationId xmlns:a16="http://schemas.microsoft.com/office/drawing/2014/main" id="{47489E50-1A45-4FCD-A5E4-5571C534C006}"/>
               </a:ext>
             </a:extLst>
           </p:cNvPr>
@@ -13910,7 +13910,7 @@
           <p:cNvPr id="8" name="">
             <a:extLst xmlns:a="http://schemas.openxmlformats.org/drawingml/2006/main">
               <a:ext uri="{FF2B5EF4-FFF2-40B4-BE49-F238E27FC236}">
-                <a16:creationId xmlns:a16="http://schemas.microsoft.com/office/drawing/2014/main" id="{B7380227-7650-4F8F-BA1C-FA6048A2CE86}"/>
+                <a16:creationId xmlns:a16="http://schemas.microsoft.com/office/drawing/2014/main" id="{F2243D48-28D8-45CB-82AF-44634B38DDB8}"/>
               </a:ext>
             </a:extLst>
           </p:cNvPr>
@@ -13943,7 +13943,7 @@
           <p:cNvPr id="9" name="pipeline-0">
             <a:extLst xmlns:a="http://schemas.openxmlformats.org/drawingml/2006/main">
               <a:ext uri="{FF2B5EF4-FFF2-40B4-BE49-F238E27FC236}">
-                <a16:creationId xmlns:a16="http://schemas.microsoft.com/office/drawing/2014/main" id="{3D92346C-E53C-40A6-A57C-CC6810AA8D8A}"/>
+                <a16:creationId xmlns:a16="http://schemas.microsoft.com/office/drawing/2014/main" id="{47FEA968-353B-4191-A3E2-3F4C2EC3E746}"/>
               </a:ext>
             </a:extLst>
           </p:cNvPr>
@@ -13984,7 +13984,7 @@
           <p:cNvPr id="10" name="">
             <a:extLst xmlns:a="http://schemas.openxmlformats.org/drawingml/2006/main">
               <a:ext uri="{FF2B5EF4-FFF2-40B4-BE49-F238E27FC236}">
-                <a16:creationId xmlns:a16="http://schemas.microsoft.com/office/drawing/2014/main" id="{AAA47581-DE03-466E-9DD6-129B879F48A0}"/>
+                <a16:creationId xmlns:a16="http://schemas.microsoft.com/office/drawing/2014/main" id="{3CEE776C-FE6F-4032-BA74-BA7EB81BC73C}"/>
               </a:ext>
             </a:extLst>
           </p:cNvPr>
@@ -14034,7 +14034,7 @@
           <p:cNvPr id="11" name="">
             <a:extLst xmlns:a="http://schemas.openxmlformats.org/drawingml/2006/main">
               <a:ext uri="{FF2B5EF4-FFF2-40B4-BE49-F238E27FC236}">
-                <a16:creationId xmlns:a16="http://schemas.microsoft.com/office/drawing/2014/main" id="{8DCE2CAD-84E8-4CA9-A5AD-AA03E94DA3FC}"/>
+                <a16:creationId xmlns:a16="http://schemas.microsoft.com/office/drawing/2014/main" id="{CD660309-BEF3-470B-97A5-4CC7652B1C04}"/>
               </a:ext>
             </a:extLst>
           </p:cNvPr>
@@ -14101,7 +14101,7 @@
           <p:cNvPr id="12" name="pipeline-1">
             <a:extLst xmlns:a="http://schemas.openxmlformats.org/drawingml/2006/main">
               <a:ext uri="{FF2B5EF4-FFF2-40B4-BE49-F238E27FC236}">
-                <a16:creationId xmlns:a16="http://schemas.microsoft.com/office/drawing/2014/main" id="{EB245E9A-5A97-4770-8F69-53568595D8A4}"/>
+                <a16:creationId xmlns:a16="http://schemas.microsoft.com/office/drawing/2014/main" id="{25A0EDE7-5784-4941-93A2-288CD83DCE5D}"/>
               </a:ext>
             </a:extLst>
           </p:cNvPr>
@@ -14142,7 +14142,7 @@
           <p:cNvPr id="13" name="">
             <a:extLst xmlns:a="http://schemas.openxmlformats.org/drawingml/2006/main">
               <a:ext uri="{FF2B5EF4-FFF2-40B4-BE49-F238E27FC236}">
-                <a16:creationId xmlns:a16="http://schemas.microsoft.com/office/drawing/2014/main" id="{A09858EA-F37A-46D9-8F06-F3B7E0E6E4D1}"/>
+                <a16:creationId xmlns:a16="http://schemas.microsoft.com/office/drawing/2014/main" id="{F66EC480-DE8D-4EFF-8EA0-51DE31B183D2}"/>
               </a:ext>
             </a:extLst>
           </p:cNvPr>
@@ -14192,7 +14192,7 @@
           <p:cNvPr id="14" name="">
             <a:extLst xmlns:a="http://schemas.openxmlformats.org/drawingml/2006/main">
               <a:ext uri="{FF2B5EF4-FFF2-40B4-BE49-F238E27FC236}">
-                <a16:creationId xmlns:a16="http://schemas.microsoft.com/office/drawing/2014/main" id="{762E15F4-6816-4D86-83FB-1A76E1AF4E52}"/>
+                <a16:creationId xmlns:a16="http://schemas.microsoft.com/office/drawing/2014/main" id="{BE3D061D-371C-4228-8399-5EE383A7071F}"/>
               </a:ext>
             </a:extLst>
           </p:cNvPr>
@@ -14259,7 +14259,7 @@
           <p:cNvPr id="15" name="pipeline-2">
             <a:extLst xmlns:a="http://schemas.openxmlformats.org/drawingml/2006/main">
               <a:ext uri="{FF2B5EF4-FFF2-40B4-BE49-F238E27FC236}">
-                <a16:creationId xmlns:a16="http://schemas.microsoft.com/office/drawing/2014/main" id="{38CE50BE-E4B5-45D9-8F7E-F9C9D1FA27F9}"/>
+                <a16:creationId xmlns:a16="http://schemas.microsoft.com/office/drawing/2014/main" id="{4296F9FA-D919-4E2E-8DC5-C36D8AF60870}"/>
               </a:ext>
             </a:extLst>
           </p:cNvPr>
@@ -14300,7 +14300,7 @@
           <p:cNvPr id="16" name="">
             <a:extLst xmlns:a="http://schemas.openxmlformats.org/drawingml/2006/main">
               <a:ext uri="{FF2B5EF4-FFF2-40B4-BE49-F238E27FC236}">
-                <a16:creationId xmlns:a16="http://schemas.microsoft.com/office/drawing/2014/main" id="{DCFCACED-EEB5-465A-B065-D2C71C76665D}"/>
+                <a16:creationId xmlns:a16="http://schemas.microsoft.com/office/drawing/2014/main" id="{6CB89BF5-4C97-42FF-A318-94A19E118EC9}"/>
               </a:ext>
             </a:extLst>
           </p:cNvPr>
@@ -14350,7 +14350,7 @@
           <p:cNvPr id="17" name="">
             <a:extLst xmlns:a="http://schemas.openxmlformats.org/drawingml/2006/main">
               <a:ext uri="{FF2B5EF4-FFF2-40B4-BE49-F238E27FC236}">
-                <a16:creationId xmlns:a16="http://schemas.microsoft.com/office/drawing/2014/main" id="{7FCD0C8A-A6B1-42E2-8BAD-A7FD6D45E448}"/>
+                <a16:creationId xmlns:a16="http://schemas.microsoft.com/office/drawing/2014/main" id="{CFA43481-11BC-415A-8132-02E185B25D0A}"/>
               </a:ext>
             </a:extLst>
           </p:cNvPr>
@@ -14417,7 +14417,7 @@
           <p:cNvPr id="18" name="pipeline-3">
             <a:extLst xmlns:a="http://schemas.openxmlformats.org/drawingml/2006/main">
               <a:ext uri="{FF2B5EF4-FFF2-40B4-BE49-F238E27FC236}">
-                <a16:creationId xmlns:a16="http://schemas.microsoft.com/office/drawing/2014/main" id="{4AF82569-597B-4DAF-9D54-49DAEE0B0470}"/>
+                <a16:creationId xmlns:a16="http://schemas.microsoft.com/office/drawing/2014/main" id="{70B442B2-7888-4C5F-8CEE-C5F5F6A025EF}"/>
               </a:ext>
             </a:extLst>
           </p:cNvPr>
@@ -14458,7 +14458,7 @@
           <p:cNvPr id="19" name="">
             <a:extLst xmlns:a="http://schemas.openxmlformats.org/drawingml/2006/main">
               <a:ext uri="{FF2B5EF4-FFF2-40B4-BE49-F238E27FC236}">
-                <a16:creationId xmlns:a16="http://schemas.microsoft.com/office/drawing/2014/main" id="{61757D5D-E99E-4ECC-BBC4-F22BAA72670C}"/>
+                <a16:creationId xmlns:a16="http://schemas.microsoft.com/office/drawing/2014/main" id="{5E83B1DB-E7E9-4494-819A-8E961AE447BD}"/>
               </a:ext>
             </a:extLst>
           </p:cNvPr>
@@ -14508,7 +14508,7 @@
           <p:cNvPr id="20" name="">
             <a:extLst xmlns:a="http://schemas.openxmlformats.org/drawingml/2006/main">
               <a:ext uri="{FF2B5EF4-FFF2-40B4-BE49-F238E27FC236}">
-                <a16:creationId xmlns:a16="http://schemas.microsoft.com/office/drawing/2014/main" id="{FF0A376C-C844-4B95-B6BF-4F51DC309241}"/>
+                <a16:creationId xmlns:a16="http://schemas.microsoft.com/office/drawing/2014/main" id="{47D17432-AA13-4E40-8E7D-D03F45CEB7A6}"/>
               </a:ext>
             </a:extLst>
           </p:cNvPr>
@@ -14575,7 +14575,7 @@
           <p:cNvPr id="21" name="pipeline-4">
             <a:extLst xmlns:a="http://schemas.openxmlformats.org/drawingml/2006/main">
               <a:ext uri="{FF2B5EF4-FFF2-40B4-BE49-F238E27FC236}">
-                <a16:creationId xmlns:a16="http://schemas.microsoft.com/office/drawing/2014/main" id="{4888943F-9DD1-4308-B28C-A645FD40A8E3}"/>
+                <a16:creationId xmlns:a16="http://schemas.microsoft.com/office/drawing/2014/main" id="{724903D4-28F7-4213-B923-105D9BC4C634}"/>
               </a:ext>
             </a:extLst>
           </p:cNvPr>
@@ -14616,7 +14616,7 @@
           <p:cNvPr id="22" name="">
             <a:extLst xmlns:a="http://schemas.openxmlformats.org/drawingml/2006/main">
               <a:ext uri="{FF2B5EF4-FFF2-40B4-BE49-F238E27FC236}">
-                <a16:creationId xmlns:a16="http://schemas.microsoft.com/office/drawing/2014/main" id="{94852F1E-5684-4867-B2E8-7AD04EF9C6BF}"/>
+                <a16:creationId xmlns:a16="http://schemas.microsoft.com/office/drawing/2014/main" id="{63376F8C-DBCF-4DE1-97D2-94A840AB3C35}"/>
               </a:ext>
             </a:extLst>
           </p:cNvPr>
@@ -14666,7 +14666,7 @@
           <p:cNvPr id="23" name="">
             <a:extLst xmlns:a="http://schemas.openxmlformats.org/drawingml/2006/main">
               <a:ext uri="{FF2B5EF4-FFF2-40B4-BE49-F238E27FC236}">
-                <a16:creationId xmlns:a16="http://schemas.microsoft.com/office/drawing/2014/main" id="{F765FDE4-1387-46A5-BBDC-330C6ED10790}"/>
+                <a16:creationId xmlns:a16="http://schemas.microsoft.com/office/drawing/2014/main" id="{5B56EDAA-ED8B-4836-B539-E6F033CC9798}"/>
               </a:ext>
             </a:extLst>
           </p:cNvPr>
@@ -14733,7 +14733,7 @@
           <p:cNvPr id="24" name="">
             <a:extLst xmlns:a="http://schemas.openxmlformats.org/drawingml/2006/main">
               <a:ext uri="{FF2B5EF4-FFF2-40B4-BE49-F238E27FC236}">
-                <a16:creationId xmlns:a16="http://schemas.microsoft.com/office/drawing/2014/main" id="{1742A217-8236-4DF3-B9C4-DA15037F2C2E}"/>
+                <a16:creationId xmlns:a16="http://schemas.microsoft.com/office/drawing/2014/main" id="{0CCBD389-74E3-4439-953B-B768C89E7775}"/>
               </a:ext>
             </a:extLst>
           </p:cNvPr>
@@ -14783,7 +14783,7 @@
           <p:cNvPr id="25" name="">
             <a:extLst xmlns:a="http://schemas.openxmlformats.org/drawingml/2006/main">
               <a:ext uri="{FF2B5EF4-FFF2-40B4-BE49-F238E27FC236}">
-                <a16:creationId xmlns:a16="http://schemas.microsoft.com/office/drawing/2014/main" id="{B0D40EBB-104C-41C1-96B8-C3A19D8F9987}"/>
+                <a16:creationId xmlns:a16="http://schemas.microsoft.com/office/drawing/2014/main" id="{43568C9F-D533-4920-BD48-4FD3A4A25067}"/>
               </a:ext>
             </a:extLst>
           </p:cNvPr>
@@ -14833,7 +14833,7 @@
           <p:cNvPr id="26" name="">
             <a:extLst xmlns:a="http://schemas.openxmlformats.org/drawingml/2006/main">
               <a:ext uri="{FF2B5EF4-FFF2-40B4-BE49-F238E27FC236}">
-                <a16:creationId xmlns:a16="http://schemas.microsoft.com/office/drawing/2014/main" id="{CF2CAECC-F4AD-43B6-9F05-6B09D7FD86B8}"/>
+                <a16:creationId xmlns:a16="http://schemas.microsoft.com/office/drawing/2014/main" id="{FD30615A-7D2C-4B2B-8107-41F5C8456A4A}"/>
               </a:ext>
             </a:extLst>
           </p:cNvPr>
@@ -14883,7 +14883,7 @@
           <p:cNvPr id="27" name="">
             <a:extLst xmlns:a="http://schemas.openxmlformats.org/drawingml/2006/main">
               <a:ext uri="{FF2B5EF4-FFF2-40B4-BE49-F238E27FC236}">
-                <a16:creationId xmlns:a16="http://schemas.microsoft.com/office/drawing/2014/main" id="{B93F4C7D-1FF0-4CE5-A513-06A14BE090FD}"/>
+                <a16:creationId xmlns:a16="http://schemas.microsoft.com/office/drawing/2014/main" id="{34BA0A81-6071-464E-B633-6B5E1055B518}"/>
               </a:ext>
             </a:extLst>
           </p:cNvPr>
@@ -14914,7 +14914,7 @@
           <p:cNvPr id="28" name="source-3">
             <a:extLst xmlns:a="http://schemas.openxmlformats.org/drawingml/2006/main">
               <a:ext uri="{FF2B5EF4-FFF2-40B4-BE49-F238E27FC236}">
-                <a16:creationId xmlns:a16="http://schemas.microsoft.com/office/drawing/2014/main" id="{ADB9AA83-A714-47B8-9D36-8C6E240E1A61}"/>
+                <a16:creationId xmlns:a16="http://schemas.microsoft.com/office/drawing/2014/main" id="{F93DD858-C72B-41D2-8A67-DD21C12DC3D5}"/>
               </a:ext>
             </a:extLst>
           </p:cNvPr>
@@ -14964,7 +14964,7 @@
           <p:cNvPr id="29" name="page-3">
             <a:extLst xmlns:a="http://schemas.openxmlformats.org/drawingml/2006/main">
               <a:ext uri="{FF2B5EF4-FFF2-40B4-BE49-F238E27FC236}">
-                <a16:creationId xmlns:a16="http://schemas.microsoft.com/office/drawing/2014/main" id="{4B992F04-3CBF-4AA0-87CC-F22FCB12CC2E}"/>
+                <a16:creationId xmlns:a16="http://schemas.microsoft.com/office/drawing/2014/main" id="{8DC4715B-0E33-4CB6-9900-8C70CE3D97E0}"/>
               </a:ext>
             </a:extLst>
           </p:cNvPr>
@@ -15012,7 +15012,7 @@
     </p:spTree>
     <p:extLst>
       <p:ext uri="{BB962C8B-B14F-4D97-AF65-F5344CB8AC3E}">
-        <p14:creationId xmlns:p14="http://schemas.microsoft.com/office/powerpoint/2010/main" val="431526574"/>
+        <p14:creationId xmlns:p14="http://schemas.microsoft.com/office/powerpoint/2010/main" val="731911166"/>
       </p:ext>
     </p:extLst>
   </p:cSld>
@@ -15043,7 +15043,7 @@
           <p:cNvPr id="49" name="kicker-4">
             <a:extLst xmlns:a="http://schemas.openxmlformats.org/drawingml/2006/main">
               <a:ext uri="{FF2B5EF4-FFF2-40B4-BE49-F238E27FC236}">
-                <a16:creationId xmlns:a16="http://schemas.microsoft.com/office/drawing/2014/main" id="{F3770956-D3DF-465C-BD32-B51EEF66C21D}"/>
+                <a16:creationId xmlns:a16="http://schemas.microsoft.com/office/drawing/2014/main" id="{9F3A29E2-1221-4468-9114-7CE5D9E89E55}"/>
               </a:ext>
             </a:extLst>
           </p:cNvPr>
@@ -15093,7 +15093,7 @@
           <p:cNvPr id="2" name="title-4">
             <a:extLst xmlns:a="http://schemas.openxmlformats.org/drawingml/2006/main">
               <a:ext uri="{FF2B5EF4-FFF2-40B4-BE49-F238E27FC236}">
-                <a16:creationId xmlns:a16="http://schemas.microsoft.com/office/drawing/2014/main" id="{C55925CE-21AD-4E90-8E90-8CF0F64B0AD2}"/>
+                <a16:creationId xmlns:a16="http://schemas.microsoft.com/office/drawing/2014/main" id="{2B0C3459-5559-4C4D-A634-289E195EFC5D}"/>
               </a:ext>
             </a:extLst>
           </p:cNvPr>
@@ -15143,7 +15143,7 @@
           <p:cNvPr id="3" name="">
             <a:extLst xmlns:a="http://schemas.openxmlformats.org/drawingml/2006/main">
               <a:ext uri="{FF2B5EF4-FFF2-40B4-BE49-F238E27FC236}">
-                <a16:creationId xmlns:a16="http://schemas.microsoft.com/office/drawing/2014/main" id="{F270F2F1-50EC-42C7-8C9B-C02BFADD878B}"/>
+                <a16:creationId xmlns:a16="http://schemas.microsoft.com/office/drawing/2014/main" id="{7FF0CF03-89CE-4D31-97E5-90C4D5415286}"/>
               </a:ext>
             </a:extLst>
           </p:cNvPr>
@@ -15174,7 +15174,7 @@
           <p:cNvPr id="4" name="">
             <a:extLst xmlns:a="http://schemas.openxmlformats.org/drawingml/2006/main">
               <a:ext uri="{FF2B5EF4-FFF2-40B4-BE49-F238E27FC236}">
-                <a16:creationId xmlns:a16="http://schemas.microsoft.com/office/drawing/2014/main" id="{F1154465-AC73-4FF3-80A9-F222CC4DB665}"/>
+                <a16:creationId xmlns:a16="http://schemas.microsoft.com/office/drawing/2014/main" id="{042CFD87-2786-49E4-9E4F-E650B08F9E42}"/>
               </a:ext>
             </a:extLst>
           </p:cNvPr>
@@ -15224,7 +15224,7 @@
           <p:cNvPr id="5" name="">
             <a:extLst xmlns:a="http://schemas.openxmlformats.org/drawingml/2006/main">
               <a:ext uri="{FF2B5EF4-FFF2-40B4-BE49-F238E27FC236}">
-                <a16:creationId xmlns:a16="http://schemas.microsoft.com/office/drawing/2014/main" id="{F0A5411D-B21A-4571-8BB3-5F2EFDFE8B79}"/>
+                <a16:creationId xmlns:a16="http://schemas.microsoft.com/office/drawing/2014/main" id="{D34C3FE4-5F11-47A0-AA4E-BADE0B3DB655}"/>
               </a:ext>
             </a:extLst>
           </p:cNvPr>
@@ -15257,7 +15257,7 @@
           <p:cNvPr id="6" name="">
             <a:extLst xmlns:a="http://schemas.openxmlformats.org/drawingml/2006/main">
               <a:ext uri="{FF2B5EF4-FFF2-40B4-BE49-F238E27FC236}">
-                <a16:creationId xmlns:a16="http://schemas.microsoft.com/office/drawing/2014/main" id="{1BB0C206-BEF9-4DF4-A419-5FB89813341B}"/>
+                <a16:creationId xmlns:a16="http://schemas.microsoft.com/office/drawing/2014/main" id="{F11245FD-0B7E-4D70-81A9-3DEB252C7FCF}"/>
               </a:ext>
             </a:extLst>
           </p:cNvPr>
@@ -15290,7 +15290,7 @@
           <p:cNvPr id="7" name="">
             <a:extLst xmlns:a="http://schemas.openxmlformats.org/drawingml/2006/main">
               <a:ext uri="{FF2B5EF4-FFF2-40B4-BE49-F238E27FC236}">
-                <a16:creationId xmlns:a16="http://schemas.microsoft.com/office/drawing/2014/main" id="{DC7376AC-CB55-4F88-939D-B65386772127}"/>
+                <a16:creationId xmlns:a16="http://schemas.microsoft.com/office/drawing/2014/main" id="{38B47B91-D37D-46CE-B12E-0FA40E89D44F}"/>
               </a:ext>
             </a:extLst>
           </p:cNvPr>
@@ -15323,7 +15323,7 @@
           <p:cNvPr id="8" name="">
             <a:extLst xmlns:a="http://schemas.openxmlformats.org/drawingml/2006/main">
               <a:ext uri="{FF2B5EF4-FFF2-40B4-BE49-F238E27FC236}">
-                <a16:creationId xmlns:a16="http://schemas.microsoft.com/office/drawing/2014/main" id="{EFCADD07-D045-4334-8985-D7D28168B6F5}"/>
+                <a16:creationId xmlns:a16="http://schemas.microsoft.com/office/drawing/2014/main" id="{527E705D-5DC8-42B1-8C3D-A1790195D05A}"/>
               </a:ext>
             </a:extLst>
           </p:cNvPr>
@@ -15356,7 +15356,7 @@
           <p:cNvPr id="9" name="">
             <a:extLst xmlns:a="http://schemas.openxmlformats.org/drawingml/2006/main">
               <a:ext uri="{FF2B5EF4-FFF2-40B4-BE49-F238E27FC236}">
-                <a16:creationId xmlns:a16="http://schemas.microsoft.com/office/drawing/2014/main" id="{7248CB93-5EC2-4620-A532-8FD32149234D}"/>
+                <a16:creationId xmlns:a16="http://schemas.microsoft.com/office/drawing/2014/main" id="{3615CE5E-20BA-411A-B9F4-8155EB90FEEF}"/>
               </a:ext>
             </a:extLst>
           </p:cNvPr>
@@ -15389,7 +15389,7 @@
           <p:cNvPr id="10" name="">
             <a:extLst xmlns:a="http://schemas.openxmlformats.org/drawingml/2006/main">
               <a:ext uri="{FF2B5EF4-FFF2-40B4-BE49-F238E27FC236}">
-                <a16:creationId xmlns:a16="http://schemas.microsoft.com/office/drawing/2014/main" id="{1686CA34-57FA-4DD4-BA19-9F2388285F29}"/>
+                <a16:creationId xmlns:a16="http://schemas.microsoft.com/office/drawing/2014/main" id="{FF512F77-0CC5-44B8-B192-E4568CB4ABF1}"/>
               </a:ext>
             </a:extLst>
           </p:cNvPr>
@@ -15422,7 +15422,7 @@
           <p:cNvPr id="11" name="">
             <a:extLst xmlns:a="http://schemas.openxmlformats.org/drawingml/2006/main">
               <a:ext uri="{FF2B5EF4-FFF2-40B4-BE49-F238E27FC236}">
-                <a16:creationId xmlns:a16="http://schemas.microsoft.com/office/drawing/2014/main" id="{EEACDBE3-1EA3-4FFD-B8A7-28816010C342}"/>
+                <a16:creationId xmlns:a16="http://schemas.microsoft.com/office/drawing/2014/main" id="{59B66290-E55E-44E6-A36D-A205887DD27D}"/>
               </a:ext>
             </a:extLst>
           </p:cNvPr>
@@ -15455,7 +15455,7 @@
           <p:cNvPr id="12" name="">
             <a:extLst xmlns:a="http://schemas.openxmlformats.org/drawingml/2006/main">
               <a:ext uri="{FF2B5EF4-FFF2-40B4-BE49-F238E27FC236}">
-                <a16:creationId xmlns:a16="http://schemas.microsoft.com/office/drawing/2014/main" id="{FE2E6800-5B74-4761-BABA-575E79D8A0AE}"/>
+                <a16:creationId xmlns:a16="http://schemas.microsoft.com/office/drawing/2014/main" id="{8369D14A-B57F-40D3-AE7B-D10869BBBE2E}"/>
               </a:ext>
             </a:extLst>
           </p:cNvPr>
@@ -15488,7 +15488,7 @@
           <p:cNvPr id="13" name="">
             <a:extLst xmlns:a="http://schemas.openxmlformats.org/drawingml/2006/main">
               <a:ext uri="{FF2B5EF4-FFF2-40B4-BE49-F238E27FC236}">
-                <a16:creationId xmlns:a16="http://schemas.microsoft.com/office/drawing/2014/main" id="{B82D4D4E-3146-40DD-B953-A0D8BABA2E1E}"/>
+                <a16:creationId xmlns:a16="http://schemas.microsoft.com/office/drawing/2014/main" id="{1A0133B5-F642-4C94-9E94-5E1A68C21DA8}"/>
               </a:ext>
             </a:extLst>
           </p:cNvPr>
@@ -15529,7 +15529,7 @@
           <p:cNvPr id="14" name="">
             <a:extLst xmlns:a="http://schemas.openxmlformats.org/drawingml/2006/main">
               <a:ext uri="{FF2B5EF4-FFF2-40B4-BE49-F238E27FC236}">
-                <a16:creationId xmlns:a16="http://schemas.microsoft.com/office/drawing/2014/main" id="{19B7BAE8-5DA5-45FE-A2B4-F800A5F52989}"/>
+                <a16:creationId xmlns:a16="http://schemas.microsoft.com/office/drawing/2014/main" id="{DE880372-1C2D-4CB8-9DCC-7002FD4715DE}"/>
               </a:ext>
             </a:extLst>
           </p:cNvPr>
@@ -15579,7 +15579,7 @@
           <p:cNvPr id="15" name="">
             <a:extLst xmlns:a="http://schemas.openxmlformats.org/drawingml/2006/main">
               <a:ext uri="{FF2B5EF4-FFF2-40B4-BE49-F238E27FC236}">
-                <a16:creationId xmlns:a16="http://schemas.microsoft.com/office/drawing/2014/main" id="{9745BFE1-57F3-443E-8932-6B2F6DBE1F6C}"/>
+                <a16:creationId xmlns:a16="http://schemas.microsoft.com/office/drawing/2014/main" id="{DEB854DF-94FC-49B0-AE7F-5A76B79B7293}"/>
               </a:ext>
             </a:extLst>
           </p:cNvPr>
@@ -15629,7 +15629,7 @@
           <p:cNvPr id="16" name="">
             <a:extLst xmlns:a="http://schemas.openxmlformats.org/drawingml/2006/main">
               <a:ext uri="{FF2B5EF4-FFF2-40B4-BE49-F238E27FC236}">
-                <a16:creationId xmlns:a16="http://schemas.microsoft.com/office/drawing/2014/main" id="{FBD0C670-5F98-436F-9D56-2C304F8C6F56}"/>
+                <a16:creationId xmlns:a16="http://schemas.microsoft.com/office/drawing/2014/main" id="{CE5C03C8-AACB-45E3-9306-D6A9D9CDF95C}"/>
               </a:ext>
             </a:extLst>
           </p:cNvPr>
@@ -15662,7 +15662,7 @@
           <p:cNvPr id="17" name="">
             <a:extLst xmlns:a="http://schemas.openxmlformats.org/drawingml/2006/main">
               <a:ext uri="{FF2B5EF4-FFF2-40B4-BE49-F238E27FC236}">
-                <a16:creationId xmlns:a16="http://schemas.microsoft.com/office/drawing/2014/main" id="{0D1E5AA6-B55A-4142-AEC3-1E3E9188CA28}"/>
+                <a16:creationId xmlns:a16="http://schemas.microsoft.com/office/drawing/2014/main" id="{664F09DA-B9C6-49E4-8464-006A551A00D1}"/>
               </a:ext>
             </a:extLst>
           </p:cNvPr>
@@ -15729,7 +15729,7 @@
           <p:cNvPr id="18" name="">
             <a:extLst xmlns:a="http://schemas.openxmlformats.org/drawingml/2006/main">
               <a:ext uri="{FF2B5EF4-FFF2-40B4-BE49-F238E27FC236}">
-                <a16:creationId xmlns:a16="http://schemas.microsoft.com/office/drawing/2014/main" id="{64C50910-C0F5-4552-8356-2F1E1E1F9A83}"/>
+                <a16:creationId xmlns:a16="http://schemas.microsoft.com/office/drawing/2014/main" id="{36488B1E-5E64-4D66-82A3-0349A8B5FDA3}"/>
               </a:ext>
             </a:extLst>
           </p:cNvPr>
@@ -15762,7 +15762,7 @@
           <p:cNvPr id="19" name="">
             <a:extLst xmlns:a="http://schemas.openxmlformats.org/drawingml/2006/main">
               <a:ext uri="{FF2B5EF4-FFF2-40B4-BE49-F238E27FC236}">
-                <a16:creationId xmlns:a16="http://schemas.microsoft.com/office/drawing/2014/main" id="{6CB007AC-2325-49C3-A460-51892E46F6EB}"/>
+                <a16:creationId xmlns:a16="http://schemas.microsoft.com/office/drawing/2014/main" id="{851D6612-13E6-45A2-9F0D-12BCD8724060}"/>
               </a:ext>
             </a:extLst>
           </p:cNvPr>
@@ -15829,7 +15829,7 @@
           <p:cNvPr id="20" name="">
             <a:extLst xmlns:a="http://schemas.openxmlformats.org/drawingml/2006/main">
               <a:ext uri="{FF2B5EF4-FFF2-40B4-BE49-F238E27FC236}">
-                <a16:creationId xmlns:a16="http://schemas.microsoft.com/office/drawing/2014/main" id="{CE6E395F-12B7-4B4F-B80A-E526B6E09E3B}"/>
+                <a16:creationId xmlns:a16="http://schemas.microsoft.com/office/drawing/2014/main" id="{D04359D0-40A4-4ABA-8957-FFF1B78FD945}"/>
               </a:ext>
             </a:extLst>
           </p:cNvPr>
@@ -15862,7 +15862,7 @@
           <p:cNvPr id="21" name="">
             <a:extLst xmlns:a="http://schemas.openxmlformats.org/drawingml/2006/main">
               <a:ext uri="{FF2B5EF4-FFF2-40B4-BE49-F238E27FC236}">
-                <a16:creationId xmlns:a16="http://schemas.microsoft.com/office/drawing/2014/main" id="{A67898C3-8A1E-4E44-B5E7-3F904A61ECB6}"/>
+                <a16:creationId xmlns:a16="http://schemas.microsoft.com/office/drawing/2014/main" id="{5BA6E8FF-30EB-403D-8BE1-8910960A68E9}"/>
               </a:ext>
             </a:extLst>
           </p:cNvPr>
@@ -15929,7 +15929,7 @@
           <p:cNvPr id="22" name="">
             <a:extLst xmlns:a="http://schemas.openxmlformats.org/drawingml/2006/main">
               <a:ext uri="{FF2B5EF4-FFF2-40B4-BE49-F238E27FC236}">
-                <a16:creationId xmlns:a16="http://schemas.microsoft.com/office/drawing/2014/main" id="{6F74641E-DFD8-4974-AAEF-0DF71B0E5F99}"/>
+                <a16:creationId xmlns:a16="http://schemas.microsoft.com/office/drawing/2014/main" id="{73A21A85-17BE-4FE5-A061-673601D29F31}"/>
               </a:ext>
             </a:extLst>
           </p:cNvPr>
@@ -15979,7 +15979,7 @@
           <p:cNvPr id="23" name="">
             <a:extLst xmlns:a="http://schemas.openxmlformats.org/drawingml/2006/main">
               <a:ext uri="{FF2B5EF4-FFF2-40B4-BE49-F238E27FC236}">
-                <a16:creationId xmlns:a16="http://schemas.microsoft.com/office/drawing/2014/main" id="{6969763D-B551-4F85-84A2-D26430EAB5A2}"/>
+                <a16:creationId xmlns:a16="http://schemas.microsoft.com/office/drawing/2014/main" id="{A1327364-6007-4F9D-87EF-CFDA47E15BC9}"/>
               </a:ext>
             </a:extLst>
           </p:cNvPr>
@@ -16029,7 +16029,7 @@
           <p:cNvPr id="24" name="">
             <a:extLst xmlns:a="http://schemas.openxmlformats.org/drawingml/2006/main">
               <a:ext uri="{FF2B5EF4-FFF2-40B4-BE49-F238E27FC236}">
-                <a16:creationId xmlns:a16="http://schemas.microsoft.com/office/drawing/2014/main" id="{50BC603B-0F84-4819-8559-83097C24AC0E}"/>
+                <a16:creationId xmlns:a16="http://schemas.microsoft.com/office/drawing/2014/main" id="{51263DDE-1994-4FCA-9E86-7B71F11993E5}"/>
               </a:ext>
             </a:extLst>
           </p:cNvPr>
@@ -16079,7 +16079,7 @@
           <p:cNvPr id="25" name="">
             <a:extLst xmlns:a="http://schemas.openxmlformats.org/drawingml/2006/main">
               <a:ext uri="{FF2B5EF4-FFF2-40B4-BE49-F238E27FC236}">
-                <a16:creationId xmlns:a16="http://schemas.microsoft.com/office/drawing/2014/main" id="{CCDBD7DF-5EF4-456C-B994-CB1EF3C5D71F}"/>
+                <a16:creationId xmlns:a16="http://schemas.microsoft.com/office/drawing/2014/main" id="{558718BA-9EC3-453C-A9F2-E35D7945EA27}"/>
               </a:ext>
             </a:extLst>
           </p:cNvPr>
@@ -16129,7 +16129,7 @@
           <p:cNvPr id="26" name="">
             <a:extLst xmlns:a="http://schemas.openxmlformats.org/drawingml/2006/main">
               <a:ext uri="{FF2B5EF4-FFF2-40B4-BE49-F238E27FC236}">
-                <a16:creationId xmlns:a16="http://schemas.microsoft.com/office/drawing/2014/main" id="{19126A0F-7091-4E6D-AC3A-DCFF7A737CDA}"/>
+                <a16:creationId xmlns:a16="http://schemas.microsoft.com/office/drawing/2014/main" id="{1613C312-C23D-4BBD-BC20-539BB89BF4C5}"/>
               </a:ext>
             </a:extLst>
           </p:cNvPr>
@@ -16179,7 +16179,7 @@
           <p:cNvPr id="27" name="">
             <a:extLst xmlns:a="http://schemas.openxmlformats.org/drawingml/2006/main">
               <a:ext uri="{FF2B5EF4-FFF2-40B4-BE49-F238E27FC236}">
-                <a16:creationId xmlns:a16="http://schemas.microsoft.com/office/drawing/2014/main" id="{248CE98F-2C08-44BB-BAEA-FF82F2A86ED5}"/>
+                <a16:creationId xmlns:a16="http://schemas.microsoft.com/office/drawing/2014/main" id="{ED5A6609-CA18-4390-8A74-3B017871116B}"/>
               </a:ext>
             </a:extLst>
           </p:cNvPr>
@@ -16229,7 +16229,7 @@
           <p:cNvPr id="28" name="">
             <a:extLst xmlns:a="http://schemas.openxmlformats.org/drawingml/2006/main">
               <a:ext uri="{FF2B5EF4-FFF2-40B4-BE49-F238E27FC236}">
-                <a16:creationId xmlns:a16="http://schemas.microsoft.com/office/drawing/2014/main" id="{D7FF8619-47A6-4C1F-BAFB-64EBA51FA7FA}"/>
+                <a16:creationId xmlns:a16="http://schemas.microsoft.com/office/drawing/2014/main" id="{EE05702A-0C67-420F-80D9-4479CE0C2442}"/>
               </a:ext>
             </a:extLst>
           </p:cNvPr>
@@ -16264,7 +16264,7 @@
           <p:cNvPr id="29" name="">
             <a:extLst xmlns:a="http://schemas.openxmlformats.org/drawingml/2006/main">
               <a:ext uri="{FF2B5EF4-FFF2-40B4-BE49-F238E27FC236}">
-                <a16:creationId xmlns:a16="http://schemas.microsoft.com/office/drawing/2014/main" id="{182A7141-716B-47F7-AABF-20212444B7D6}"/>
+                <a16:creationId xmlns:a16="http://schemas.microsoft.com/office/drawing/2014/main" id="{288650ED-888C-4EDF-A74A-FB6D22CD71ED}"/>
               </a:ext>
             </a:extLst>
           </p:cNvPr>
@@ -16331,7 +16331,7 @@
           <p:cNvPr id="30" name="">
             <a:extLst xmlns:a="http://schemas.openxmlformats.org/drawingml/2006/main">
               <a:ext uri="{FF2B5EF4-FFF2-40B4-BE49-F238E27FC236}">
-                <a16:creationId xmlns:a16="http://schemas.microsoft.com/office/drawing/2014/main" id="{E7753B00-DC18-4DE6-BCE2-AC61A51F61D2}"/>
+                <a16:creationId xmlns:a16="http://schemas.microsoft.com/office/drawing/2014/main" id="{D6CE71F1-8CB5-4444-950C-8D6B01BB390C}"/>
               </a:ext>
             </a:extLst>
           </p:cNvPr>
@@ -16398,7 +16398,7 @@
           <p:cNvPr id="31" name="">
             <a:extLst xmlns:a="http://schemas.openxmlformats.org/drawingml/2006/main">
               <a:ext uri="{FF2B5EF4-FFF2-40B4-BE49-F238E27FC236}">
-                <a16:creationId xmlns:a16="http://schemas.microsoft.com/office/drawing/2014/main" id="{502F6549-0232-40DD-BB28-CE7B96A6B91A}"/>
+                <a16:creationId xmlns:a16="http://schemas.microsoft.com/office/drawing/2014/main" id="{0F415C97-59F0-476F-B107-0AA5D8405279}"/>
               </a:ext>
             </a:extLst>
           </p:cNvPr>
@@ -16433,7 +16433,7 @@
           <p:cNvPr id="32" name="">
             <a:extLst xmlns:a="http://schemas.openxmlformats.org/drawingml/2006/main">
               <a:ext uri="{FF2B5EF4-FFF2-40B4-BE49-F238E27FC236}">
-                <a16:creationId xmlns:a16="http://schemas.microsoft.com/office/drawing/2014/main" id="{0D868773-FC40-4009-8945-A1864E55071D}"/>
+                <a16:creationId xmlns:a16="http://schemas.microsoft.com/office/drawing/2014/main" id="{73FD6DAE-0D6D-4490-AC83-0B81E2F0F129}"/>
               </a:ext>
             </a:extLst>
           </p:cNvPr>
@@ -16500,7 +16500,7 @@
           <p:cNvPr id="33" name="">
             <a:extLst xmlns:a="http://schemas.openxmlformats.org/drawingml/2006/main">
               <a:ext uri="{FF2B5EF4-FFF2-40B4-BE49-F238E27FC236}">
-                <a16:creationId xmlns:a16="http://schemas.microsoft.com/office/drawing/2014/main" id="{EA7D7DF7-2A0F-491F-822F-BF644AF5FF92}"/>
+                <a16:creationId xmlns:a16="http://schemas.microsoft.com/office/drawing/2014/main" id="{37360508-0719-4A8D-9580-68C0CF5158BA}"/>
               </a:ext>
             </a:extLst>
           </p:cNvPr>
@@ -16567,7 +16567,7 @@
           <p:cNvPr id="34" name="">
             <a:extLst xmlns:a="http://schemas.openxmlformats.org/drawingml/2006/main">
               <a:ext uri="{FF2B5EF4-FFF2-40B4-BE49-F238E27FC236}">
-                <a16:creationId xmlns:a16="http://schemas.microsoft.com/office/drawing/2014/main" id="{A41AA20A-A339-4E70-ACA0-E1B71A3A958F}"/>
+                <a16:creationId xmlns:a16="http://schemas.microsoft.com/office/drawing/2014/main" id="{35727961-A64C-46A8-B5AD-4D3DB00E40E6}"/>
               </a:ext>
             </a:extLst>
           </p:cNvPr>
@@ -16602,7 +16602,7 @@
           <p:cNvPr id="35" name="">
             <a:extLst xmlns:a="http://schemas.openxmlformats.org/drawingml/2006/main">
               <a:ext uri="{FF2B5EF4-FFF2-40B4-BE49-F238E27FC236}">
-                <a16:creationId xmlns:a16="http://schemas.microsoft.com/office/drawing/2014/main" id="{1388BAB1-8B40-4B56-80A2-2A2AA0D29B4E}"/>
+                <a16:creationId xmlns:a16="http://schemas.microsoft.com/office/drawing/2014/main" id="{B6A9D03F-EA33-4C78-B06B-A80E5E9B1CE8}"/>
               </a:ext>
             </a:extLst>
           </p:cNvPr>
@@ -16669,7 +16669,7 @@
           <p:cNvPr id="36" name="">
             <a:extLst xmlns:a="http://schemas.openxmlformats.org/drawingml/2006/main">
               <a:ext uri="{FF2B5EF4-FFF2-40B4-BE49-F238E27FC236}">
-                <a16:creationId xmlns:a16="http://schemas.microsoft.com/office/drawing/2014/main" id="{800ECCD2-3600-4604-8D5D-6E4C5BDE80FB}"/>
+                <a16:creationId xmlns:a16="http://schemas.microsoft.com/office/drawing/2014/main" id="{DD58D856-F908-4FE3-988D-1F310A84837F}"/>
               </a:ext>
             </a:extLst>
           </p:cNvPr>
@@ -16736,7 +16736,7 @@
           <p:cNvPr id="37" name="">
             <a:extLst xmlns:a="http://schemas.openxmlformats.org/drawingml/2006/main">
               <a:ext uri="{FF2B5EF4-FFF2-40B4-BE49-F238E27FC236}">
-                <a16:creationId xmlns:a16="http://schemas.microsoft.com/office/drawing/2014/main" id="{76178EA8-DE3F-4450-A574-C0604E38A53F}"/>
+                <a16:creationId xmlns:a16="http://schemas.microsoft.com/office/drawing/2014/main" id="{54ECC40C-34ED-4F4F-9CAE-A63396500667}"/>
               </a:ext>
             </a:extLst>
           </p:cNvPr>
@@ -16777,7 +16777,7 @@
           <p:cNvPr id="38" name="">
             <a:extLst xmlns:a="http://schemas.openxmlformats.org/drawingml/2006/main">
               <a:ext uri="{FF2B5EF4-FFF2-40B4-BE49-F238E27FC236}">
-                <a16:creationId xmlns:a16="http://schemas.microsoft.com/office/drawing/2014/main" id="{50B07A8A-6BBE-44A8-9FF2-F0986EBA860E}"/>
+                <a16:creationId xmlns:a16="http://schemas.microsoft.com/office/drawing/2014/main" id="{6D63C5D2-571E-4814-BCD7-119021C6703F}"/>
               </a:ext>
             </a:extLst>
           </p:cNvPr>
@@ -16827,7 +16827,7 @@
           <p:cNvPr id="39" name="">
             <a:extLst xmlns:a="http://schemas.openxmlformats.org/drawingml/2006/main">
               <a:ext uri="{FF2B5EF4-FFF2-40B4-BE49-F238E27FC236}">
-                <a16:creationId xmlns:a16="http://schemas.microsoft.com/office/drawing/2014/main" id="{254F35B7-B07B-47C0-8002-6F76D41EFB4E}"/>
+                <a16:creationId xmlns:a16="http://schemas.microsoft.com/office/drawing/2014/main" id="{B0CF0BF7-017A-47DE-9258-A0FA95711CA1}"/>
               </a:ext>
             </a:extLst>
           </p:cNvPr>
@@ -16877,7 +16877,7 @@
           <p:cNvPr id="40" name="">
             <a:extLst xmlns:a="http://schemas.openxmlformats.org/drawingml/2006/main">
               <a:ext uri="{FF2B5EF4-FFF2-40B4-BE49-F238E27FC236}">
-                <a16:creationId xmlns:a16="http://schemas.microsoft.com/office/drawing/2014/main" id="{59F92819-6538-433D-9469-D104C30B90CE}"/>
+                <a16:creationId xmlns:a16="http://schemas.microsoft.com/office/drawing/2014/main" id="{DB69F0D2-2055-4FD8-81D1-473530B16FE0}"/>
               </a:ext>
             </a:extLst>
           </p:cNvPr>
@@ -16918,7 +16918,7 @@
           <p:cNvPr id="41" name="">
             <a:extLst xmlns:a="http://schemas.openxmlformats.org/drawingml/2006/main">
               <a:ext uri="{FF2B5EF4-FFF2-40B4-BE49-F238E27FC236}">
-                <a16:creationId xmlns:a16="http://schemas.microsoft.com/office/drawing/2014/main" id="{6E79ED03-E387-4E12-9D99-02379C83B815}"/>
+                <a16:creationId xmlns:a16="http://schemas.microsoft.com/office/drawing/2014/main" id="{46A7AE90-E3ED-4CBF-A7F6-1F6523577072}"/>
               </a:ext>
             </a:extLst>
           </p:cNvPr>
@@ -16968,7 +16968,7 @@
           <p:cNvPr id="42" name="">
             <a:extLst xmlns:a="http://schemas.openxmlformats.org/drawingml/2006/main">
               <a:ext uri="{FF2B5EF4-FFF2-40B4-BE49-F238E27FC236}">
-                <a16:creationId xmlns:a16="http://schemas.microsoft.com/office/drawing/2014/main" id="{B78A2339-0A5C-4FFC-B761-1886BB006B3C}"/>
+                <a16:creationId xmlns:a16="http://schemas.microsoft.com/office/drawing/2014/main" id="{A42723E5-DD2F-42AC-AEF8-819A612D311A}"/>
               </a:ext>
             </a:extLst>
           </p:cNvPr>
@@ -17035,7 +17035,7 @@
           <p:cNvPr id="43" name="">
             <a:extLst xmlns:a="http://schemas.openxmlformats.org/drawingml/2006/main">
               <a:ext uri="{FF2B5EF4-FFF2-40B4-BE49-F238E27FC236}">
-                <a16:creationId xmlns:a16="http://schemas.microsoft.com/office/drawing/2014/main" id="{0FEA05BC-ED18-47A9-B18E-DE8FABE13DB4}"/>
+                <a16:creationId xmlns:a16="http://schemas.microsoft.com/office/drawing/2014/main" id="{6D222451-F7BC-4BAB-BABB-E10DCB7F95D1}"/>
               </a:ext>
             </a:extLst>
           </p:cNvPr>
@@ -17070,7 +17070,7 @@
           <p:cNvPr id="44" name="">
             <a:extLst xmlns:a="http://schemas.openxmlformats.org/drawingml/2006/main">
               <a:ext uri="{FF2B5EF4-FFF2-40B4-BE49-F238E27FC236}">
-                <a16:creationId xmlns:a16="http://schemas.microsoft.com/office/drawing/2014/main" id="{C22770A2-E22C-4541-87B4-F0C2444937A6}"/>
+                <a16:creationId xmlns:a16="http://schemas.microsoft.com/office/drawing/2014/main" id="{D10C1A1C-5300-4A4E-BF97-B162438F21E0}"/>
               </a:ext>
             </a:extLst>
           </p:cNvPr>
@@ -17120,7 +17120,7 @@
           <p:cNvPr id="45" name="">
             <a:extLst xmlns:a="http://schemas.openxmlformats.org/drawingml/2006/main">
               <a:ext uri="{FF2B5EF4-FFF2-40B4-BE49-F238E27FC236}">
-                <a16:creationId xmlns:a16="http://schemas.microsoft.com/office/drawing/2014/main" id="{DF6C7761-5113-4C80-BD3E-FC0161896692}"/>
+                <a16:creationId xmlns:a16="http://schemas.microsoft.com/office/drawing/2014/main" id="{128EBB01-95D5-4B32-BACF-C6ABE50B4FFD}"/>
               </a:ext>
             </a:extLst>
           </p:cNvPr>
@@ -17170,7 +17170,7 @@
           <p:cNvPr id="46" name="">
             <a:extLst xmlns:a="http://schemas.openxmlformats.org/drawingml/2006/main">
               <a:ext uri="{FF2B5EF4-FFF2-40B4-BE49-F238E27FC236}">
-                <a16:creationId xmlns:a16="http://schemas.microsoft.com/office/drawing/2014/main" id="{45B00BC6-BB8C-4F4F-98BF-B4B11F51835E}"/>
+                <a16:creationId xmlns:a16="http://schemas.microsoft.com/office/drawing/2014/main" id="{D229B867-44D1-47ED-B0A8-16AB8F4EFBF1}"/>
               </a:ext>
             </a:extLst>
           </p:cNvPr>
@@ -17201,7 +17201,7 @@
           <p:cNvPr id="47" name="source-4">
             <a:extLst xmlns:a="http://schemas.openxmlformats.org/drawingml/2006/main">
               <a:ext uri="{FF2B5EF4-FFF2-40B4-BE49-F238E27FC236}">
-                <a16:creationId xmlns:a16="http://schemas.microsoft.com/office/drawing/2014/main" id="{B410C05E-C62B-4A59-A31E-2BB25D6B9187}"/>
+                <a16:creationId xmlns:a16="http://schemas.microsoft.com/office/drawing/2014/main" id="{30A32FBD-7239-42BE-A526-C57BC5392971}"/>
               </a:ext>
             </a:extLst>
           </p:cNvPr>
@@ -17251,7 +17251,7 @@
           <p:cNvPr id="48" name="page-4">
             <a:extLst xmlns:a="http://schemas.openxmlformats.org/drawingml/2006/main">
               <a:ext uri="{FF2B5EF4-FFF2-40B4-BE49-F238E27FC236}">
-                <a16:creationId xmlns:a16="http://schemas.microsoft.com/office/drawing/2014/main" id="{25B52782-070B-454F-A627-E4124D491F88}"/>
+                <a16:creationId xmlns:a16="http://schemas.microsoft.com/office/drawing/2014/main" id="{C2A1892B-BBE5-435E-BBA7-2ECD4120E2B4}"/>
               </a:ext>
             </a:extLst>
           </p:cNvPr>
@@ -17299,7 +17299,7 @@
     </p:spTree>
     <p:extLst>
       <p:ext uri="{BB962C8B-B14F-4D97-AF65-F5344CB8AC3E}">
-        <p14:creationId xmlns:p14="http://schemas.microsoft.com/office/powerpoint/2010/main" val="1581744459"/>
+        <p14:creationId xmlns:p14="http://schemas.microsoft.com/office/powerpoint/2010/main" val="471816339"/>
       </p:ext>
     </p:extLst>
   </p:cSld>
@@ -17330,7 +17330,7 @@
           <p:cNvPr id="43" name="kicker-5">
             <a:extLst xmlns:a="http://schemas.openxmlformats.org/drawingml/2006/main">
               <a:ext uri="{FF2B5EF4-FFF2-40B4-BE49-F238E27FC236}">
-                <a16:creationId xmlns:a16="http://schemas.microsoft.com/office/drawing/2014/main" id="{924F3AB4-76F7-405C-8028-F2CF9A02A809}"/>
+                <a16:creationId xmlns:a16="http://schemas.microsoft.com/office/drawing/2014/main" id="{618A35C3-47C4-48F6-A39A-BF7540858594}"/>
               </a:ext>
             </a:extLst>
           </p:cNvPr>
@@ -17380,7 +17380,7 @@
           <p:cNvPr id="2" name="title-5">
             <a:extLst xmlns:a="http://schemas.openxmlformats.org/drawingml/2006/main">
               <a:ext uri="{FF2B5EF4-FFF2-40B4-BE49-F238E27FC236}">
-                <a16:creationId xmlns:a16="http://schemas.microsoft.com/office/drawing/2014/main" id="{0CAABA8B-50AC-4769-BD14-8034690BB191}"/>
+                <a16:creationId xmlns:a16="http://schemas.microsoft.com/office/drawing/2014/main" id="{929C1CE2-E695-47E4-A694-83011D1A8763}"/>
               </a:ext>
             </a:extLst>
           </p:cNvPr>
@@ -17430,7 +17430,7 @@
           <p:cNvPr id="3" name="">
             <a:extLst xmlns:a="http://schemas.openxmlformats.org/drawingml/2006/main">
               <a:ext uri="{FF2B5EF4-FFF2-40B4-BE49-F238E27FC236}">
-                <a16:creationId xmlns:a16="http://schemas.microsoft.com/office/drawing/2014/main" id="{FE2460B0-00CA-416B-AF0F-89FAFF5531D6}"/>
+                <a16:creationId xmlns:a16="http://schemas.microsoft.com/office/drawing/2014/main" id="{042A1347-FE9D-43D3-893B-5EAD4AA415B1}"/>
               </a:ext>
             </a:extLst>
           </p:cNvPr>
@@ -17461,7 +17461,7 @@
           <p:cNvPr id="4" name="">
             <a:extLst xmlns:a="http://schemas.openxmlformats.org/drawingml/2006/main">
               <a:ext uri="{FF2B5EF4-FFF2-40B4-BE49-F238E27FC236}">
-                <a16:creationId xmlns:a16="http://schemas.microsoft.com/office/drawing/2014/main" id="{662C7CFB-C4FA-4B42-80FE-81A79A17559E}"/>
+                <a16:creationId xmlns:a16="http://schemas.microsoft.com/office/drawing/2014/main" id="{FA5E9D00-EF1F-4D55-9AE4-D81B295C68DB}"/>
               </a:ext>
             </a:extLst>
           </p:cNvPr>
@@ -17511,7 +17511,7 @@
           <p:cNvPr id="5" name="">
             <a:extLst xmlns:a="http://schemas.openxmlformats.org/drawingml/2006/main">
               <a:ext uri="{FF2B5EF4-FFF2-40B4-BE49-F238E27FC236}">
-                <a16:creationId xmlns:a16="http://schemas.microsoft.com/office/drawing/2014/main" id="{181780FD-4834-4686-AB2C-01301FFBE416}"/>
+                <a16:creationId xmlns:a16="http://schemas.microsoft.com/office/drawing/2014/main" id="{EED90EB8-F55C-4460-8A13-A501F78E0060}"/>
               </a:ext>
             </a:extLst>
           </p:cNvPr>
@@ -17552,7 +17552,7 @@
           <p:cNvPr id="6" name="">
             <a:extLst xmlns:a="http://schemas.openxmlformats.org/drawingml/2006/main">
               <a:ext uri="{FF2B5EF4-FFF2-40B4-BE49-F238E27FC236}">
-                <a16:creationId xmlns:a16="http://schemas.microsoft.com/office/drawing/2014/main" id="{347B71AD-7683-4D90-842D-D893D12CC996}"/>
+                <a16:creationId xmlns:a16="http://schemas.microsoft.com/office/drawing/2014/main" id="{610B8C89-8FC4-4790-8C34-84172DB5FE54}"/>
               </a:ext>
             </a:extLst>
           </p:cNvPr>
@@ -17602,7 +17602,7 @@
           <p:cNvPr id="7" name="">
             <a:extLst xmlns:a="http://schemas.openxmlformats.org/drawingml/2006/main">
               <a:ext uri="{FF2B5EF4-FFF2-40B4-BE49-F238E27FC236}">
-                <a16:creationId xmlns:a16="http://schemas.microsoft.com/office/drawing/2014/main" id="{D86B13D3-AC31-4139-9916-20FB47178CE4}"/>
+                <a16:creationId xmlns:a16="http://schemas.microsoft.com/office/drawing/2014/main" id="{1355E712-AC15-4DED-9D35-25A08FF1B3E0}"/>
               </a:ext>
             </a:extLst>
           </p:cNvPr>
@@ -17637,7 +17637,7 @@
           <p:cNvPr id="8" name="">
             <a:extLst xmlns:a="http://schemas.openxmlformats.org/drawingml/2006/main">
               <a:ext uri="{FF2B5EF4-FFF2-40B4-BE49-F238E27FC236}">
-                <a16:creationId xmlns:a16="http://schemas.microsoft.com/office/drawing/2014/main" id="{4DF91B90-EDC3-4D65-BD0C-5E2B4A28BA21}"/>
+                <a16:creationId xmlns:a16="http://schemas.microsoft.com/office/drawing/2014/main" id="{6E507E20-8586-46A7-836E-4C0B73834D68}"/>
               </a:ext>
             </a:extLst>
           </p:cNvPr>
@@ -17687,7 +17687,7 @@
           <p:cNvPr id="9" name="">
             <a:extLst xmlns:a="http://schemas.openxmlformats.org/drawingml/2006/main">
               <a:ext uri="{FF2B5EF4-FFF2-40B4-BE49-F238E27FC236}">
-                <a16:creationId xmlns:a16="http://schemas.microsoft.com/office/drawing/2014/main" id="{18BC1209-E044-4371-96E0-48131727A261}"/>
+                <a16:creationId xmlns:a16="http://schemas.microsoft.com/office/drawing/2014/main" id="{AE467811-FC93-4158-9BA3-3781BFC53D49}"/>
               </a:ext>
             </a:extLst>
           </p:cNvPr>
@@ -17722,7 +17722,7 @@
           <p:cNvPr id="10" name="">
             <a:extLst xmlns:a="http://schemas.openxmlformats.org/drawingml/2006/main">
               <a:ext uri="{FF2B5EF4-FFF2-40B4-BE49-F238E27FC236}">
-                <a16:creationId xmlns:a16="http://schemas.microsoft.com/office/drawing/2014/main" id="{2924391C-324A-4CBE-B1C9-BBCE81CAFB05}"/>
+                <a16:creationId xmlns:a16="http://schemas.microsoft.com/office/drawing/2014/main" id="{A75D73B8-BA07-4BE0-A075-93BB10F7773A}"/>
               </a:ext>
             </a:extLst>
           </p:cNvPr>
@@ -17772,7 +17772,7 @@
           <p:cNvPr id="11" name="">
             <a:extLst xmlns:a="http://schemas.openxmlformats.org/drawingml/2006/main">
               <a:ext uri="{FF2B5EF4-FFF2-40B4-BE49-F238E27FC236}">
-                <a16:creationId xmlns:a16="http://schemas.microsoft.com/office/drawing/2014/main" id="{BD5C5FB0-46B3-4E79-B8B4-3847329F1466}"/>
+                <a16:creationId xmlns:a16="http://schemas.microsoft.com/office/drawing/2014/main" id="{7C524ADE-CD38-4284-AF6B-41DB71A46F1D}"/>
               </a:ext>
             </a:extLst>
           </p:cNvPr>
@@ -17807,7 +17807,7 @@
           <p:cNvPr id="12" name="">
             <a:extLst xmlns:a="http://schemas.openxmlformats.org/drawingml/2006/main">
               <a:ext uri="{FF2B5EF4-FFF2-40B4-BE49-F238E27FC236}">
-                <a16:creationId xmlns:a16="http://schemas.microsoft.com/office/drawing/2014/main" id="{CE1CDAC1-F803-436B-B705-D2BBDE508A82}"/>
+                <a16:creationId xmlns:a16="http://schemas.microsoft.com/office/drawing/2014/main" id="{FC7CCE28-F4AB-4028-A3A5-24A9A3FAC690}"/>
               </a:ext>
             </a:extLst>
           </p:cNvPr>
@@ -17857,7 +17857,7 @@
           <p:cNvPr id="13" name="">
             <a:extLst xmlns:a="http://schemas.openxmlformats.org/drawingml/2006/main">
               <a:ext uri="{FF2B5EF4-FFF2-40B4-BE49-F238E27FC236}">
-                <a16:creationId xmlns:a16="http://schemas.microsoft.com/office/drawing/2014/main" id="{43E49A6A-3C96-46F3-BDFA-F44C31B0CB04}"/>
+                <a16:creationId xmlns:a16="http://schemas.microsoft.com/office/drawing/2014/main" id="{A07B4E95-ACEB-489F-8094-78BE2AD71B1B}"/>
               </a:ext>
             </a:extLst>
           </p:cNvPr>
@@ -17898,7 +17898,7 @@
           <p:cNvPr id="14" name="">
             <a:extLst xmlns:a="http://schemas.openxmlformats.org/drawingml/2006/main">
               <a:ext uri="{FF2B5EF4-FFF2-40B4-BE49-F238E27FC236}">
-                <a16:creationId xmlns:a16="http://schemas.microsoft.com/office/drawing/2014/main" id="{B6C7F01D-898D-49DA-96C7-77823B205BF9}"/>
+                <a16:creationId xmlns:a16="http://schemas.microsoft.com/office/drawing/2014/main" id="{DFD4B71B-9175-4345-ACBB-7B4DA70FBD1C}"/>
               </a:ext>
             </a:extLst>
           </p:cNvPr>
@@ -17948,7 +17948,7 @@
           <p:cNvPr id="15" name="">
             <a:extLst xmlns:a="http://schemas.openxmlformats.org/drawingml/2006/main">
               <a:ext uri="{FF2B5EF4-FFF2-40B4-BE49-F238E27FC236}">
-                <a16:creationId xmlns:a16="http://schemas.microsoft.com/office/drawing/2014/main" id="{6DCF6FE2-E6D8-4DC3-B41F-4450B3309AB4}"/>
+                <a16:creationId xmlns:a16="http://schemas.microsoft.com/office/drawing/2014/main" id="{187FB47C-845B-45E6-84ED-964B06B639B6}"/>
               </a:ext>
             </a:extLst>
           </p:cNvPr>
@@ -17983,7 +17983,7 @@
           <p:cNvPr id="16" name="">
             <a:extLst xmlns:a="http://schemas.openxmlformats.org/drawingml/2006/main">
               <a:ext uri="{FF2B5EF4-FFF2-40B4-BE49-F238E27FC236}">
-                <a16:creationId xmlns:a16="http://schemas.microsoft.com/office/drawing/2014/main" id="{21C1D41C-D8D1-4F43-8C2C-FF81BD7B9300}"/>
+                <a16:creationId xmlns:a16="http://schemas.microsoft.com/office/drawing/2014/main" id="{3DDB91DA-D18D-4292-BB47-E5641A7945F4}"/>
               </a:ext>
             </a:extLst>
           </p:cNvPr>
@@ -18033,7 +18033,7 @@
           <p:cNvPr id="17" name="">
             <a:extLst xmlns:a="http://schemas.openxmlformats.org/drawingml/2006/main">
               <a:ext uri="{FF2B5EF4-FFF2-40B4-BE49-F238E27FC236}">
-                <a16:creationId xmlns:a16="http://schemas.microsoft.com/office/drawing/2014/main" id="{4D1B5BD6-BA18-4973-BAE3-ABB98A2744C0}"/>
+                <a16:creationId xmlns:a16="http://schemas.microsoft.com/office/drawing/2014/main" id="{7E1E3E31-74EC-4429-B379-9B3D415BC0FF}"/>
               </a:ext>
             </a:extLst>
           </p:cNvPr>
@@ -18068,7 +18068,7 @@
           <p:cNvPr id="18" name="">
             <a:extLst xmlns:a="http://schemas.openxmlformats.org/drawingml/2006/main">
               <a:ext uri="{FF2B5EF4-FFF2-40B4-BE49-F238E27FC236}">
-                <a16:creationId xmlns:a16="http://schemas.microsoft.com/office/drawing/2014/main" id="{DBC09783-DC86-4433-937F-3FA4610A964D}"/>
+                <a16:creationId xmlns:a16="http://schemas.microsoft.com/office/drawing/2014/main" id="{F0FC9A51-4584-4AC8-803A-96348FA59FD3}"/>
               </a:ext>
             </a:extLst>
           </p:cNvPr>
@@ -18118,7 +18118,7 @@
           <p:cNvPr id="19" name="">
             <a:extLst xmlns:a="http://schemas.openxmlformats.org/drawingml/2006/main">
               <a:ext uri="{FF2B5EF4-FFF2-40B4-BE49-F238E27FC236}">
-                <a16:creationId xmlns:a16="http://schemas.microsoft.com/office/drawing/2014/main" id="{0E781974-DEB0-4DD7-AE3C-65FFFD4727AF}"/>
+                <a16:creationId xmlns:a16="http://schemas.microsoft.com/office/drawing/2014/main" id="{0E3C90E9-3DBD-4E2F-B683-4AC4F32FED35}"/>
               </a:ext>
             </a:extLst>
           </p:cNvPr>
@@ -18153,7 +18153,7 @@
           <p:cNvPr id="20" name="">
             <a:extLst xmlns:a="http://schemas.openxmlformats.org/drawingml/2006/main">
               <a:ext uri="{FF2B5EF4-FFF2-40B4-BE49-F238E27FC236}">
-                <a16:creationId xmlns:a16="http://schemas.microsoft.com/office/drawing/2014/main" id="{17FAE886-5E27-499B-A6B1-189D66B4FA5B}"/>
+                <a16:creationId xmlns:a16="http://schemas.microsoft.com/office/drawing/2014/main" id="{C2313B14-671F-4421-BE8C-E5C3DDED62DB}"/>
               </a:ext>
             </a:extLst>
           </p:cNvPr>
@@ -18203,7 +18203,7 @@
           <p:cNvPr id="21" name="">
             <a:extLst xmlns:a="http://schemas.openxmlformats.org/drawingml/2006/main">
               <a:ext uri="{FF2B5EF4-FFF2-40B4-BE49-F238E27FC236}">
-                <a16:creationId xmlns:a16="http://schemas.microsoft.com/office/drawing/2014/main" id="{A4F94258-6E64-4BA1-820F-A481821109E4}"/>
+                <a16:creationId xmlns:a16="http://schemas.microsoft.com/office/drawing/2014/main" id="{CECB8BC6-F6BA-4ED8-AD90-EE7CEBCCCB2C}"/>
               </a:ext>
             </a:extLst>
           </p:cNvPr>
@@ -18244,7 +18244,7 @@
           <p:cNvPr id="22" name="">
             <a:extLst xmlns:a="http://schemas.openxmlformats.org/drawingml/2006/main">
               <a:ext uri="{FF2B5EF4-FFF2-40B4-BE49-F238E27FC236}">
-                <a16:creationId xmlns:a16="http://schemas.microsoft.com/office/drawing/2014/main" id="{96A0B664-4D0D-4D3F-802E-4DAD4EDE175D}"/>
+                <a16:creationId xmlns:a16="http://schemas.microsoft.com/office/drawing/2014/main" id="{D598A079-97B4-4730-B30A-6139C0D571ED}"/>
               </a:ext>
             </a:extLst>
           </p:cNvPr>
@@ -18294,7 +18294,7 @@
           <p:cNvPr id="23" name="">
             <a:extLst xmlns:a="http://schemas.openxmlformats.org/drawingml/2006/main">
               <a:ext uri="{FF2B5EF4-FFF2-40B4-BE49-F238E27FC236}">
-                <a16:creationId xmlns:a16="http://schemas.microsoft.com/office/drawing/2014/main" id="{438D50E0-2355-4C43-B6C8-C3C458601098}"/>
+                <a16:creationId xmlns:a16="http://schemas.microsoft.com/office/drawing/2014/main" id="{25B6E4C2-6906-488F-9E0F-41703D94AC62}"/>
               </a:ext>
             </a:extLst>
           </p:cNvPr>
@@ -18329,7 +18329,7 @@
           <p:cNvPr id="24" name="">
             <a:extLst xmlns:a="http://schemas.openxmlformats.org/drawingml/2006/main">
               <a:ext uri="{FF2B5EF4-FFF2-40B4-BE49-F238E27FC236}">
-                <a16:creationId xmlns:a16="http://schemas.microsoft.com/office/drawing/2014/main" id="{209CBDC2-DF61-4C4D-8963-1EB0940E5BF5}"/>
+                <a16:creationId xmlns:a16="http://schemas.microsoft.com/office/drawing/2014/main" id="{75EE1D62-4C42-427E-9798-1AF849425FCC}"/>
               </a:ext>
             </a:extLst>
           </p:cNvPr>
@@ -18379,7 +18379,7 @@
           <p:cNvPr id="25" name="">
             <a:extLst xmlns:a="http://schemas.openxmlformats.org/drawingml/2006/main">
               <a:ext uri="{FF2B5EF4-FFF2-40B4-BE49-F238E27FC236}">
-                <a16:creationId xmlns:a16="http://schemas.microsoft.com/office/drawing/2014/main" id="{13E17B3A-7162-40E6-8DA4-E16F6D0EA1BC}"/>
+                <a16:creationId xmlns:a16="http://schemas.microsoft.com/office/drawing/2014/main" id="{624A71BB-5E7A-42E2-8688-04E42520BF1E}"/>
               </a:ext>
             </a:extLst>
           </p:cNvPr>
@@ -18414,7 +18414,7 @@
           <p:cNvPr id="26" name="">
             <a:extLst xmlns:a="http://schemas.openxmlformats.org/drawingml/2006/main">
               <a:ext uri="{FF2B5EF4-FFF2-40B4-BE49-F238E27FC236}">
-                <a16:creationId xmlns:a16="http://schemas.microsoft.com/office/drawing/2014/main" id="{67A4E429-B7EA-4C2A-B889-7129FAD1BD5C}"/>
+                <a16:creationId xmlns:a16="http://schemas.microsoft.com/office/drawing/2014/main" id="{3263A4C6-AE77-4C2D-9562-A621B395F31D}"/>
               </a:ext>
             </a:extLst>
           </p:cNvPr>
@@ -18464,7 +18464,7 @@
           <p:cNvPr id="27" name="">
             <a:extLst xmlns:a="http://schemas.openxmlformats.org/drawingml/2006/main">
               <a:ext uri="{FF2B5EF4-FFF2-40B4-BE49-F238E27FC236}">
-                <a16:creationId xmlns:a16="http://schemas.microsoft.com/office/drawing/2014/main" id="{9A99F522-152F-4236-941E-6335ADDFA9A4}"/>
+                <a16:creationId xmlns:a16="http://schemas.microsoft.com/office/drawing/2014/main" id="{0C3DE6BF-071E-451A-9FBF-C039E5379692}"/>
               </a:ext>
             </a:extLst>
           </p:cNvPr>
@@ -18499,7 +18499,7 @@
           <p:cNvPr id="28" name="">
             <a:extLst xmlns:a="http://schemas.openxmlformats.org/drawingml/2006/main">
               <a:ext uri="{FF2B5EF4-FFF2-40B4-BE49-F238E27FC236}">
-                <a16:creationId xmlns:a16="http://schemas.microsoft.com/office/drawing/2014/main" id="{E9562022-B311-42F0-B8CA-26B6035995C6}"/>
+                <a16:creationId xmlns:a16="http://schemas.microsoft.com/office/drawing/2014/main" id="{DB4D1CFC-5FBB-4639-B5A2-2C159D2A5864}"/>
               </a:ext>
             </a:extLst>
           </p:cNvPr>
@@ -18549,7 +18549,7 @@
           <p:cNvPr id="29" name="">
             <a:extLst xmlns:a="http://schemas.openxmlformats.org/drawingml/2006/main">
               <a:ext uri="{FF2B5EF4-FFF2-40B4-BE49-F238E27FC236}">
-                <a16:creationId xmlns:a16="http://schemas.microsoft.com/office/drawing/2014/main" id="{808F9D3E-9B2E-4793-B5B3-C238B4B8A472}"/>
+                <a16:creationId xmlns:a16="http://schemas.microsoft.com/office/drawing/2014/main" id="{B2715886-AFE9-4E27-B173-9C55CA1795ED}"/>
               </a:ext>
             </a:extLst>
           </p:cNvPr>
@@ -18590,7 +18590,7 @@
           <p:cNvPr id="30" name="">
             <a:extLst xmlns:a="http://schemas.openxmlformats.org/drawingml/2006/main">
               <a:ext uri="{FF2B5EF4-FFF2-40B4-BE49-F238E27FC236}">
-                <a16:creationId xmlns:a16="http://schemas.microsoft.com/office/drawing/2014/main" id="{C105B6DC-FC85-45B6-A579-32832F966EF0}"/>
+                <a16:creationId xmlns:a16="http://schemas.microsoft.com/office/drawing/2014/main" id="{2B7EB13F-123E-4A63-952C-11D03B164556}"/>
               </a:ext>
             </a:extLst>
           </p:cNvPr>
@@ -18640,7 +18640,7 @@
           <p:cNvPr id="31" name="">
             <a:extLst xmlns:a="http://schemas.openxmlformats.org/drawingml/2006/main">
               <a:ext uri="{FF2B5EF4-FFF2-40B4-BE49-F238E27FC236}">
-                <a16:creationId xmlns:a16="http://schemas.microsoft.com/office/drawing/2014/main" id="{36E2095D-A339-4169-9CA1-30B1292913E6}"/>
+                <a16:creationId xmlns:a16="http://schemas.microsoft.com/office/drawing/2014/main" id="{7388AA65-AB7B-4A90-8617-D29FB6F7F84B}"/>
               </a:ext>
             </a:extLst>
           </p:cNvPr>
@@ -18675,7 +18675,7 @@
           <p:cNvPr id="32" name="">
             <a:extLst xmlns:a="http://schemas.openxmlformats.org/drawingml/2006/main">
               <a:ext uri="{FF2B5EF4-FFF2-40B4-BE49-F238E27FC236}">
-                <a16:creationId xmlns:a16="http://schemas.microsoft.com/office/drawing/2014/main" id="{36AF00FD-889C-4F6C-B131-4D8E13D84E28}"/>
+                <a16:creationId xmlns:a16="http://schemas.microsoft.com/office/drawing/2014/main" id="{4A14B5C4-943A-46B9-8766-6D0187E36836}"/>
               </a:ext>
             </a:extLst>
           </p:cNvPr>
@@ -18725,7 +18725,7 @@
           <p:cNvPr id="33" name="">
             <a:extLst xmlns:a="http://schemas.openxmlformats.org/drawingml/2006/main">
               <a:ext uri="{FF2B5EF4-FFF2-40B4-BE49-F238E27FC236}">
-                <a16:creationId xmlns:a16="http://schemas.microsoft.com/office/drawing/2014/main" id="{E003E87C-4F6C-4AC3-A10A-6EE64FB41981}"/>
+                <a16:creationId xmlns:a16="http://schemas.microsoft.com/office/drawing/2014/main" id="{85493658-E4EF-4AD9-A95F-629AE027FB4F}"/>
               </a:ext>
             </a:extLst>
           </p:cNvPr>
@@ -18760,7 +18760,7 @@
           <p:cNvPr id="34" name="">
             <a:extLst xmlns:a="http://schemas.openxmlformats.org/drawingml/2006/main">
               <a:ext uri="{FF2B5EF4-FFF2-40B4-BE49-F238E27FC236}">
-                <a16:creationId xmlns:a16="http://schemas.microsoft.com/office/drawing/2014/main" id="{24C706F7-C83C-4B05-AAFA-32B2130578D9}"/>
+                <a16:creationId xmlns:a16="http://schemas.microsoft.com/office/drawing/2014/main" id="{98FCB2CF-1EE7-497A-B286-045814546142}"/>
               </a:ext>
             </a:extLst>
           </p:cNvPr>
@@ -18810,7 +18810,7 @@
           <p:cNvPr id="35" name="">
             <a:extLst xmlns:a="http://schemas.openxmlformats.org/drawingml/2006/main">
               <a:ext uri="{FF2B5EF4-FFF2-40B4-BE49-F238E27FC236}">
-                <a16:creationId xmlns:a16="http://schemas.microsoft.com/office/drawing/2014/main" id="{B80227E8-38FE-4FE3-BDC1-C4B2B6791E85}"/>
+                <a16:creationId xmlns:a16="http://schemas.microsoft.com/office/drawing/2014/main" id="{BB1014E1-2CAF-4C22-90C5-68763CD5C692}"/>
               </a:ext>
             </a:extLst>
           </p:cNvPr>
@@ -18845,7 +18845,7 @@
           <p:cNvPr id="36" name="">
             <a:extLst xmlns:a="http://schemas.openxmlformats.org/drawingml/2006/main">
               <a:ext uri="{FF2B5EF4-FFF2-40B4-BE49-F238E27FC236}">
-                <a16:creationId xmlns:a16="http://schemas.microsoft.com/office/drawing/2014/main" id="{CE5E912F-1F2E-46FB-BD2B-7CA26C50A738}"/>
+                <a16:creationId xmlns:a16="http://schemas.microsoft.com/office/drawing/2014/main" id="{7143EFC3-B83B-4C0F-B1F6-2A038B37FE08}"/>
               </a:ext>
             </a:extLst>
           </p:cNvPr>
@@ -18895,7 +18895,7 @@
           <p:cNvPr id="37" name="">
             <a:extLst xmlns:a="http://schemas.openxmlformats.org/drawingml/2006/main">
               <a:ext uri="{FF2B5EF4-FFF2-40B4-BE49-F238E27FC236}">
-                <a16:creationId xmlns:a16="http://schemas.microsoft.com/office/drawing/2014/main" id="{4D877C43-D094-45B8-B0B9-22E9FC9AFFFA}"/>
+                <a16:creationId xmlns:a16="http://schemas.microsoft.com/office/drawing/2014/main" id="{82C9C97A-FA13-44C0-88EA-E7CB3D941CC1}"/>
               </a:ext>
             </a:extLst>
           </p:cNvPr>
@@ -18930,7 +18930,7 @@
           <p:cNvPr id="38" name="">
             <a:extLst xmlns:a="http://schemas.openxmlformats.org/drawingml/2006/main">
               <a:ext uri="{FF2B5EF4-FFF2-40B4-BE49-F238E27FC236}">
-                <a16:creationId xmlns:a16="http://schemas.microsoft.com/office/drawing/2014/main" id="{C94CAAC5-A0BA-4F46-9F26-E2DFADA550A8}"/>
+                <a16:creationId xmlns:a16="http://schemas.microsoft.com/office/drawing/2014/main" id="{8936C3D0-A7A2-4B99-AAED-96BB4E6E1D18}"/>
               </a:ext>
             </a:extLst>
           </p:cNvPr>
@@ -18980,7 +18980,7 @@
           <p:cNvPr id="39" name="">
             <a:extLst xmlns:a="http://schemas.openxmlformats.org/drawingml/2006/main">
               <a:ext uri="{FF2B5EF4-FFF2-40B4-BE49-F238E27FC236}">
-                <a16:creationId xmlns:a16="http://schemas.microsoft.com/office/drawing/2014/main" id="{C00D764F-D160-4D3B-9979-858FEFB1FB20}"/>
+                <a16:creationId xmlns:a16="http://schemas.microsoft.com/office/drawing/2014/main" id="{CD973F10-E094-4278-8BC6-AFABB4541FBC}"/>
               </a:ext>
             </a:extLst>
           </p:cNvPr>
@@ -19030,7 +19030,7 @@
           <p:cNvPr id="40" name="">
             <a:extLst xmlns:a="http://schemas.openxmlformats.org/drawingml/2006/main">
               <a:ext uri="{FF2B5EF4-FFF2-40B4-BE49-F238E27FC236}">
-                <a16:creationId xmlns:a16="http://schemas.microsoft.com/office/drawing/2014/main" id="{F3139F0E-0E1A-4101-A393-D2A27E54D504}"/>
+                <a16:creationId xmlns:a16="http://schemas.microsoft.com/office/drawing/2014/main" id="{CB798A52-0FFA-4905-998A-47D62BA2A5AA}"/>
               </a:ext>
             </a:extLst>
           </p:cNvPr>
@@ -19061,7 +19061,7 @@
           <p:cNvPr id="41" name="source-5">
             <a:extLst xmlns:a="http://schemas.openxmlformats.org/drawingml/2006/main">
               <a:ext uri="{FF2B5EF4-FFF2-40B4-BE49-F238E27FC236}">
-                <a16:creationId xmlns:a16="http://schemas.microsoft.com/office/drawing/2014/main" id="{4DC4D951-EBF2-4355-BA73-3E98DC6EEA7E}"/>
+                <a16:creationId xmlns:a16="http://schemas.microsoft.com/office/drawing/2014/main" id="{58B1EABB-07CA-4A7D-BF3A-158969B1B08F}"/>
               </a:ext>
             </a:extLst>
           </p:cNvPr>
@@ -19111,7 +19111,7 @@
           <p:cNvPr id="42" name="page-5">
             <a:extLst xmlns:a="http://schemas.openxmlformats.org/drawingml/2006/main">
               <a:ext uri="{FF2B5EF4-FFF2-40B4-BE49-F238E27FC236}">
-                <a16:creationId xmlns:a16="http://schemas.microsoft.com/office/drawing/2014/main" id="{2BEBC254-4BF6-4B15-ABCA-6C919D52CD9A}"/>
+                <a16:creationId xmlns:a16="http://schemas.microsoft.com/office/drawing/2014/main" id="{F98A9595-74B4-418D-A2AB-9414F3B855F5}"/>
               </a:ext>
             </a:extLst>
           </p:cNvPr>
@@ -19159,7 +19159,7 @@
     </p:spTree>
     <p:extLst>
       <p:ext uri="{BB962C8B-B14F-4D97-AF65-F5344CB8AC3E}">
-        <p14:creationId xmlns:p14="http://schemas.microsoft.com/office/powerpoint/2010/main" val="784401618"/>
+        <p14:creationId xmlns:p14="http://schemas.microsoft.com/office/powerpoint/2010/main" val="1248703227"/>
       </p:ext>
     </p:extLst>
   </p:cSld>
@@ -19190,7 +19190,7 @@
           <p:cNvPr id="36" name="kicker-6">
             <a:extLst xmlns:a="http://schemas.openxmlformats.org/drawingml/2006/main">
               <a:ext uri="{FF2B5EF4-FFF2-40B4-BE49-F238E27FC236}">
-                <a16:creationId xmlns:a16="http://schemas.microsoft.com/office/drawing/2014/main" id="{2599ABB6-07E4-4971-957F-DF7552D10563}"/>
+                <a16:creationId xmlns:a16="http://schemas.microsoft.com/office/drawing/2014/main" id="{42801365-F285-45DD-8B42-D668DEFF3FA9}"/>
               </a:ext>
             </a:extLst>
           </p:cNvPr>
@@ -19240,7 +19240,7 @@
           <p:cNvPr id="2" name="title-6">
             <a:extLst xmlns:a="http://schemas.openxmlformats.org/drawingml/2006/main">
               <a:ext uri="{FF2B5EF4-FFF2-40B4-BE49-F238E27FC236}">
-                <a16:creationId xmlns:a16="http://schemas.microsoft.com/office/drawing/2014/main" id="{0878B60B-0635-4DF3-AD17-2995707604DA}"/>
+                <a16:creationId xmlns:a16="http://schemas.microsoft.com/office/drawing/2014/main" id="{8F6851D2-DB83-451B-BE05-8F2A496193EF}"/>
               </a:ext>
             </a:extLst>
           </p:cNvPr>
@@ -19290,7 +19290,7 @@
           <p:cNvPr id="3" name="">
             <a:extLst xmlns:a="http://schemas.openxmlformats.org/drawingml/2006/main">
               <a:ext uri="{FF2B5EF4-FFF2-40B4-BE49-F238E27FC236}">
-                <a16:creationId xmlns:a16="http://schemas.microsoft.com/office/drawing/2014/main" id="{DD943A92-3A9A-4033-B95F-B5FEBFB774DB}"/>
+                <a16:creationId xmlns:a16="http://schemas.microsoft.com/office/drawing/2014/main" id="{79AF736C-198F-41D0-84B1-1B79BD7BDE97}"/>
               </a:ext>
             </a:extLst>
           </p:cNvPr>
@@ -19321,7 +19321,7 @@
           <p:cNvPr id="4" name="">
             <a:extLst xmlns:a="http://schemas.openxmlformats.org/drawingml/2006/main">
               <a:ext uri="{FF2B5EF4-FFF2-40B4-BE49-F238E27FC236}">
-                <a16:creationId xmlns:a16="http://schemas.microsoft.com/office/drawing/2014/main" id="{71DC1E76-B20D-405B-8174-483F7040F600}"/>
+                <a16:creationId xmlns:a16="http://schemas.microsoft.com/office/drawing/2014/main" id="{7DB4089A-AC56-4A7F-8546-B04A8294C5C0}"/>
               </a:ext>
             </a:extLst>
           </p:cNvPr>
@@ -19371,7 +19371,7 @@
           <p:cNvPr id="5" name="">
             <a:extLst xmlns:a="http://schemas.openxmlformats.org/drawingml/2006/main">
               <a:ext uri="{FF2B5EF4-FFF2-40B4-BE49-F238E27FC236}">
-                <a16:creationId xmlns:a16="http://schemas.microsoft.com/office/drawing/2014/main" id="{22BC1458-260D-454D-B6E2-3E5E219D336A}"/>
+                <a16:creationId xmlns:a16="http://schemas.microsoft.com/office/drawing/2014/main" id="{FB4470C1-1CEE-4AAA-ABCC-A3AAB88BA8CF}"/>
               </a:ext>
             </a:extLst>
           </p:cNvPr>
@@ -19404,7 +19404,7 @@
           <p:cNvPr id="6" name="">
             <a:extLst xmlns:a="http://schemas.openxmlformats.org/drawingml/2006/main">
               <a:ext uri="{FF2B5EF4-FFF2-40B4-BE49-F238E27FC236}">
-                <a16:creationId xmlns:a16="http://schemas.microsoft.com/office/drawing/2014/main" id="{D0416776-BAA9-4665-B508-CC8A41C40240}"/>
+                <a16:creationId xmlns:a16="http://schemas.microsoft.com/office/drawing/2014/main" id="{36CF15EE-62AC-4DB2-844C-664FA9DE7A47}"/>
               </a:ext>
             </a:extLst>
           </p:cNvPr>
@@ -19445,7 +19445,7 @@
           <p:cNvPr id="7" name="">
             <a:extLst xmlns:a="http://schemas.openxmlformats.org/drawingml/2006/main">
               <a:ext uri="{FF2B5EF4-FFF2-40B4-BE49-F238E27FC236}">
-                <a16:creationId xmlns:a16="http://schemas.microsoft.com/office/drawing/2014/main" id="{07ABC6F5-B8CB-45CC-A7B4-9F421083B2C7}"/>
+                <a16:creationId xmlns:a16="http://schemas.microsoft.com/office/drawing/2014/main" id="{43737E8B-B18B-4387-9BA8-3FADDB4D103B}"/>
               </a:ext>
             </a:extLst>
           </p:cNvPr>
@@ -19495,7 +19495,7 @@
           <p:cNvPr id="8" name="">
             <a:extLst xmlns:a="http://schemas.openxmlformats.org/drawingml/2006/main">
               <a:ext uri="{FF2B5EF4-FFF2-40B4-BE49-F238E27FC236}">
-                <a16:creationId xmlns:a16="http://schemas.microsoft.com/office/drawing/2014/main" id="{D5609CC6-2AC4-42D2-9E3F-0EB995ECB538}"/>
+                <a16:creationId xmlns:a16="http://schemas.microsoft.com/office/drawing/2014/main" id="{7423D10F-44DC-4823-A5CF-77AD5D0C12DF}"/>
               </a:ext>
             </a:extLst>
           </p:cNvPr>
@@ -19545,7 +19545,7 @@
           <p:cNvPr id="9" name="">
             <a:extLst xmlns:a="http://schemas.openxmlformats.org/drawingml/2006/main">
               <a:ext uri="{FF2B5EF4-FFF2-40B4-BE49-F238E27FC236}">
-                <a16:creationId xmlns:a16="http://schemas.microsoft.com/office/drawing/2014/main" id="{D2DC9306-DD9B-4E5B-91BE-CBC2F341791C}"/>
+                <a16:creationId xmlns:a16="http://schemas.microsoft.com/office/drawing/2014/main" id="{8A3C3A45-5959-4F2D-BD1D-4016EB31B563}"/>
               </a:ext>
             </a:extLst>
           </p:cNvPr>
@@ -19595,7 +19595,7 @@
           <p:cNvPr id="10" name="">
             <a:extLst xmlns:a="http://schemas.openxmlformats.org/drawingml/2006/main">
               <a:ext uri="{FF2B5EF4-FFF2-40B4-BE49-F238E27FC236}">
-                <a16:creationId xmlns:a16="http://schemas.microsoft.com/office/drawing/2014/main" id="{2948E435-EFFB-4BBF-B3BD-7FB8C02B7150}"/>
+                <a16:creationId xmlns:a16="http://schemas.microsoft.com/office/drawing/2014/main" id="{960123F4-2BED-4500-8C62-9FE703E5186D}"/>
               </a:ext>
             </a:extLst>
           </p:cNvPr>
@@ -19626,7 +19626,7 @@
           <p:cNvPr id="11" name="">
             <a:extLst xmlns:a="http://schemas.openxmlformats.org/drawingml/2006/main">
               <a:ext uri="{FF2B5EF4-FFF2-40B4-BE49-F238E27FC236}">
-                <a16:creationId xmlns:a16="http://schemas.microsoft.com/office/drawing/2014/main" id="{41144988-E3F1-4248-A36F-74E9906756B7}"/>
+                <a16:creationId xmlns:a16="http://schemas.microsoft.com/office/drawing/2014/main" id="{39270B24-E48A-4AFB-945B-8F14EE8E1816}"/>
               </a:ext>
             </a:extLst>
           </p:cNvPr>
@@ -19676,7 +19676,7 @@
           <p:cNvPr id="12" name="">
             <a:extLst xmlns:a="http://schemas.openxmlformats.org/drawingml/2006/main">
               <a:ext uri="{FF2B5EF4-FFF2-40B4-BE49-F238E27FC236}">
-                <a16:creationId xmlns:a16="http://schemas.microsoft.com/office/drawing/2014/main" id="{E4334294-FBE2-4A84-912B-74478FF46332}"/>
+                <a16:creationId xmlns:a16="http://schemas.microsoft.com/office/drawing/2014/main" id="{D996BB65-A02B-467D-A329-2D889970A8FE}"/>
               </a:ext>
             </a:extLst>
           </p:cNvPr>
@@ -19726,7 +19726,7 @@
           <p:cNvPr id="13" name="">
             <a:extLst xmlns:a="http://schemas.openxmlformats.org/drawingml/2006/main">
               <a:ext uri="{FF2B5EF4-FFF2-40B4-BE49-F238E27FC236}">
-                <a16:creationId xmlns:a16="http://schemas.microsoft.com/office/drawing/2014/main" id="{2450A96E-3181-4859-B80C-A867B7B351F6}"/>
+                <a16:creationId xmlns:a16="http://schemas.microsoft.com/office/drawing/2014/main" id="{1A39E986-BF7C-4DC8-B5F1-6D8958069A21}"/>
               </a:ext>
             </a:extLst>
           </p:cNvPr>
@@ -19776,7 +19776,7 @@
           <p:cNvPr id="14" name="">
             <a:extLst xmlns:a="http://schemas.openxmlformats.org/drawingml/2006/main">
               <a:ext uri="{FF2B5EF4-FFF2-40B4-BE49-F238E27FC236}">
-                <a16:creationId xmlns:a16="http://schemas.microsoft.com/office/drawing/2014/main" id="{21DBCAF3-A2CC-45F4-AB7B-804B5FC8BDFD}"/>
+                <a16:creationId xmlns:a16="http://schemas.microsoft.com/office/drawing/2014/main" id="{8DBCA879-03F9-4FDF-844D-459169FDFA9A}"/>
               </a:ext>
             </a:extLst>
           </p:cNvPr>
@@ -19826,7 +19826,7 @@
           <p:cNvPr id="15" name="">
             <a:extLst xmlns:a="http://schemas.openxmlformats.org/drawingml/2006/main">
               <a:ext uri="{FF2B5EF4-FFF2-40B4-BE49-F238E27FC236}">
-                <a16:creationId xmlns:a16="http://schemas.microsoft.com/office/drawing/2014/main" id="{3E1A53AA-6DFF-4AD0-82E0-25533C70EB2F}"/>
+                <a16:creationId xmlns:a16="http://schemas.microsoft.com/office/drawing/2014/main" id="{43BF0021-9A4A-4A3E-B404-E503066C0004}"/>
               </a:ext>
             </a:extLst>
           </p:cNvPr>
@@ -19876,7 +19876,7 @@
           <p:cNvPr id="16" name="">
             <a:extLst xmlns:a="http://schemas.openxmlformats.org/drawingml/2006/main">
               <a:ext uri="{FF2B5EF4-FFF2-40B4-BE49-F238E27FC236}">
-                <a16:creationId xmlns:a16="http://schemas.microsoft.com/office/drawing/2014/main" id="{FDF9300E-79C7-4CA3-86A5-ADE01DDD5D8C}"/>
+                <a16:creationId xmlns:a16="http://schemas.microsoft.com/office/drawing/2014/main" id="{5052D6A4-E502-4C1C-B2CC-729143491A66}"/>
               </a:ext>
             </a:extLst>
           </p:cNvPr>
@@ -19917,7 +19917,7 @@
           <p:cNvPr id="17" name="">
             <a:extLst xmlns:a="http://schemas.openxmlformats.org/drawingml/2006/main">
               <a:ext uri="{FF2B5EF4-FFF2-40B4-BE49-F238E27FC236}">
-                <a16:creationId xmlns:a16="http://schemas.microsoft.com/office/drawing/2014/main" id="{CD1DC070-8EB0-40E0-AFBF-C317DE5C78EF}"/>
+                <a16:creationId xmlns:a16="http://schemas.microsoft.com/office/drawing/2014/main" id="{161519CA-BB45-49E4-A1D0-1F93147C92DE}"/>
               </a:ext>
             </a:extLst>
           </p:cNvPr>
@@ -19967,7 +19967,7 @@
           <p:cNvPr id="18" name="">
             <a:extLst xmlns:a="http://schemas.openxmlformats.org/drawingml/2006/main">
               <a:ext uri="{FF2B5EF4-FFF2-40B4-BE49-F238E27FC236}">
-                <a16:creationId xmlns:a16="http://schemas.microsoft.com/office/drawing/2014/main" id="{69CBC65B-23EC-4B25-BF03-C52163051F36}"/>
+                <a16:creationId xmlns:a16="http://schemas.microsoft.com/office/drawing/2014/main" id="{25F7D93A-4495-42C5-A1F8-19C1F34CBAAF}"/>
               </a:ext>
             </a:extLst>
           </p:cNvPr>
@@ -20017,7 +20017,7 @@
           <p:cNvPr id="19" name="">
             <a:extLst xmlns:a="http://schemas.openxmlformats.org/drawingml/2006/main">
               <a:ext uri="{FF2B5EF4-FFF2-40B4-BE49-F238E27FC236}">
-                <a16:creationId xmlns:a16="http://schemas.microsoft.com/office/drawing/2014/main" id="{B062C088-9704-4BF9-9593-4ACCA70E1EFC}"/>
+                <a16:creationId xmlns:a16="http://schemas.microsoft.com/office/drawing/2014/main" id="{63E4F18B-9580-4962-825C-BF513DE0A8AD}"/>
               </a:ext>
             </a:extLst>
           </p:cNvPr>
@@ -20067,7 +20067,7 @@
           <p:cNvPr id="20" name="">
             <a:extLst xmlns:a="http://schemas.openxmlformats.org/drawingml/2006/main">
               <a:ext uri="{FF2B5EF4-FFF2-40B4-BE49-F238E27FC236}">
-                <a16:creationId xmlns:a16="http://schemas.microsoft.com/office/drawing/2014/main" id="{57C99803-B970-4705-9321-33321BCBE3DF}"/>
+                <a16:creationId xmlns:a16="http://schemas.microsoft.com/office/drawing/2014/main" id="{704B4357-5E18-4E2A-B885-1239977DFD5F}"/>
               </a:ext>
             </a:extLst>
           </p:cNvPr>
@@ -20117,7 +20117,7 @@
           <p:cNvPr id="21" name="">
             <a:extLst xmlns:a="http://schemas.openxmlformats.org/drawingml/2006/main">
               <a:ext uri="{FF2B5EF4-FFF2-40B4-BE49-F238E27FC236}">
-                <a16:creationId xmlns:a16="http://schemas.microsoft.com/office/drawing/2014/main" id="{C2DD0BBF-8246-497F-B6BA-18833BEB42DE}"/>
+                <a16:creationId xmlns:a16="http://schemas.microsoft.com/office/drawing/2014/main" id="{58D65BA3-BEC0-478E-930D-F55FB5F0CE76}"/>
               </a:ext>
             </a:extLst>
           </p:cNvPr>
@@ -20148,7 +20148,7 @@
           <p:cNvPr id="22" name="">
             <a:extLst xmlns:a="http://schemas.openxmlformats.org/drawingml/2006/main">
               <a:ext uri="{FF2B5EF4-FFF2-40B4-BE49-F238E27FC236}">
-                <a16:creationId xmlns:a16="http://schemas.microsoft.com/office/drawing/2014/main" id="{A2239794-6321-434D-93F9-D2A3690CF55A}"/>
+                <a16:creationId xmlns:a16="http://schemas.microsoft.com/office/drawing/2014/main" id="{35F87DDA-027D-474F-9F94-A890D5B80CD8}"/>
               </a:ext>
             </a:extLst>
           </p:cNvPr>
@@ -20198,7 +20198,7 @@
           <p:cNvPr id="23" name="">
             <a:extLst xmlns:a="http://schemas.openxmlformats.org/drawingml/2006/main">
               <a:ext uri="{FF2B5EF4-FFF2-40B4-BE49-F238E27FC236}">
-                <a16:creationId xmlns:a16="http://schemas.microsoft.com/office/drawing/2014/main" id="{186FE927-5402-4C66-94BD-27B56B2EBC59}"/>
+                <a16:creationId xmlns:a16="http://schemas.microsoft.com/office/drawing/2014/main" id="{BD62F074-F446-481B-BA64-1D7DCF101FAC}"/>
               </a:ext>
             </a:extLst>
           </p:cNvPr>
@@ -20248,7 +20248,7 @@
           <p:cNvPr id="24" name="">
             <a:extLst xmlns:a="http://schemas.openxmlformats.org/drawingml/2006/main">
               <a:ext uri="{FF2B5EF4-FFF2-40B4-BE49-F238E27FC236}">
-                <a16:creationId xmlns:a16="http://schemas.microsoft.com/office/drawing/2014/main" id="{B3189D8D-28BA-43A5-AAE4-DD6A63503137}"/>
+                <a16:creationId xmlns:a16="http://schemas.microsoft.com/office/drawing/2014/main" id="{01468A19-A986-4314-A5C9-E38BC14BEC35}"/>
               </a:ext>
             </a:extLst>
           </p:cNvPr>
@@ -20298,7 +20298,7 @@
           <p:cNvPr id="25" name="">
             <a:extLst xmlns:a="http://schemas.openxmlformats.org/drawingml/2006/main">
               <a:ext uri="{FF2B5EF4-FFF2-40B4-BE49-F238E27FC236}">
-                <a16:creationId xmlns:a16="http://schemas.microsoft.com/office/drawing/2014/main" id="{2C0CFF20-DB12-4A99-95D3-09AEE3606C93}"/>
+                <a16:creationId xmlns:a16="http://schemas.microsoft.com/office/drawing/2014/main" id="{BCDB3E40-EA8B-4CE7-AD52-F46BCF025575}"/>
               </a:ext>
             </a:extLst>
           </p:cNvPr>
@@ -20329,7 +20329,7 @@
           <p:cNvPr id="26" name="">
             <a:extLst xmlns:a="http://schemas.openxmlformats.org/drawingml/2006/main">
               <a:ext uri="{FF2B5EF4-FFF2-40B4-BE49-F238E27FC236}">
-                <a16:creationId xmlns:a16="http://schemas.microsoft.com/office/drawing/2014/main" id="{164C4F09-D40F-44F8-9F34-1A761B6B8391}"/>
+                <a16:creationId xmlns:a16="http://schemas.microsoft.com/office/drawing/2014/main" id="{AF8D649F-2C2E-4D17-A627-134C9078B2A6}"/>
               </a:ext>
             </a:extLst>
           </p:cNvPr>
@@ -20379,7 +20379,7 @@
           <p:cNvPr id="27" name="">
             <a:extLst xmlns:a="http://schemas.openxmlformats.org/drawingml/2006/main">
               <a:ext uri="{FF2B5EF4-FFF2-40B4-BE49-F238E27FC236}">
-                <a16:creationId xmlns:a16="http://schemas.microsoft.com/office/drawing/2014/main" id="{65B729BA-6F23-4385-976D-A937C1CFE982}"/>
+                <a16:creationId xmlns:a16="http://schemas.microsoft.com/office/drawing/2014/main" id="{6A3C62A6-9CBF-474A-BE4A-D9E6B1166B0D}"/>
               </a:ext>
             </a:extLst>
           </p:cNvPr>
@@ -20429,7 +20429,7 @@
           <p:cNvPr id="28" name="">
             <a:extLst xmlns:a="http://schemas.openxmlformats.org/drawingml/2006/main">
               <a:ext uri="{FF2B5EF4-FFF2-40B4-BE49-F238E27FC236}">
-                <a16:creationId xmlns:a16="http://schemas.microsoft.com/office/drawing/2014/main" id="{3EFDAB20-AE24-401E-9421-B4E6A8D2DD02}"/>
+                <a16:creationId xmlns:a16="http://schemas.microsoft.com/office/drawing/2014/main" id="{B6E67E58-3D35-4880-AC67-62EFF8B2D227}"/>
               </a:ext>
             </a:extLst>
           </p:cNvPr>
@@ -20479,7 +20479,7 @@
           <p:cNvPr id="29" name="">
             <a:extLst xmlns:a="http://schemas.openxmlformats.org/drawingml/2006/main">
               <a:ext uri="{FF2B5EF4-FFF2-40B4-BE49-F238E27FC236}">
-                <a16:creationId xmlns:a16="http://schemas.microsoft.com/office/drawing/2014/main" id="{B9A52391-F3AB-486E-97D7-8E2DF6B22A99}"/>
+                <a16:creationId xmlns:a16="http://schemas.microsoft.com/office/drawing/2014/main" id="{857F2D87-E453-4B9D-9213-8AE73D5B264F}"/>
               </a:ext>
             </a:extLst>
           </p:cNvPr>
@@ -20510,7 +20510,7 @@
           <p:cNvPr id="30" name="">
             <a:extLst xmlns:a="http://schemas.openxmlformats.org/drawingml/2006/main">
               <a:ext uri="{FF2B5EF4-FFF2-40B4-BE49-F238E27FC236}">
-                <a16:creationId xmlns:a16="http://schemas.microsoft.com/office/drawing/2014/main" id="{3B915C68-4F75-4BF2-B1C1-90C74FD0A729}"/>
+                <a16:creationId xmlns:a16="http://schemas.microsoft.com/office/drawing/2014/main" id="{3CE59EA0-4A49-4400-AAA3-8EAF95457DFC}"/>
               </a:ext>
             </a:extLst>
           </p:cNvPr>
@@ -20545,7 +20545,7 @@
           <p:cNvPr id="31" name="">
             <a:extLst xmlns:a="http://schemas.openxmlformats.org/drawingml/2006/main">
               <a:ext uri="{FF2B5EF4-FFF2-40B4-BE49-F238E27FC236}">
-                <a16:creationId xmlns:a16="http://schemas.microsoft.com/office/drawing/2014/main" id="{1A8612D9-E80E-49A7-AA34-CA8F1760F9C5}"/>
+                <a16:creationId xmlns:a16="http://schemas.microsoft.com/office/drawing/2014/main" id="{4B16FD4E-6963-42F1-973A-A6429703465F}"/>
               </a:ext>
             </a:extLst>
           </p:cNvPr>
@@ -20595,7 +20595,7 @@
           <p:cNvPr id="32" name="">
             <a:extLst xmlns:a="http://schemas.openxmlformats.org/drawingml/2006/main">
               <a:ext uri="{FF2B5EF4-FFF2-40B4-BE49-F238E27FC236}">
-                <a16:creationId xmlns:a16="http://schemas.microsoft.com/office/drawing/2014/main" id="{C66AB4B4-288D-4AB1-ADC4-793D84B23691}"/>
+                <a16:creationId xmlns:a16="http://schemas.microsoft.com/office/drawing/2014/main" id="{07FCBF51-C3E5-4A84-B769-2AA74ABEC560}"/>
               </a:ext>
             </a:extLst>
           </p:cNvPr>
@@ -20645,7 +20645,7 @@
           <p:cNvPr id="33" name="">
             <a:extLst xmlns:a="http://schemas.openxmlformats.org/drawingml/2006/main">
               <a:ext uri="{FF2B5EF4-FFF2-40B4-BE49-F238E27FC236}">
-                <a16:creationId xmlns:a16="http://schemas.microsoft.com/office/drawing/2014/main" id="{332D968B-6E68-4F50-AAAA-9C20BCE1D283}"/>
+                <a16:creationId xmlns:a16="http://schemas.microsoft.com/office/drawing/2014/main" id="{30000E33-A0DE-4A14-8011-7041E2980313}"/>
               </a:ext>
             </a:extLst>
           </p:cNvPr>
@@ -20676,7 +20676,7 @@
           <p:cNvPr id="34" name="source-6">
             <a:extLst xmlns:a="http://schemas.openxmlformats.org/drawingml/2006/main">
               <a:ext uri="{FF2B5EF4-FFF2-40B4-BE49-F238E27FC236}">
-                <a16:creationId xmlns:a16="http://schemas.microsoft.com/office/drawing/2014/main" id="{257D4432-4688-41E2-9D88-8FB07C0603F5}"/>
+                <a16:creationId xmlns:a16="http://schemas.microsoft.com/office/drawing/2014/main" id="{A4DB96C9-64F6-4880-8856-D71217AA6D3D}"/>
               </a:ext>
             </a:extLst>
           </p:cNvPr>
@@ -20726,7 +20726,7 @@
           <p:cNvPr id="35" name="page-6">
             <a:extLst xmlns:a="http://schemas.openxmlformats.org/drawingml/2006/main">
               <a:ext uri="{FF2B5EF4-FFF2-40B4-BE49-F238E27FC236}">
-                <a16:creationId xmlns:a16="http://schemas.microsoft.com/office/drawing/2014/main" id="{760EE6E6-C66C-4B4B-9EE6-318D633A5F41}"/>
+                <a16:creationId xmlns:a16="http://schemas.microsoft.com/office/drawing/2014/main" id="{E61EBC4D-4E30-4C20-95C3-4FF50712265D}"/>
               </a:ext>
             </a:extLst>
           </p:cNvPr>
@@ -20774,7 +20774,7 @@
     </p:spTree>
     <p:extLst>
       <p:ext uri="{BB962C8B-B14F-4D97-AF65-F5344CB8AC3E}">
-        <p14:creationId xmlns:p14="http://schemas.microsoft.com/office/powerpoint/2010/main" val="25027811"/>
+        <p14:creationId xmlns:p14="http://schemas.microsoft.com/office/powerpoint/2010/main" val="1822816628"/>
       </p:ext>
     </p:extLst>
   </p:cSld>
@@ -20805,7 +20805,7 @@
           <p:cNvPr id="40" name="kicker-7">
             <a:extLst xmlns:a="http://schemas.openxmlformats.org/drawingml/2006/main">
               <a:ext uri="{FF2B5EF4-FFF2-40B4-BE49-F238E27FC236}">
-                <a16:creationId xmlns:a16="http://schemas.microsoft.com/office/drawing/2014/main" id="{9AC84BD7-1F5A-4D00-AB75-6AE79FB7EBF9}"/>
+                <a16:creationId xmlns:a16="http://schemas.microsoft.com/office/drawing/2014/main" id="{7D7A4F50-4021-4493-89C5-44922ADC2290}"/>
               </a:ext>
             </a:extLst>
           </p:cNvPr>
@@ -20855,7 +20855,7 @@
           <p:cNvPr id="2" name="title-7">
             <a:extLst xmlns:a="http://schemas.openxmlformats.org/drawingml/2006/main">
               <a:ext uri="{FF2B5EF4-FFF2-40B4-BE49-F238E27FC236}">
-                <a16:creationId xmlns:a16="http://schemas.microsoft.com/office/drawing/2014/main" id="{EF31A820-6534-42DB-B221-D63BAE48A681}"/>
+                <a16:creationId xmlns:a16="http://schemas.microsoft.com/office/drawing/2014/main" id="{EDED1E81-0260-4C0A-824D-29800D6E6F59}"/>
               </a:ext>
             </a:extLst>
           </p:cNvPr>
@@ -20905,7 +20905,7 @@
           <p:cNvPr id="3" name="">
             <a:extLst xmlns:a="http://schemas.openxmlformats.org/drawingml/2006/main">
               <a:ext uri="{FF2B5EF4-FFF2-40B4-BE49-F238E27FC236}">
-                <a16:creationId xmlns:a16="http://schemas.microsoft.com/office/drawing/2014/main" id="{0BED1D7A-2FAD-42A8-80DD-3BC902166601}"/>
+                <a16:creationId xmlns:a16="http://schemas.microsoft.com/office/drawing/2014/main" id="{00DF7FDC-B97E-4D81-878F-9D718FC60A3C}"/>
               </a:ext>
             </a:extLst>
           </p:cNvPr>
@@ -20936,7 +20936,7 @@
           <p:cNvPr id="4" name="">
             <a:extLst xmlns:a="http://schemas.openxmlformats.org/drawingml/2006/main">
               <a:ext uri="{FF2B5EF4-FFF2-40B4-BE49-F238E27FC236}">
-                <a16:creationId xmlns:a16="http://schemas.microsoft.com/office/drawing/2014/main" id="{9DDAB2AF-43C7-45ED-B1A8-4CC502DA95E8}"/>
+                <a16:creationId xmlns:a16="http://schemas.microsoft.com/office/drawing/2014/main" id="{4DDC0752-2554-4B47-B863-F4F234CF8CA4}"/>
               </a:ext>
             </a:extLst>
           </p:cNvPr>
@@ -20986,7 +20986,7 @@
           <p:cNvPr id="5" name="">
             <a:extLst xmlns:a="http://schemas.openxmlformats.org/drawingml/2006/main">
               <a:ext uri="{FF2B5EF4-FFF2-40B4-BE49-F238E27FC236}">
-                <a16:creationId xmlns:a16="http://schemas.microsoft.com/office/drawing/2014/main" id="{73E1DEFF-9C23-4B3D-808F-0788820B6116}"/>
+                <a16:creationId xmlns:a16="http://schemas.microsoft.com/office/drawing/2014/main" id="{A30FFEAA-D089-46D3-8740-3C5E26236F8B}"/>
               </a:ext>
             </a:extLst>
           </p:cNvPr>
@@ -21019,7 +21019,7 @@
           <p:cNvPr id="6" name="">
             <a:extLst xmlns:a="http://schemas.openxmlformats.org/drawingml/2006/main">
               <a:ext uri="{FF2B5EF4-FFF2-40B4-BE49-F238E27FC236}">
-                <a16:creationId xmlns:a16="http://schemas.microsoft.com/office/drawing/2014/main" id="{7E7785E4-C854-47A3-AF12-9F4E5238B1B0}"/>
+                <a16:creationId xmlns:a16="http://schemas.microsoft.com/office/drawing/2014/main" id="{D10DD7F2-F8C5-4BA9-8C68-7191BFB3870A}"/>
               </a:ext>
             </a:extLst>
           </p:cNvPr>
@@ -21052,7 +21052,7 @@
           <p:cNvPr id="7" name="">
             <a:extLst xmlns:a="http://schemas.openxmlformats.org/drawingml/2006/main">
               <a:ext uri="{FF2B5EF4-FFF2-40B4-BE49-F238E27FC236}">
-                <a16:creationId xmlns:a16="http://schemas.microsoft.com/office/drawing/2014/main" id="{5B495E2B-9192-4448-8A6F-C57696ACE841}"/>
+                <a16:creationId xmlns:a16="http://schemas.microsoft.com/office/drawing/2014/main" id="{291149CA-9347-49D1-9FDB-7A1130944FF1}"/>
               </a:ext>
             </a:extLst>
           </p:cNvPr>
@@ -21085,7 +21085,7 @@
           <p:cNvPr id="8" name="">
             <a:extLst xmlns:a="http://schemas.openxmlformats.org/drawingml/2006/main">
               <a:ext uri="{FF2B5EF4-FFF2-40B4-BE49-F238E27FC236}">
-                <a16:creationId xmlns:a16="http://schemas.microsoft.com/office/drawing/2014/main" id="{52C025D1-9D07-4E79-A264-C5DF5EB9C85B}"/>
+                <a16:creationId xmlns:a16="http://schemas.microsoft.com/office/drawing/2014/main" id="{DA09B373-81A0-41C0-B69D-6BF24E70B7F5}"/>
               </a:ext>
             </a:extLst>
           </p:cNvPr>
@@ -21118,7 +21118,7 @@
           <p:cNvPr id="9" name="">
             <a:extLst xmlns:a="http://schemas.openxmlformats.org/drawingml/2006/main">
               <a:ext uri="{FF2B5EF4-FFF2-40B4-BE49-F238E27FC236}">
-                <a16:creationId xmlns:a16="http://schemas.microsoft.com/office/drawing/2014/main" id="{B6B36102-4F4F-4EDF-BFAD-9B6082687020}"/>
+                <a16:creationId xmlns:a16="http://schemas.microsoft.com/office/drawing/2014/main" id="{51BF6E31-CFF4-4395-B31D-4C671365F92D}"/>
               </a:ext>
             </a:extLst>
           </p:cNvPr>
@@ -21153,7 +21153,7 @@
           <p:cNvPr id="10" name="">
             <a:extLst xmlns:a="http://schemas.openxmlformats.org/drawingml/2006/main">
               <a:ext uri="{FF2B5EF4-FFF2-40B4-BE49-F238E27FC236}">
-                <a16:creationId xmlns:a16="http://schemas.microsoft.com/office/drawing/2014/main" id="{16C22D7D-77B2-481A-BBD2-F1CDD6684F55}"/>
+                <a16:creationId xmlns:a16="http://schemas.microsoft.com/office/drawing/2014/main" id="{BE40A079-ACAE-4FEE-B8B9-83513ADE6F0F}"/>
               </a:ext>
             </a:extLst>
           </p:cNvPr>
@@ -21203,7 +21203,7 @@
           <p:cNvPr id="11" name="">
             <a:extLst xmlns:a="http://schemas.openxmlformats.org/drawingml/2006/main">
               <a:ext uri="{FF2B5EF4-FFF2-40B4-BE49-F238E27FC236}">
-                <a16:creationId xmlns:a16="http://schemas.microsoft.com/office/drawing/2014/main" id="{DA7AFB5D-8862-4D25-8F47-247AE2AB91C1}"/>
+                <a16:creationId xmlns:a16="http://schemas.microsoft.com/office/drawing/2014/main" id="{10E81093-FB89-48CC-B02F-C331F12FB1E4}"/>
               </a:ext>
             </a:extLst>
           </p:cNvPr>
@@ -21270,7 +21270,7 @@
           <p:cNvPr id="12" name="">
             <a:extLst xmlns:a="http://schemas.openxmlformats.org/drawingml/2006/main">
               <a:ext uri="{FF2B5EF4-FFF2-40B4-BE49-F238E27FC236}">
-                <a16:creationId xmlns:a16="http://schemas.microsoft.com/office/drawing/2014/main" id="{4485C75F-2057-452E-8A1D-60D6A9E4256A}"/>
+                <a16:creationId xmlns:a16="http://schemas.microsoft.com/office/drawing/2014/main" id="{4FFD879C-7ECD-4C1B-8BA3-CBE950E84CF2}"/>
               </a:ext>
             </a:extLst>
           </p:cNvPr>
@@ -21305,7 +21305,7 @@
           <p:cNvPr id="13" name="">
             <a:extLst xmlns:a="http://schemas.openxmlformats.org/drawingml/2006/main">
               <a:ext uri="{FF2B5EF4-FFF2-40B4-BE49-F238E27FC236}">
-                <a16:creationId xmlns:a16="http://schemas.microsoft.com/office/drawing/2014/main" id="{B9AFC0B8-F448-4794-AD09-39C201795FB7}"/>
+                <a16:creationId xmlns:a16="http://schemas.microsoft.com/office/drawing/2014/main" id="{7737D56E-467C-4AB0-8668-B7CAD7DFE92F}"/>
               </a:ext>
             </a:extLst>
           </p:cNvPr>
@@ -21355,7 +21355,7 @@
           <p:cNvPr id="14" name="">
             <a:extLst xmlns:a="http://schemas.openxmlformats.org/drawingml/2006/main">
               <a:ext uri="{FF2B5EF4-FFF2-40B4-BE49-F238E27FC236}">
-                <a16:creationId xmlns:a16="http://schemas.microsoft.com/office/drawing/2014/main" id="{95CA1CA2-4327-4621-BE2F-C73E135A5E6B}"/>
+                <a16:creationId xmlns:a16="http://schemas.microsoft.com/office/drawing/2014/main" id="{D01BEED4-34B0-4961-B94F-54016421078E}"/>
               </a:ext>
             </a:extLst>
           </p:cNvPr>
@@ -21422,7 +21422,7 @@
           <p:cNvPr id="15" name="">
             <a:extLst xmlns:a="http://schemas.openxmlformats.org/drawingml/2006/main">
               <a:ext uri="{FF2B5EF4-FFF2-40B4-BE49-F238E27FC236}">
-                <a16:creationId xmlns:a16="http://schemas.microsoft.com/office/drawing/2014/main" id="{6FB0EC72-DF27-404F-8EDF-62F2CE2893E4}"/>
+                <a16:creationId xmlns:a16="http://schemas.microsoft.com/office/drawing/2014/main" id="{4ED1ACAF-C688-4069-991C-E4FFA8B68499}"/>
               </a:ext>
             </a:extLst>
           </p:cNvPr>
@@ -21457,7 +21457,7 @@
           <p:cNvPr id="16" name="">
             <a:extLst xmlns:a="http://schemas.openxmlformats.org/drawingml/2006/main">
               <a:ext uri="{FF2B5EF4-FFF2-40B4-BE49-F238E27FC236}">
-                <a16:creationId xmlns:a16="http://schemas.microsoft.com/office/drawing/2014/main" id="{E08A683F-E571-4996-91B1-6BB003874EDA}"/>
+                <a16:creationId xmlns:a16="http://schemas.microsoft.com/office/drawing/2014/main" id="{E3A2FA5F-D8A2-4233-AEE3-F99C9D68DE86}"/>
               </a:ext>
             </a:extLst>
           </p:cNvPr>
@@ -21507,7 +21507,7 @@
           <p:cNvPr id="17" name="">
             <a:extLst xmlns:a="http://schemas.openxmlformats.org/drawingml/2006/main">
               <a:ext uri="{FF2B5EF4-FFF2-40B4-BE49-F238E27FC236}">
-                <a16:creationId xmlns:a16="http://schemas.microsoft.com/office/drawing/2014/main" id="{DCC83D81-F6A0-4465-BC82-1A3999DDB25B}"/>
+                <a16:creationId xmlns:a16="http://schemas.microsoft.com/office/drawing/2014/main" id="{15A6EDA6-51C8-42BD-97A4-1362D177227A}"/>
               </a:ext>
             </a:extLst>
           </p:cNvPr>
@@ -21574,7 +21574,7 @@
           <p:cNvPr id="18" name="">
             <a:extLst xmlns:a="http://schemas.openxmlformats.org/drawingml/2006/main">
               <a:ext uri="{FF2B5EF4-FFF2-40B4-BE49-F238E27FC236}">
-                <a16:creationId xmlns:a16="http://schemas.microsoft.com/office/drawing/2014/main" id="{4ABB0127-BBC7-4FF1-8F58-75592BCF868D}"/>
+                <a16:creationId xmlns:a16="http://schemas.microsoft.com/office/drawing/2014/main" id="{44EAAF04-8907-4E4F-AD3C-ADBF85942358}"/>
               </a:ext>
             </a:extLst>
           </p:cNvPr>
@@ -21609,7 +21609,7 @@
           <p:cNvPr id="19" name="">
             <a:extLst xmlns:a="http://schemas.openxmlformats.org/drawingml/2006/main">
               <a:ext uri="{FF2B5EF4-FFF2-40B4-BE49-F238E27FC236}">
-                <a16:creationId xmlns:a16="http://schemas.microsoft.com/office/drawing/2014/main" id="{EADBC860-B6BE-45FA-AE40-183E68376C9C}"/>
+                <a16:creationId xmlns:a16="http://schemas.microsoft.com/office/drawing/2014/main" id="{67AC4948-4EAA-41C2-86F7-AE3DE7AFE462}"/>
               </a:ext>
             </a:extLst>
           </p:cNvPr>
@@ -21659,7 +21659,7 @@
           <p:cNvPr id="20" name="">
             <a:extLst xmlns:a="http://schemas.openxmlformats.org/drawingml/2006/main">
               <a:ext uri="{FF2B5EF4-FFF2-40B4-BE49-F238E27FC236}">
-                <a16:creationId xmlns:a16="http://schemas.microsoft.com/office/drawing/2014/main" id="{2D86C306-04A5-4B95-A74B-33C2800006A1}"/>
+                <a16:creationId xmlns:a16="http://schemas.microsoft.com/office/drawing/2014/main" id="{4424736B-165B-4143-B347-FA609ADF0CB1}"/>
               </a:ext>
             </a:extLst>
           </p:cNvPr>
@@ -21726,7 +21726,7 @@
           <p:cNvPr id="21" name="">
             <a:extLst xmlns:a="http://schemas.openxmlformats.org/drawingml/2006/main">
               <a:ext uri="{FF2B5EF4-FFF2-40B4-BE49-F238E27FC236}">
-                <a16:creationId xmlns:a16="http://schemas.microsoft.com/office/drawing/2014/main" id="{FE0EE3C1-7756-4ABD-9D41-92841F11A240}"/>
+                <a16:creationId xmlns:a16="http://schemas.microsoft.com/office/drawing/2014/main" id="{7F7B1DD6-CB80-4C60-B020-B93463C6169A}"/>
               </a:ext>
             </a:extLst>
           </p:cNvPr>
@@ -21767,7 +21767,7 @@
           <p:cNvPr id="22" name="">
             <a:extLst xmlns:a="http://schemas.openxmlformats.org/drawingml/2006/main">
               <a:ext uri="{FF2B5EF4-FFF2-40B4-BE49-F238E27FC236}">
-                <a16:creationId xmlns:a16="http://schemas.microsoft.com/office/drawing/2014/main" id="{D2341CE3-C667-47DE-8AA9-7FCD55B902B1}"/>
+                <a16:creationId xmlns:a16="http://schemas.microsoft.com/office/drawing/2014/main" id="{A73AE4B8-27B0-4458-8481-071DE62236FF}"/>
               </a:ext>
             </a:extLst>
           </p:cNvPr>
@@ -21817,7 +21817,7 @@
           <p:cNvPr id="23" name="">
             <a:extLst xmlns:a="http://schemas.openxmlformats.org/drawingml/2006/main">
               <a:ext uri="{FF2B5EF4-FFF2-40B4-BE49-F238E27FC236}">
-                <a16:creationId xmlns:a16="http://schemas.microsoft.com/office/drawing/2014/main" id="{23E3048C-6F9A-4836-B381-953BEB23659D}"/>
+                <a16:creationId xmlns:a16="http://schemas.microsoft.com/office/drawing/2014/main" id="{9C90B000-FC96-407D-A12F-08DCF1D7E833}"/>
               </a:ext>
             </a:extLst>
           </p:cNvPr>
@@ -21884,7 +21884,7 @@
           <p:cNvPr id="24" name="">
             <a:extLst xmlns:a="http://schemas.openxmlformats.org/drawingml/2006/main">
               <a:ext uri="{FF2B5EF4-FFF2-40B4-BE49-F238E27FC236}">
-                <a16:creationId xmlns:a16="http://schemas.microsoft.com/office/drawing/2014/main" id="{01C3373C-0963-467D-A607-ADB21612C6A8}"/>
+                <a16:creationId xmlns:a16="http://schemas.microsoft.com/office/drawing/2014/main" id="{87EBA29B-EF82-4340-BF4B-3F555F45E900}"/>
               </a:ext>
             </a:extLst>
           </p:cNvPr>
@@ -21934,7 +21934,7 @@
           <p:cNvPr id="25" name="">
             <a:extLst xmlns:a="http://schemas.openxmlformats.org/drawingml/2006/main">
               <a:ext uri="{FF2B5EF4-FFF2-40B4-BE49-F238E27FC236}">
-                <a16:creationId xmlns:a16="http://schemas.microsoft.com/office/drawing/2014/main" id="{1CB135E2-2E50-48D0-9B7D-7544FF53467E}"/>
+                <a16:creationId xmlns:a16="http://schemas.microsoft.com/office/drawing/2014/main" id="{B897D94A-C1B2-4A5D-B222-8081E6E0AA11}"/>
               </a:ext>
             </a:extLst>
           </p:cNvPr>
@@ -21969,7 +21969,7 @@
           <p:cNvPr id="26" name="">
             <a:extLst xmlns:a="http://schemas.openxmlformats.org/drawingml/2006/main">
               <a:ext uri="{FF2B5EF4-FFF2-40B4-BE49-F238E27FC236}">
-                <a16:creationId xmlns:a16="http://schemas.microsoft.com/office/drawing/2014/main" id="{7F72A583-7E6F-4C67-B315-E1A10A40932E}"/>
+                <a16:creationId xmlns:a16="http://schemas.microsoft.com/office/drawing/2014/main" id="{A5843389-38D1-41D4-8CEF-E17C42001002}"/>
               </a:ext>
             </a:extLst>
           </p:cNvPr>
@@ -22019,7 +22019,7 @@
           <p:cNvPr id="27" name="">
             <a:extLst xmlns:a="http://schemas.openxmlformats.org/drawingml/2006/main">
               <a:ext uri="{FF2B5EF4-FFF2-40B4-BE49-F238E27FC236}">
-                <a16:creationId xmlns:a16="http://schemas.microsoft.com/office/drawing/2014/main" id="{6E639F33-AC88-4BD6-AE78-ECBFE46E6432}"/>
+                <a16:creationId xmlns:a16="http://schemas.microsoft.com/office/drawing/2014/main" id="{CFDA2308-FEED-4A16-ADD4-8FAA159FF915}"/>
               </a:ext>
             </a:extLst>
           </p:cNvPr>
@@ -22069,7 +22069,7 @@
           <p:cNvPr id="28" name="">
             <a:extLst xmlns:a="http://schemas.openxmlformats.org/drawingml/2006/main">
               <a:ext uri="{FF2B5EF4-FFF2-40B4-BE49-F238E27FC236}">
-                <a16:creationId xmlns:a16="http://schemas.microsoft.com/office/drawing/2014/main" id="{86EFA4ED-616C-40B3-B94F-5EAC4EAD294A}"/>
+                <a16:creationId xmlns:a16="http://schemas.microsoft.com/office/drawing/2014/main" id="{D98C57F3-6C17-4DE1-95C3-72FB6E1E7B95}"/>
               </a:ext>
             </a:extLst>
           </p:cNvPr>
@@ -22119,7 +22119,7 @@
           <p:cNvPr id="29" name="">
             <a:extLst xmlns:a="http://schemas.openxmlformats.org/drawingml/2006/main">
               <a:ext uri="{FF2B5EF4-FFF2-40B4-BE49-F238E27FC236}">
-                <a16:creationId xmlns:a16="http://schemas.microsoft.com/office/drawing/2014/main" id="{B326B4E5-0014-47F5-94A0-1115B5E65688}"/>
+                <a16:creationId xmlns:a16="http://schemas.microsoft.com/office/drawing/2014/main" id="{F51D6580-B2FF-4920-9F27-F9960A74FBCD}"/>
               </a:ext>
             </a:extLst>
           </p:cNvPr>
@@ -22150,7 +22150,7 @@
           <p:cNvPr id="30" name="">
             <a:extLst xmlns:a="http://schemas.openxmlformats.org/drawingml/2006/main">
               <a:ext uri="{FF2B5EF4-FFF2-40B4-BE49-F238E27FC236}">
-                <a16:creationId xmlns:a16="http://schemas.microsoft.com/office/drawing/2014/main" id="{16C12165-8396-43C7-AC6F-21AE2F8ECD0C}"/>
+                <a16:creationId xmlns:a16="http://schemas.microsoft.com/office/drawing/2014/main" id="{B419A719-B8AC-49F0-8183-3A084F96BC78}"/>
               </a:ext>
             </a:extLst>
           </p:cNvPr>
@@ -22200,7 +22200,7 @@
           <p:cNvPr id="31" name="">
             <a:extLst xmlns:a="http://schemas.openxmlformats.org/drawingml/2006/main">
               <a:ext uri="{FF2B5EF4-FFF2-40B4-BE49-F238E27FC236}">
-                <a16:creationId xmlns:a16="http://schemas.microsoft.com/office/drawing/2014/main" id="{CB897E20-B1E0-4C71-B98E-CA11A1540FCB}"/>
+                <a16:creationId xmlns:a16="http://schemas.microsoft.com/office/drawing/2014/main" id="{898074B9-975B-4E38-8660-F9332CA55179}"/>
               </a:ext>
             </a:extLst>
           </p:cNvPr>
@@ -22250,7 +22250,7 @@
           <p:cNvPr id="32" name="">
             <a:extLst xmlns:a="http://schemas.openxmlformats.org/drawingml/2006/main">
               <a:ext uri="{FF2B5EF4-FFF2-40B4-BE49-F238E27FC236}">
-                <a16:creationId xmlns:a16="http://schemas.microsoft.com/office/drawing/2014/main" id="{09278AC4-2A8E-4A26-B526-F97684891D4D}"/>
+                <a16:creationId xmlns:a16="http://schemas.microsoft.com/office/drawing/2014/main" id="{E3C00D96-6D01-4109-8FC9-0FC2B9213737}"/>
               </a:ext>
             </a:extLst>
           </p:cNvPr>
@@ -22300,7 +22300,7 @@
           <p:cNvPr id="33" name="">
             <a:extLst xmlns:a="http://schemas.openxmlformats.org/drawingml/2006/main">
               <a:ext uri="{FF2B5EF4-FFF2-40B4-BE49-F238E27FC236}">
-                <a16:creationId xmlns:a16="http://schemas.microsoft.com/office/drawing/2014/main" id="{9ABF999F-DA7D-4911-A62F-6C9630661BF3}"/>
+                <a16:creationId xmlns:a16="http://schemas.microsoft.com/office/drawing/2014/main" id="{4F2F9C0C-1DC6-4375-ADAE-D70731BA1587}"/>
               </a:ext>
             </a:extLst>
           </p:cNvPr>
@@ -22331,7 +22331,7 @@
           <p:cNvPr id="34" name="">
             <a:extLst xmlns:a="http://schemas.openxmlformats.org/drawingml/2006/main">
               <a:ext uri="{FF2B5EF4-FFF2-40B4-BE49-F238E27FC236}">
-                <a16:creationId xmlns:a16="http://schemas.microsoft.com/office/drawing/2014/main" id="{58B74789-0887-49BA-AB6C-CEC5C342A502}"/>
+                <a16:creationId xmlns:a16="http://schemas.microsoft.com/office/drawing/2014/main" id="{B7CE9F4D-F433-441C-96A8-34D673675D12}"/>
               </a:ext>
             </a:extLst>
           </p:cNvPr>
@@ -22381,7 +22381,7 @@
           <p:cNvPr id="35" name="">
             <a:extLst xmlns:a="http://schemas.openxmlformats.org/drawingml/2006/main">
               <a:ext uri="{FF2B5EF4-FFF2-40B4-BE49-F238E27FC236}">
-                <a16:creationId xmlns:a16="http://schemas.microsoft.com/office/drawing/2014/main" id="{CF1A9821-46A2-4870-B583-385731B9F7DD}"/>
+                <a16:creationId xmlns:a16="http://schemas.microsoft.com/office/drawing/2014/main" id="{C83E159B-A90E-4919-ACFE-90D8C19FA99F}"/>
               </a:ext>
             </a:extLst>
           </p:cNvPr>
@@ -22431,7 +22431,7 @@
           <p:cNvPr id="36" name="">
             <a:extLst xmlns:a="http://schemas.openxmlformats.org/drawingml/2006/main">
               <a:ext uri="{FF2B5EF4-FFF2-40B4-BE49-F238E27FC236}">
-                <a16:creationId xmlns:a16="http://schemas.microsoft.com/office/drawing/2014/main" id="{76D9C160-EA3B-4F0B-94E0-B15317DE26FB}"/>
+                <a16:creationId xmlns:a16="http://schemas.microsoft.com/office/drawing/2014/main" id="{9183107D-F567-4281-9A76-9557A44C0C5E}"/>
               </a:ext>
             </a:extLst>
           </p:cNvPr>
@@ -22481,7 +22481,7 @@
           <p:cNvPr id="37" name="">
             <a:extLst xmlns:a="http://schemas.openxmlformats.org/drawingml/2006/main">
               <a:ext uri="{FF2B5EF4-FFF2-40B4-BE49-F238E27FC236}">
-                <a16:creationId xmlns:a16="http://schemas.microsoft.com/office/drawing/2014/main" id="{A672F945-26EB-4DD1-B9F1-A78C25005D74}"/>
+                <a16:creationId xmlns:a16="http://schemas.microsoft.com/office/drawing/2014/main" id="{44D3C8B9-5B59-47A1-8318-AE71EA0C9A2C}"/>
               </a:ext>
             </a:extLst>
           </p:cNvPr>
@@ -22512,7 +22512,7 @@
           <p:cNvPr id="38" name="source-7">
             <a:extLst xmlns:a="http://schemas.openxmlformats.org/drawingml/2006/main">
               <a:ext uri="{FF2B5EF4-FFF2-40B4-BE49-F238E27FC236}">
-                <a16:creationId xmlns:a16="http://schemas.microsoft.com/office/drawing/2014/main" id="{DA0D36ED-EB40-4917-A3F0-16715CFF0AA5}"/>
+                <a16:creationId xmlns:a16="http://schemas.microsoft.com/office/drawing/2014/main" id="{E5B9D1A5-D4CC-4F4E-A871-C828120885AF}"/>
               </a:ext>
             </a:extLst>
           </p:cNvPr>
@@ -22562,7 +22562,7 @@
           <p:cNvPr id="39" name="page-7">
             <a:extLst xmlns:a="http://schemas.openxmlformats.org/drawingml/2006/main">
               <a:ext uri="{FF2B5EF4-FFF2-40B4-BE49-F238E27FC236}">
-                <a16:creationId xmlns:a16="http://schemas.microsoft.com/office/drawing/2014/main" id="{F912922F-8628-407E-9830-862DA21465F5}"/>
+                <a16:creationId xmlns:a16="http://schemas.microsoft.com/office/drawing/2014/main" id="{8FFB5AD0-C52C-4DF5-B44D-6877374BC840}"/>
               </a:ext>
             </a:extLst>
           </p:cNvPr>
@@ -22610,7 +22610,7 @@
     </p:spTree>
     <p:extLst>
       <p:ext uri="{BB962C8B-B14F-4D97-AF65-F5344CB8AC3E}">
-        <p14:creationId xmlns:p14="http://schemas.microsoft.com/office/powerpoint/2010/main" val="356367732"/>
+        <p14:creationId xmlns:p14="http://schemas.microsoft.com/office/powerpoint/2010/main" val="1424654819"/>
       </p:ext>
     </p:extLst>
   </p:cSld>
@@ -22641,7 +22641,7 @@
           <p:cNvPr id="20" name="kicker-8">
             <a:extLst xmlns:a="http://schemas.openxmlformats.org/drawingml/2006/main">
               <a:ext uri="{FF2B5EF4-FFF2-40B4-BE49-F238E27FC236}">
-                <a16:creationId xmlns:a16="http://schemas.microsoft.com/office/drawing/2014/main" id="{67A36711-7D88-4290-8F06-63309EB507F7}"/>
+                <a16:creationId xmlns:a16="http://schemas.microsoft.com/office/drawing/2014/main" id="{D85C6EC4-40CF-4EE8-A91B-4914215D9AB8}"/>
               </a:ext>
             </a:extLst>
           </p:cNvPr>
@@ -22691,7 +22691,7 @@
           <p:cNvPr id="2" name="title-8">
             <a:extLst xmlns:a="http://schemas.openxmlformats.org/drawingml/2006/main">
               <a:ext uri="{FF2B5EF4-FFF2-40B4-BE49-F238E27FC236}">
-                <a16:creationId xmlns:a16="http://schemas.microsoft.com/office/drawing/2014/main" id="{18E5175F-8A7B-4CD7-99F0-665082F2EE86}"/>
+                <a16:creationId xmlns:a16="http://schemas.microsoft.com/office/drawing/2014/main" id="{0C72DA74-6FA3-4637-AA13-95E5237E96CE}"/>
               </a:ext>
             </a:extLst>
           </p:cNvPr>
@@ -22741,7 +22741,7 @@
           <p:cNvPr id="3" name="">
             <a:extLst xmlns:a="http://schemas.openxmlformats.org/drawingml/2006/main">
               <a:ext uri="{FF2B5EF4-FFF2-40B4-BE49-F238E27FC236}">
-                <a16:creationId xmlns:a16="http://schemas.microsoft.com/office/drawing/2014/main" id="{EB2675D7-576F-48B0-ABE0-89FB3D75FE26}"/>
+                <a16:creationId xmlns:a16="http://schemas.microsoft.com/office/drawing/2014/main" id="{FABD7773-F378-46D6-A376-D7FE19545DB9}"/>
               </a:ext>
             </a:extLst>
           </p:cNvPr>
@@ -22772,7 +22772,7 @@
           <p:cNvPr id="4" name="">
             <a:extLst xmlns:a="http://schemas.openxmlformats.org/drawingml/2006/main">
               <a:ext uri="{FF2B5EF4-FFF2-40B4-BE49-F238E27FC236}">
-                <a16:creationId xmlns:a16="http://schemas.microsoft.com/office/drawing/2014/main" id="{C90E021B-75F2-479B-A6BA-51634624BA9D}"/>
+                <a16:creationId xmlns:a16="http://schemas.microsoft.com/office/drawing/2014/main" id="{20ED478E-2C8E-4015-97E1-2EB8E8DD4DD5}"/>
               </a:ext>
             </a:extLst>
           </p:cNvPr>
@@ -22822,7 +22822,7 @@
           <p:cNvPr id="5" name="">
             <a:extLst xmlns:a="http://schemas.openxmlformats.org/drawingml/2006/main">
               <a:ext uri="{FF2B5EF4-FFF2-40B4-BE49-F238E27FC236}">
-                <a16:creationId xmlns:a16="http://schemas.microsoft.com/office/drawing/2014/main" id="{10C1363E-B166-41B3-8E9F-BD4D26C07247}"/>
+                <a16:creationId xmlns:a16="http://schemas.microsoft.com/office/drawing/2014/main" id="{ACAA3E6F-7202-402E-9092-49BFE2D4B776}"/>
               </a:ext>
             </a:extLst>
           </p:cNvPr>
@@ -22863,7 +22863,7 @@
           <p:cNvPr id="6" name="">
             <a:extLst xmlns:a="http://schemas.openxmlformats.org/drawingml/2006/main">
               <a:ext uri="{FF2B5EF4-FFF2-40B4-BE49-F238E27FC236}">
-                <a16:creationId xmlns:a16="http://schemas.microsoft.com/office/drawing/2014/main" id="{091FA42F-1B1C-434B-991B-EA7FA8D1C7B9}"/>
+                <a16:creationId xmlns:a16="http://schemas.microsoft.com/office/drawing/2014/main" id="{CA967460-6F3E-48C0-8907-12F9C8A2EBB9}"/>
               </a:ext>
             </a:extLst>
           </p:cNvPr>
@@ -22913,7 +22913,7 @@
           <p:cNvPr id="7" name="">
             <a:extLst xmlns:a="http://schemas.openxmlformats.org/drawingml/2006/main">
               <a:ext uri="{FF2B5EF4-FFF2-40B4-BE49-F238E27FC236}">
-                <a16:creationId xmlns:a16="http://schemas.microsoft.com/office/drawing/2014/main" id="{D31D08AA-CFF1-4623-AB8C-E6D10DF467D3}"/>
+                <a16:creationId xmlns:a16="http://schemas.microsoft.com/office/drawing/2014/main" id="{0D2019EA-A1D7-47B6-9BB7-1D63A227B0D1}"/>
               </a:ext>
             </a:extLst>
           </p:cNvPr>
@@ -22963,7 +22963,7 @@
           <p:cNvPr id="8" name="">
             <a:extLst xmlns:a="http://schemas.openxmlformats.org/drawingml/2006/main">
               <a:ext uri="{FF2B5EF4-FFF2-40B4-BE49-F238E27FC236}">
-                <a16:creationId xmlns:a16="http://schemas.microsoft.com/office/drawing/2014/main" id="{B34C9760-AAAC-4DBF-A1E3-FD39014E09C5}"/>
+                <a16:creationId xmlns:a16="http://schemas.microsoft.com/office/drawing/2014/main" id="{FC59DB85-1346-4518-9C51-D4DD4FCFEEEE}"/>
               </a:ext>
             </a:extLst>
           </p:cNvPr>
@@ -23013,7 +23013,7 @@
           <p:cNvPr id="9" name="">
             <a:extLst xmlns:a="http://schemas.openxmlformats.org/drawingml/2006/main">
               <a:ext uri="{FF2B5EF4-FFF2-40B4-BE49-F238E27FC236}">
-                <a16:creationId xmlns:a16="http://schemas.microsoft.com/office/drawing/2014/main" id="{373217E0-A462-489A-BE3D-B31C24E5AE6A}"/>
+                <a16:creationId xmlns:a16="http://schemas.microsoft.com/office/drawing/2014/main" id="{1D5C912B-36EF-4AE5-899F-B35527818B9F}"/>
               </a:ext>
             </a:extLst>
           </p:cNvPr>
@@ -23063,7 +23063,7 @@
           <p:cNvPr id="10" name="">
             <a:extLst xmlns:a="http://schemas.openxmlformats.org/drawingml/2006/main">
               <a:ext uri="{FF2B5EF4-FFF2-40B4-BE49-F238E27FC236}">
-                <a16:creationId xmlns:a16="http://schemas.microsoft.com/office/drawing/2014/main" id="{8062AAB9-CCA9-4E5F-9127-21B629EA9389}"/>
+                <a16:creationId xmlns:a16="http://schemas.microsoft.com/office/drawing/2014/main" id="{0EE2EEEF-3CE9-427D-84EA-D47A4615AF39}"/>
               </a:ext>
             </a:extLst>
           </p:cNvPr>
@@ -23104,7 +23104,7 @@
           <p:cNvPr id="11" name="">
             <a:extLst xmlns:a="http://schemas.openxmlformats.org/drawingml/2006/main">
               <a:ext uri="{FF2B5EF4-FFF2-40B4-BE49-F238E27FC236}">
-                <a16:creationId xmlns:a16="http://schemas.microsoft.com/office/drawing/2014/main" id="{496CCB4B-DB40-49C1-BE27-8FCC7640AC33}"/>
+                <a16:creationId xmlns:a16="http://schemas.microsoft.com/office/drawing/2014/main" id="{81641F71-C01B-4179-915E-C6ECB777DE6A}"/>
               </a:ext>
             </a:extLst>
           </p:cNvPr>
@@ -23154,7 +23154,7 @@
           <p:cNvPr id="12" name="">
             <a:extLst xmlns:a="http://schemas.openxmlformats.org/drawingml/2006/main">
               <a:ext uri="{FF2B5EF4-FFF2-40B4-BE49-F238E27FC236}">
-                <a16:creationId xmlns:a16="http://schemas.microsoft.com/office/drawing/2014/main" id="{0C7BFB41-945E-4960-AA7A-63E2D9EF34B3}"/>
+                <a16:creationId xmlns:a16="http://schemas.microsoft.com/office/drawing/2014/main" id="{194D14D8-44C3-466D-82A0-8073C7F64941}"/>
               </a:ext>
             </a:extLst>
           </p:cNvPr>
@@ -23204,7 +23204,7 @@
           <p:cNvPr id="13" name="">
             <a:extLst xmlns:a="http://schemas.openxmlformats.org/drawingml/2006/main">
               <a:ext uri="{FF2B5EF4-FFF2-40B4-BE49-F238E27FC236}">
-                <a16:creationId xmlns:a16="http://schemas.microsoft.com/office/drawing/2014/main" id="{0FAF1CAD-F838-484E-99A5-4B92E71447F9}"/>
+                <a16:creationId xmlns:a16="http://schemas.microsoft.com/office/drawing/2014/main" id="{36F4F052-AD63-47FA-AD45-8D015AB47A5E}"/>
               </a:ext>
             </a:extLst>
           </p:cNvPr>
@@ -23254,7 +23254,7 @@
           <p:cNvPr id="14" name="">
             <a:extLst xmlns:a="http://schemas.openxmlformats.org/drawingml/2006/main">
               <a:ext uri="{FF2B5EF4-FFF2-40B4-BE49-F238E27FC236}">
-                <a16:creationId xmlns:a16="http://schemas.microsoft.com/office/drawing/2014/main" id="{A5180923-8B1E-4AC0-A504-553FE502E27F}"/>
+                <a16:creationId xmlns:a16="http://schemas.microsoft.com/office/drawing/2014/main" id="{C0B3EEC1-D034-4C64-92B5-DEE5C554854E}"/>
               </a:ext>
             </a:extLst>
           </p:cNvPr>
@@ -23304,7 +23304,7 @@
           <p:cNvPr id="15" name="">
             <a:extLst xmlns:a="http://schemas.openxmlformats.org/drawingml/2006/main">
               <a:ext uri="{FF2B5EF4-FFF2-40B4-BE49-F238E27FC236}">
-                <a16:creationId xmlns:a16="http://schemas.microsoft.com/office/drawing/2014/main" id="{61D17D5C-376D-411F-9AE3-40A60190B615}"/>
+                <a16:creationId xmlns:a16="http://schemas.microsoft.com/office/drawing/2014/main" id="{D36B03E2-464E-4D7B-BE11-46409B2A8474}"/>
               </a:ext>
             </a:extLst>
           </p:cNvPr>
@@ -23339,7 +23339,7 @@
           <p:cNvPr id="16" name="">
             <a:extLst xmlns:a="http://schemas.openxmlformats.org/drawingml/2006/main">
               <a:ext uri="{FF2B5EF4-FFF2-40B4-BE49-F238E27FC236}">
-                <a16:creationId xmlns:a16="http://schemas.microsoft.com/office/drawing/2014/main" id="{2945483A-B50F-4881-89F0-2394632D1405}"/>
+                <a16:creationId xmlns:a16="http://schemas.microsoft.com/office/drawing/2014/main" id="{2C11FE44-4481-4EB3-AA33-FE3630A910C0}"/>
               </a:ext>
             </a:extLst>
           </p:cNvPr>
@@ -23389,7 +23389,7 @@
           <p:cNvPr id="17" name="">
             <a:extLst xmlns:a="http://schemas.openxmlformats.org/drawingml/2006/main">
               <a:ext uri="{FF2B5EF4-FFF2-40B4-BE49-F238E27FC236}">
-                <a16:creationId xmlns:a16="http://schemas.microsoft.com/office/drawing/2014/main" id="{33AE2A18-6A9F-43B4-B7F5-58F57EF17E8A}"/>
+                <a16:creationId xmlns:a16="http://schemas.microsoft.com/office/drawing/2014/main" id="{4F3E40AC-F69B-483F-873D-8DAFC1A3434C}"/>
               </a:ext>
             </a:extLst>
           </p:cNvPr>
@@ -23420,7 +23420,7 @@
           <p:cNvPr id="18" name="source-8">
             <a:extLst xmlns:a="http://schemas.openxmlformats.org/drawingml/2006/main">
               <a:ext uri="{FF2B5EF4-FFF2-40B4-BE49-F238E27FC236}">
-                <a16:creationId xmlns:a16="http://schemas.microsoft.com/office/drawing/2014/main" id="{60C764D7-087A-46A1-AD63-4C0F99EC7FC9}"/>
+                <a16:creationId xmlns:a16="http://schemas.microsoft.com/office/drawing/2014/main" id="{B7A848B1-D2D3-4947-A71B-9F0728DC1F65}"/>
               </a:ext>
             </a:extLst>
           </p:cNvPr>
@@ -23470,7 +23470,7 @@
           <p:cNvPr id="19" name="page-8">
             <a:extLst xmlns:a="http://schemas.openxmlformats.org/drawingml/2006/main">
               <a:ext uri="{FF2B5EF4-FFF2-40B4-BE49-F238E27FC236}">
-                <a16:creationId xmlns:a16="http://schemas.microsoft.com/office/drawing/2014/main" id="{5F780113-BCFB-4B5A-BE1D-2EF28B9D157B}"/>
+                <a16:creationId xmlns:a16="http://schemas.microsoft.com/office/drawing/2014/main" id="{BB6FBEA7-B029-4374-8F9A-F189E13622BB}"/>
               </a:ext>
             </a:extLst>
           </p:cNvPr>
@@ -23518,7 +23518,7 @@
     </p:spTree>
     <p:extLst>
       <p:ext uri="{BB962C8B-B14F-4D97-AF65-F5344CB8AC3E}">
-        <p14:creationId xmlns:p14="http://schemas.microsoft.com/office/powerpoint/2010/main" val="1016838993"/>
+        <p14:creationId xmlns:p14="http://schemas.microsoft.com/office/powerpoint/2010/main" val="175299940"/>
       </p:ext>
     </p:extLst>
   </p:cSld>
@@ -23549,7 +23549,7 @@
           <p:cNvPr id="53" name="kicker-9">
             <a:extLst xmlns:a="http://schemas.openxmlformats.org/drawingml/2006/main">
               <a:ext uri="{FF2B5EF4-FFF2-40B4-BE49-F238E27FC236}">
-                <a16:creationId xmlns:a16="http://schemas.microsoft.com/office/drawing/2014/main" id="{3BC5C86C-01CE-4F06-AD3B-B79DD3634290}"/>
+                <a16:creationId xmlns:a16="http://schemas.microsoft.com/office/drawing/2014/main" id="{FD4F8904-FDEF-425C-BF0E-468CED389002}"/>
               </a:ext>
             </a:extLst>
           </p:cNvPr>
@@ -23599,7 +23599,7 @@
           <p:cNvPr id="2" name="title-9">
             <a:extLst xmlns:a="http://schemas.openxmlformats.org/drawingml/2006/main">
               <a:ext uri="{FF2B5EF4-FFF2-40B4-BE49-F238E27FC236}">
-                <a16:creationId xmlns:a16="http://schemas.microsoft.com/office/drawing/2014/main" id="{F380AEFB-7786-4CE5-992F-CECBED440441}"/>
+                <a16:creationId xmlns:a16="http://schemas.microsoft.com/office/drawing/2014/main" id="{E7EB26C2-5775-4AB0-B293-137EBE47D67F}"/>
               </a:ext>
             </a:extLst>
           </p:cNvPr>
@@ -23649,7 +23649,7 @@
           <p:cNvPr id="3" name="">
             <a:extLst xmlns:a="http://schemas.openxmlformats.org/drawingml/2006/main">
               <a:ext uri="{FF2B5EF4-FFF2-40B4-BE49-F238E27FC236}">
-                <a16:creationId xmlns:a16="http://schemas.microsoft.com/office/drawing/2014/main" id="{337460D5-A53A-496F-86B0-7BE580604181}"/>
+                <a16:creationId xmlns:a16="http://schemas.microsoft.com/office/drawing/2014/main" id="{A0EB5D59-35D0-4815-A45D-5AAAE1E342F4}"/>
               </a:ext>
             </a:extLst>
           </p:cNvPr>
@@ -23680,7 +23680,7 @@
           <p:cNvPr id="4" name="">
             <a:extLst xmlns:a="http://schemas.openxmlformats.org/drawingml/2006/main">
               <a:ext uri="{FF2B5EF4-FFF2-40B4-BE49-F238E27FC236}">
-                <a16:creationId xmlns:a16="http://schemas.microsoft.com/office/drawing/2014/main" id="{DAEA1017-83A7-42D4-96E2-93123328655D}"/>
+                <a16:creationId xmlns:a16="http://schemas.microsoft.com/office/drawing/2014/main" id="{4B259D92-7CD9-41EC-A78E-9D9F608D8939}"/>
               </a:ext>
             </a:extLst>
           </p:cNvPr>
@@ -23730,7 +23730,7 @@
           <p:cNvPr id="5" name="">
             <a:extLst xmlns:a="http://schemas.openxmlformats.org/drawingml/2006/main">
               <a:ext uri="{FF2B5EF4-FFF2-40B4-BE49-F238E27FC236}">
-                <a16:creationId xmlns:a16="http://schemas.microsoft.com/office/drawing/2014/main" id="{A0A8B68E-592C-4F74-AD45-30B171A293DE}"/>
+                <a16:creationId xmlns:a16="http://schemas.microsoft.com/office/drawing/2014/main" id="{BFFB90A3-84FF-4531-9E8F-5C8823A440B2}"/>
               </a:ext>
             </a:extLst>
           </p:cNvPr>
@@ -23763,7 +23763,7 @@
           <p:cNvPr id="6" name="">
             <a:extLst xmlns:a="http://schemas.openxmlformats.org/drawingml/2006/main">
               <a:ext uri="{FF2B5EF4-FFF2-40B4-BE49-F238E27FC236}">
-                <a16:creationId xmlns:a16="http://schemas.microsoft.com/office/drawing/2014/main" id="{FA18B1B1-CC10-441B-9F74-6FBCB6250F23}"/>
+                <a16:creationId xmlns:a16="http://schemas.microsoft.com/office/drawing/2014/main" id="{9D837823-B34C-463A-AEF5-2C921A493580}"/>
               </a:ext>
             </a:extLst>
           </p:cNvPr>
@@ -23796,7 +23796,7 @@
           <p:cNvPr id="7" name="">
             <a:extLst xmlns:a="http://schemas.openxmlformats.org/drawingml/2006/main">
               <a:ext uri="{FF2B5EF4-FFF2-40B4-BE49-F238E27FC236}">
-                <a16:creationId xmlns:a16="http://schemas.microsoft.com/office/drawing/2014/main" id="{FB2C5FE0-0B3E-4852-8631-30493058145B}"/>
+                <a16:creationId xmlns:a16="http://schemas.microsoft.com/office/drawing/2014/main" id="{3798B6E4-865C-4753-B194-8506BC670E34}"/>
               </a:ext>
             </a:extLst>
           </p:cNvPr>
@@ -23837,7 +23837,7 @@
           <p:cNvPr id="8" name="">
             <a:extLst xmlns:a="http://schemas.openxmlformats.org/drawingml/2006/main">
               <a:ext uri="{FF2B5EF4-FFF2-40B4-BE49-F238E27FC236}">
-                <a16:creationId xmlns:a16="http://schemas.microsoft.com/office/drawing/2014/main" id="{EF32A767-7CC9-4153-A029-88A05DF4109C}"/>
+                <a16:creationId xmlns:a16="http://schemas.microsoft.com/office/drawing/2014/main" id="{4C73B597-FD6E-4FAC-B210-7B5DCF4C5936}"/>
               </a:ext>
             </a:extLst>
           </p:cNvPr>
@@ -23904,7 +23904,7 @@
           <p:cNvPr id="9" name="">
             <a:extLst xmlns:a="http://schemas.openxmlformats.org/drawingml/2006/main">
               <a:ext uri="{FF2B5EF4-FFF2-40B4-BE49-F238E27FC236}">
-                <a16:creationId xmlns:a16="http://schemas.microsoft.com/office/drawing/2014/main" id="{C884DB28-F5EC-4A23-9C11-0DA826561896}"/>
+                <a16:creationId xmlns:a16="http://schemas.microsoft.com/office/drawing/2014/main" id="{8E0C503D-8A45-449A-9505-15B7FDE62E5F}"/>
               </a:ext>
             </a:extLst>
           </p:cNvPr>
@@ -23954,7 +23954,7 @@
           <p:cNvPr id="10" name="">
             <a:extLst xmlns:a="http://schemas.openxmlformats.org/drawingml/2006/main">
               <a:ext uri="{FF2B5EF4-FFF2-40B4-BE49-F238E27FC236}">
-                <a16:creationId xmlns:a16="http://schemas.microsoft.com/office/drawing/2014/main" id="{66719C5E-F4F0-48E6-AAE7-D1961A2B7367}"/>
+                <a16:creationId xmlns:a16="http://schemas.microsoft.com/office/drawing/2014/main" id="{A3CD7114-594C-4C21-B564-93FDD58C0458}"/>
               </a:ext>
             </a:extLst>
           </p:cNvPr>
@@ -24004,7 +24004,7 @@
           <p:cNvPr id="11" name="">
             <a:extLst xmlns:a="http://schemas.openxmlformats.org/drawingml/2006/main">
               <a:ext uri="{FF2B5EF4-FFF2-40B4-BE49-F238E27FC236}">
-                <a16:creationId xmlns:a16="http://schemas.microsoft.com/office/drawing/2014/main" id="{F485C928-9FEC-445B-AAFC-8EE14AF9B619}"/>
+                <a16:creationId xmlns:a16="http://schemas.microsoft.com/office/drawing/2014/main" id="{037399B5-B7E8-4AE0-A434-341B6DF5B1F4}"/>
               </a:ext>
             </a:extLst>
           </p:cNvPr>
@@ -24054,7 +24054,7 @@
           <p:cNvPr id="12" name="">
             <a:extLst xmlns:a="http://schemas.openxmlformats.org/drawingml/2006/main">
               <a:ext uri="{FF2B5EF4-FFF2-40B4-BE49-F238E27FC236}">
-                <a16:creationId xmlns:a16="http://schemas.microsoft.com/office/drawing/2014/main" id="{1D584F27-DEBF-47FD-9625-9987B88F0C2B}"/>
+                <a16:creationId xmlns:a16="http://schemas.microsoft.com/office/drawing/2014/main" id="{539C45A1-5AD9-4752-A7C2-F8C7F5A11A0B}"/>
               </a:ext>
             </a:extLst>
           </p:cNvPr>
@@ -24104,7 +24104,7 @@
           <p:cNvPr id="13" name="">
             <a:extLst xmlns:a="http://schemas.openxmlformats.org/drawingml/2006/main">
               <a:ext uri="{FF2B5EF4-FFF2-40B4-BE49-F238E27FC236}">
-                <a16:creationId xmlns:a16="http://schemas.microsoft.com/office/drawing/2014/main" id="{DC057E7E-B587-41B1-9742-4B325B52D43B}"/>
+                <a16:creationId xmlns:a16="http://schemas.microsoft.com/office/drawing/2014/main" id="{31D9D124-62F9-4D2C-BEBD-08F87079FD45}"/>
               </a:ext>
             </a:extLst>
           </p:cNvPr>
@@ -24154,7 +24154,7 @@
           <p:cNvPr id="14" name="">
             <a:extLst xmlns:a="http://schemas.openxmlformats.org/drawingml/2006/main">
               <a:ext uri="{FF2B5EF4-FFF2-40B4-BE49-F238E27FC236}">
-                <a16:creationId xmlns:a16="http://schemas.microsoft.com/office/drawing/2014/main" id="{547023E5-52D4-4B4D-814E-7B351EF68A9A}"/>
+                <a16:creationId xmlns:a16="http://schemas.microsoft.com/office/drawing/2014/main" id="{26578B0F-E77B-41E4-BCB1-B7966D4397CA}"/>
               </a:ext>
             </a:extLst>
           </p:cNvPr>
@@ -24204,7 +24204,7 @@
           <p:cNvPr id="15" name="">
             <a:extLst xmlns:a="http://schemas.openxmlformats.org/drawingml/2006/main">
               <a:ext uri="{FF2B5EF4-FFF2-40B4-BE49-F238E27FC236}">
-                <a16:creationId xmlns:a16="http://schemas.microsoft.com/office/drawing/2014/main" id="{00997CA3-8F9A-4434-A9B5-25153E4448BD}"/>
+                <a16:creationId xmlns:a16="http://schemas.microsoft.com/office/drawing/2014/main" id="{6110DCF0-0612-42C6-8154-E42FEB27E457}"/>
               </a:ext>
             </a:extLst>
           </p:cNvPr>
@@ -24254,7 +24254,7 @@
           <p:cNvPr id="16" name="">
             <a:extLst xmlns:a="http://schemas.openxmlformats.org/drawingml/2006/main">
               <a:ext uri="{FF2B5EF4-FFF2-40B4-BE49-F238E27FC236}">
-                <a16:creationId xmlns:a16="http://schemas.microsoft.com/office/drawing/2014/main" id="{A98887D4-2D05-4324-B236-63CF83D18087}"/>
+                <a16:creationId xmlns:a16="http://schemas.microsoft.com/office/drawing/2014/main" id="{A712A859-9040-4990-AB35-D8E0D177C8C6}"/>
               </a:ext>
             </a:extLst>
           </p:cNvPr>
@@ -24304,7 +24304,7 @@
           <p:cNvPr id="17" name="">
             <a:extLst xmlns:a="http://schemas.openxmlformats.org/drawingml/2006/main">
               <a:ext uri="{FF2B5EF4-FFF2-40B4-BE49-F238E27FC236}">
-                <a16:creationId xmlns:a16="http://schemas.microsoft.com/office/drawing/2014/main" id="{E5C8266E-E177-4AC4-8681-F809FCD26565}"/>
+                <a16:creationId xmlns:a16="http://schemas.microsoft.com/office/drawing/2014/main" id="{65A3423E-4738-402F-AEDC-C2349387C68A}"/>
               </a:ext>
             </a:extLst>
           </p:cNvPr>
@@ -24354,7 +24354,7 @@
           <p:cNvPr id="18" name="">
             <a:extLst xmlns:a="http://schemas.openxmlformats.org/drawingml/2006/main">
               <a:ext uri="{FF2B5EF4-FFF2-40B4-BE49-F238E27FC236}">
-                <a16:creationId xmlns:a16="http://schemas.microsoft.com/office/drawing/2014/main" id="{E150820B-2419-4ECC-BAED-80A64934D431}"/>
+                <a16:creationId xmlns:a16="http://schemas.microsoft.com/office/drawing/2014/main" id="{2D5A5E45-D642-482A-8DC1-0549C94459D8}"/>
               </a:ext>
             </a:extLst>
           </p:cNvPr>
@@ -24404,7 +24404,7 @@
           <p:cNvPr id="19" name="">
             <a:extLst xmlns:a="http://schemas.openxmlformats.org/drawingml/2006/main">
               <a:ext uri="{FF2B5EF4-FFF2-40B4-BE49-F238E27FC236}">
-                <a16:creationId xmlns:a16="http://schemas.microsoft.com/office/drawing/2014/main" id="{36A801D9-707D-4A7E-B2CB-FCDBA2A95FB3}"/>
+                <a16:creationId xmlns:a16="http://schemas.microsoft.com/office/drawing/2014/main" id="{A90400D4-CD85-42A3-B214-A49FB259DFA1}"/>
               </a:ext>
             </a:extLst>
           </p:cNvPr>
@@ -24454,7 +24454,7 @@
           <p:cNvPr id="20" name="">
             <a:extLst xmlns:a="http://schemas.openxmlformats.org/drawingml/2006/main">
               <a:ext uri="{FF2B5EF4-FFF2-40B4-BE49-F238E27FC236}">
-                <a16:creationId xmlns:a16="http://schemas.microsoft.com/office/drawing/2014/main" id="{8E36B02D-8418-4F80-A80F-6AFC2BBE2BD7}"/>
+                <a16:creationId xmlns:a16="http://schemas.microsoft.com/office/drawing/2014/main" id="{B2D37EA2-B2C7-4956-A8FE-00BC39BF52B5}"/>
               </a:ext>
             </a:extLst>
           </p:cNvPr>
@@ -24504,7 +24504,7 @@
           <p:cNvPr id="21" name="">
             <a:extLst xmlns:a="http://schemas.openxmlformats.org/drawingml/2006/main">
               <a:ext uri="{FF2B5EF4-FFF2-40B4-BE49-F238E27FC236}">
-                <a16:creationId xmlns:a16="http://schemas.microsoft.com/office/drawing/2014/main" id="{7FD832C8-A82A-439C-AFD3-6842CDFF28A3}"/>
+                <a16:creationId xmlns:a16="http://schemas.microsoft.com/office/drawing/2014/main" id="{2A885726-8256-43EC-8312-7EED0137FA10}"/>
               </a:ext>
             </a:extLst>
           </p:cNvPr>
@@ -24554,7 +24554,7 @@
           <p:cNvPr id="22" name="">
             <a:extLst xmlns:a="http://schemas.openxmlformats.org/drawingml/2006/main">
               <a:ext uri="{FF2B5EF4-FFF2-40B4-BE49-F238E27FC236}">
-                <a16:creationId xmlns:a16="http://schemas.microsoft.com/office/drawing/2014/main" id="{028964B9-DF65-4D6F-AD11-2DABDBE471F8}"/>
+                <a16:creationId xmlns:a16="http://schemas.microsoft.com/office/drawing/2014/main" id="{B479C039-487A-4B6D-BBC1-4D55D56A7B4A}"/>
               </a:ext>
             </a:extLst>
           </p:cNvPr>
@@ -24589,7 +24589,7 @@
           <p:cNvPr id="23" name="">
             <a:extLst xmlns:a="http://schemas.openxmlformats.org/drawingml/2006/main">
               <a:ext uri="{FF2B5EF4-FFF2-40B4-BE49-F238E27FC236}">
-                <a16:creationId xmlns:a16="http://schemas.microsoft.com/office/drawing/2014/main" id="{2762DDD1-2086-4901-B0CE-F8DBF03EF2FB}"/>
+                <a16:creationId xmlns:a16="http://schemas.microsoft.com/office/drawing/2014/main" id="{9C3A9493-E36E-4E94-A189-ECF56BA4C7CC}"/>
               </a:ext>
             </a:extLst>
           </p:cNvPr>
@@ -24639,7 +24639,7 @@
           <p:cNvPr id="24" name="">
             <a:extLst xmlns:a="http://schemas.openxmlformats.org/drawingml/2006/main">
               <a:ext uri="{FF2B5EF4-FFF2-40B4-BE49-F238E27FC236}">
-                <a16:creationId xmlns:a16="http://schemas.microsoft.com/office/drawing/2014/main" id="{82778209-24D2-4322-8099-E5AF510B911C}"/>
+                <a16:creationId xmlns:a16="http://schemas.microsoft.com/office/drawing/2014/main" id="{39CECD32-B24A-4DF4-A909-35DA87D37995}"/>
               </a:ext>
             </a:extLst>
           </p:cNvPr>
@@ -24689,7 +24689,7 @@
           <p:cNvPr id="25" name="">
             <a:extLst xmlns:a="http://schemas.openxmlformats.org/drawingml/2006/main">
               <a:ext uri="{FF2B5EF4-FFF2-40B4-BE49-F238E27FC236}">
-                <a16:creationId xmlns:a16="http://schemas.microsoft.com/office/drawing/2014/main" id="{330F11CD-CDC2-4F28-B618-CEA82D989890}"/>
+                <a16:creationId xmlns:a16="http://schemas.microsoft.com/office/drawing/2014/main" id="{0B7EC195-D941-4E15-A6AF-6C80EF179BAB}"/>
               </a:ext>
             </a:extLst>
           </p:cNvPr>
@@ -24739,7 +24739,7 @@
           <p:cNvPr id="26" name="">
             <a:extLst xmlns:a="http://schemas.openxmlformats.org/drawingml/2006/main">
               <a:ext uri="{FF2B5EF4-FFF2-40B4-BE49-F238E27FC236}">
-                <a16:creationId xmlns:a16="http://schemas.microsoft.com/office/drawing/2014/main" id="{310ECF57-AF47-4F79-B087-7308360C6FC9}"/>
+                <a16:creationId xmlns:a16="http://schemas.microsoft.com/office/drawing/2014/main" id="{3FFBB91E-F55A-4964-9480-83AC5BFE1B26}"/>
               </a:ext>
             </a:extLst>
           </p:cNvPr>
@@ -24774,7 +24774,7 @@
           <p:cNvPr id="27" name="">
             <a:extLst xmlns:a="http://schemas.openxmlformats.org/drawingml/2006/main">
               <a:ext uri="{FF2B5EF4-FFF2-40B4-BE49-F238E27FC236}">
-                <a16:creationId xmlns:a16="http://schemas.microsoft.com/office/drawing/2014/main" id="{A585775E-03F6-4D6B-ADFC-D99D0CA62D16}"/>
+                <a16:creationId xmlns:a16="http://schemas.microsoft.com/office/drawing/2014/main" id="{47791DBE-9170-4E0D-8082-95138C83A9A8}"/>
               </a:ext>
             </a:extLst>
           </p:cNvPr>
@@ -24824,7 +24824,7 @@
           <p:cNvPr id="28" name="">
             <a:extLst xmlns:a="http://schemas.openxmlformats.org/drawingml/2006/main">
               <a:ext uri="{FF2B5EF4-FFF2-40B4-BE49-F238E27FC236}">
-                <a16:creationId xmlns:a16="http://schemas.microsoft.com/office/drawing/2014/main" id="{280A77DA-4969-4B5A-AC31-CFD4345AA09B}"/>
+                <a16:creationId xmlns:a16="http://schemas.microsoft.com/office/drawing/2014/main" id="{FE7BCCDA-E71B-4FF5-A836-DFD261B778A9}"/>
               </a:ext>
             </a:extLst>
           </p:cNvPr>
@@ -24874,7 +24874,7 @@
           <p:cNvPr id="29" name="">
             <a:extLst xmlns:a="http://schemas.openxmlformats.org/drawingml/2006/main">
               <a:ext uri="{FF2B5EF4-FFF2-40B4-BE49-F238E27FC236}">
-                <a16:creationId xmlns:a16="http://schemas.microsoft.com/office/drawing/2014/main" id="{4C395AD7-5CF4-4C89-B2B4-AC33D90D0FBD}"/>
+                <a16:creationId xmlns:a16="http://schemas.microsoft.com/office/drawing/2014/main" id="{0F6B292F-19EB-434C-B90B-98EB7607B13D}"/>
               </a:ext>
             </a:extLst>
           </p:cNvPr>
@@ -24924,7 +24924,7 @@
           <p:cNvPr id="30" name="">
             <a:extLst xmlns:a="http://schemas.openxmlformats.org/drawingml/2006/main">
               <a:ext uri="{FF2B5EF4-FFF2-40B4-BE49-F238E27FC236}">
-                <a16:creationId xmlns:a16="http://schemas.microsoft.com/office/drawing/2014/main" id="{B90E1A29-4B0B-4ACE-97FF-3DBB7B6CCAA9}"/>
+                <a16:creationId xmlns:a16="http://schemas.microsoft.com/office/drawing/2014/main" id="{D9215995-2AE3-43C5-A1D6-37CB1CB7ABCF}"/>
               </a:ext>
             </a:extLst>
           </p:cNvPr>
@@ -24959,7 +24959,7 @@
           <p:cNvPr id="31" name="">
             <a:extLst xmlns:a="http://schemas.openxmlformats.org/drawingml/2006/main">
               <a:ext uri="{FF2B5EF4-FFF2-40B4-BE49-F238E27FC236}">
-                <a16:creationId xmlns:a16="http://schemas.microsoft.com/office/drawing/2014/main" id="{B4EF1111-9B56-4681-9FB9-DFDCD4A6C5A7}"/>
+                <a16:creationId xmlns:a16="http://schemas.microsoft.com/office/drawing/2014/main" id="{4224C003-782E-4265-BD94-0998CF314423}"/>
               </a:ext>
             </a:extLst>
           </p:cNvPr>
@@ -25009,7 +25009,7 @@
           <p:cNvPr id="32" name="">
             <a:extLst xmlns:a="http://schemas.openxmlformats.org/drawingml/2006/main">
               <a:ext uri="{FF2B5EF4-FFF2-40B4-BE49-F238E27FC236}">
-                <a16:creationId xmlns:a16="http://schemas.microsoft.com/office/drawing/2014/main" id="{14578A0E-306F-4EC0-B30D-DEBB6CF58A32}"/>
+                <a16:creationId xmlns:a16="http://schemas.microsoft.com/office/drawing/2014/main" id="{3533A3F9-B210-4C8B-9CC8-39C376DDDB0D}"/>
               </a:ext>
             </a:extLst>
           </p:cNvPr>
@@ -25059,7 +25059,7 @@
           <p:cNvPr id="33" name="">
             <a:extLst xmlns:a="http://schemas.openxmlformats.org/drawingml/2006/main">
               <a:ext uri="{FF2B5EF4-FFF2-40B4-BE49-F238E27FC236}">
-                <a16:creationId xmlns:a16="http://schemas.microsoft.com/office/drawing/2014/main" id="{7A76C063-844E-4ABC-88F6-1F2B93367B68}"/>
+                <a16:creationId xmlns:a16="http://schemas.microsoft.com/office/drawing/2014/main" id="{80D4CF0A-7F0B-4D51-A864-63A788D57534}"/>
               </a:ext>
             </a:extLst>
           </p:cNvPr>
@@ -25109,7 +25109,7 @@
           <p:cNvPr id="34" name="">
             <a:extLst xmlns:a="http://schemas.openxmlformats.org/drawingml/2006/main">
               <a:ext uri="{FF2B5EF4-FFF2-40B4-BE49-F238E27FC236}">
-                <a16:creationId xmlns:a16="http://schemas.microsoft.com/office/drawing/2014/main" id="{446B7D57-A7AE-49C5-9556-CB08BAE7634B}"/>
+                <a16:creationId xmlns:a16="http://schemas.microsoft.com/office/drawing/2014/main" id="{F31A5AEB-4924-482C-B0F7-C0A3E10D4AF7}"/>
               </a:ext>
             </a:extLst>
           </p:cNvPr>
@@ -25144,7 +25144,7 @@
           <p:cNvPr id="35" name="">
             <a:extLst xmlns:a="http://schemas.openxmlformats.org/drawingml/2006/main">
               <a:ext uri="{FF2B5EF4-FFF2-40B4-BE49-F238E27FC236}">
-                <a16:creationId xmlns:a16="http://schemas.microsoft.com/office/drawing/2014/main" id="{ED0059BC-9FFC-499A-881F-A9BB2B5A5093}"/>
+                <a16:creationId xmlns:a16="http://schemas.microsoft.com/office/drawing/2014/main" id="{4BA607CD-7F77-4168-9B05-64A1D9CFEDA9}"/>
               </a:ext>
             </a:extLst>
           </p:cNvPr>
@@ -25194,7 +25194,7 @@
           <p:cNvPr id="36" name="">
             <a:extLst xmlns:a="http://schemas.openxmlformats.org/drawingml/2006/main">
               <a:ext uri="{FF2B5EF4-FFF2-40B4-BE49-F238E27FC236}">
-                <a16:creationId xmlns:a16="http://schemas.microsoft.com/office/drawing/2014/main" id="{594BD822-577C-4B2B-BB88-3954EC26AFC1}"/>
+                <a16:creationId xmlns:a16="http://schemas.microsoft.com/office/drawing/2014/main" id="{B014E69B-04A2-4072-8BAA-CE80552DB8BF}"/>
               </a:ext>
             </a:extLst>
           </p:cNvPr>
@@ -25244,7 +25244,7 @@
           <p:cNvPr id="37" name="">
             <a:extLst xmlns:a="http://schemas.openxmlformats.org/drawingml/2006/main">
               <a:ext uri="{FF2B5EF4-FFF2-40B4-BE49-F238E27FC236}">
-                <a16:creationId xmlns:a16="http://schemas.microsoft.com/office/drawing/2014/main" id="{A6ECDE24-C8FD-4E5B-8E23-98B730F253FB}"/>
+                <a16:creationId xmlns:a16="http://schemas.microsoft.com/office/drawing/2014/main" id="{EDDE125B-F49E-435F-9BF6-76B85996B193}"/>
               </a:ext>
             </a:extLst>
           </p:cNvPr>
@@ -25294,7 +25294,7 @@
           <p:cNvPr id="38" name="">
             <a:extLst xmlns:a="http://schemas.openxmlformats.org/drawingml/2006/main">
               <a:ext uri="{FF2B5EF4-FFF2-40B4-BE49-F238E27FC236}">
-                <a16:creationId xmlns:a16="http://schemas.microsoft.com/office/drawing/2014/main" id="{CDE6AC11-9075-4BF8-A0A7-D816E01405A9}"/>
+                <a16:creationId xmlns:a16="http://schemas.microsoft.com/office/drawing/2014/main" id="{90B11AF7-04D8-45F0-8010-678165A0AB62}"/>
               </a:ext>
             </a:extLst>
           </p:cNvPr>
@@ -25344,7 +25344,7 @@
           <p:cNvPr id="39" name="">
             <a:extLst xmlns:a="http://schemas.openxmlformats.org/drawingml/2006/main">
               <a:ext uri="{FF2B5EF4-FFF2-40B4-BE49-F238E27FC236}">
-                <a16:creationId xmlns:a16="http://schemas.microsoft.com/office/drawing/2014/main" id="{083F2F84-1EBD-4E87-BE35-CFAFE4615566}"/>
+                <a16:creationId xmlns:a16="http://schemas.microsoft.com/office/drawing/2014/main" id="{B507EBC2-B869-4B51-86F1-D1A3DAA56D75}"/>
               </a:ext>
             </a:extLst>
           </p:cNvPr>
@@ -25385,7 +25385,7 @@
           <p:cNvPr id="40" name="">
             <a:extLst xmlns:a="http://schemas.openxmlformats.org/drawingml/2006/main">
               <a:ext uri="{FF2B5EF4-FFF2-40B4-BE49-F238E27FC236}">
-                <a16:creationId xmlns:a16="http://schemas.microsoft.com/office/drawing/2014/main" id="{4761D539-521F-4F48-AE5B-7B7198F554FA}"/>
+                <a16:creationId xmlns:a16="http://schemas.microsoft.com/office/drawing/2014/main" id="{6F021255-AA67-465D-8792-FDE63762A1E6}"/>
               </a:ext>
             </a:extLst>
           </p:cNvPr>
@@ -25435,7 +25435,7 @@
           <p:cNvPr id="41" name="">
             <a:extLst xmlns:a="http://schemas.openxmlformats.org/drawingml/2006/main">
               <a:ext uri="{FF2B5EF4-FFF2-40B4-BE49-F238E27FC236}">
-                <a16:creationId xmlns:a16="http://schemas.microsoft.com/office/drawing/2014/main" id="{D5770D95-E125-4A2B-8FE9-FB5B32449DB2}"/>
+                <a16:creationId xmlns:a16="http://schemas.microsoft.com/office/drawing/2014/main" id="{471FC09E-66FF-41AF-B8E5-35D7EC9A5827}"/>
               </a:ext>
             </a:extLst>
           </p:cNvPr>
@@ -25485,7 +25485,7 @@
           <p:cNvPr id="42" name="">
             <a:extLst xmlns:a="http://schemas.openxmlformats.org/drawingml/2006/main">
               <a:ext uri="{FF2B5EF4-FFF2-40B4-BE49-F238E27FC236}">
-                <a16:creationId xmlns:a16="http://schemas.microsoft.com/office/drawing/2014/main" id="{69F4FF3D-95B4-4C89-8EA3-AB4B94118F4C}"/>
+                <a16:creationId xmlns:a16="http://schemas.microsoft.com/office/drawing/2014/main" id="{AA1A7357-AAD5-4C1E-A367-FA1E90AFBB7A}"/>
               </a:ext>
             </a:extLst>
           </p:cNvPr>
@@ -25535,7 +25535,7 @@
           <p:cNvPr id="43" name="">
             <a:extLst xmlns:a="http://schemas.openxmlformats.org/drawingml/2006/main">
               <a:ext uri="{FF2B5EF4-FFF2-40B4-BE49-F238E27FC236}">
-                <a16:creationId xmlns:a16="http://schemas.microsoft.com/office/drawing/2014/main" id="{6C95B36C-41E3-4AF9-A1BE-432BCBD47503}"/>
+                <a16:creationId xmlns:a16="http://schemas.microsoft.com/office/drawing/2014/main" id="{4B29C1E1-4D16-4D12-B6F4-E41042CAE0A7}"/>
               </a:ext>
             </a:extLst>
           </p:cNvPr>
@@ -25585,7 +25585,7 @@
           <p:cNvPr id="44" name="">
             <a:extLst xmlns:a="http://schemas.openxmlformats.org/drawingml/2006/main">
               <a:ext uri="{FF2B5EF4-FFF2-40B4-BE49-F238E27FC236}">
-                <a16:creationId xmlns:a16="http://schemas.microsoft.com/office/drawing/2014/main" id="{75F590CD-D450-4A3D-A1D1-1BEFF57DC03B}"/>
+                <a16:creationId xmlns:a16="http://schemas.microsoft.com/office/drawing/2014/main" id="{BEA81012-4DB7-41DB-ABE6-90915FDF05E3}"/>
               </a:ext>
             </a:extLst>
           </p:cNvPr>
@@ -25635,7 +25635,7 @@
           <p:cNvPr id="45" name="">
             <a:extLst xmlns:a="http://schemas.openxmlformats.org/drawingml/2006/main">
               <a:ext uri="{FF2B5EF4-FFF2-40B4-BE49-F238E27FC236}">
-                <a16:creationId xmlns:a16="http://schemas.microsoft.com/office/drawing/2014/main" id="{D78D40BE-E8C2-41F1-8B0D-BE3ACE2B89A8}"/>
+                <a16:creationId xmlns:a16="http://schemas.microsoft.com/office/drawing/2014/main" id="{D4604A52-3ECC-4B2A-996D-A02F5D678400}"/>
               </a:ext>
             </a:extLst>
           </p:cNvPr>
@@ -25685,7 +25685,7 @@
           <p:cNvPr id="46" name="">
             <a:extLst xmlns:a="http://schemas.openxmlformats.org/drawingml/2006/main">
               <a:ext uri="{FF2B5EF4-FFF2-40B4-BE49-F238E27FC236}">
-                <a16:creationId xmlns:a16="http://schemas.microsoft.com/office/drawing/2014/main" id="{FF995652-32BA-4DF0-BCF9-CC0B1C316ACC}"/>
+                <a16:creationId xmlns:a16="http://schemas.microsoft.com/office/drawing/2014/main" id="{FB2FE8C7-1F9B-4F75-9F60-A2EB22E3582A}"/>
               </a:ext>
             </a:extLst>
           </p:cNvPr>
@@ -25735,7 +25735,7 @@
           <p:cNvPr id="47" name="">
             <a:extLst xmlns:a="http://schemas.openxmlformats.org/drawingml/2006/main">
               <a:ext uri="{FF2B5EF4-FFF2-40B4-BE49-F238E27FC236}">
-                <a16:creationId xmlns:a16="http://schemas.microsoft.com/office/drawing/2014/main" id="{F87C326F-4B13-4290-B19F-13302AB724DB}"/>
+                <a16:creationId xmlns:a16="http://schemas.microsoft.com/office/drawing/2014/main" id="{D24013D8-8175-45F5-AC4D-5F82D3B269C3}"/>
               </a:ext>
             </a:extLst>
           </p:cNvPr>
@@ -25785,7 +25785,7 @@
           <p:cNvPr id="48" name="">
             <a:extLst xmlns:a="http://schemas.openxmlformats.org/drawingml/2006/main">
               <a:ext uri="{FF2B5EF4-FFF2-40B4-BE49-F238E27FC236}">
-                <a16:creationId xmlns:a16="http://schemas.microsoft.com/office/drawing/2014/main" id="{3B54C11C-3B13-41FB-AB03-60352606F8BB}"/>
+                <a16:creationId xmlns:a16="http://schemas.microsoft.com/office/drawing/2014/main" id="{9027CD96-7C4B-4D62-BBA2-5E7C94C384B6}"/>
               </a:ext>
             </a:extLst>
           </p:cNvPr>
@@ -25835,7 +25835,7 @@
           <p:cNvPr id="49" name="">
             <a:extLst xmlns:a="http://schemas.openxmlformats.org/drawingml/2006/main">
               <a:ext uri="{FF2B5EF4-FFF2-40B4-BE49-F238E27FC236}">
-                <a16:creationId xmlns:a16="http://schemas.microsoft.com/office/drawing/2014/main" id="{E238E341-DF5E-41DE-A5EC-7983D06BA07D}"/>
+                <a16:creationId xmlns:a16="http://schemas.microsoft.com/office/drawing/2014/main" id="{54F3827E-5F0C-46F3-A20A-6C80E8825CE6}"/>
               </a:ext>
             </a:extLst>
           </p:cNvPr>
@@ -25885,7 +25885,7 @@
           <p:cNvPr id="50" name="">
             <a:extLst xmlns:a="http://schemas.openxmlformats.org/drawingml/2006/main">
               <a:ext uri="{FF2B5EF4-FFF2-40B4-BE49-F238E27FC236}">
-                <a16:creationId xmlns:a16="http://schemas.microsoft.com/office/drawing/2014/main" id="{3EB0A1F2-4F6C-4ED7-AD53-E134A5C871DC}"/>
+                <a16:creationId xmlns:a16="http://schemas.microsoft.com/office/drawing/2014/main" id="{203DDBB5-0E35-414B-8AAA-F4F2CB33958B}"/>
               </a:ext>
             </a:extLst>
           </p:cNvPr>
@@ -25916,7 +25916,7 @@
           <p:cNvPr id="51" name="source-9">
             <a:extLst xmlns:a="http://schemas.openxmlformats.org/drawingml/2006/main">
               <a:ext uri="{FF2B5EF4-FFF2-40B4-BE49-F238E27FC236}">
-                <a16:creationId xmlns:a16="http://schemas.microsoft.com/office/drawing/2014/main" id="{3AF3CDF5-DFDB-4923-B451-FFE0A0AA6384}"/>
+                <a16:creationId xmlns:a16="http://schemas.microsoft.com/office/drawing/2014/main" id="{A6431AA1-8957-41EB-A43C-F915B8BFB872}"/>
               </a:ext>
             </a:extLst>
           </p:cNvPr>
@@ -25966,7 +25966,7 @@
           <p:cNvPr id="52" name="page-9">
             <a:extLst xmlns:a="http://schemas.openxmlformats.org/drawingml/2006/main">
               <a:ext uri="{FF2B5EF4-FFF2-40B4-BE49-F238E27FC236}">
-                <a16:creationId xmlns:a16="http://schemas.microsoft.com/office/drawing/2014/main" id="{52D82AB4-DD87-4A61-BB33-0F924146164E}"/>
+                <a16:creationId xmlns:a16="http://schemas.microsoft.com/office/drawing/2014/main" id="{E7E35BE0-9965-4622-B65C-4EC702FB9889}"/>
               </a:ext>
             </a:extLst>
           </p:cNvPr>
@@ -26014,7 +26014,7 @@
     </p:spTree>
     <p:extLst>
       <p:ext uri="{BB962C8B-B14F-4D97-AF65-F5344CB8AC3E}">
-        <p14:creationId xmlns:p14="http://schemas.microsoft.com/office/powerpoint/2010/main" val="1341004235"/>
+        <p14:creationId xmlns:p14="http://schemas.microsoft.com/office/powerpoint/2010/main" val="1439275797"/>
       </p:ext>
     </p:extLst>
   </p:cSld>

</xml_diff>